<commit_message>
docs: correct defense startup paths
</commit_message>
<xml_diff>
--- a/docs/AI求职雷达课程项目答辩.pptx
+++ b/docs/AI求职雷达课程项目答辩.pptx
@@ -2,27 +2,27 @@
 <file path=ppt/presentation.xml><?xml version="1.0" encoding="utf-8"?>
 <p:presentation xmlns:p="http://schemas.openxmlformats.org/presentationml/2006/main">
   <p:sldMasterIdLst>
-    <p:sldMasterId xmlns:r="http://schemas.openxmlformats.org/officeDocument/2006/relationships" id="2147483648" r:id="Re778a741432f47ac"/>
+    <p:sldMasterId xmlns:r="http://schemas.openxmlformats.org/officeDocument/2006/relationships" id="2147483648" r:id="R4466c7e726ca486c"/>
   </p:sldMasterIdLst>
   <p:notesMasterIdLst>
-    <p:notesMasterId xmlns:r="http://schemas.openxmlformats.org/officeDocument/2006/relationships" r:id="Rb4997a8427a14561"/>
+    <p:notesMasterId xmlns:r="http://schemas.openxmlformats.org/officeDocument/2006/relationships" r:id="R6d13a50b3214430e"/>
   </p:notesMasterIdLst>
   <p:sldIdLst>
-    <p:sldId xmlns:r="http://schemas.openxmlformats.org/officeDocument/2006/relationships" id="256" r:id="R8043d7178a2e4659"/>
-    <p:sldId xmlns:r="http://schemas.openxmlformats.org/officeDocument/2006/relationships" id="257" r:id="R10fce1b9af6848ed"/>
-    <p:sldId xmlns:r="http://schemas.openxmlformats.org/officeDocument/2006/relationships" id="258" r:id="R26e07229b12445ac"/>
-    <p:sldId xmlns:r="http://schemas.openxmlformats.org/officeDocument/2006/relationships" id="259" r:id="R4689c5ffed394040"/>
-    <p:sldId xmlns:r="http://schemas.openxmlformats.org/officeDocument/2006/relationships" id="260" r:id="R93c4e304e8e14814"/>
-    <p:sldId xmlns:r="http://schemas.openxmlformats.org/officeDocument/2006/relationships" id="261" r:id="Rfe2cc2cadd1640e7"/>
-    <p:sldId xmlns:r="http://schemas.openxmlformats.org/officeDocument/2006/relationships" id="262" r:id="Re0f7c4e4330f45b2"/>
-    <p:sldId xmlns:r="http://schemas.openxmlformats.org/officeDocument/2006/relationships" id="263" r:id="R85057740fb08486d"/>
-    <p:sldId xmlns:r="http://schemas.openxmlformats.org/officeDocument/2006/relationships" id="264" r:id="R915ac79152a94645"/>
-    <p:sldId xmlns:r="http://schemas.openxmlformats.org/officeDocument/2006/relationships" id="265" r:id="R00c7348129144042"/>
-    <p:sldId xmlns:r="http://schemas.openxmlformats.org/officeDocument/2006/relationships" id="266" r:id="R56daa4e37eab40ef"/>
-    <p:sldId xmlns:r="http://schemas.openxmlformats.org/officeDocument/2006/relationships" id="267" r:id="R5bf7607d8cd149d3"/>
-    <p:sldId xmlns:r="http://schemas.openxmlformats.org/officeDocument/2006/relationships" id="268" r:id="Rc91fc3c49ad04e5c"/>
-    <p:sldId xmlns:r="http://schemas.openxmlformats.org/officeDocument/2006/relationships" id="269" r:id="R266409b43fa94db3"/>
-    <p:sldId xmlns:r="http://schemas.openxmlformats.org/officeDocument/2006/relationships" id="270" r:id="R49d72c078236443e"/>
+    <p:sldId xmlns:r="http://schemas.openxmlformats.org/officeDocument/2006/relationships" id="256" r:id="R4477f3193b8b4c32"/>
+    <p:sldId xmlns:r="http://schemas.openxmlformats.org/officeDocument/2006/relationships" id="257" r:id="R5521e2670db04323"/>
+    <p:sldId xmlns:r="http://schemas.openxmlformats.org/officeDocument/2006/relationships" id="258" r:id="R401254d0185646c4"/>
+    <p:sldId xmlns:r="http://schemas.openxmlformats.org/officeDocument/2006/relationships" id="259" r:id="Rc10fd2799efc4d48"/>
+    <p:sldId xmlns:r="http://schemas.openxmlformats.org/officeDocument/2006/relationships" id="260" r:id="Rb8b0140987cb4173"/>
+    <p:sldId xmlns:r="http://schemas.openxmlformats.org/officeDocument/2006/relationships" id="261" r:id="R377ca72f90ea4849"/>
+    <p:sldId xmlns:r="http://schemas.openxmlformats.org/officeDocument/2006/relationships" id="262" r:id="R365483fefa9f44e4"/>
+    <p:sldId xmlns:r="http://schemas.openxmlformats.org/officeDocument/2006/relationships" id="263" r:id="Re9fc2e42ab6349fb"/>
+    <p:sldId xmlns:r="http://schemas.openxmlformats.org/officeDocument/2006/relationships" id="264" r:id="R38673a3f73054705"/>
+    <p:sldId xmlns:r="http://schemas.openxmlformats.org/officeDocument/2006/relationships" id="265" r:id="R652a925fc7a841fe"/>
+    <p:sldId xmlns:r="http://schemas.openxmlformats.org/officeDocument/2006/relationships" id="266" r:id="R3349a40e5da94580"/>
+    <p:sldId xmlns:r="http://schemas.openxmlformats.org/officeDocument/2006/relationships" id="267" r:id="R1813c8003b954925"/>
+    <p:sldId xmlns:r="http://schemas.openxmlformats.org/officeDocument/2006/relationships" id="268" r:id="R0e4284a5462a41b1"/>
+    <p:sldId xmlns:r="http://schemas.openxmlformats.org/officeDocument/2006/relationships" id="269" r:id="R78f575ea341a431f"/>
+    <p:sldId xmlns:r="http://schemas.openxmlformats.org/officeDocument/2006/relationships" id="270" r:id="R0b46c8d579ea49fc"/>
   </p:sldIdLst>
   <p:sldSz cx="12192000" cy="6858000"/>
   <p:notesSz cx="6858000" cy="9144000"/>
@@ -1539,7 +1539,7 @@
   </p:cSld>
   <p:clrMap bg1="lt1" tx1="dk1" bg2="lt2" tx2="dk2" accent1="accent1" accent2="accent2" accent3="accent3" accent4="accent4" accent5="accent5" accent6="accent6" hlink="hlink" folHlink="folHlink"/>
   <p:sldLayoutIdLst>
-    <p:sldLayoutId xmlns:r="http://schemas.openxmlformats.org/officeDocument/2006/relationships" id="2147483649" r:id="R2b71fb57d745479f"/>
+    <p:sldLayoutId xmlns:r="http://schemas.openxmlformats.org/officeDocument/2006/relationships" id="2147483649" r:id="Rf23847fbc92d4509"/>
   </p:sldLayoutIdLst>
   <p:txStyles>
     <p:titleStyle>
@@ -2090,7 +2090,7 @@
           <p:cNvPr id="1" name="cover-eyebrow">
             <a:extLst xmlns:a="http://schemas.openxmlformats.org/drawingml/2006/main">
               <a:ext uri="{FF2B5EF4-FFF2-40B4-BE49-F238E27FC236}">
-                <a16:creationId xmlns:a16="http://schemas.microsoft.com/office/drawing/2014/main" id="{038E2D7F-4881-4036-99D0-F8D0ADC6B6A9}"/>
+                <a16:creationId xmlns:a16="http://schemas.microsoft.com/office/drawing/2014/main" id="{E596D452-33B1-4740-85BD-FC919AA66DF2}"/>
               </a:ext>
             </a:extLst>
           </p:cNvPr>
@@ -2148,7 +2148,7 @@
           <p:cNvPr id="2" name="cover-accent">
             <a:extLst xmlns:a="http://schemas.openxmlformats.org/drawingml/2006/main">
               <a:ext uri="{FF2B5EF4-FFF2-40B4-BE49-F238E27FC236}">
-                <a16:creationId xmlns:a16="http://schemas.microsoft.com/office/drawing/2014/main" id="{8C8C679C-572B-410D-A004-D6F051C10CD5}"/>
+                <a16:creationId xmlns:a16="http://schemas.microsoft.com/office/drawing/2014/main" id="{99ACEAF6-9D47-48FB-A67A-B8BB67404EA1}"/>
               </a:ext>
             </a:extLst>
           </p:cNvPr>
@@ -2179,7 +2179,7 @@
           <p:cNvPr id="3" name="cover-title">
             <a:extLst xmlns:a="http://schemas.openxmlformats.org/drawingml/2006/main">
               <a:ext uri="{FF2B5EF4-FFF2-40B4-BE49-F238E27FC236}">
-                <a16:creationId xmlns:a16="http://schemas.microsoft.com/office/drawing/2014/main" id="{D5BC7BCA-4252-46E4-A6E7-57B1FF4B14C2}"/>
+                <a16:creationId xmlns:a16="http://schemas.microsoft.com/office/drawing/2014/main" id="{267DB346-4236-4E3C-BBE7-9E631D600C78}"/>
               </a:ext>
             </a:extLst>
           </p:cNvPr>
@@ -2237,7 +2237,7 @@
           <p:cNvPr id="4" name="cover-subtitle">
             <a:extLst xmlns:a="http://schemas.openxmlformats.org/drawingml/2006/main">
               <a:ext uri="{FF2B5EF4-FFF2-40B4-BE49-F238E27FC236}">
-                <a16:creationId xmlns:a16="http://schemas.microsoft.com/office/drawing/2014/main" id="{2E8C6D0D-F45F-46B8-ABF7-39432F8EFF51}"/>
+                <a16:creationId xmlns:a16="http://schemas.microsoft.com/office/drawing/2014/main" id="{C355593A-4B46-4F6B-BEBE-1C92A07F4F00}"/>
               </a:ext>
             </a:extLst>
           </p:cNvPr>
@@ -2295,7 +2295,7 @@
           <p:cNvPr id="5" name="cover-desc">
             <a:extLst xmlns:a="http://schemas.openxmlformats.org/drawingml/2006/main">
               <a:ext uri="{FF2B5EF4-FFF2-40B4-BE49-F238E27FC236}">
-                <a16:creationId xmlns:a16="http://schemas.microsoft.com/office/drawing/2014/main" id="{01124C07-D354-472D-94E9-9ED84BB3FA2E}"/>
+                <a16:creationId xmlns:a16="http://schemas.microsoft.com/office/drawing/2014/main" id="{355E1A6B-676C-41B4-BF83-0D4EBFBC07C1}"/>
               </a:ext>
             </a:extLst>
           </p:cNvPr>
@@ -2353,7 +2353,7 @@
           <p:cNvPr id="6" name="pill-7 个微服务">
             <a:extLst xmlns:a="http://schemas.openxmlformats.org/drawingml/2006/main">
               <a:ext uri="{FF2B5EF4-FFF2-40B4-BE49-F238E27FC236}">
-                <a16:creationId xmlns:a16="http://schemas.microsoft.com/office/drawing/2014/main" id="{3BCCA7A4-C9BA-4164-B674-2BB4D09101E6}"/>
+                <a16:creationId xmlns:a16="http://schemas.microsoft.com/office/drawing/2014/main" id="{1D9D363B-9E3F-4445-9997-FF4C3A406C61}"/>
               </a:ext>
             </a:extLst>
           </p:cNvPr>
@@ -2386,7 +2386,7 @@
           <p:cNvPr id="7" name="pill-text-7 个微服务">
             <a:extLst xmlns:a="http://schemas.openxmlformats.org/drawingml/2006/main">
               <a:ext uri="{FF2B5EF4-FFF2-40B4-BE49-F238E27FC236}">
-                <a16:creationId xmlns:a16="http://schemas.microsoft.com/office/drawing/2014/main" id="{073D04DA-23B5-4866-B504-815398FA7367}"/>
+                <a16:creationId xmlns:a16="http://schemas.microsoft.com/office/drawing/2014/main" id="{755A404F-2B54-4044-8938-1C602CD7A280}"/>
               </a:ext>
             </a:extLst>
           </p:cNvPr>
@@ -2444,7 +2444,7 @@
           <p:cNvPr id="8" name="pill-6 个业务模块">
             <a:extLst xmlns:a="http://schemas.openxmlformats.org/drawingml/2006/main">
               <a:ext uri="{FF2B5EF4-FFF2-40B4-BE49-F238E27FC236}">
-                <a16:creationId xmlns:a16="http://schemas.microsoft.com/office/drawing/2014/main" id="{84784AED-CB86-4B05-BB6F-B87E644BD4B5}"/>
+                <a16:creationId xmlns:a16="http://schemas.microsoft.com/office/drawing/2014/main" id="{7BB3EBC5-C199-45D3-A934-2D65B35EB48B}"/>
               </a:ext>
             </a:extLst>
           </p:cNvPr>
@@ -2477,7 +2477,7 @@
           <p:cNvPr id="9" name="pill-text-6 个业务模块">
             <a:extLst xmlns:a="http://schemas.openxmlformats.org/drawingml/2006/main">
               <a:ext uri="{FF2B5EF4-FFF2-40B4-BE49-F238E27FC236}">
-                <a16:creationId xmlns:a16="http://schemas.microsoft.com/office/drawing/2014/main" id="{DA8F26EC-6422-4CCD-BFA0-98B5FB34E011}"/>
+                <a16:creationId xmlns:a16="http://schemas.microsoft.com/office/drawing/2014/main" id="{5ACFD9AA-3A06-485E-90CF-5C6AD1E5179F}"/>
               </a:ext>
             </a:extLst>
           </p:cNvPr>
@@ -2535,7 +2535,7 @@
           <p:cNvPr id="10" name="pill-36 项自动化测试">
             <a:extLst xmlns:a="http://schemas.openxmlformats.org/drawingml/2006/main">
               <a:ext uri="{FF2B5EF4-FFF2-40B4-BE49-F238E27FC236}">
-                <a16:creationId xmlns:a16="http://schemas.microsoft.com/office/drawing/2014/main" id="{6823EF3C-62F7-4FFC-8BDA-406229CBDC87}"/>
+                <a16:creationId xmlns:a16="http://schemas.microsoft.com/office/drawing/2014/main" id="{0F7D14A7-FEE9-4394-B39F-D974D92B181C}"/>
               </a:ext>
             </a:extLst>
           </p:cNvPr>
@@ -2568,7 +2568,7 @@
           <p:cNvPr id="11" name="pill-text-36 项自动化测试">
             <a:extLst xmlns:a="http://schemas.openxmlformats.org/drawingml/2006/main">
               <a:ext uri="{FF2B5EF4-FFF2-40B4-BE49-F238E27FC236}">
-                <a16:creationId xmlns:a16="http://schemas.microsoft.com/office/drawing/2014/main" id="{D963D5B2-9C90-4DD3-B6AE-5B8CDD761298}"/>
+                <a16:creationId xmlns:a16="http://schemas.microsoft.com/office/drawing/2014/main" id="{D6A4D6DF-110E-4997-8625-452AA18D8D5F}"/>
               </a:ext>
             </a:extLst>
           </p:cNvPr>
@@ -2626,7 +2626,7 @@
           <p:cNvPr id="12" name="cover-team">
             <a:extLst xmlns:a="http://schemas.openxmlformats.org/drawingml/2006/main">
               <a:ext uri="{FF2B5EF4-FFF2-40B4-BE49-F238E27FC236}">
-                <a16:creationId xmlns:a16="http://schemas.microsoft.com/office/drawing/2014/main" id="{9763AF67-103E-4D2C-8C4E-8615125C4E77}"/>
+                <a16:creationId xmlns:a16="http://schemas.microsoft.com/office/drawing/2014/main" id="{283AFDEF-5FBB-4A21-872E-5CD916013F74}"/>
               </a:ext>
             </a:extLst>
           </p:cNvPr>
@@ -2682,7 +2682,7 @@
     </p:spTree>
     <p:extLst>
       <p:ext uri="{BB962C8B-B14F-4D97-AF65-F5344CB8AC3E}">
-        <p14:creationId xmlns:p14="http://schemas.microsoft.com/office/powerpoint/2010/main" val="1280858861"/>
+        <p14:creationId xmlns:p14="http://schemas.microsoft.com/office/powerpoint/2010/main" val="35242144"/>
       </p:ext>
     </p:extLst>
   </p:cSld>
@@ -2713,7 +2713,7 @@
           <p:cNvPr id="1" name="eyebrow-10">
             <a:extLst xmlns:a="http://schemas.openxmlformats.org/drawingml/2006/main">
               <a:ext uri="{FF2B5EF4-FFF2-40B4-BE49-F238E27FC236}">
-                <a16:creationId xmlns:a16="http://schemas.microsoft.com/office/drawing/2014/main" id="{1EA0AF30-4641-4FF5-899D-89B8F626E6F0}"/>
+                <a16:creationId xmlns:a16="http://schemas.microsoft.com/office/drawing/2014/main" id="{02607151-A753-4604-8A29-B70FA6CDDA4B}"/>
               </a:ext>
             </a:extLst>
           </p:cNvPr>
@@ -2771,7 +2771,7 @@
           <p:cNvPr id="2" name="slide-title-10">
             <a:extLst xmlns:a="http://schemas.openxmlformats.org/drawingml/2006/main">
               <a:ext uri="{FF2B5EF4-FFF2-40B4-BE49-F238E27FC236}">
-                <a16:creationId xmlns:a16="http://schemas.microsoft.com/office/drawing/2014/main" id="{1F75923B-9E26-4E2B-8464-D2041BEA22B8}"/>
+                <a16:creationId xmlns:a16="http://schemas.microsoft.com/office/drawing/2014/main" id="{8FA40704-90D6-4994-9F0E-5E4C0CA37224}"/>
               </a:ext>
             </a:extLst>
           </p:cNvPr>
@@ -2829,7 +2829,7 @@
           <p:cNvPr id="3" name="title-rule-10">
             <a:extLst xmlns:a="http://schemas.openxmlformats.org/drawingml/2006/main">
               <a:ext uri="{FF2B5EF4-FFF2-40B4-BE49-F238E27FC236}">
-                <a16:creationId xmlns:a16="http://schemas.microsoft.com/office/drawing/2014/main" id="{2C99AF98-4A02-43EC-B415-FEB3E87D4A15}"/>
+                <a16:creationId xmlns:a16="http://schemas.microsoft.com/office/drawing/2014/main" id="{B2895226-446A-40A1-85FE-7569D5130B3F}"/>
               </a:ext>
             </a:extLst>
           </p:cNvPr>
@@ -2860,7 +2860,7 @@
           <p:cNvPr id="4" name="page-number-10">
             <a:extLst xmlns:a="http://schemas.openxmlformats.org/drawingml/2006/main">
               <a:ext uri="{FF2B5EF4-FFF2-40B4-BE49-F238E27FC236}">
-                <a16:creationId xmlns:a16="http://schemas.microsoft.com/office/drawing/2014/main" id="{57B5FA28-11B7-451C-9DD9-8A5ADC10604B}"/>
+                <a16:creationId xmlns:a16="http://schemas.microsoft.com/office/drawing/2014/main" id="{D7D18EF7-ED3A-47CD-A12D-2A68981B656B}"/>
               </a:ext>
             </a:extLst>
           </p:cNvPr>
@@ -2918,7 +2918,7 @@
           <p:cNvPr id="5" name="eng-0">
             <a:extLst xmlns:a="http://schemas.openxmlformats.org/drawingml/2006/main">
               <a:ext uri="{FF2B5EF4-FFF2-40B4-BE49-F238E27FC236}">
-                <a16:creationId xmlns:a16="http://schemas.microsoft.com/office/drawing/2014/main" id="{8DB94F1D-8919-4E3F-B415-0BA4F9A857F4}"/>
+                <a16:creationId xmlns:a16="http://schemas.microsoft.com/office/drawing/2014/main" id="{91B9A7BF-0C10-4E5C-ACE2-57847BA20521}"/>
               </a:ext>
             </a:extLst>
           </p:cNvPr>
@@ -2953,7 +2953,7 @@
           <p:cNvPr id="6" name="text">
             <a:extLst xmlns:a="http://schemas.openxmlformats.org/drawingml/2006/main">
               <a:ext uri="{FF2B5EF4-FFF2-40B4-BE49-F238E27FC236}">
-                <a16:creationId xmlns:a16="http://schemas.microsoft.com/office/drawing/2014/main" id="{A7DC5025-B5E8-43AE-A89B-DA117C93F1D4}"/>
+                <a16:creationId xmlns:a16="http://schemas.microsoft.com/office/drawing/2014/main" id="{A349C722-B743-444E-853B-4CC5813FAB15}"/>
               </a:ext>
             </a:extLst>
           </p:cNvPr>
@@ -3011,7 +3011,7 @@
           <p:cNvPr id="7" name="text">
             <a:extLst xmlns:a="http://schemas.openxmlformats.org/drawingml/2006/main">
               <a:ext uri="{FF2B5EF4-FFF2-40B4-BE49-F238E27FC236}">
-                <a16:creationId xmlns:a16="http://schemas.microsoft.com/office/drawing/2014/main" id="{789BD073-DD6B-41CA-A6A8-513AA88461BC}"/>
+                <a16:creationId xmlns:a16="http://schemas.microsoft.com/office/drawing/2014/main" id="{3CD84B85-426E-44EB-A378-876E1CDD27FB}"/>
               </a:ext>
             </a:extLst>
           </p:cNvPr>
@@ -3069,7 +3069,7 @@
           <p:cNvPr id="8" name="text">
             <a:extLst xmlns:a="http://schemas.openxmlformats.org/drawingml/2006/main">
               <a:ext uri="{FF2B5EF4-FFF2-40B4-BE49-F238E27FC236}">
-                <a16:creationId xmlns:a16="http://schemas.microsoft.com/office/drawing/2014/main" id="{18B19560-4030-4700-996F-3D1F8BE9F61F}"/>
+                <a16:creationId xmlns:a16="http://schemas.microsoft.com/office/drawing/2014/main" id="{D3E9B5F1-15C5-46B8-892C-5118BCA38A3C}"/>
               </a:ext>
             </a:extLst>
           </p:cNvPr>
@@ -3127,7 +3127,7 @@
           <p:cNvPr id="9" name="eng-1">
             <a:extLst xmlns:a="http://schemas.openxmlformats.org/drawingml/2006/main">
               <a:ext uri="{FF2B5EF4-FFF2-40B4-BE49-F238E27FC236}">
-                <a16:creationId xmlns:a16="http://schemas.microsoft.com/office/drawing/2014/main" id="{CC03D92C-2E64-4CFF-915B-4160DA58FC8E}"/>
+                <a16:creationId xmlns:a16="http://schemas.microsoft.com/office/drawing/2014/main" id="{129A270A-F9D9-40B4-BA6B-800467B2D0E6}"/>
               </a:ext>
             </a:extLst>
           </p:cNvPr>
@@ -3162,7 +3162,7 @@
           <p:cNvPr id="10" name="text">
             <a:extLst xmlns:a="http://schemas.openxmlformats.org/drawingml/2006/main">
               <a:ext uri="{FF2B5EF4-FFF2-40B4-BE49-F238E27FC236}">
-                <a16:creationId xmlns:a16="http://schemas.microsoft.com/office/drawing/2014/main" id="{BDF830A9-E552-4E99-A83B-F7DF3DBCFA14}"/>
+                <a16:creationId xmlns:a16="http://schemas.microsoft.com/office/drawing/2014/main" id="{918DDEE5-80B6-4A2C-9407-1A27DF561159}"/>
               </a:ext>
             </a:extLst>
           </p:cNvPr>
@@ -3220,7 +3220,7 @@
           <p:cNvPr id="11" name="text">
             <a:extLst xmlns:a="http://schemas.openxmlformats.org/drawingml/2006/main">
               <a:ext uri="{FF2B5EF4-FFF2-40B4-BE49-F238E27FC236}">
-                <a16:creationId xmlns:a16="http://schemas.microsoft.com/office/drawing/2014/main" id="{0E5EE5FE-1B45-44DA-9388-A8B7349C5ECB}"/>
+                <a16:creationId xmlns:a16="http://schemas.microsoft.com/office/drawing/2014/main" id="{38A83979-FC38-4F48-8DAE-E9C828F7C92C}"/>
               </a:ext>
             </a:extLst>
           </p:cNvPr>
@@ -3278,7 +3278,7 @@
           <p:cNvPr id="12" name="text">
             <a:extLst xmlns:a="http://schemas.openxmlformats.org/drawingml/2006/main">
               <a:ext uri="{FF2B5EF4-FFF2-40B4-BE49-F238E27FC236}">
-                <a16:creationId xmlns:a16="http://schemas.microsoft.com/office/drawing/2014/main" id="{05A31B7D-1DFD-4C12-A575-72D7110D0FAC}"/>
+                <a16:creationId xmlns:a16="http://schemas.microsoft.com/office/drawing/2014/main" id="{64032703-AC6F-4343-8FC6-C989924B707A}"/>
               </a:ext>
             </a:extLst>
           </p:cNvPr>
@@ -3336,7 +3336,7 @@
           <p:cNvPr id="13" name="eng-2">
             <a:extLst xmlns:a="http://schemas.openxmlformats.org/drawingml/2006/main">
               <a:ext uri="{FF2B5EF4-FFF2-40B4-BE49-F238E27FC236}">
-                <a16:creationId xmlns:a16="http://schemas.microsoft.com/office/drawing/2014/main" id="{A75FD660-4A59-4646-A0C6-0BE798DDC3AE}"/>
+                <a16:creationId xmlns:a16="http://schemas.microsoft.com/office/drawing/2014/main" id="{190C03F3-8FC2-42ED-9D13-6446A7607F06}"/>
               </a:ext>
             </a:extLst>
           </p:cNvPr>
@@ -3371,7 +3371,7 @@
           <p:cNvPr id="14" name="text">
             <a:extLst xmlns:a="http://schemas.openxmlformats.org/drawingml/2006/main">
               <a:ext uri="{FF2B5EF4-FFF2-40B4-BE49-F238E27FC236}">
-                <a16:creationId xmlns:a16="http://schemas.microsoft.com/office/drawing/2014/main" id="{243E4651-B1BF-4504-94FC-E3AD493D77BB}"/>
+                <a16:creationId xmlns:a16="http://schemas.microsoft.com/office/drawing/2014/main" id="{89CB50B5-4AF5-4395-BA4D-6BD6C27F8B5B}"/>
               </a:ext>
             </a:extLst>
           </p:cNvPr>
@@ -3429,7 +3429,7 @@
           <p:cNvPr id="15" name="text">
             <a:extLst xmlns:a="http://schemas.openxmlformats.org/drawingml/2006/main">
               <a:ext uri="{FF2B5EF4-FFF2-40B4-BE49-F238E27FC236}">
-                <a16:creationId xmlns:a16="http://schemas.microsoft.com/office/drawing/2014/main" id="{A57936C6-5D42-42A0-9B78-2A51CD84BE99}"/>
+                <a16:creationId xmlns:a16="http://schemas.microsoft.com/office/drawing/2014/main" id="{CF765286-D33C-425C-A766-D55A851FBA10}"/>
               </a:ext>
             </a:extLst>
           </p:cNvPr>
@@ -3487,7 +3487,7 @@
           <p:cNvPr id="16" name="text">
             <a:extLst xmlns:a="http://schemas.openxmlformats.org/drawingml/2006/main">
               <a:ext uri="{FF2B5EF4-FFF2-40B4-BE49-F238E27FC236}">
-                <a16:creationId xmlns:a16="http://schemas.microsoft.com/office/drawing/2014/main" id="{AC0ED917-812C-4B4B-BF59-9C2D2589BBB6}"/>
+                <a16:creationId xmlns:a16="http://schemas.microsoft.com/office/drawing/2014/main" id="{2F965A47-1CAB-4177-88DF-B422830914CA}"/>
               </a:ext>
             </a:extLst>
           </p:cNvPr>
@@ -3545,7 +3545,7 @@
           <p:cNvPr id="17" name="eng-3">
             <a:extLst xmlns:a="http://schemas.openxmlformats.org/drawingml/2006/main">
               <a:ext uri="{FF2B5EF4-FFF2-40B4-BE49-F238E27FC236}">
-                <a16:creationId xmlns:a16="http://schemas.microsoft.com/office/drawing/2014/main" id="{A6AAA110-88AC-44D0-8042-59228F2046AD}"/>
+                <a16:creationId xmlns:a16="http://schemas.microsoft.com/office/drawing/2014/main" id="{67B68EEE-0AF6-4745-B9C1-0C91A87B3986}"/>
               </a:ext>
             </a:extLst>
           </p:cNvPr>
@@ -3580,7 +3580,7 @@
           <p:cNvPr id="18" name="text">
             <a:extLst xmlns:a="http://schemas.openxmlformats.org/drawingml/2006/main">
               <a:ext uri="{FF2B5EF4-FFF2-40B4-BE49-F238E27FC236}">
-                <a16:creationId xmlns:a16="http://schemas.microsoft.com/office/drawing/2014/main" id="{4006734F-C8C1-46CD-9065-A819FEF42D57}"/>
+                <a16:creationId xmlns:a16="http://schemas.microsoft.com/office/drawing/2014/main" id="{13087AF3-F06C-43C2-A5DE-FEFCF7581463}"/>
               </a:ext>
             </a:extLst>
           </p:cNvPr>
@@ -3638,7 +3638,7 @@
           <p:cNvPr id="19" name="text">
             <a:extLst xmlns:a="http://schemas.openxmlformats.org/drawingml/2006/main">
               <a:ext uri="{FF2B5EF4-FFF2-40B4-BE49-F238E27FC236}">
-                <a16:creationId xmlns:a16="http://schemas.microsoft.com/office/drawing/2014/main" id="{B9C0C5B3-7DAF-4C21-8DBC-7CD809B3F8C8}"/>
+                <a16:creationId xmlns:a16="http://schemas.microsoft.com/office/drawing/2014/main" id="{1852DBB8-AF9B-4EAF-8D6B-539004FE9C5B}"/>
               </a:ext>
             </a:extLst>
           </p:cNvPr>
@@ -3696,7 +3696,7 @@
           <p:cNvPr id="20" name="text">
             <a:extLst xmlns:a="http://schemas.openxmlformats.org/drawingml/2006/main">
               <a:ext uri="{FF2B5EF4-FFF2-40B4-BE49-F238E27FC236}">
-                <a16:creationId xmlns:a16="http://schemas.microsoft.com/office/drawing/2014/main" id="{D6DE865C-EF6D-4DFE-97B7-E34549392958}"/>
+                <a16:creationId xmlns:a16="http://schemas.microsoft.com/office/drawing/2014/main" id="{768B70CE-42D9-41F0-99F3-95537A7E58B0}"/>
               </a:ext>
             </a:extLst>
           </p:cNvPr>
@@ -3752,7 +3752,7 @@
     </p:spTree>
     <p:extLst>
       <p:ext uri="{BB962C8B-B14F-4D97-AF65-F5344CB8AC3E}">
-        <p14:creationId xmlns:p14="http://schemas.microsoft.com/office/powerpoint/2010/main" val="1941275611"/>
+        <p14:creationId xmlns:p14="http://schemas.microsoft.com/office/powerpoint/2010/main" val="1339436533"/>
       </p:ext>
     </p:extLst>
   </p:cSld>
@@ -3783,7 +3783,7 @@
           <p:cNvPr id="1" name="eyebrow-11">
             <a:extLst xmlns:a="http://schemas.openxmlformats.org/drawingml/2006/main">
               <a:ext uri="{FF2B5EF4-FFF2-40B4-BE49-F238E27FC236}">
-                <a16:creationId xmlns:a16="http://schemas.microsoft.com/office/drawing/2014/main" id="{2603D8DB-0F2A-4DFF-87D6-644E46584B90}"/>
+                <a16:creationId xmlns:a16="http://schemas.microsoft.com/office/drawing/2014/main" id="{34D93353-1AC5-4047-B6BF-FB6F4A73D2FF}"/>
               </a:ext>
             </a:extLst>
           </p:cNvPr>
@@ -3841,7 +3841,7 @@
           <p:cNvPr id="2" name="slide-title-11">
             <a:extLst xmlns:a="http://schemas.openxmlformats.org/drawingml/2006/main">
               <a:ext uri="{FF2B5EF4-FFF2-40B4-BE49-F238E27FC236}">
-                <a16:creationId xmlns:a16="http://schemas.microsoft.com/office/drawing/2014/main" id="{E2A23308-DB4E-4AF9-BD89-B62EDB32D594}"/>
+                <a16:creationId xmlns:a16="http://schemas.microsoft.com/office/drawing/2014/main" id="{52847A74-77D9-4EB9-B3BB-B5A47FFD71CE}"/>
               </a:ext>
             </a:extLst>
           </p:cNvPr>
@@ -3899,7 +3899,7 @@
           <p:cNvPr id="3" name="title-rule-11">
             <a:extLst xmlns:a="http://schemas.openxmlformats.org/drawingml/2006/main">
               <a:ext uri="{FF2B5EF4-FFF2-40B4-BE49-F238E27FC236}">
-                <a16:creationId xmlns:a16="http://schemas.microsoft.com/office/drawing/2014/main" id="{37017C70-81B8-49F8-8984-15CF665430BF}"/>
+                <a16:creationId xmlns:a16="http://schemas.microsoft.com/office/drawing/2014/main" id="{2E2E8241-6BC1-4452-BD22-3AE402147941}"/>
               </a:ext>
             </a:extLst>
           </p:cNvPr>
@@ -3930,7 +3930,7 @@
           <p:cNvPr id="4" name="page-number-11">
             <a:extLst xmlns:a="http://schemas.openxmlformats.org/drawingml/2006/main">
               <a:ext uri="{FF2B5EF4-FFF2-40B4-BE49-F238E27FC236}">
-                <a16:creationId xmlns:a16="http://schemas.microsoft.com/office/drawing/2014/main" id="{89A06761-6E4E-4BCF-AC81-7D26F36E8C6A}"/>
+                <a16:creationId xmlns:a16="http://schemas.microsoft.com/office/drawing/2014/main" id="{574C7F67-9AB2-412B-A4A9-D24FB5CC2CA9}"/>
               </a:ext>
             </a:extLst>
           </p:cNvPr>
@@ -3988,7 +3988,7 @@
           <p:cNvPr id="5" name="timeline-line">
             <a:extLst xmlns:a="http://schemas.openxmlformats.org/drawingml/2006/main">
               <a:ext uri="{FF2B5EF4-FFF2-40B4-BE49-F238E27FC236}">
-                <a16:creationId xmlns:a16="http://schemas.microsoft.com/office/drawing/2014/main" id="{8CCE2B63-1BFD-4AE2-86BD-915EBD39D7A4}"/>
+                <a16:creationId xmlns:a16="http://schemas.microsoft.com/office/drawing/2014/main" id="{0749A7F4-4727-4346-BD7B-E1174AF42988}"/>
               </a:ext>
             </a:extLst>
           </p:cNvPr>
@@ -4019,7 +4019,7 @@
           <p:cNvPr id="6" name="timeline-dot-0">
             <a:extLst xmlns:a="http://schemas.openxmlformats.org/drawingml/2006/main">
               <a:ext uri="{FF2B5EF4-FFF2-40B4-BE49-F238E27FC236}">
-                <a16:creationId xmlns:a16="http://schemas.microsoft.com/office/drawing/2014/main" id="{F1C1A22E-5717-4DF1-99E6-C7A189E4327D}"/>
+                <a16:creationId xmlns:a16="http://schemas.microsoft.com/office/drawing/2014/main" id="{327D8379-D181-40C4-81B2-4D968ED3CE64}"/>
               </a:ext>
             </a:extLst>
           </p:cNvPr>
@@ -4052,7 +4052,7 @@
           <p:cNvPr id="7" name="text">
             <a:extLst xmlns:a="http://schemas.openxmlformats.org/drawingml/2006/main">
               <a:ext uri="{FF2B5EF4-FFF2-40B4-BE49-F238E27FC236}">
-                <a16:creationId xmlns:a16="http://schemas.microsoft.com/office/drawing/2014/main" id="{B44CC638-6BF0-4758-9AC3-5444B71B5EF9}"/>
+                <a16:creationId xmlns:a16="http://schemas.microsoft.com/office/drawing/2014/main" id="{6EF037A5-3574-4AF1-96E4-AF9EEF74EFA3}"/>
               </a:ext>
             </a:extLst>
           </p:cNvPr>
@@ -4110,7 +4110,7 @@
           <p:cNvPr id="8" name="text">
             <a:extLst xmlns:a="http://schemas.openxmlformats.org/drawingml/2006/main">
               <a:ext uri="{FF2B5EF4-FFF2-40B4-BE49-F238E27FC236}">
-                <a16:creationId xmlns:a16="http://schemas.microsoft.com/office/drawing/2014/main" id="{EA106068-04E6-4CD7-9378-4624014F44C5}"/>
+                <a16:creationId xmlns:a16="http://schemas.microsoft.com/office/drawing/2014/main" id="{3983D3BF-79CB-4B96-A816-3B263BF8D43D}"/>
               </a:ext>
             </a:extLst>
           </p:cNvPr>
@@ -4168,7 +4168,7 @@
           <p:cNvPr id="9" name="text">
             <a:extLst xmlns:a="http://schemas.openxmlformats.org/drawingml/2006/main">
               <a:ext uri="{FF2B5EF4-FFF2-40B4-BE49-F238E27FC236}">
-                <a16:creationId xmlns:a16="http://schemas.microsoft.com/office/drawing/2014/main" id="{45ED9330-663A-4C41-91F6-6BC1A620457B}"/>
+                <a16:creationId xmlns:a16="http://schemas.microsoft.com/office/drawing/2014/main" id="{D934DFB6-99B5-456A-AE55-ED20A084032D}"/>
               </a:ext>
             </a:extLst>
           </p:cNvPr>
@@ -4226,7 +4226,7 @@
           <p:cNvPr id="10" name="text">
             <a:extLst xmlns:a="http://schemas.openxmlformats.org/drawingml/2006/main">
               <a:ext uri="{FF2B5EF4-FFF2-40B4-BE49-F238E27FC236}">
-                <a16:creationId xmlns:a16="http://schemas.microsoft.com/office/drawing/2014/main" id="{68C938C3-D4C7-4093-909C-11DE474497B1}"/>
+                <a16:creationId xmlns:a16="http://schemas.microsoft.com/office/drawing/2014/main" id="{C61AF556-4336-4571-AEF9-E5EA9D012419}"/>
               </a:ext>
             </a:extLst>
           </p:cNvPr>
@@ -4284,7 +4284,7 @@
           <p:cNvPr id="11" name="timeline-dot-1">
             <a:extLst xmlns:a="http://schemas.openxmlformats.org/drawingml/2006/main">
               <a:ext uri="{FF2B5EF4-FFF2-40B4-BE49-F238E27FC236}">
-                <a16:creationId xmlns:a16="http://schemas.microsoft.com/office/drawing/2014/main" id="{7056732D-1CFA-4965-9DF7-07B60E7ACB50}"/>
+                <a16:creationId xmlns:a16="http://schemas.microsoft.com/office/drawing/2014/main" id="{AF850392-12E5-4C7F-B7B2-595E04A6FEE5}"/>
               </a:ext>
             </a:extLst>
           </p:cNvPr>
@@ -4317,7 +4317,7 @@
           <p:cNvPr id="12" name="text">
             <a:extLst xmlns:a="http://schemas.openxmlformats.org/drawingml/2006/main">
               <a:ext uri="{FF2B5EF4-FFF2-40B4-BE49-F238E27FC236}">
-                <a16:creationId xmlns:a16="http://schemas.microsoft.com/office/drawing/2014/main" id="{53ECCD8D-A2C2-4D80-839A-D829CD5042AB}"/>
+                <a16:creationId xmlns:a16="http://schemas.microsoft.com/office/drawing/2014/main" id="{EEECF991-2AD8-4403-9EDF-C97CAC3D0A53}"/>
               </a:ext>
             </a:extLst>
           </p:cNvPr>
@@ -4375,7 +4375,7 @@
           <p:cNvPr id="13" name="text">
             <a:extLst xmlns:a="http://schemas.openxmlformats.org/drawingml/2006/main">
               <a:ext uri="{FF2B5EF4-FFF2-40B4-BE49-F238E27FC236}">
-                <a16:creationId xmlns:a16="http://schemas.microsoft.com/office/drawing/2014/main" id="{661D32A8-55D0-43CF-A001-B0870A31045D}"/>
+                <a16:creationId xmlns:a16="http://schemas.microsoft.com/office/drawing/2014/main" id="{6FF55457-FA79-4DEC-8212-FFA5AC58E7D2}"/>
               </a:ext>
             </a:extLst>
           </p:cNvPr>
@@ -4433,7 +4433,7 @@
           <p:cNvPr id="14" name="text">
             <a:extLst xmlns:a="http://schemas.openxmlformats.org/drawingml/2006/main">
               <a:ext uri="{FF2B5EF4-FFF2-40B4-BE49-F238E27FC236}">
-                <a16:creationId xmlns:a16="http://schemas.microsoft.com/office/drawing/2014/main" id="{7B4D2ECA-DC60-4326-85D7-4C004A545E3D}"/>
+                <a16:creationId xmlns:a16="http://schemas.microsoft.com/office/drawing/2014/main" id="{7DA8DA0D-4B01-4933-A196-59AE9421FA71}"/>
               </a:ext>
             </a:extLst>
           </p:cNvPr>
@@ -4491,7 +4491,7 @@
           <p:cNvPr id="15" name="text">
             <a:extLst xmlns:a="http://schemas.openxmlformats.org/drawingml/2006/main">
               <a:ext uri="{FF2B5EF4-FFF2-40B4-BE49-F238E27FC236}">
-                <a16:creationId xmlns:a16="http://schemas.microsoft.com/office/drawing/2014/main" id="{CEA590CC-3A9A-4334-B7EA-E616ECB99866}"/>
+                <a16:creationId xmlns:a16="http://schemas.microsoft.com/office/drawing/2014/main" id="{3C418680-4B2B-43D5-ACEC-13EBD6445B6D}"/>
               </a:ext>
             </a:extLst>
           </p:cNvPr>
@@ -4549,7 +4549,7 @@
           <p:cNvPr id="16" name="timeline-dot-2">
             <a:extLst xmlns:a="http://schemas.openxmlformats.org/drawingml/2006/main">
               <a:ext uri="{FF2B5EF4-FFF2-40B4-BE49-F238E27FC236}">
-                <a16:creationId xmlns:a16="http://schemas.microsoft.com/office/drawing/2014/main" id="{D4CE1ABE-4EA2-4764-83C2-73A6ED7492F8}"/>
+                <a16:creationId xmlns:a16="http://schemas.microsoft.com/office/drawing/2014/main" id="{2F0A3612-2E46-4D72-9962-4AF9EBE485DA}"/>
               </a:ext>
             </a:extLst>
           </p:cNvPr>
@@ -4582,7 +4582,7 @@
           <p:cNvPr id="17" name="text">
             <a:extLst xmlns:a="http://schemas.openxmlformats.org/drawingml/2006/main">
               <a:ext uri="{FF2B5EF4-FFF2-40B4-BE49-F238E27FC236}">
-                <a16:creationId xmlns:a16="http://schemas.microsoft.com/office/drawing/2014/main" id="{8A02C8AD-62FD-47AC-AB6C-694F07B2DCC0}"/>
+                <a16:creationId xmlns:a16="http://schemas.microsoft.com/office/drawing/2014/main" id="{4992C274-132F-4DBB-9606-F4BEAB16629B}"/>
               </a:ext>
             </a:extLst>
           </p:cNvPr>
@@ -4640,7 +4640,7 @@
           <p:cNvPr id="18" name="text">
             <a:extLst xmlns:a="http://schemas.openxmlformats.org/drawingml/2006/main">
               <a:ext uri="{FF2B5EF4-FFF2-40B4-BE49-F238E27FC236}">
-                <a16:creationId xmlns:a16="http://schemas.microsoft.com/office/drawing/2014/main" id="{F254A988-D16E-4EEF-98C9-D9382AAF9F32}"/>
+                <a16:creationId xmlns:a16="http://schemas.microsoft.com/office/drawing/2014/main" id="{A3128F6A-64DF-4DD2-B68E-35F0B19576E8}"/>
               </a:ext>
             </a:extLst>
           </p:cNvPr>
@@ -4698,7 +4698,7 @@
           <p:cNvPr id="19" name="text">
             <a:extLst xmlns:a="http://schemas.openxmlformats.org/drawingml/2006/main">
               <a:ext uri="{FF2B5EF4-FFF2-40B4-BE49-F238E27FC236}">
-                <a16:creationId xmlns:a16="http://schemas.microsoft.com/office/drawing/2014/main" id="{73A569DC-DBD2-49DD-B289-DDE446B0E841}"/>
+                <a16:creationId xmlns:a16="http://schemas.microsoft.com/office/drawing/2014/main" id="{1FBD7100-9BA1-4C0F-9267-0F879129F111}"/>
               </a:ext>
             </a:extLst>
           </p:cNvPr>
@@ -4756,7 +4756,7 @@
           <p:cNvPr id="20" name="text">
             <a:extLst xmlns:a="http://schemas.openxmlformats.org/drawingml/2006/main">
               <a:ext uri="{FF2B5EF4-FFF2-40B4-BE49-F238E27FC236}">
-                <a16:creationId xmlns:a16="http://schemas.microsoft.com/office/drawing/2014/main" id="{08AD313E-9F47-4521-9A5B-1C1419047408}"/>
+                <a16:creationId xmlns:a16="http://schemas.microsoft.com/office/drawing/2014/main" id="{8E4DA30F-5BA9-4D66-85B5-07DA122977F1}"/>
               </a:ext>
             </a:extLst>
           </p:cNvPr>
@@ -4814,7 +4814,7 @@
           <p:cNvPr id="21" name="timeline-dot-3">
             <a:extLst xmlns:a="http://schemas.openxmlformats.org/drawingml/2006/main">
               <a:ext uri="{FF2B5EF4-FFF2-40B4-BE49-F238E27FC236}">
-                <a16:creationId xmlns:a16="http://schemas.microsoft.com/office/drawing/2014/main" id="{8A2071F3-A3C8-4290-97B4-06C2F0024B7B}"/>
+                <a16:creationId xmlns:a16="http://schemas.microsoft.com/office/drawing/2014/main" id="{1D2279AA-B7D6-4150-9433-5E33B2A821C6}"/>
               </a:ext>
             </a:extLst>
           </p:cNvPr>
@@ -4847,7 +4847,7 @@
           <p:cNvPr id="22" name="text">
             <a:extLst xmlns:a="http://schemas.openxmlformats.org/drawingml/2006/main">
               <a:ext uri="{FF2B5EF4-FFF2-40B4-BE49-F238E27FC236}">
-                <a16:creationId xmlns:a16="http://schemas.microsoft.com/office/drawing/2014/main" id="{0796D874-8C46-44F6-A1B6-5A9D231BF641}"/>
+                <a16:creationId xmlns:a16="http://schemas.microsoft.com/office/drawing/2014/main" id="{80758210-767B-4510-8D3A-61D46C839936}"/>
               </a:ext>
             </a:extLst>
           </p:cNvPr>
@@ -4905,7 +4905,7 @@
           <p:cNvPr id="23" name="text">
             <a:extLst xmlns:a="http://schemas.openxmlformats.org/drawingml/2006/main">
               <a:ext uri="{FF2B5EF4-FFF2-40B4-BE49-F238E27FC236}">
-                <a16:creationId xmlns:a16="http://schemas.microsoft.com/office/drawing/2014/main" id="{CDE5158C-5150-4ECF-A5E1-8C5A8121B564}"/>
+                <a16:creationId xmlns:a16="http://schemas.microsoft.com/office/drawing/2014/main" id="{CC91B2E7-88DF-47B8-BCAA-D660CF9F32CD}"/>
               </a:ext>
             </a:extLst>
           </p:cNvPr>
@@ -4963,7 +4963,7 @@
           <p:cNvPr id="24" name="text">
             <a:extLst xmlns:a="http://schemas.openxmlformats.org/drawingml/2006/main">
               <a:ext uri="{FF2B5EF4-FFF2-40B4-BE49-F238E27FC236}">
-                <a16:creationId xmlns:a16="http://schemas.microsoft.com/office/drawing/2014/main" id="{10D65053-BDCF-47FF-8DDD-721F1396CF6E}"/>
+                <a16:creationId xmlns:a16="http://schemas.microsoft.com/office/drawing/2014/main" id="{7665163C-005D-4886-B4FA-D603A32114DE}"/>
               </a:ext>
             </a:extLst>
           </p:cNvPr>
@@ -5021,7 +5021,7 @@
           <p:cNvPr id="25" name="text">
             <a:extLst xmlns:a="http://schemas.openxmlformats.org/drawingml/2006/main">
               <a:ext uri="{FF2B5EF4-FFF2-40B4-BE49-F238E27FC236}">
-                <a16:creationId xmlns:a16="http://schemas.microsoft.com/office/drawing/2014/main" id="{4484FFC5-B950-4E17-9D10-563B888262DF}"/>
+                <a16:creationId xmlns:a16="http://schemas.microsoft.com/office/drawing/2014/main" id="{6A9BD779-060F-4314-B800-B0308A9D942A}"/>
               </a:ext>
             </a:extLst>
           </p:cNvPr>
@@ -5079,7 +5079,7 @@
           <p:cNvPr id="26" name="timeline-dot-4">
             <a:extLst xmlns:a="http://schemas.openxmlformats.org/drawingml/2006/main">
               <a:ext uri="{FF2B5EF4-FFF2-40B4-BE49-F238E27FC236}">
-                <a16:creationId xmlns:a16="http://schemas.microsoft.com/office/drawing/2014/main" id="{F5B0EDCB-E369-416A-BED7-104EF09284DC}"/>
+                <a16:creationId xmlns:a16="http://schemas.microsoft.com/office/drawing/2014/main" id="{7B1D70D8-7161-4D7D-B47F-0E20F5A3B8B1}"/>
               </a:ext>
             </a:extLst>
           </p:cNvPr>
@@ -5112,7 +5112,7 @@
           <p:cNvPr id="27" name="text">
             <a:extLst xmlns:a="http://schemas.openxmlformats.org/drawingml/2006/main">
               <a:ext uri="{FF2B5EF4-FFF2-40B4-BE49-F238E27FC236}">
-                <a16:creationId xmlns:a16="http://schemas.microsoft.com/office/drawing/2014/main" id="{4448A247-9FFD-400E-8181-BEB41970D0FB}"/>
+                <a16:creationId xmlns:a16="http://schemas.microsoft.com/office/drawing/2014/main" id="{1AF6E6D0-AE06-4079-87A3-01D31504C2E0}"/>
               </a:ext>
             </a:extLst>
           </p:cNvPr>
@@ -5170,7 +5170,7 @@
           <p:cNvPr id="28" name="text">
             <a:extLst xmlns:a="http://schemas.openxmlformats.org/drawingml/2006/main">
               <a:ext uri="{FF2B5EF4-FFF2-40B4-BE49-F238E27FC236}">
-                <a16:creationId xmlns:a16="http://schemas.microsoft.com/office/drawing/2014/main" id="{C0FA514E-1E45-4992-BD1E-ABBC97F10B13}"/>
+                <a16:creationId xmlns:a16="http://schemas.microsoft.com/office/drawing/2014/main" id="{B0CB3B88-26B9-493D-B212-58E02C7795B4}"/>
               </a:ext>
             </a:extLst>
           </p:cNvPr>
@@ -5228,7 +5228,7 @@
           <p:cNvPr id="29" name="text">
             <a:extLst xmlns:a="http://schemas.openxmlformats.org/drawingml/2006/main">
               <a:ext uri="{FF2B5EF4-FFF2-40B4-BE49-F238E27FC236}">
-                <a16:creationId xmlns:a16="http://schemas.microsoft.com/office/drawing/2014/main" id="{84A77C3C-3AEC-4239-8EC6-F60E53C8743A}"/>
+                <a16:creationId xmlns:a16="http://schemas.microsoft.com/office/drawing/2014/main" id="{02F1F6CF-5EE8-4E44-9AAD-41DE76A98E34}"/>
               </a:ext>
             </a:extLst>
           </p:cNvPr>
@@ -5286,7 +5286,7 @@
           <p:cNvPr id="30" name="text">
             <a:extLst xmlns:a="http://schemas.openxmlformats.org/drawingml/2006/main">
               <a:ext uri="{FF2B5EF4-FFF2-40B4-BE49-F238E27FC236}">
-                <a16:creationId xmlns:a16="http://schemas.microsoft.com/office/drawing/2014/main" id="{AABF744F-1780-424A-8509-391F30DC3530}"/>
+                <a16:creationId xmlns:a16="http://schemas.microsoft.com/office/drawing/2014/main" id="{369D977A-66E3-4325-90EE-09F5091AC009}"/>
               </a:ext>
             </a:extLst>
           </p:cNvPr>
@@ -5344,7 +5344,7 @@
           <p:cNvPr id="31" name="timeline-dot-5">
             <a:extLst xmlns:a="http://schemas.openxmlformats.org/drawingml/2006/main">
               <a:ext uri="{FF2B5EF4-FFF2-40B4-BE49-F238E27FC236}">
-                <a16:creationId xmlns:a16="http://schemas.microsoft.com/office/drawing/2014/main" id="{8FD09794-7FE7-4687-8B9F-2E10E231A27A}"/>
+                <a16:creationId xmlns:a16="http://schemas.microsoft.com/office/drawing/2014/main" id="{58741568-E0B9-4000-8649-9F3AF7E6B1CD}"/>
               </a:ext>
             </a:extLst>
           </p:cNvPr>
@@ -5377,7 +5377,7 @@
           <p:cNvPr id="32" name="text">
             <a:extLst xmlns:a="http://schemas.openxmlformats.org/drawingml/2006/main">
               <a:ext uri="{FF2B5EF4-FFF2-40B4-BE49-F238E27FC236}">
-                <a16:creationId xmlns:a16="http://schemas.microsoft.com/office/drawing/2014/main" id="{221E3298-4A0E-42C5-A0A1-678B4C4487BC}"/>
+                <a16:creationId xmlns:a16="http://schemas.microsoft.com/office/drawing/2014/main" id="{4E6E042B-F3AE-4125-AA4B-1CF7C33D2746}"/>
               </a:ext>
             </a:extLst>
           </p:cNvPr>
@@ -5435,7 +5435,7 @@
           <p:cNvPr id="33" name="text">
             <a:extLst xmlns:a="http://schemas.openxmlformats.org/drawingml/2006/main">
               <a:ext uri="{FF2B5EF4-FFF2-40B4-BE49-F238E27FC236}">
-                <a16:creationId xmlns:a16="http://schemas.microsoft.com/office/drawing/2014/main" id="{A99DDFF2-8F41-4846-AB9B-2266621BCB35}"/>
+                <a16:creationId xmlns:a16="http://schemas.microsoft.com/office/drawing/2014/main" id="{BC1F91C1-F024-48D5-87A9-70FFFDC67B1F}"/>
               </a:ext>
             </a:extLst>
           </p:cNvPr>
@@ -5493,7 +5493,7 @@
           <p:cNvPr id="34" name="text">
             <a:extLst xmlns:a="http://schemas.openxmlformats.org/drawingml/2006/main">
               <a:ext uri="{FF2B5EF4-FFF2-40B4-BE49-F238E27FC236}">
-                <a16:creationId xmlns:a16="http://schemas.microsoft.com/office/drawing/2014/main" id="{506F0E6B-72A0-41FE-9EAA-EC4884415AE0}"/>
+                <a16:creationId xmlns:a16="http://schemas.microsoft.com/office/drawing/2014/main" id="{93A8E779-8A20-419A-B993-05E46AEF60F3}"/>
               </a:ext>
             </a:extLst>
           </p:cNvPr>
@@ -5551,7 +5551,7 @@
           <p:cNvPr id="35" name="text">
             <a:extLst xmlns:a="http://schemas.openxmlformats.org/drawingml/2006/main">
               <a:ext uri="{FF2B5EF4-FFF2-40B4-BE49-F238E27FC236}">
-                <a16:creationId xmlns:a16="http://schemas.microsoft.com/office/drawing/2014/main" id="{3E584E8B-C2CC-49B9-AA56-B3D3EEBE3AAD}"/>
+                <a16:creationId xmlns:a16="http://schemas.microsoft.com/office/drawing/2014/main" id="{2032C5A2-BEC5-4440-A376-A6265CD352BC}"/>
               </a:ext>
             </a:extLst>
           </p:cNvPr>
@@ -5607,7 +5607,7 @@
     </p:spTree>
     <p:extLst>
       <p:ext uri="{BB962C8B-B14F-4D97-AF65-F5344CB8AC3E}">
-        <p14:creationId xmlns:p14="http://schemas.microsoft.com/office/powerpoint/2010/main" val="621770446"/>
+        <p14:creationId xmlns:p14="http://schemas.microsoft.com/office/powerpoint/2010/main" val="130180256"/>
       </p:ext>
     </p:extLst>
   </p:cSld>
@@ -5638,7 +5638,7 @@
           <p:cNvPr id="1" name="eyebrow-12">
             <a:extLst xmlns:a="http://schemas.openxmlformats.org/drawingml/2006/main">
               <a:ext uri="{FF2B5EF4-FFF2-40B4-BE49-F238E27FC236}">
-                <a16:creationId xmlns:a16="http://schemas.microsoft.com/office/drawing/2014/main" id="{1A03F1BC-7AF2-4391-BE78-DC702B6FE996}"/>
+                <a16:creationId xmlns:a16="http://schemas.microsoft.com/office/drawing/2014/main" id="{BF7C95B0-FAB8-4609-A55F-4CB8B5708F6E}"/>
               </a:ext>
             </a:extLst>
           </p:cNvPr>
@@ -5696,7 +5696,7 @@
           <p:cNvPr id="2" name="slide-title-12">
             <a:extLst xmlns:a="http://schemas.openxmlformats.org/drawingml/2006/main">
               <a:ext uri="{FF2B5EF4-FFF2-40B4-BE49-F238E27FC236}">
-                <a16:creationId xmlns:a16="http://schemas.microsoft.com/office/drawing/2014/main" id="{93C96CE5-6793-44D9-B820-2C88F32FE663}"/>
+                <a16:creationId xmlns:a16="http://schemas.microsoft.com/office/drawing/2014/main" id="{146B1581-7A7B-46D1-86EC-1A5C99533A0E}"/>
               </a:ext>
             </a:extLst>
           </p:cNvPr>
@@ -5754,7 +5754,7 @@
           <p:cNvPr id="3" name="title-rule-12">
             <a:extLst xmlns:a="http://schemas.openxmlformats.org/drawingml/2006/main">
               <a:ext uri="{FF2B5EF4-FFF2-40B4-BE49-F238E27FC236}">
-                <a16:creationId xmlns:a16="http://schemas.microsoft.com/office/drawing/2014/main" id="{0F848325-CBE6-4FD1-A41E-3FFF5B4E3C67}"/>
+                <a16:creationId xmlns:a16="http://schemas.microsoft.com/office/drawing/2014/main" id="{2C8369C1-AB84-4A22-8061-CCB356BA0A7A}"/>
               </a:ext>
             </a:extLst>
           </p:cNvPr>
@@ -5785,7 +5785,7 @@
           <p:cNvPr id="4" name="page-number-12">
             <a:extLst xmlns:a="http://schemas.openxmlformats.org/drawingml/2006/main">
               <a:ext uri="{FF2B5EF4-FFF2-40B4-BE49-F238E27FC236}">
-                <a16:creationId xmlns:a16="http://schemas.microsoft.com/office/drawing/2014/main" id="{A26A61A4-D3B6-4E20-ABB7-7BB8D8CFB7A9}"/>
+                <a16:creationId xmlns:a16="http://schemas.microsoft.com/office/drawing/2014/main" id="{5628742E-F6CF-42C5-8EC7-00D577F4FE71}"/>
               </a:ext>
             </a:extLst>
           </p:cNvPr>
@@ -5843,7 +5843,7 @@
           <p:cNvPr id="5" name="stat-后端测试 · 0 失败">
             <a:extLst xmlns:a="http://schemas.openxmlformats.org/drawingml/2006/main">
               <a:ext uri="{FF2B5EF4-FFF2-40B4-BE49-F238E27FC236}">
-                <a16:creationId xmlns:a16="http://schemas.microsoft.com/office/drawing/2014/main" id="{7C3BD02C-8E64-4F3A-BA93-404C35C696E8}"/>
+                <a16:creationId xmlns:a16="http://schemas.microsoft.com/office/drawing/2014/main" id="{8A856683-F997-4888-B9D1-DB8FF6648721}"/>
               </a:ext>
             </a:extLst>
           </p:cNvPr>
@@ -5878,7 +5878,7 @@
           <p:cNvPr id="6" name="stat-accent-后端测试 · 0 失败">
             <a:extLst xmlns:a="http://schemas.openxmlformats.org/drawingml/2006/main">
               <a:ext uri="{FF2B5EF4-FFF2-40B4-BE49-F238E27FC236}">
-                <a16:creationId xmlns:a16="http://schemas.microsoft.com/office/drawing/2014/main" id="{0024EC7E-FAAB-48F5-B604-F10D2E3E3102}"/>
+                <a16:creationId xmlns:a16="http://schemas.microsoft.com/office/drawing/2014/main" id="{96C5F1B6-2124-424C-8C11-441E8DC712AA}"/>
               </a:ext>
             </a:extLst>
           </p:cNvPr>
@@ -5909,7 +5909,7 @@
           <p:cNvPr id="7" name="stat-value-后端测试 · 0 失败">
             <a:extLst xmlns:a="http://schemas.openxmlformats.org/drawingml/2006/main">
               <a:ext uri="{FF2B5EF4-FFF2-40B4-BE49-F238E27FC236}">
-                <a16:creationId xmlns:a16="http://schemas.microsoft.com/office/drawing/2014/main" id="{F03EC1FF-BB2F-47EF-B9B7-8BF73D88864D}"/>
+                <a16:creationId xmlns:a16="http://schemas.microsoft.com/office/drawing/2014/main" id="{342225CF-4245-4D00-9684-8851EED1C3CF}"/>
               </a:ext>
             </a:extLst>
           </p:cNvPr>
@@ -5967,7 +5967,7 @@
           <p:cNvPr id="8" name="stat-label-后端测试 · 0 失败">
             <a:extLst xmlns:a="http://schemas.openxmlformats.org/drawingml/2006/main">
               <a:ext uri="{FF2B5EF4-FFF2-40B4-BE49-F238E27FC236}">
-                <a16:creationId xmlns:a16="http://schemas.microsoft.com/office/drawing/2014/main" id="{E3472D12-E2B8-4F1A-A3AD-5A57C1D9BD04}"/>
+                <a16:creationId xmlns:a16="http://schemas.microsoft.com/office/drawing/2014/main" id="{55906881-9A2F-4CAD-8DA7-7A7233A66270}"/>
               </a:ext>
             </a:extLst>
           </p:cNvPr>
@@ -6025,7 +6025,7 @@
           <p:cNvPr id="9" name="stat-前端测试 · 0 失败">
             <a:extLst xmlns:a="http://schemas.openxmlformats.org/drawingml/2006/main">
               <a:ext uri="{FF2B5EF4-FFF2-40B4-BE49-F238E27FC236}">
-                <a16:creationId xmlns:a16="http://schemas.microsoft.com/office/drawing/2014/main" id="{519599E9-84B0-46DE-846F-BB85ACCE446E}"/>
+                <a16:creationId xmlns:a16="http://schemas.microsoft.com/office/drawing/2014/main" id="{094B4CAA-346B-4E33-B4A6-FB6D280646CB}"/>
               </a:ext>
             </a:extLst>
           </p:cNvPr>
@@ -6060,7 +6060,7 @@
           <p:cNvPr id="10" name="stat-accent-前端测试 · 0 失败">
             <a:extLst xmlns:a="http://schemas.openxmlformats.org/drawingml/2006/main">
               <a:ext uri="{FF2B5EF4-FFF2-40B4-BE49-F238E27FC236}">
-                <a16:creationId xmlns:a16="http://schemas.microsoft.com/office/drawing/2014/main" id="{A2135EA5-47D5-471D-A5E1-D517A6F9BBAC}"/>
+                <a16:creationId xmlns:a16="http://schemas.microsoft.com/office/drawing/2014/main" id="{FB017D6F-F73D-43F0-BA1F-A2B2CE25CD16}"/>
               </a:ext>
             </a:extLst>
           </p:cNvPr>
@@ -6091,7 +6091,7 @@
           <p:cNvPr id="11" name="stat-value-前端测试 · 0 失败">
             <a:extLst xmlns:a="http://schemas.openxmlformats.org/drawingml/2006/main">
               <a:ext uri="{FF2B5EF4-FFF2-40B4-BE49-F238E27FC236}">
-                <a16:creationId xmlns:a16="http://schemas.microsoft.com/office/drawing/2014/main" id="{7B17ECB5-F3C0-4BAB-80DD-1756AF037BCD}"/>
+                <a16:creationId xmlns:a16="http://schemas.microsoft.com/office/drawing/2014/main" id="{20B04A6C-4F8B-49A5-B220-79CD41645F8A}"/>
               </a:ext>
             </a:extLst>
           </p:cNvPr>
@@ -6149,7 +6149,7 @@
           <p:cNvPr id="12" name="stat-label-前端测试 · 0 失败">
             <a:extLst xmlns:a="http://schemas.openxmlformats.org/drawingml/2006/main">
               <a:ext uri="{FF2B5EF4-FFF2-40B4-BE49-F238E27FC236}">
-                <a16:creationId xmlns:a16="http://schemas.microsoft.com/office/drawing/2014/main" id="{39BB121F-E1B5-4782-BD48-2F8B7F9483B0}"/>
+                <a16:creationId xmlns:a16="http://schemas.microsoft.com/office/drawing/2014/main" id="{EE2449F9-B5A1-42D8-B037-8800125F2DBC}"/>
               </a:ext>
             </a:extLst>
           </p:cNvPr>
@@ -6207,7 +6207,7 @@
           <p:cNvPr id="13" name="stat-后端服务端口 9000–9006">
             <a:extLst xmlns:a="http://schemas.openxmlformats.org/drawingml/2006/main">
               <a:ext uri="{FF2B5EF4-FFF2-40B4-BE49-F238E27FC236}">
-                <a16:creationId xmlns:a16="http://schemas.microsoft.com/office/drawing/2014/main" id="{67E10F39-8242-4782-AF51-0A6011B4222F}"/>
+                <a16:creationId xmlns:a16="http://schemas.microsoft.com/office/drawing/2014/main" id="{148F675E-6DAB-4354-9F54-67FC4B694CC9}"/>
               </a:ext>
             </a:extLst>
           </p:cNvPr>
@@ -6242,7 +6242,7 @@
           <p:cNvPr id="14" name="stat-accent-后端服务端口 9000–9006">
             <a:extLst xmlns:a="http://schemas.openxmlformats.org/drawingml/2006/main">
               <a:ext uri="{FF2B5EF4-FFF2-40B4-BE49-F238E27FC236}">
-                <a16:creationId xmlns:a16="http://schemas.microsoft.com/office/drawing/2014/main" id="{E421A8B9-C53A-4CE1-A8F3-B1360DCE360E}"/>
+                <a16:creationId xmlns:a16="http://schemas.microsoft.com/office/drawing/2014/main" id="{A654FCA4-0411-4A20-BE6A-FB5198852F42}"/>
               </a:ext>
             </a:extLst>
           </p:cNvPr>
@@ -6273,7 +6273,7 @@
           <p:cNvPr id="15" name="stat-value-后端服务端口 9000–9006">
             <a:extLst xmlns:a="http://schemas.openxmlformats.org/drawingml/2006/main">
               <a:ext uri="{FF2B5EF4-FFF2-40B4-BE49-F238E27FC236}">
-                <a16:creationId xmlns:a16="http://schemas.microsoft.com/office/drawing/2014/main" id="{9564DB4E-AD3B-4E6B-88ED-673EE628E6B7}"/>
+                <a16:creationId xmlns:a16="http://schemas.microsoft.com/office/drawing/2014/main" id="{FE58D1E7-AA41-4994-B001-6EBC538F666A}"/>
               </a:ext>
             </a:extLst>
           </p:cNvPr>
@@ -6331,7 +6331,7 @@
           <p:cNvPr id="16" name="stat-label-后端服务端口 9000–9006">
             <a:extLst xmlns:a="http://schemas.openxmlformats.org/drawingml/2006/main">
               <a:ext uri="{FF2B5EF4-FFF2-40B4-BE49-F238E27FC236}">
-                <a16:creationId xmlns:a16="http://schemas.microsoft.com/office/drawing/2014/main" id="{EAA70D29-8B6F-4943-93AE-FE4EA10DDDCF}"/>
+                <a16:creationId xmlns:a16="http://schemas.microsoft.com/office/drawing/2014/main" id="{DC0D646B-0D4C-4E51-9190-5463B18421B1}"/>
               </a:ext>
             </a:extLst>
           </p:cNvPr>
@@ -6389,7 +6389,7 @@
           <p:cNvPr id="17" name="stat-演示职位数据">
             <a:extLst xmlns:a="http://schemas.openxmlformats.org/drawingml/2006/main">
               <a:ext uri="{FF2B5EF4-FFF2-40B4-BE49-F238E27FC236}">
-                <a16:creationId xmlns:a16="http://schemas.microsoft.com/office/drawing/2014/main" id="{6E3D0873-9439-46E2-8A51-EA614ADFAF80}"/>
+                <a16:creationId xmlns:a16="http://schemas.microsoft.com/office/drawing/2014/main" id="{3C1A49C7-05FF-4906-9126-09CE1503E927}"/>
               </a:ext>
             </a:extLst>
           </p:cNvPr>
@@ -6424,7 +6424,7 @@
           <p:cNvPr id="18" name="stat-accent-演示职位数据">
             <a:extLst xmlns:a="http://schemas.openxmlformats.org/drawingml/2006/main">
               <a:ext uri="{FF2B5EF4-FFF2-40B4-BE49-F238E27FC236}">
-                <a16:creationId xmlns:a16="http://schemas.microsoft.com/office/drawing/2014/main" id="{C49EAD89-89A8-4332-A7B1-4F3313E2E523}"/>
+                <a16:creationId xmlns:a16="http://schemas.microsoft.com/office/drawing/2014/main" id="{984294FC-C19C-4165-A3EC-5285212173D1}"/>
               </a:ext>
             </a:extLst>
           </p:cNvPr>
@@ -6455,7 +6455,7 @@
           <p:cNvPr id="19" name="stat-value-演示职位数据">
             <a:extLst xmlns:a="http://schemas.openxmlformats.org/drawingml/2006/main">
               <a:ext uri="{FF2B5EF4-FFF2-40B4-BE49-F238E27FC236}">
-                <a16:creationId xmlns:a16="http://schemas.microsoft.com/office/drawing/2014/main" id="{836943CE-7560-443D-9A90-52B30EB64A40}"/>
+                <a16:creationId xmlns:a16="http://schemas.microsoft.com/office/drawing/2014/main" id="{56AC708F-945E-4031-AF14-F413FF5C4C4D}"/>
               </a:ext>
             </a:extLst>
           </p:cNvPr>
@@ -6513,7 +6513,7 @@
           <p:cNvPr id="20" name="stat-label-演示职位数据">
             <a:extLst xmlns:a="http://schemas.openxmlformats.org/drawingml/2006/main">
               <a:ext uri="{FF2B5EF4-FFF2-40B4-BE49-F238E27FC236}">
-                <a16:creationId xmlns:a16="http://schemas.microsoft.com/office/drawing/2014/main" id="{0B680E42-8189-4405-B7E1-B5788CDED548}"/>
+                <a16:creationId xmlns:a16="http://schemas.microsoft.com/office/drawing/2014/main" id="{096D01C3-0EB3-43CA-AC3C-407C2C6C0514}"/>
               </a:ext>
             </a:extLst>
           </p:cNvPr>
@@ -6571,7 +6571,7 @@
           <p:cNvPr id="21" name="text">
             <a:extLst xmlns:a="http://schemas.openxmlformats.org/drawingml/2006/main">
               <a:ext uri="{FF2B5EF4-FFF2-40B4-BE49-F238E27FC236}">
-                <a16:creationId xmlns:a16="http://schemas.microsoft.com/office/drawing/2014/main" id="{C3ECC6B4-84C5-4384-819C-ED85C0D07368}"/>
+                <a16:creationId xmlns:a16="http://schemas.microsoft.com/office/drawing/2014/main" id="{1CD3EEA6-0632-4A39-A0D8-0F0B4F83A67D}"/>
               </a:ext>
             </a:extLst>
           </p:cNvPr>
@@ -6629,7 +6629,7 @@
           <p:cNvPr id="22" name="dep-0">
             <a:extLst xmlns:a="http://schemas.openxmlformats.org/drawingml/2006/main">
               <a:ext uri="{FF2B5EF4-FFF2-40B4-BE49-F238E27FC236}">
-                <a16:creationId xmlns:a16="http://schemas.microsoft.com/office/drawing/2014/main" id="{D5622D47-5350-41B1-860E-0D94CF5F2DC0}"/>
+                <a16:creationId xmlns:a16="http://schemas.microsoft.com/office/drawing/2014/main" id="{AC313300-9758-42DA-869D-2CACEA58969C}"/>
               </a:ext>
             </a:extLst>
           </p:cNvPr>
@@ -6664,7 +6664,7 @@
           <p:cNvPr id="23" name="text">
             <a:extLst xmlns:a="http://schemas.openxmlformats.org/drawingml/2006/main">
               <a:ext uri="{FF2B5EF4-FFF2-40B4-BE49-F238E27FC236}">
-                <a16:creationId xmlns:a16="http://schemas.microsoft.com/office/drawing/2014/main" id="{0DB1253F-3E57-44D6-8AFF-AAD223745577}"/>
+                <a16:creationId xmlns:a16="http://schemas.microsoft.com/office/drawing/2014/main" id="{3A3E4BC3-3402-4E5F-812E-7F565085E96B}"/>
               </a:ext>
             </a:extLst>
           </p:cNvPr>
@@ -6722,7 +6722,7 @@
           <p:cNvPr id="24" name="text">
             <a:extLst xmlns:a="http://schemas.openxmlformats.org/drawingml/2006/main">
               <a:ext uri="{FF2B5EF4-FFF2-40B4-BE49-F238E27FC236}">
-                <a16:creationId xmlns:a16="http://schemas.microsoft.com/office/drawing/2014/main" id="{91EB21D6-C19B-466E-A40B-50486EC9394A}"/>
+                <a16:creationId xmlns:a16="http://schemas.microsoft.com/office/drawing/2014/main" id="{F761A297-0B6C-4D54-85F6-1AD88E355AEF}"/>
               </a:ext>
             </a:extLst>
           </p:cNvPr>
@@ -6780,7 +6780,7 @@
           <p:cNvPr id="25" name="dep-1">
             <a:extLst xmlns:a="http://schemas.openxmlformats.org/drawingml/2006/main">
               <a:ext uri="{FF2B5EF4-FFF2-40B4-BE49-F238E27FC236}">
-                <a16:creationId xmlns:a16="http://schemas.microsoft.com/office/drawing/2014/main" id="{B31B0D89-92E8-45CA-81F9-42DFB07505FC}"/>
+                <a16:creationId xmlns:a16="http://schemas.microsoft.com/office/drawing/2014/main" id="{13D07CB6-30F0-4501-8FBE-6E262B37D293}"/>
               </a:ext>
             </a:extLst>
           </p:cNvPr>
@@ -6815,7 +6815,7 @@
           <p:cNvPr id="26" name="text">
             <a:extLst xmlns:a="http://schemas.openxmlformats.org/drawingml/2006/main">
               <a:ext uri="{FF2B5EF4-FFF2-40B4-BE49-F238E27FC236}">
-                <a16:creationId xmlns:a16="http://schemas.microsoft.com/office/drawing/2014/main" id="{97535065-F066-4147-945B-964C677FAD4D}"/>
+                <a16:creationId xmlns:a16="http://schemas.microsoft.com/office/drawing/2014/main" id="{68BAE013-BFC0-4E8E-A56A-4B62CD91B678}"/>
               </a:ext>
             </a:extLst>
           </p:cNvPr>
@@ -6873,7 +6873,7 @@
           <p:cNvPr id="27" name="text">
             <a:extLst xmlns:a="http://schemas.openxmlformats.org/drawingml/2006/main">
               <a:ext uri="{FF2B5EF4-FFF2-40B4-BE49-F238E27FC236}">
-                <a16:creationId xmlns:a16="http://schemas.microsoft.com/office/drawing/2014/main" id="{10892E27-08A1-4602-8C19-9FA897DDFF87}"/>
+                <a16:creationId xmlns:a16="http://schemas.microsoft.com/office/drawing/2014/main" id="{08D133BF-A085-453A-A70D-B9BB67BCB38B}"/>
               </a:ext>
             </a:extLst>
           </p:cNvPr>
@@ -6931,7 +6931,7 @@
           <p:cNvPr id="28" name="dep-2">
             <a:extLst xmlns:a="http://schemas.openxmlformats.org/drawingml/2006/main">
               <a:ext uri="{FF2B5EF4-FFF2-40B4-BE49-F238E27FC236}">
-                <a16:creationId xmlns:a16="http://schemas.microsoft.com/office/drawing/2014/main" id="{0F52B5C1-4BAC-4721-A28F-942916FC483D}"/>
+                <a16:creationId xmlns:a16="http://schemas.microsoft.com/office/drawing/2014/main" id="{3CFDC510-EEFF-4A61-B3E4-B83C48BBD6F3}"/>
               </a:ext>
             </a:extLst>
           </p:cNvPr>
@@ -6966,7 +6966,7 @@
           <p:cNvPr id="29" name="text">
             <a:extLst xmlns:a="http://schemas.openxmlformats.org/drawingml/2006/main">
               <a:ext uri="{FF2B5EF4-FFF2-40B4-BE49-F238E27FC236}">
-                <a16:creationId xmlns:a16="http://schemas.microsoft.com/office/drawing/2014/main" id="{A4AB4E44-CC19-4FB5-910F-F7A806CCC73B}"/>
+                <a16:creationId xmlns:a16="http://schemas.microsoft.com/office/drawing/2014/main" id="{4BB5149B-0364-4322-B33A-BF507D016A51}"/>
               </a:ext>
             </a:extLst>
           </p:cNvPr>
@@ -7024,7 +7024,7 @@
           <p:cNvPr id="30" name="text">
             <a:extLst xmlns:a="http://schemas.openxmlformats.org/drawingml/2006/main">
               <a:ext uri="{FF2B5EF4-FFF2-40B4-BE49-F238E27FC236}">
-                <a16:creationId xmlns:a16="http://schemas.microsoft.com/office/drawing/2014/main" id="{C858D3A4-6E7C-4D6A-B147-86AB7A503C64}"/>
+                <a16:creationId xmlns:a16="http://schemas.microsoft.com/office/drawing/2014/main" id="{180E7270-112F-4934-AF20-BD0993D4138E}"/>
               </a:ext>
             </a:extLst>
           </p:cNvPr>
@@ -7082,7 +7082,7 @@
           <p:cNvPr id="31" name="dep-3">
             <a:extLst xmlns:a="http://schemas.openxmlformats.org/drawingml/2006/main">
               <a:ext uri="{FF2B5EF4-FFF2-40B4-BE49-F238E27FC236}">
-                <a16:creationId xmlns:a16="http://schemas.microsoft.com/office/drawing/2014/main" id="{7551DB62-B0AE-4461-AC39-D3B40B9ABDCF}"/>
+                <a16:creationId xmlns:a16="http://schemas.microsoft.com/office/drawing/2014/main" id="{A6330AB7-85D0-46F9-AEDF-C272C2B8EF71}"/>
               </a:ext>
             </a:extLst>
           </p:cNvPr>
@@ -7117,7 +7117,7 @@
           <p:cNvPr id="32" name="text">
             <a:extLst xmlns:a="http://schemas.openxmlformats.org/drawingml/2006/main">
               <a:ext uri="{FF2B5EF4-FFF2-40B4-BE49-F238E27FC236}">
-                <a16:creationId xmlns:a16="http://schemas.microsoft.com/office/drawing/2014/main" id="{D4722C08-A1F6-4760-B525-7F838B1BD07C}"/>
+                <a16:creationId xmlns:a16="http://schemas.microsoft.com/office/drawing/2014/main" id="{B3DFFC86-208E-4EE6-9E9C-64308A1E4CFF}"/>
               </a:ext>
             </a:extLst>
           </p:cNvPr>
@@ -7175,7 +7175,7 @@
           <p:cNvPr id="33" name="text">
             <a:extLst xmlns:a="http://schemas.openxmlformats.org/drawingml/2006/main">
               <a:ext uri="{FF2B5EF4-FFF2-40B4-BE49-F238E27FC236}">
-                <a16:creationId xmlns:a16="http://schemas.microsoft.com/office/drawing/2014/main" id="{21EEF5CD-21BB-40A4-9588-2EE8D0290A00}"/>
+                <a16:creationId xmlns:a16="http://schemas.microsoft.com/office/drawing/2014/main" id="{C662B7BD-2823-41FB-9C25-3B2D45670EC8}"/>
               </a:ext>
             </a:extLst>
           </p:cNvPr>
@@ -7233,7 +7233,7 @@
           <p:cNvPr id="34" name="verification-box">
             <a:extLst xmlns:a="http://schemas.openxmlformats.org/drawingml/2006/main">
               <a:ext uri="{FF2B5EF4-FFF2-40B4-BE49-F238E27FC236}">
-                <a16:creationId xmlns:a16="http://schemas.microsoft.com/office/drawing/2014/main" id="{EE3F2609-3662-4A7D-9FA0-45EAE87FCB9F}"/>
+                <a16:creationId xmlns:a16="http://schemas.microsoft.com/office/drawing/2014/main" id="{BC3870C0-E6EE-41D9-8DD3-AEA2E7758D5C}"/>
               </a:ext>
             </a:extLst>
           </p:cNvPr>
@@ -7268,7 +7268,7 @@
           <p:cNvPr id="35" name="text">
             <a:extLst xmlns:a="http://schemas.openxmlformats.org/drawingml/2006/main">
               <a:ext uri="{FF2B5EF4-FFF2-40B4-BE49-F238E27FC236}">
-                <a16:creationId xmlns:a16="http://schemas.microsoft.com/office/drawing/2014/main" id="{9AF730D0-4E68-4CC6-8D20-0A90659E45D1}"/>
+                <a16:creationId xmlns:a16="http://schemas.microsoft.com/office/drawing/2014/main" id="{02F9ED24-12F5-472E-97CB-C0D3AD928BF2}"/>
               </a:ext>
             </a:extLst>
           </p:cNvPr>
@@ -7326,7 +7326,7 @@
           <p:cNvPr id="36" name="text">
             <a:extLst xmlns:a="http://schemas.openxmlformats.org/drawingml/2006/main">
               <a:ext uri="{FF2B5EF4-FFF2-40B4-BE49-F238E27FC236}">
-                <a16:creationId xmlns:a16="http://schemas.microsoft.com/office/drawing/2014/main" id="{A272D5B1-D16E-421A-9796-FBCD23C04A5B}"/>
+                <a16:creationId xmlns:a16="http://schemas.microsoft.com/office/drawing/2014/main" id="{BE45E10D-1CA5-40F1-BEE8-59BCCD952C56}"/>
               </a:ext>
             </a:extLst>
           </p:cNvPr>
@@ -7397,7 +7397,7 @@
                 <a:ea typeface="Microsoft YaHei"/>
                 <a:cs typeface="Microsoft YaHei"/>
               </a:rPr>
-              <a:t>2. 导入 sql/init.sql</a:t>
+              <a:t>2. 导入 sql/ai_job_radar.sql</a:t>
             </a:r>
           </a:p>
           <a:p xmlns:a="http://schemas.openxmlformats.org/drawingml/2006/main">
@@ -7453,7 +7453,7 @@
           <p:cNvPr id="37" name="pill-mvn test ✓">
             <a:extLst xmlns:a="http://schemas.openxmlformats.org/drawingml/2006/main">
               <a:ext uri="{FF2B5EF4-FFF2-40B4-BE49-F238E27FC236}">
-                <a16:creationId xmlns:a16="http://schemas.microsoft.com/office/drawing/2014/main" id="{F633E47E-5445-4BC4-B3FC-19D74E9E0978}"/>
+                <a16:creationId xmlns:a16="http://schemas.microsoft.com/office/drawing/2014/main" id="{5B94C1A7-236C-4B43-B849-04876D88065E}"/>
               </a:ext>
             </a:extLst>
           </p:cNvPr>
@@ -7486,7 +7486,7 @@
           <p:cNvPr id="38" name="pill-text-mvn test ✓">
             <a:extLst xmlns:a="http://schemas.openxmlformats.org/drawingml/2006/main">
               <a:ext uri="{FF2B5EF4-FFF2-40B4-BE49-F238E27FC236}">
-                <a16:creationId xmlns:a16="http://schemas.microsoft.com/office/drawing/2014/main" id="{17E29E7A-D025-45BD-9582-650A893C5F6E}"/>
+                <a16:creationId xmlns:a16="http://schemas.microsoft.com/office/drawing/2014/main" id="{A8B72EF3-7075-4AA8-AE84-A197A1B84D37}"/>
               </a:ext>
             </a:extLst>
           </p:cNvPr>
@@ -7544,7 +7544,7 @@
           <p:cNvPr id="39" name="pill-npm test ✓">
             <a:extLst xmlns:a="http://schemas.openxmlformats.org/drawingml/2006/main">
               <a:ext uri="{FF2B5EF4-FFF2-40B4-BE49-F238E27FC236}">
-                <a16:creationId xmlns:a16="http://schemas.microsoft.com/office/drawing/2014/main" id="{00BF9FC4-8E07-4DDC-A149-839028BA5DFA}"/>
+                <a16:creationId xmlns:a16="http://schemas.microsoft.com/office/drawing/2014/main" id="{9F234CC7-D630-48C5-9848-1E323D5E16D2}"/>
               </a:ext>
             </a:extLst>
           </p:cNvPr>
@@ -7577,7 +7577,7 @@
           <p:cNvPr id="40" name="pill-text-npm test ✓">
             <a:extLst xmlns:a="http://schemas.openxmlformats.org/drawingml/2006/main">
               <a:ext uri="{FF2B5EF4-FFF2-40B4-BE49-F238E27FC236}">
-                <a16:creationId xmlns:a16="http://schemas.microsoft.com/office/drawing/2014/main" id="{4D6BDED8-7B07-469A-A609-5FE420FC25B1}"/>
+                <a16:creationId xmlns:a16="http://schemas.microsoft.com/office/drawing/2014/main" id="{BF2D6864-FC87-4BBA-8DEE-3E05E81BA329}"/>
               </a:ext>
             </a:extLst>
           </p:cNvPr>
@@ -7635,7 +7635,7 @@
           <p:cNvPr id="41" name="pill-vite build ✓">
             <a:extLst xmlns:a="http://schemas.openxmlformats.org/drawingml/2006/main">
               <a:ext uri="{FF2B5EF4-FFF2-40B4-BE49-F238E27FC236}">
-                <a16:creationId xmlns:a16="http://schemas.microsoft.com/office/drawing/2014/main" id="{08166AAF-EDF7-4187-8EA8-F9C62EAF5C61}"/>
+                <a16:creationId xmlns:a16="http://schemas.microsoft.com/office/drawing/2014/main" id="{BD63D3E9-B600-4A0B-AD67-7E0FA61E04D9}"/>
               </a:ext>
             </a:extLst>
           </p:cNvPr>
@@ -7668,7 +7668,7 @@
           <p:cNvPr id="42" name="pill-text-vite build ✓">
             <a:extLst xmlns:a="http://schemas.openxmlformats.org/drawingml/2006/main">
               <a:ext uri="{FF2B5EF4-FFF2-40B4-BE49-F238E27FC236}">
-                <a16:creationId xmlns:a16="http://schemas.microsoft.com/office/drawing/2014/main" id="{2241500E-E6EC-40E4-B63D-F6733D7AC1EB}"/>
+                <a16:creationId xmlns:a16="http://schemas.microsoft.com/office/drawing/2014/main" id="{EA46A191-52E6-439A-9D5C-4D0C70403BE8}"/>
               </a:ext>
             </a:extLst>
           </p:cNvPr>
@@ -7724,7 +7724,7 @@
     </p:spTree>
     <p:extLst>
       <p:ext uri="{BB962C8B-B14F-4D97-AF65-F5344CB8AC3E}">
-        <p14:creationId xmlns:p14="http://schemas.microsoft.com/office/powerpoint/2010/main" val="1812839028"/>
+        <p14:creationId xmlns:p14="http://schemas.microsoft.com/office/powerpoint/2010/main" val="119618974"/>
       </p:ext>
     </p:extLst>
   </p:cSld>
@@ -7755,7 +7755,7 @@
           <p:cNvPr id="1" name="eyebrow-13">
             <a:extLst xmlns:a="http://schemas.openxmlformats.org/drawingml/2006/main">
               <a:ext uri="{FF2B5EF4-FFF2-40B4-BE49-F238E27FC236}">
-                <a16:creationId xmlns:a16="http://schemas.microsoft.com/office/drawing/2014/main" id="{F42912D0-9A91-4C26-9357-C6834761D2BA}"/>
+                <a16:creationId xmlns:a16="http://schemas.microsoft.com/office/drawing/2014/main" id="{BE61ECC5-F4F9-40E3-A5E7-505895F1B4FD}"/>
               </a:ext>
             </a:extLst>
           </p:cNvPr>
@@ -7813,7 +7813,7 @@
           <p:cNvPr id="2" name="slide-title-13">
             <a:extLst xmlns:a="http://schemas.openxmlformats.org/drawingml/2006/main">
               <a:ext uri="{FF2B5EF4-FFF2-40B4-BE49-F238E27FC236}">
-                <a16:creationId xmlns:a16="http://schemas.microsoft.com/office/drawing/2014/main" id="{81B1E587-226D-408F-BD46-74D2285B3DD2}"/>
+                <a16:creationId xmlns:a16="http://schemas.microsoft.com/office/drawing/2014/main" id="{63DF0040-FAAF-4E11-9CDA-66184AE553E9}"/>
               </a:ext>
             </a:extLst>
           </p:cNvPr>
@@ -7871,7 +7871,7 @@
           <p:cNvPr id="3" name="title-rule-13">
             <a:extLst xmlns:a="http://schemas.openxmlformats.org/drawingml/2006/main">
               <a:ext uri="{FF2B5EF4-FFF2-40B4-BE49-F238E27FC236}">
-                <a16:creationId xmlns:a16="http://schemas.microsoft.com/office/drawing/2014/main" id="{DBE7C428-1B0A-433F-8A6B-791CE7DB8B4C}"/>
+                <a16:creationId xmlns:a16="http://schemas.microsoft.com/office/drawing/2014/main" id="{9F999EB2-6F1C-4A16-B2A2-D00041341998}"/>
               </a:ext>
             </a:extLst>
           </p:cNvPr>
@@ -7902,7 +7902,7 @@
           <p:cNvPr id="4" name="page-number-13">
             <a:extLst xmlns:a="http://schemas.openxmlformats.org/drawingml/2006/main">
               <a:ext uri="{FF2B5EF4-FFF2-40B4-BE49-F238E27FC236}">
-                <a16:creationId xmlns:a16="http://schemas.microsoft.com/office/drawing/2014/main" id="{2255BB92-77DD-40EA-915E-DC487434A3CC}"/>
+                <a16:creationId xmlns:a16="http://schemas.microsoft.com/office/drawing/2014/main" id="{CD6079CA-4F74-4E7C-8940-303B0B7D8D87}"/>
               </a:ext>
             </a:extLst>
           </p:cNvPr>
@@ -7960,7 +7960,7 @@
           <p:cNvPr id="5" name="GitHub 提交记录-frame">
             <a:extLst xmlns:a="http://schemas.openxmlformats.org/drawingml/2006/main">
               <a:ext uri="{FF2B5EF4-FFF2-40B4-BE49-F238E27FC236}">
-                <a16:creationId xmlns:a16="http://schemas.microsoft.com/office/drawing/2014/main" id="{6B58161E-54A1-4488-805C-99264A0FAEC3}"/>
+                <a16:creationId xmlns:a16="http://schemas.microsoft.com/office/drawing/2014/main" id="{DA5B3724-9C3E-4CB9-A831-13CBE863482B}"/>
               </a:ext>
             </a:extLst>
           </p:cNvPr>
@@ -7999,7 +7999,7 @@
           <p:nvPr/>
         </p:nvPicPr>
         <p:blipFill>
-          <a:blip xmlns:r="http://schemas.openxmlformats.org/officeDocument/2006/relationships" xmlns:a="http://schemas.openxmlformats.org/drawingml/2006/main" r:embed="R1c8eacda05e0487f"/>
+          <a:blip xmlns:r="http://schemas.openxmlformats.org/officeDocument/2006/relationships" xmlns:a="http://schemas.openxmlformats.org/drawingml/2006/main" r:embed="Rc00799c2010c43f3"/>
           <a:srcRect xmlns:a="http://schemas.openxmlformats.org/drawingml/2006/main" l="0" t="8604" r="0" b="8604"/>
           <a:stretch xmlns:a="http://schemas.openxmlformats.org/drawingml/2006/main">
             <a:fillRect l="0" t="0" r="0" b="0"/>
@@ -8022,7 +8022,7 @@
           <p:cNvPr id="7" name="git-notes">
             <a:extLst xmlns:a="http://schemas.openxmlformats.org/drawingml/2006/main">
               <a:ext uri="{FF2B5EF4-FFF2-40B4-BE49-F238E27FC236}">
-                <a16:creationId xmlns:a16="http://schemas.microsoft.com/office/drawing/2014/main" id="{CC96343D-D38F-4552-93DF-F019F1D162F8}"/>
+                <a16:creationId xmlns:a16="http://schemas.microsoft.com/office/drawing/2014/main" id="{E293C083-3305-4D7D-969E-57382CE39CC0}"/>
               </a:ext>
             </a:extLst>
           </p:cNvPr>
@@ -8057,7 +8057,7 @@
           <p:cNvPr id="8" name="text">
             <a:extLst xmlns:a="http://schemas.openxmlformats.org/drawingml/2006/main">
               <a:ext uri="{FF2B5EF4-FFF2-40B4-BE49-F238E27FC236}">
-                <a16:creationId xmlns:a16="http://schemas.microsoft.com/office/drawing/2014/main" id="{5ED5AC55-4455-47C6-BC85-86FFB4C6C1EA}"/>
+                <a16:creationId xmlns:a16="http://schemas.microsoft.com/office/drawing/2014/main" id="{16C09234-DD15-4DEA-8DA6-960041E4EDBA}"/>
               </a:ext>
             </a:extLst>
           </p:cNvPr>
@@ -8115,7 +8115,7 @@
           <p:cNvPr id="9" name="text">
             <a:extLst xmlns:a="http://schemas.openxmlformats.org/drawingml/2006/main">
               <a:ext uri="{FF2B5EF4-FFF2-40B4-BE49-F238E27FC236}">
-                <a16:creationId xmlns:a16="http://schemas.microsoft.com/office/drawing/2014/main" id="{F60679F8-A3D2-4B03-ADC2-8F8F90F90ED4}"/>
+                <a16:creationId xmlns:a16="http://schemas.microsoft.com/office/drawing/2014/main" id="{E83D2703-0099-416B-B2B8-CEF9718AB15B}"/>
               </a:ext>
             </a:extLst>
           </p:cNvPr>
@@ -8173,7 +8173,7 @@
           <p:cNvPr id="10" name="text">
             <a:extLst xmlns:a="http://schemas.openxmlformats.org/drawingml/2006/main">
               <a:ext uri="{FF2B5EF4-FFF2-40B4-BE49-F238E27FC236}">
-                <a16:creationId xmlns:a16="http://schemas.microsoft.com/office/drawing/2014/main" id="{C2AFCF18-7421-4CC8-AA0B-01C038656091}"/>
+                <a16:creationId xmlns:a16="http://schemas.microsoft.com/office/drawing/2014/main" id="{33F1E858-2279-467A-91BC-240CEA090BB7}"/>
               </a:ext>
             </a:extLst>
           </p:cNvPr>
@@ -8231,7 +8231,7 @@
           <p:cNvPr id="11" name="text">
             <a:extLst xmlns:a="http://schemas.openxmlformats.org/drawingml/2006/main">
               <a:ext uri="{FF2B5EF4-FFF2-40B4-BE49-F238E27FC236}">
-                <a16:creationId xmlns:a16="http://schemas.microsoft.com/office/drawing/2014/main" id="{9A9B2E70-4AAC-462B-863F-123C70519F17}"/>
+                <a16:creationId xmlns:a16="http://schemas.microsoft.com/office/drawing/2014/main" id="{15913C5B-2EE0-419B-BFBB-1365EE2C9A49}"/>
               </a:ext>
             </a:extLst>
           </p:cNvPr>
@@ -8289,7 +8289,7 @@
           <p:cNvPr id="12" name="text">
             <a:extLst xmlns:a="http://schemas.openxmlformats.org/drawingml/2006/main">
               <a:ext uri="{FF2B5EF4-FFF2-40B4-BE49-F238E27FC236}">
-                <a16:creationId xmlns:a16="http://schemas.microsoft.com/office/drawing/2014/main" id="{C26A97EC-29A7-4BB2-BD8A-7D5B92ED71F3}"/>
+                <a16:creationId xmlns:a16="http://schemas.microsoft.com/office/drawing/2014/main" id="{97745CE8-5A87-4B3E-9612-A4FFA66852F2}"/>
               </a:ext>
             </a:extLst>
           </p:cNvPr>
@@ -8347,7 +8347,7 @@
           <p:cNvPr id="13" name="text">
             <a:extLst xmlns:a="http://schemas.openxmlformats.org/drawingml/2006/main">
               <a:ext uri="{FF2B5EF4-FFF2-40B4-BE49-F238E27FC236}">
-                <a16:creationId xmlns:a16="http://schemas.microsoft.com/office/drawing/2014/main" id="{EA5ADA23-329B-4D3E-B822-0928F48C578E}"/>
+                <a16:creationId xmlns:a16="http://schemas.microsoft.com/office/drawing/2014/main" id="{65204B6E-BFB8-4A2B-B0C5-CAAD0A7971CC}"/>
               </a:ext>
             </a:extLst>
           </p:cNvPr>
@@ -8405,7 +8405,7 @@
           <p:cNvPr id="14" name="text">
             <a:extLst xmlns:a="http://schemas.openxmlformats.org/drawingml/2006/main">
               <a:ext uri="{FF2B5EF4-FFF2-40B4-BE49-F238E27FC236}">
-                <a16:creationId xmlns:a16="http://schemas.microsoft.com/office/drawing/2014/main" id="{5D5D355A-41E6-474A-9A39-32D08953FEDF}"/>
+                <a16:creationId xmlns:a16="http://schemas.microsoft.com/office/drawing/2014/main" id="{E09665CF-1B60-42FC-B2B7-430A19512CE5}"/>
               </a:ext>
             </a:extLst>
           </p:cNvPr>
@@ -8463,7 +8463,7 @@
           <p:cNvPr id="15" name="text">
             <a:extLst xmlns:a="http://schemas.openxmlformats.org/drawingml/2006/main">
               <a:ext uri="{FF2B5EF4-FFF2-40B4-BE49-F238E27FC236}">
-                <a16:creationId xmlns:a16="http://schemas.microsoft.com/office/drawing/2014/main" id="{2978D6AD-1F77-43D1-9D3B-7E6796DBF11A}"/>
+                <a16:creationId xmlns:a16="http://schemas.microsoft.com/office/drawing/2014/main" id="{436AECCA-1349-44C0-AB71-100CA0D36D75}"/>
               </a:ext>
             </a:extLst>
           </p:cNvPr>
@@ -8521,7 +8521,7 @@
           <p:cNvPr id="16" name="text">
             <a:extLst xmlns:a="http://schemas.openxmlformats.org/drawingml/2006/main">
               <a:ext uri="{FF2B5EF4-FFF2-40B4-BE49-F238E27FC236}">
-                <a16:creationId xmlns:a16="http://schemas.microsoft.com/office/drawing/2014/main" id="{B53AA1AA-6B82-45BB-9A57-DF8A66A51196}"/>
+                <a16:creationId xmlns:a16="http://schemas.microsoft.com/office/drawing/2014/main" id="{4A404210-F832-4A20-A52C-BA895EE9FB55}"/>
               </a:ext>
             </a:extLst>
           </p:cNvPr>
@@ -8579,7 +8579,7 @@
           <p:cNvPr id="17" name="pill-Public">
             <a:extLst xmlns:a="http://schemas.openxmlformats.org/drawingml/2006/main">
               <a:ext uri="{FF2B5EF4-FFF2-40B4-BE49-F238E27FC236}">
-                <a16:creationId xmlns:a16="http://schemas.microsoft.com/office/drawing/2014/main" id="{9E3504B4-6015-4D9E-97DE-48D3DA31E1C2}"/>
+                <a16:creationId xmlns:a16="http://schemas.microsoft.com/office/drawing/2014/main" id="{12EC945F-5361-4EBD-A042-B4ED8E79ACF5}"/>
               </a:ext>
             </a:extLst>
           </p:cNvPr>
@@ -8612,7 +8612,7 @@
           <p:cNvPr id="18" name="pill-text-Public">
             <a:extLst xmlns:a="http://schemas.openxmlformats.org/drawingml/2006/main">
               <a:ext uri="{FF2B5EF4-FFF2-40B4-BE49-F238E27FC236}">
-                <a16:creationId xmlns:a16="http://schemas.microsoft.com/office/drawing/2014/main" id="{F6446E66-C4B4-4F5F-9255-3BA01D5AF6AB}"/>
+                <a16:creationId xmlns:a16="http://schemas.microsoft.com/office/drawing/2014/main" id="{FD47ADAB-94D5-423C-8382-317D6237896D}"/>
               </a:ext>
             </a:extLst>
           </p:cNvPr>
@@ -8670,7 +8670,7 @@
           <p:cNvPr id="19" name="pill-main">
             <a:extLst xmlns:a="http://schemas.openxmlformats.org/drawingml/2006/main">
               <a:ext uri="{FF2B5EF4-FFF2-40B4-BE49-F238E27FC236}">
-                <a16:creationId xmlns:a16="http://schemas.microsoft.com/office/drawing/2014/main" id="{BC3365D3-D044-4C99-BFEB-A458D9E60313}"/>
+                <a16:creationId xmlns:a16="http://schemas.microsoft.com/office/drawing/2014/main" id="{ADB81162-AE26-432A-AFA6-9DB9123D247A}"/>
               </a:ext>
             </a:extLst>
           </p:cNvPr>
@@ -8703,7 +8703,7 @@
           <p:cNvPr id="20" name="pill-text-main">
             <a:extLst xmlns:a="http://schemas.openxmlformats.org/drawingml/2006/main">
               <a:ext uri="{FF2B5EF4-FFF2-40B4-BE49-F238E27FC236}">
-                <a16:creationId xmlns:a16="http://schemas.microsoft.com/office/drawing/2014/main" id="{8D2DE745-DCDD-4015-96E6-347097019E43}"/>
+                <a16:creationId xmlns:a16="http://schemas.microsoft.com/office/drawing/2014/main" id="{EAD27308-4546-4F92-AAA0-992C62DB4A75}"/>
               </a:ext>
             </a:extLst>
           </p:cNvPr>
@@ -8759,7 +8759,7 @@
     </p:spTree>
     <p:extLst>
       <p:ext uri="{BB962C8B-B14F-4D97-AF65-F5344CB8AC3E}">
-        <p14:creationId xmlns:p14="http://schemas.microsoft.com/office/powerpoint/2010/main" val="1669086036"/>
+        <p14:creationId xmlns:p14="http://schemas.microsoft.com/office/powerpoint/2010/main" val="982762868"/>
       </p:ext>
     </p:extLst>
   </p:cSld>
@@ -8790,7 +8790,7 @@
           <p:cNvPr id="1" name="eyebrow-14">
             <a:extLst xmlns:a="http://schemas.openxmlformats.org/drawingml/2006/main">
               <a:ext uri="{FF2B5EF4-FFF2-40B4-BE49-F238E27FC236}">
-                <a16:creationId xmlns:a16="http://schemas.microsoft.com/office/drawing/2014/main" id="{7CB83CAA-138F-4142-BBB5-E5E9FAD10C23}"/>
+                <a16:creationId xmlns:a16="http://schemas.microsoft.com/office/drawing/2014/main" id="{C7C9397D-6243-4AD7-AD39-E98B79D983BD}"/>
               </a:ext>
             </a:extLst>
           </p:cNvPr>
@@ -8848,7 +8848,7 @@
           <p:cNvPr id="2" name="slide-title-14">
             <a:extLst xmlns:a="http://schemas.openxmlformats.org/drawingml/2006/main">
               <a:ext uri="{FF2B5EF4-FFF2-40B4-BE49-F238E27FC236}">
-                <a16:creationId xmlns:a16="http://schemas.microsoft.com/office/drawing/2014/main" id="{2FD63934-BBAC-4827-9315-2F719C904E70}"/>
+                <a16:creationId xmlns:a16="http://schemas.microsoft.com/office/drawing/2014/main" id="{C0989FF0-A331-4F16-A78F-AE31E17BFC7B}"/>
               </a:ext>
             </a:extLst>
           </p:cNvPr>
@@ -8906,7 +8906,7 @@
           <p:cNvPr id="3" name="title-rule-14">
             <a:extLst xmlns:a="http://schemas.openxmlformats.org/drawingml/2006/main">
               <a:ext uri="{FF2B5EF4-FFF2-40B4-BE49-F238E27FC236}">
-                <a16:creationId xmlns:a16="http://schemas.microsoft.com/office/drawing/2014/main" id="{AA3986D3-176E-43F3-8601-8B2F1726FCC6}"/>
+                <a16:creationId xmlns:a16="http://schemas.microsoft.com/office/drawing/2014/main" id="{2FBD610F-7EB6-4144-9F48-833E4C803920}"/>
               </a:ext>
             </a:extLst>
           </p:cNvPr>
@@ -8937,7 +8937,7 @@
           <p:cNvPr id="4" name="page-number-14">
             <a:extLst xmlns:a="http://schemas.openxmlformats.org/drawingml/2006/main">
               <a:ext uri="{FF2B5EF4-FFF2-40B4-BE49-F238E27FC236}">
-                <a16:creationId xmlns:a16="http://schemas.microsoft.com/office/drawing/2014/main" id="{77D84C8E-7578-4D6B-9818-FCD17FC2CD9A}"/>
+                <a16:creationId xmlns:a16="http://schemas.microsoft.com/office/drawing/2014/main" id="{E13EECCE-FE29-4E97-A66A-027F3D991E59}"/>
               </a:ext>
             </a:extLst>
           </p:cNvPr>
@@ -8995,7 +8995,7 @@
           <p:cNvPr id="5" name="team-header">
             <a:extLst xmlns:a="http://schemas.openxmlformats.org/drawingml/2006/main">
               <a:ext uri="{FF2B5EF4-FFF2-40B4-BE49-F238E27FC236}">
-                <a16:creationId xmlns:a16="http://schemas.microsoft.com/office/drawing/2014/main" id="{7D8CA813-56CD-447E-9B34-F84ECCEC78A8}"/>
+                <a16:creationId xmlns:a16="http://schemas.microsoft.com/office/drawing/2014/main" id="{4A635FFF-E1C8-4AA6-9DFB-2D4F246E7EFB}"/>
               </a:ext>
             </a:extLst>
           </p:cNvPr>
@@ -9028,7 +9028,7 @@
           <p:cNvPr id="6" name="text">
             <a:extLst xmlns:a="http://schemas.openxmlformats.org/drawingml/2006/main">
               <a:ext uri="{FF2B5EF4-FFF2-40B4-BE49-F238E27FC236}">
-                <a16:creationId xmlns:a16="http://schemas.microsoft.com/office/drawing/2014/main" id="{C41FFFC6-E2E4-4775-8E55-6F6AA8A619C8}"/>
+                <a16:creationId xmlns:a16="http://schemas.microsoft.com/office/drawing/2014/main" id="{AE0756B4-9B57-4438-A5E5-1A6BA194DFED}"/>
               </a:ext>
             </a:extLst>
           </p:cNvPr>
@@ -9086,7 +9086,7 @@
           <p:cNvPr id="7" name="text">
             <a:extLst xmlns:a="http://schemas.openxmlformats.org/drawingml/2006/main">
               <a:ext uri="{FF2B5EF4-FFF2-40B4-BE49-F238E27FC236}">
-                <a16:creationId xmlns:a16="http://schemas.microsoft.com/office/drawing/2014/main" id="{CD4C5E46-3F6B-4687-8D40-FB92CA857A44}"/>
+                <a16:creationId xmlns:a16="http://schemas.microsoft.com/office/drawing/2014/main" id="{117F7311-85D5-4888-8AE8-A00F6D4CF2F8}"/>
               </a:ext>
             </a:extLst>
           </p:cNvPr>
@@ -9144,7 +9144,7 @@
           <p:cNvPr id="8" name="text">
             <a:extLst xmlns:a="http://schemas.openxmlformats.org/drawingml/2006/main">
               <a:ext uri="{FF2B5EF4-FFF2-40B4-BE49-F238E27FC236}">
-                <a16:creationId xmlns:a16="http://schemas.microsoft.com/office/drawing/2014/main" id="{E595805E-6C27-4D4B-AA60-480AFD615138}"/>
+                <a16:creationId xmlns:a16="http://schemas.microsoft.com/office/drawing/2014/main" id="{54DF03C0-7066-42F3-84F2-4B0AFD9D7D7A}"/>
               </a:ext>
             </a:extLst>
           </p:cNvPr>
@@ -9202,7 +9202,7 @@
           <p:cNvPr id="9" name="text">
             <a:extLst xmlns:a="http://schemas.openxmlformats.org/drawingml/2006/main">
               <a:ext uri="{FF2B5EF4-FFF2-40B4-BE49-F238E27FC236}">
-                <a16:creationId xmlns:a16="http://schemas.microsoft.com/office/drawing/2014/main" id="{81A248D4-93CD-4015-8309-204C7EBA61BC}"/>
+                <a16:creationId xmlns:a16="http://schemas.microsoft.com/office/drawing/2014/main" id="{D0883870-8847-4E73-A7AF-936ED11A5EB3}"/>
               </a:ext>
             </a:extLst>
           </p:cNvPr>
@@ -9260,7 +9260,7 @@
           <p:cNvPr id="10" name="team-row-0">
             <a:extLst xmlns:a="http://schemas.openxmlformats.org/drawingml/2006/main">
               <a:ext uri="{FF2B5EF4-FFF2-40B4-BE49-F238E27FC236}">
-                <a16:creationId xmlns:a16="http://schemas.microsoft.com/office/drawing/2014/main" id="{A3E9F82A-78AB-4A37-B565-43EBF624C9E5}"/>
+                <a16:creationId xmlns:a16="http://schemas.microsoft.com/office/drawing/2014/main" id="{78139A51-0EB9-4F34-A45C-1A9EA54437AB}"/>
               </a:ext>
             </a:extLst>
           </p:cNvPr>
@@ -9293,7 +9293,7 @@
           <p:cNvPr id="11" name="text">
             <a:extLst xmlns:a="http://schemas.openxmlformats.org/drawingml/2006/main">
               <a:ext uri="{FF2B5EF4-FFF2-40B4-BE49-F238E27FC236}">
-                <a16:creationId xmlns:a16="http://schemas.microsoft.com/office/drawing/2014/main" id="{B9D92CD0-B498-496D-A7FE-0B62BA0F9264}"/>
+                <a16:creationId xmlns:a16="http://schemas.microsoft.com/office/drawing/2014/main" id="{16793791-35B6-48B4-B324-39F2DAE389E0}"/>
               </a:ext>
             </a:extLst>
           </p:cNvPr>
@@ -9351,7 +9351,7 @@
           <p:cNvPr id="12" name="text">
             <a:extLst xmlns:a="http://schemas.openxmlformats.org/drawingml/2006/main">
               <a:ext uri="{FF2B5EF4-FFF2-40B4-BE49-F238E27FC236}">
-                <a16:creationId xmlns:a16="http://schemas.microsoft.com/office/drawing/2014/main" id="{20F85ED6-DFE3-4BE5-8717-1700CE9012F6}"/>
+                <a16:creationId xmlns:a16="http://schemas.microsoft.com/office/drawing/2014/main" id="{1ABD24C1-A410-4AFB-A52E-6A30CB455A8B}"/>
               </a:ext>
             </a:extLst>
           </p:cNvPr>
@@ -9409,7 +9409,7 @@
           <p:cNvPr id="13" name="text">
             <a:extLst xmlns:a="http://schemas.openxmlformats.org/drawingml/2006/main">
               <a:ext uri="{FF2B5EF4-FFF2-40B4-BE49-F238E27FC236}">
-                <a16:creationId xmlns:a16="http://schemas.microsoft.com/office/drawing/2014/main" id="{B8E61725-D6B6-4053-90F4-49180FC8ACBC}"/>
+                <a16:creationId xmlns:a16="http://schemas.microsoft.com/office/drawing/2014/main" id="{FF8A2D66-2A24-4ECF-9E1E-127EE2B6B039}"/>
               </a:ext>
             </a:extLst>
           </p:cNvPr>
@@ -9467,7 +9467,7 @@
           <p:cNvPr id="14" name="text">
             <a:extLst xmlns:a="http://schemas.openxmlformats.org/drawingml/2006/main">
               <a:ext uri="{FF2B5EF4-FFF2-40B4-BE49-F238E27FC236}">
-                <a16:creationId xmlns:a16="http://schemas.microsoft.com/office/drawing/2014/main" id="{3DDA3FBD-83DD-4CA9-991C-D2A4BE633D72}"/>
+                <a16:creationId xmlns:a16="http://schemas.microsoft.com/office/drawing/2014/main" id="{31C358E0-AAA2-4381-AC0E-11F33B8A900E}"/>
               </a:ext>
             </a:extLst>
           </p:cNvPr>
@@ -9525,7 +9525,7 @@
           <p:cNvPr id="15" name="team-row-1">
             <a:extLst xmlns:a="http://schemas.openxmlformats.org/drawingml/2006/main">
               <a:ext uri="{FF2B5EF4-FFF2-40B4-BE49-F238E27FC236}">
-                <a16:creationId xmlns:a16="http://schemas.microsoft.com/office/drawing/2014/main" id="{A0E4F8AA-CEB5-4EDE-B138-4CFD33BF2E5B}"/>
+                <a16:creationId xmlns:a16="http://schemas.microsoft.com/office/drawing/2014/main" id="{81E725D2-182F-4BD8-A306-AE0B67D56B02}"/>
               </a:ext>
             </a:extLst>
           </p:cNvPr>
@@ -9558,7 +9558,7 @@
           <p:cNvPr id="16" name="text">
             <a:extLst xmlns:a="http://schemas.openxmlformats.org/drawingml/2006/main">
               <a:ext uri="{FF2B5EF4-FFF2-40B4-BE49-F238E27FC236}">
-                <a16:creationId xmlns:a16="http://schemas.microsoft.com/office/drawing/2014/main" id="{6465CA77-DF69-4103-8763-1FD54D5227D7}"/>
+                <a16:creationId xmlns:a16="http://schemas.microsoft.com/office/drawing/2014/main" id="{A52AB309-FDE2-4EFA-B710-A00C7B55DACB}"/>
               </a:ext>
             </a:extLst>
           </p:cNvPr>
@@ -9616,7 +9616,7 @@
           <p:cNvPr id="17" name="text">
             <a:extLst xmlns:a="http://schemas.openxmlformats.org/drawingml/2006/main">
               <a:ext uri="{FF2B5EF4-FFF2-40B4-BE49-F238E27FC236}">
-                <a16:creationId xmlns:a16="http://schemas.microsoft.com/office/drawing/2014/main" id="{B2F4D9E9-45CB-4FA6-95EF-131D715B5005}"/>
+                <a16:creationId xmlns:a16="http://schemas.microsoft.com/office/drawing/2014/main" id="{9D06C247-A3B2-48AE-A29C-EA267CACBAA5}"/>
               </a:ext>
             </a:extLst>
           </p:cNvPr>
@@ -9674,7 +9674,7 @@
           <p:cNvPr id="18" name="text">
             <a:extLst xmlns:a="http://schemas.openxmlformats.org/drawingml/2006/main">
               <a:ext uri="{FF2B5EF4-FFF2-40B4-BE49-F238E27FC236}">
-                <a16:creationId xmlns:a16="http://schemas.microsoft.com/office/drawing/2014/main" id="{69680B15-EBA3-48BF-9993-C079471F5FF2}"/>
+                <a16:creationId xmlns:a16="http://schemas.microsoft.com/office/drawing/2014/main" id="{CDA74587-68D4-4A64-8487-A6E96FC7D730}"/>
               </a:ext>
             </a:extLst>
           </p:cNvPr>
@@ -9732,7 +9732,7 @@
           <p:cNvPr id="19" name="text">
             <a:extLst xmlns:a="http://schemas.openxmlformats.org/drawingml/2006/main">
               <a:ext uri="{FF2B5EF4-FFF2-40B4-BE49-F238E27FC236}">
-                <a16:creationId xmlns:a16="http://schemas.microsoft.com/office/drawing/2014/main" id="{1A9E6576-422B-4589-A28F-9104657901BE}"/>
+                <a16:creationId xmlns:a16="http://schemas.microsoft.com/office/drawing/2014/main" id="{88073C0D-950A-4409-8A4B-367981D86C7A}"/>
               </a:ext>
             </a:extLst>
           </p:cNvPr>
@@ -9790,7 +9790,7 @@
           <p:cNvPr id="20" name="team-row-2">
             <a:extLst xmlns:a="http://schemas.openxmlformats.org/drawingml/2006/main">
               <a:ext uri="{FF2B5EF4-FFF2-40B4-BE49-F238E27FC236}">
-                <a16:creationId xmlns:a16="http://schemas.microsoft.com/office/drawing/2014/main" id="{658298CB-1650-437B-8702-BA71ABB05B72}"/>
+                <a16:creationId xmlns:a16="http://schemas.microsoft.com/office/drawing/2014/main" id="{EE5E8726-774E-4FA4-867E-94E5F2A7A556}"/>
               </a:ext>
             </a:extLst>
           </p:cNvPr>
@@ -9823,7 +9823,7 @@
           <p:cNvPr id="21" name="text">
             <a:extLst xmlns:a="http://schemas.openxmlformats.org/drawingml/2006/main">
               <a:ext uri="{FF2B5EF4-FFF2-40B4-BE49-F238E27FC236}">
-                <a16:creationId xmlns:a16="http://schemas.microsoft.com/office/drawing/2014/main" id="{A0F4EC7C-CB85-443D-80F3-F29309966BE5}"/>
+                <a16:creationId xmlns:a16="http://schemas.microsoft.com/office/drawing/2014/main" id="{3F212866-F289-48C6-9CEF-9C331C77B7AA}"/>
               </a:ext>
             </a:extLst>
           </p:cNvPr>
@@ -9881,7 +9881,7 @@
           <p:cNvPr id="22" name="text">
             <a:extLst xmlns:a="http://schemas.openxmlformats.org/drawingml/2006/main">
               <a:ext uri="{FF2B5EF4-FFF2-40B4-BE49-F238E27FC236}">
-                <a16:creationId xmlns:a16="http://schemas.microsoft.com/office/drawing/2014/main" id="{B5334A89-F355-4F70-A9DF-DDCFF4307D5C}"/>
+                <a16:creationId xmlns:a16="http://schemas.microsoft.com/office/drawing/2014/main" id="{A6761DBF-3F90-4EFE-937A-E9E4E07D94DD}"/>
               </a:ext>
             </a:extLst>
           </p:cNvPr>
@@ -9939,7 +9939,7 @@
           <p:cNvPr id="23" name="text">
             <a:extLst xmlns:a="http://schemas.openxmlformats.org/drawingml/2006/main">
               <a:ext uri="{FF2B5EF4-FFF2-40B4-BE49-F238E27FC236}">
-                <a16:creationId xmlns:a16="http://schemas.microsoft.com/office/drawing/2014/main" id="{D595C3E3-B1B2-41ED-ACCA-6D72EDD30EEF}"/>
+                <a16:creationId xmlns:a16="http://schemas.microsoft.com/office/drawing/2014/main" id="{72E6DBCB-A012-4A7C-8A8C-4630F1A1E74D}"/>
               </a:ext>
             </a:extLst>
           </p:cNvPr>
@@ -9997,7 +9997,7 @@
           <p:cNvPr id="24" name="text">
             <a:extLst xmlns:a="http://schemas.openxmlformats.org/drawingml/2006/main">
               <a:ext uri="{FF2B5EF4-FFF2-40B4-BE49-F238E27FC236}">
-                <a16:creationId xmlns:a16="http://schemas.microsoft.com/office/drawing/2014/main" id="{0B4BF214-186B-4E7A-A4C2-F51B869D14E0}"/>
+                <a16:creationId xmlns:a16="http://schemas.microsoft.com/office/drawing/2014/main" id="{386A0ABB-95EA-43C8-9ADE-776BAD4D5B07}"/>
               </a:ext>
             </a:extLst>
           </p:cNvPr>
@@ -10055,7 +10055,7 @@
           <p:cNvPr id="25" name="team-row-3">
             <a:extLst xmlns:a="http://schemas.openxmlformats.org/drawingml/2006/main">
               <a:ext uri="{FF2B5EF4-FFF2-40B4-BE49-F238E27FC236}">
-                <a16:creationId xmlns:a16="http://schemas.microsoft.com/office/drawing/2014/main" id="{E68466B4-1629-454D-B20C-E31C35489591}"/>
+                <a16:creationId xmlns:a16="http://schemas.microsoft.com/office/drawing/2014/main" id="{428B3028-5916-4B4C-B2AA-D77A06951B37}"/>
               </a:ext>
             </a:extLst>
           </p:cNvPr>
@@ -10088,7 +10088,7 @@
           <p:cNvPr id="26" name="text">
             <a:extLst xmlns:a="http://schemas.openxmlformats.org/drawingml/2006/main">
               <a:ext uri="{FF2B5EF4-FFF2-40B4-BE49-F238E27FC236}">
-                <a16:creationId xmlns:a16="http://schemas.microsoft.com/office/drawing/2014/main" id="{8DFECF08-6B91-45E9-845B-9FB67F356083}"/>
+                <a16:creationId xmlns:a16="http://schemas.microsoft.com/office/drawing/2014/main" id="{CA0E39B4-F167-4102-9CCC-A72D7609C5EB}"/>
               </a:ext>
             </a:extLst>
           </p:cNvPr>
@@ -10146,7 +10146,7 @@
           <p:cNvPr id="27" name="text">
             <a:extLst xmlns:a="http://schemas.openxmlformats.org/drawingml/2006/main">
               <a:ext uri="{FF2B5EF4-FFF2-40B4-BE49-F238E27FC236}">
-                <a16:creationId xmlns:a16="http://schemas.microsoft.com/office/drawing/2014/main" id="{27DE8F7E-CB7E-47E1-9F34-8368F16B476F}"/>
+                <a16:creationId xmlns:a16="http://schemas.microsoft.com/office/drawing/2014/main" id="{F86D17EB-5711-4CFC-A787-4C755B97793E}"/>
               </a:ext>
             </a:extLst>
           </p:cNvPr>
@@ -10204,7 +10204,7 @@
           <p:cNvPr id="28" name="text">
             <a:extLst xmlns:a="http://schemas.openxmlformats.org/drawingml/2006/main">
               <a:ext uri="{FF2B5EF4-FFF2-40B4-BE49-F238E27FC236}">
-                <a16:creationId xmlns:a16="http://schemas.microsoft.com/office/drawing/2014/main" id="{EF950284-AE60-417B-A241-D1CE5CE61BB8}"/>
+                <a16:creationId xmlns:a16="http://schemas.microsoft.com/office/drawing/2014/main" id="{5352A7F1-0E79-4AFA-BCBF-D402D84C05B6}"/>
               </a:ext>
             </a:extLst>
           </p:cNvPr>
@@ -10262,7 +10262,7 @@
           <p:cNvPr id="29" name="text">
             <a:extLst xmlns:a="http://schemas.openxmlformats.org/drawingml/2006/main">
               <a:ext uri="{FF2B5EF4-FFF2-40B4-BE49-F238E27FC236}">
-                <a16:creationId xmlns:a16="http://schemas.microsoft.com/office/drawing/2014/main" id="{DF09569E-63AD-4AAC-BBB7-ECBB17F27EE4}"/>
+                <a16:creationId xmlns:a16="http://schemas.microsoft.com/office/drawing/2014/main" id="{4BA870F9-B296-4296-AC7C-836115BB2C40}"/>
               </a:ext>
             </a:extLst>
           </p:cNvPr>
@@ -10320,7 +10320,7 @@
           <p:cNvPr id="30" name="team-row-4">
             <a:extLst xmlns:a="http://schemas.openxmlformats.org/drawingml/2006/main">
               <a:ext uri="{FF2B5EF4-FFF2-40B4-BE49-F238E27FC236}">
-                <a16:creationId xmlns:a16="http://schemas.microsoft.com/office/drawing/2014/main" id="{D43E51A7-5AE8-4CD6-B1CE-2AA2E4F3FB97}"/>
+                <a16:creationId xmlns:a16="http://schemas.microsoft.com/office/drawing/2014/main" id="{E8FEFCCA-9EF2-4EDE-A7E4-8537E9B923D2}"/>
               </a:ext>
             </a:extLst>
           </p:cNvPr>
@@ -10353,7 +10353,7 @@
           <p:cNvPr id="31" name="text">
             <a:extLst xmlns:a="http://schemas.openxmlformats.org/drawingml/2006/main">
               <a:ext uri="{FF2B5EF4-FFF2-40B4-BE49-F238E27FC236}">
-                <a16:creationId xmlns:a16="http://schemas.microsoft.com/office/drawing/2014/main" id="{B2D96D0B-0EE9-4A8D-AC58-0699DB021FA7}"/>
+                <a16:creationId xmlns:a16="http://schemas.microsoft.com/office/drawing/2014/main" id="{B7C64988-D96E-4C76-8B56-C3D68E75F705}"/>
               </a:ext>
             </a:extLst>
           </p:cNvPr>
@@ -10411,7 +10411,7 @@
           <p:cNvPr id="32" name="text">
             <a:extLst xmlns:a="http://schemas.openxmlformats.org/drawingml/2006/main">
               <a:ext uri="{FF2B5EF4-FFF2-40B4-BE49-F238E27FC236}">
-                <a16:creationId xmlns:a16="http://schemas.microsoft.com/office/drawing/2014/main" id="{ADBEB93F-22A3-4067-B93C-9B2E1FF5B9C1}"/>
+                <a16:creationId xmlns:a16="http://schemas.microsoft.com/office/drawing/2014/main" id="{F311F2CD-3271-49CB-BF50-3952261C90D1}"/>
               </a:ext>
             </a:extLst>
           </p:cNvPr>
@@ -10469,7 +10469,7 @@
           <p:cNvPr id="33" name="text">
             <a:extLst xmlns:a="http://schemas.openxmlformats.org/drawingml/2006/main">
               <a:ext uri="{FF2B5EF4-FFF2-40B4-BE49-F238E27FC236}">
-                <a16:creationId xmlns:a16="http://schemas.microsoft.com/office/drawing/2014/main" id="{17C0A3B3-3792-424B-8A42-23A92448902A}"/>
+                <a16:creationId xmlns:a16="http://schemas.microsoft.com/office/drawing/2014/main" id="{526620DE-BC80-4241-BA77-F09D3FCE1A7E}"/>
               </a:ext>
             </a:extLst>
           </p:cNvPr>
@@ -10527,7 +10527,7 @@
           <p:cNvPr id="34" name="text">
             <a:extLst xmlns:a="http://schemas.openxmlformats.org/drawingml/2006/main">
               <a:ext uri="{FF2B5EF4-FFF2-40B4-BE49-F238E27FC236}">
-                <a16:creationId xmlns:a16="http://schemas.microsoft.com/office/drawing/2014/main" id="{3EF7E161-1C91-45AE-84B3-BE3727B6A3B1}"/>
+                <a16:creationId xmlns:a16="http://schemas.microsoft.com/office/drawing/2014/main" id="{8CD8DED3-8B32-40E8-BEF4-CAB7DD1910A8}"/>
               </a:ext>
             </a:extLst>
           </p:cNvPr>
@@ -10585,7 +10585,7 @@
           <p:cNvPr id="35" name="team-row-5">
             <a:extLst xmlns:a="http://schemas.openxmlformats.org/drawingml/2006/main">
               <a:ext uri="{FF2B5EF4-FFF2-40B4-BE49-F238E27FC236}">
-                <a16:creationId xmlns:a16="http://schemas.microsoft.com/office/drawing/2014/main" id="{8D22CE7F-C26F-4402-9F74-B5B66BE9E39D}"/>
+                <a16:creationId xmlns:a16="http://schemas.microsoft.com/office/drawing/2014/main" id="{18FE5F50-3F9B-428C-B69C-0D718869E516}"/>
               </a:ext>
             </a:extLst>
           </p:cNvPr>
@@ -10618,7 +10618,7 @@
           <p:cNvPr id="36" name="text">
             <a:extLst xmlns:a="http://schemas.openxmlformats.org/drawingml/2006/main">
               <a:ext uri="{FF2B5EF4-FFF2-40B4-BE49-F238E27FC236}">
-                <a16:creationId xmlns:a16="http://schemas.microsoft.com/office/drawing/2014/main" id="{762D74E4-EA7D-4366-9466-490C554F3FD4}"/>
+                <a16:creationId xmlns:a16="http://schemas.microsoft.com/office/drawing/2014/main" id="{0D4DA361-4428-4462-8BDD-48A69EB97DEC}"/>
               </a:ext>
             </a:extLst>
           </p:cNvPr>
@@ -10676,7 +10676,7 @@
           <p:cNvPr id="37" name="text">
             <a:extLst xmlns:a="http://schemas.openxmlformats.org/drawingml/2006/main">
               <a:ext uri="{FF2B5EF4-FFF2-40B4-BE49-F238E27FC236}">
-                <a16:creationId xmlns:a16="http://schemas.microsoft.com/office/drawing/2014/main" id="{9D508654-24AE-4A9F-A916-1165B6058FB2}"/>
+                <a16:creationId xmlns:a16="http://schemas.microsoft.com/office/drawing/2014/main" id="{5FD2D8F9-3199-4F4E-9835-7ADEB461AF7D}"/>
               </a:ext>
             </a:extLst>
           </p:cNvPr>
@@ -10734,7 +10734,7 @@
           <p:cNvPr id="38" name="text">
             <a:extLst xmlns:a="http://schemas.openxmlformats.org/drawingml/2006/main">
               <a:ext uri="{FF2B5EF4-FFF2-40B4-BE49-F238E27FC236}">
-                <a16:creationId xmlns:a16="http://schemas.microsoft.com/office/drawing/2014/main" id="{DE7D21E9-AA03-4781-99A5-3C9102BC0F1E}"/>
+                <a16:creationId xmlns:a16="http://schemas.microsoft.com/office/drawing/2014/main" id="{379BA4E8-724B-4245-BC47-26255DA2E82A}"/>
               </a:ext>
             </a:extLst>
           </p:cNvPr>
@@ -10792,7 +10792,7 @@
           <p:cNvPr id="39" name="text">
             <a:extLst xmlns:a="http://schemas.openxmlformats.org/drawingml/2006/main">
               <a:ext uri="{FF2B5EF4-FFF2-40B4-BE49-F238E27FC236}">
-                <a16:creationId xmlns:a16="http://schemas.microsoft.com/office/drawing/2014/main" id="{F82DAF78-B19A-4492-8BAF-DB1AE2134F37}"/>
+                <a16:creationId xmlns:a16="http://schemas.microsoft.com/office/drawing/2014/main" id="{9682E425-1012-49F8-BAB3-F8D49A4C9BEE}"/>
               </a:ext>
             </a:extLst>
           </p:cNvPr>
@@ -10850,7 +10850,7 @@
           <p:cNvPr id="40" name="team-warning">
             <a:extLst xmlns:a="http://schemas.openxmlformats.org/drawingml/2006/main">
               <a:ext uri="{FF2B5EF4-FFF2-40B4-BE49-F238E27FC236}">
-                <a16:creationId xmlns:a16="http://schemas.microsoft.com/office/drawing/2014/main" id="{95E57A5C-B801-4305-90BC-0611596EEBBC}"/>
+                <a16:creationId xmlns:a16="http://schemas.microsoft.com/office/drawing/2014/main" id="{AA997E37-C77E-4FA9-8108-6732BE27EF15}"/>
               </a:ext>
             </a:extLst>
           </p:cNvPr>
@@ -10883,7 +10883,7 @@
           <p:cNvPr id="41" name="text">
             <a:extLst xmlns:a="http://schemas.openxmlformats.org/drawingml/2006/main">
               <a:ext uri="{FF2B5EF4-FFF2-40B4-BE49-F238E27FC236}">
-                <a16:creationId xmlns:a16="http://schemas.microsoft.com/office/drawing/2014/main" id="{49E7925D-2C27-415B-8574-C7B165A33103}"/>
+                <a16:creationId xmlns:a16="http://schemas.microsoft.com/office/drawing/2014/main" id="{2CF12FDA-DF38-4A4E-AB47-A55B3CFB99F3}"/>
               </a:ext>
             </a:extLst>
           </p:cNvPr>
@@ -10939,7 +10939,7 @@
     </p:spTree>
     <p:extLst>
       <p:ext uri="{BB962C8B-B14F-4D97-AF65-F5344CB8AC3E}">
-        <p14:creationId xmlns:p14="http://schemas.microsoft.com/office/powerpoint/2010/main" val="1749759693"/>
+        <p14:creationId xmlns:p14="http://schemas.microsoft.com/office/powerpoint/2010/main" val="595090749"/>
       </p:ext>
     </p:extLst>
   </p:cSld>
@@ -10970,7 +10970,7 @@
           <p:cNvPr id="1" name="text">
             <a:extLst xmlns:a="http://schemas.openxmlformats.org/drawingml/2006/main">
               <a:ext uri="{FF2B5EF4-FFF2-40B4-BE49-F238E27FC236}">
-                <a16:creationId xmlns:a16="http://schemas.microsoft.com/office/drawing/2014/main" id="{E874ED15-469C-40F9-99F4-291438173F48}"/>
+                <a16:creationId xmlns:a16="http://schemas.microsoft.com/office/drawing/2014/main" id="{0434949F-ADA1-4960-934C-40E101B475CE}"/>
               </a:ext>
             </a:extLst>
           </p:cNvPr>
@@ -11028,7 +11028,7 @@
           <p:cNvPr id="2" name="text">
             <a:extLst xmlns:a="http://schemas.openxmlformats.org/drawingml/2006/main">
               <a:ext uri="{FF2B5EF4-FFF2-40B4-BE49-F238E27FC236}">
-                <a16:creationId xmlns:a16="http://schemas.microsoft.com/office/drawing/2014/main" id="{9B02C7A5-30FA-48E4-AA89-16498AF0B67B}"/>
+                <a16:creationId xmlns:a16="http://schemas.microsoft.com/office/drawing/2014/main" id="{4645918F-A53E-49F2-9B8B-8FAB67A78B0E}"/>
               </a:ext>
             </a:extLst>
           </p:cNvPr>
@@ -11086,7 +11086,7 @@
           <p:cNvPr id="3" name="text">
             <a:extLst xmlns:a="http://schemas.openxmlformats.org/drawingml/2006/main">
               <a:ext uri="{FF2B5EF4-FFF2-40B4-BE49-F238E27FC236}">
-                <a16:creationId xmlns:a16="http://schemas.microsoft.com/office/drawing/2014/main" id="{94C20B08-FBC5-49ED-BB6A-C03DB3C649E9}"/>
+                <a16:creationId xmlns:a16="http://schemas.microsoft.com/office/drawing/2014/main" id="{F17DF231-A856-4776-B963-80CBB4EB6BDF}"/>
               </a:ext>
             </a:extLst>
           </p:cNvPr>
@@ -11144,7 +11144,7 @@
           <p:cNvPr id="4" name="text">
             <a:extLst xmlns:a="http://schemas.openxmlformats.org/drawingml/2006/main">
               <a:ext uri="{FF2B5EF4-FFF2-40B4-BE49-F238E27FC236}">
-                <a16:creationId xmlns:a16="http://schemas.microsoft.com/office/drawing/2014/main" id="{1F30B0C3-1434-4642-B23C-826691CB0F3D}"/>
+                <a16:creationId xmlns:a16="http://schemas.microsoft.com/office/drawing/2014/main" id="{97668BB5-1830-458D-9FDF-5CE365529CA1}"/>
               </a:ext>
             </a:extLst>
           </p:cNvPr>
@@ -11202,7 +11202,7 @@
           <p:cNvPr id="5" name="close-accent">
             <a:extLst xmlns:a="http://schemas.openxmlformats.org/drawingml/2006/main">
               <a:ext uri="{FF2B5EF4-FFF2-40B4-BE49-F238E27FC236}">
-                <a16:creationId xmlns:a16="http://schemas.microsoft.com/office/drawing/2014/main" id="{6284AC9E-DBE7-4A82-987B-125F5C0EA8FC}"/>
+                <a16:creationId xmlns:a16="http://schemas.microsoft.com/office/drawing/2014/main" id="{8EF92DDD-82AE-425A-80A7-6DE4A1A7F8BF}"/>
               </a:ext>
             </a:extLst>
           </p:cNvPr>
@@ -11233,7 +11233,7 @@
           <p:cNvPr id="6" name="text">
             <a:extLst xmlns:a="http://schemas.openxmlformats.org/drawingml/2006/main">
               <a:ext uri="{FF2B5EF4-FFF2-40B4-BE49-F238E27FC236}">
-                <a16:creationId xmlns:a16="http://schemas.microsoft.com/office/drawing/2014/main" id="{E4F55FC9-B7CD-4CC6-A89F-47B43DA53775}"/>
+                <a16:creationId xmlns:a16="http://schemas.microsoft.com/office/drawing/2014/main" id="{902E3266-6C89-4C15-BD58-6E37217A2829}"/>
               </a:ext>
             </a:extLst>
           </p:cNvPr>
@@ -11291,7 +11291,7 @@
           <p:cNvPr id="7" name="pill-Spring Cloud">
             <a:extLst xmlns:a="http://schemas.openxmlformats.org/drawingml/2006/main">
               <a:ext uri="{FF2B5EF4-FFF2-40B4-BE49-F238E27FC236}">
-                <a16:creationId xmlns:a16="http://schemas.microsoft.com/office/drawing/2014/main" id="{F5F0D90E-FEF3-42E5-87BC-90CBDE88C29C}"/>
+                <a16:creationId xmlns:a16="http://schemas.microsoft.com/office/drawing/2014/main" id="{8DA399DB-1618-43BA-9DA6-01E427DD0C62}"/>
               </a:ext>
             </a:extLst>
           </p:cNvPr>
@@ -11324,7 +11324,7 @@
           <p:cNvPr id="8" name="pill-text-Spring Cloud">
             <a:extLst xmlns:a="http://schemas.openxmlformats.org/drawingml/2006/main">
               <a:ext uri="{FF2B5EF4-FFF2-40B4-BE49-F238E27FC236}">
-                <a16:creationId xmlns:a16="http://schemas.microsoft.com/office/drawing/2014/main" id="{03BF3AA8-2C2F-4700-9C04-0BA4C4565D8D}"/>
+                <a16:creationId xmlns:a16="http://schemas.microsoft.com/office/drawing/2014/main" id="{B2AB62D0-783D-4106-A7A2-6D3A5B1C856B}"/>
               </a:ext>
             </a:extLst>
           </p:cNvPr>
@@ -11382,7 +11382,7 @@
           <p:cNvPr id="9" name="pill-Vue 3">
             <a:extLst xmlns:a="http://schemas.openxmlformats.org/drawingml/2006/main">
               <a:ext uri="{FF2B5EF4-FFF2-40B4-BE49-F238E27FC236}">
-                <a16:creationId xmlns:a16="http://schemas.microsoft.com/office/drawing/2014/main" id="{6FA2E270-B56B-4390-9D2B-8FF0A524629E}"/>
+                <a16:creationId xmlns:a16="http://schemas.microsoft.com/office/drawing/2014/main" id="{7757B13B-BC66-41CD-9243-3FE2BE24A51A}"/>
               </a:ext>
             </a:extLst>
           </p:cNvPr>
@@ -11415,7 +11415,7 @@
           <p:cNvPr id="10" name="pill-text-Vue 3">
             <a:extLst xmlns:a="http://schemas.openxmlformats.org/drawingml/2006/main">
               <a:ext uri="{FF2B5EF4-FFF2-40B4-BE49-F238E27FC236}">
-                <a16:creationId xmlns:a16="http://schemas.microsoft.com/office/drawing/2014/main" id="{BBEE7012-6B84-4C12-870E-205B9A0F5854}"/>
+                <a16:creationId xmlns:a16="http://schemas.microsoft.com/office/drawing/2014/main" id="{19EDA701-5788-4B0F-867B-695E4813D62B}"/>
               </a:ext>
             </a:extLst>
           </p:cNvPr>
@@ -11473,7 +11473,7 @@
           <p:cNvPr id="11" name="pill-Redis">
             <a:extLst xmlns:a="http://schemas.openxmlformats.org/drawingml/2006/main">
               <a:ext uri="{FF2B5EF4-FFF2-40B4-BE49-F238E27FC236}">
-                <a16:creationId xmlns:a16="http://schemas.microsoft.com/office/drawing/2014/main" id="{3BA74B27-172B-426C-88CE-5E7EEA831F97}"/>
+                <a16:creationId xmlns:a16="http://schemas.microsoft.com/office/drawing/2014/main" id="{667826BA-D521-4CA6-9CB0-AEABEE3D20F4}"/>
               </a:ext>
             </a:extLst>
           </p:cNvPr>
@@ -11506,7 +11506,7 @@
           <p:cNvPr id="12" name="pill-text-Redis">
             <a:extLst xmlns:a="http://schemas.openxmlformats.org/drawingml/2006/main">
               <a:ext uri="{FF2B5EF4-FFF2-40B4-BE49-F238E27FC236}">
-                <a16:creationId xmlns:a16="http://schemas.microsoft.com/office/drawing/2014/main" id="{04E7B09D-D2BE-45E1-AA20-AEE925EFDDA7}"/>
+                <a16:creationId xmlns:a16="http://schemas.microsoft.com/office/drawing/2014/main" id="{1872B9F4-8B5B-4444-B648-26707962939A}"/>
               </a:ext>
             </a:extLst>
           </p:cNvPr>
@@ -11564,7 +11564,7 @@
           <p:cNvPr id="13" name="pill-RabbitMQ">
             <a:extLst xmlns:a="http://schemas.openxmlformats.org/drawingml/2006/main">
               <a:ext uri="{FF2B5EF4-FFF2-40B4-BE49-F238E27FC236}">
-                <a16:creationId xmlns:a16="http://schemas.microsoft.com/office/drawing/2014/main" id="{E4ABD399-EC02-4F02-A18C-501E2B7F5AD0}"/>
+                <a16:creationId xmlns:a16="http://schemas.microsoft.com/office/drawing/2014/main" id="{CCD5B01C-C076-4A85-A505-BB8929FBF79E}"/>
               </a:ext>
             </a:extLst>
           </p:cNvPr>
@@ -11597,7 +11597,7 @@
           <p:cNvPr id="14" name="pill-text-RabbitMQ">
             <a:extLst xmlns:a="http://schemas.openxmlformats.org/drawingml/2006/main">
               <a:ext uri="{FF2B5EF4-FFF2-40B4-BE49-F238E27FC236}">
-                <a16:creationId xmlns:a16="http://schemas.microsoft.com/office/drawing/2014/main" id="{E684BA2E-8F45-4811-8245-4EA729C0ED50}"/>
+                <a16:creationId xmlns:a16="http://schemas.microsoft.com/office/drawing/2014/main" id="{34509DE7-8CEE-4985-BD5C-F4077F1522D1}"/>
               </a:ext>
             </a:extLst>
           </p:cNvPr>
@@ -11653,7 +11653,7 @@
     </p:spTree>
     <p:extLst>
       <p:ext uri="{BB962C8B-B14F-4D97-AF65-F5344CB8AC3E}">
-        <p14:creationId xmlns:p14="http://schemas.microsoft.com/office/powerpoint/2010/main" val="346811199"/>
+        <p14:creationId xmlns:p14="http://schemas.microsoft.com/office/powerpoint/2010/main" val="24106289"/>
       </p:ext>
     </p:extLst>
   </p:cSld>
@@ -11684,7 +11684,7 @@
           <p:cNvPr id="1" name="eyebrow-2">
             <a:extLst xmlns:a="http://schemas.openxmlformats.org/drawingml/2006/main">
               <a:ext uri="{FF2B5EF4-FFF2-40B4-BE49-F238E27FC236}">
-                <a16:creationId xmlns:a16="http://schemas.microsoft.com/office/drawing/2014/main" id="{088275D0-8456-406B-8F46-F45C8653E8C9}"/>
+                <a16:creationId xmlns:a16="http://schemas.microsoft.com/office/drawing/2014/main" id="{4EB05F30-7D4C-4D70-82C9-BC1BED53EF7B}"/>
               </a:ext>
             </a:extLst>
           </p:cNvPr>
@@ -11742,7 +11742,7 @@
           <p:cNvPr id="2" name="slide-title-2">
             <a:extLst xmlns:a="http://schemas.openxmlformats.org/drawingml/2006/main">
               <a:ext uri="{FF2B5EF4-FFF2-40B4-BE49-F238E27FC236}">
-                <a16:creationId xmlns:a16="http://schemas.microsoft.com/office/drawing/2014/main" id="{32AE9D85-ABF4-4AF7-9FDB-12910528AD6B}"/>
+                <a16:creationId xmlns:a16="http://schemas.microsoft.com/office/drawing/2014/main" id="{EA624D6E-D3BC-4597-8593-0AC5D5D46D59}"/>
               </a:ext>
             </a:extLst>
           </p:cNvPr>
@@ -11800,7 +11800,7 @@
           <p:cNvPr id="3" name="title-rule-2">
             <a:extLst xmlns:a="http://schemas.openxmlformats.org/drawingml/2006/main">
               <a:ext uri="{FF2B5EF4-FFF2-40B4-BE49-F238E27FC236}">
-                <a16:creationId xmlns:a16="http://schemas.microsoft.com/office/drawing/2014/main" id="{ED51FBFA-560C-44B0-BA77-6B8A1BCC4257}"/>
+                <a16:creationId xmlns:a16="http://schemas.microsoft.com/office/drawing/2014/main" id="{08B40CFC-C4D5-4F3A-A04D-DDC304B727BB}"/>
               </a:ext>
             </a:extLst>
           </p:cNvPr>
@@ -11831,7 +11831,7 @@
           <p:cNvPr id="4" name="page-number-2">
             <a:extLst xmlns:a="http://schemas.openxmlformats.org/drawingml/2006/main">
               <a:ext uri="{FF2B5EF4-FFF2-40B4-BE49-F238E27FC236}">
-                <a16:creationId xmlns:a16="http://schemas.microsoft.com/office/drawing/2014/main" id="{5F73B3D3-CC9E-49A9-B1DF-27B45C2EB097}"/>
+                <a16:creationId xmlns:a16="http://schemas.microsoft.com/office/drawing/2014/main" id="{FD4265F7-B5F3-4739-AD33-83C9A0EFC712}"/>
               </a:ext>
             </a:extLst>
           </p:cNvPr>
@@ -11889,7 +11889,7 @@
           <p:cNvPr id="5" name="text">
             <a:extLst xmlns:a="http://schemas.openxmlformats.org/drawingml/2006/main">
               <a:ext uri="{FF2B5EF4-FFF2-40B4-BE49-F238E27FC236}">
-                <a16:creationId xmlns:a16="http://schemas.microsoft.com/office/drawing/2014/main" id="{49A582EE-C672-40F3-8E87-B9784F3F91A0}"/>
+                <a16:creationId xmlns:a16="http://schemas.microsoft.com/office/drawing/2014/main" id="{74782881-72B3-4971-85F0-A32D91FA2626}"/>
               </a:ext>
             </a:extLst>
           </p:cNvPr>
@@ -11947,7 +11947,7 @@
           <p:cNvPr id="6" name="text">
             <a:extLst xmlns:a="http://schemas.openxmlformats.org/drawingml/2006/main">
               <a:ext uri="{FF2B5EF4-FFF2-40B4-BE49-F238E27FC236}">
-                <a16:creationId xmlns:a16="http://schemas.microsoft.com/office/drawing/2014/main" id="{D3DBBD04-A097-4C3D-A984-5A8CFC1DBA8C}"/>
+                <a16:creationId xmlns:a16="http://schemas.microsoft.com/office/drawing/2014/main" id="{A92614D8-EA55-4B87-8410-7C962F08E748}"/>
               </a:ext>
             </a:extLst>
           </p:cNvPr>
@@ -12005,7 +12005,7 @@
           <p:cNvPr id="7" name="pill-可演示">
             <a:extLst xmlns:a="http://schemas.openxmlformats.org/drawingml/2006/main">
               <a:ext uri="{FF2B5EF4-FFF2-40B4-BE49-F238E27FC236}">
-                <a16:creationId xmlns:a16="http://schemas.microsoft.com/office/drawing/2014/main" id="{6D9A1772-0D8F-45CF-95E5-3E819D9253CF}"/>
+                <a16:creationId xmlns:a16="http://schemas.microsoft.com/office/drawing/2014/main" id="{314603E9-1E49-48B0-807A-FE9A37B26BB5}"/>
               </a:ext>
             </a:extLst>
           </p:cNvPr>
@@ -12038,7 +12038,7 @@
           <p:cNvPr id="8" name="pill-text-可演示">
             <a:extLst xmlns:a="http://schemas.openxmlformats.org/drawingml/2006/main">
               <a:ext uri="{FF2B5EF4-FFF2-40B4-BE49-F238E27FC236}">
-                <a16:creationId xmlns:a16="http://schemas.microsoft.com/office/drawing/2014/main" id="{9A8FF669-C964-4B3A-90BC-1CCD04094CAC}"/>
+                <a16:creationId xmlns:a16="http://schemas.microsoft.com/office/drawing/2014/main" id="{5E82FDA7-2CC9-4C29-ADB3-E9538F314CB7}"/>
               </a:ext>
             </a:extLst>
           </p:cNvPr>
@@ -12096,7 +12096,7 @@
           <p:cNvPr id="9" name="pill-可解释">
             <a:extLst xmlns:a="http://schemas.openxmlformats.org/drawingml/2006/main">
               <a:ext uri="{FF2B5EF4-FFF2-40B4-BE49-F238E27FC236}">
-                <a16:creationId xmlns:a16="http://schemas.microsoft.com/office/drawing/2014/main" id="{5D19743D-D63B-4341-A3A4-729CEA37A185}"/>
+                <a16:creationId xmlns:a16="http://schemas.microsoft.com/office/drawing/2014/main" id="{734F9203-90F5-4BEF-BC8B-6D009375AD71}"/>
               </a:ext>
             </a:extLst>
           </p:cNvPr>
@@ -12129,7 +12129,7 @@
           <p:cNvPr id="10" name="pill-text-可解释">
             <a:extLst xmlns:a="http://schemas.openxmlformats.org/drawingml/2006/main">
               <a:ext uri="{FF2B5EF4-FFF2-40B4-BE49-F238E27FC236}">
-                <a16:creationId xmlns:a16="http://schemas.microsoft.com/office/drawing/2014/main" id="{733029C5-4894-4D96-8D1F-B2C65008A0A6}"/>
+                <a16:creationId xmlns:a16="http://schemas.microsoft.com/office/drawing/2014/main" id="{FAD787A1-3C75-4B4A-A8F4-D368C635C3AE}"/>
               </a:ext>
             </a:extLst>
           </p:cNvPr>
@@ -12187,7 +12187,7 @@
           <p:cNvPr id="11" name="pill-可分工">
             <a:extLst xmlns:a="http://schemas.openxmlformats.org/drawingml/2006/main">
               <a:ext uri="{FF2B5EF4-FFF2-40B4-BE49-F238E27FC236}">
-                <a16:creationId xmlns:a16="http://schemas.microsoft.com/office/drawing/2014/main" id="{893D9B50-0D1D-4672-A77F-B716E6D109DF}"/>
+                <a16:creationId xmlns:a16="http://schemas.microsoft.com/office/drawing/2014/main" id="{054C5FFC-6765-4555-927F-BDAE854692E5}"/>
               </a:ext>
             </a:extLst>
           </p:cNvPr>
@@ -12220,7 +12220,7 @@
           <p:cNvPr id="12" name="pill-text-可分工">
             <a:extLst xmlns:a="http://schemas.openxmlformats.org/drawingml/2006/main">
               <a:ext uri="{FF2B5EF4-FFF2-40B4-BE49-F238E27FC236}">
-                <a16:creationId xmlns:a16="http://schemas.microsoft.com/office/drawing/2014/main" id="{EFE2387B-2F62-4713-A16D-B1E661E0CCEB}"/>
+                <a16:creationId xmlns:a16="http://schemas.microsoft.com/office/drawing/2014/main" id="{F1E9AD66-B9BC-4E50-9545-75641F96F6CF}"/>
               </a:ext>
             </a:extLst>
           </p:cNvPr>
@@ -12278,7 +12278,7 @@
           <p:cNvPr id="13" name="pain-0">
             <a:extLst xmlns:a="http://schemas.openxmlformats.org/drawingml/2006/main">
               <a:ext uri="{FF2B5EF4-FFF2-40B4-BE49-F238E27FC236}">
-                <a16:creationId xmlns:a16="http://schemas.microsoft.com/office/drawing/2014/main" id="{DC4AC86D-2D8D-4FAD-9602-E2F118EF71E1}"/>
+                <a16:creationId xmlns:a16="http://schemas.microsoft.com/office/drawing/2014/main" id="{6113BFDA-AC9D-42BF-B8E0-08979DF2CA83}"/>
               </a:ext>
             </a:extLst>
           </p:cNvPr>
@@ -12313,7 +12313,7 @@
           <p:cNvPr id="14" name="text">
             <a:extLst xmlns:a="http://schemas.openxmlformats.org/drawingml/2006/main">
               <a:ext uri="{FF2B5EF4-FFF2-40B4-BE49-F238E27FC236}">
-                <a16:creationId xmlns:a16="http://schemas.microsoft.com/office/drawing/2014/main" id="{D2496218-9C9D-4B38-A7BB-2F22BE7B4BA7}"/>
+                <a16:creationId xmlns:a16="http://schemas.microsoft.com/office/drawing/2014/main" id="{3E77318F-28C1-4F22-AECB-01AD92321443}"/>
               </a:ext>
             </a:extLst>
           </p:cNvPr>
@@ -12371,7 +12371,7 @@
           <p:cNvPr id="15" name="text">
             <a:extLst xmlns:a="http://schemas.openxmlformats.org/drawingml/2006/main">
               <a:ext uri="{FF2B5EF4-FFF2-40B4-BE49-F238E27FC236}">
-                <a16:creationId xmlns:a16="http://schemas.microsoft.com/office/drawing/2014/main" id="{37DDD38A-C4E0-4FA2-A072-E084E2717E9C}"/>
+                <a16:creationId xmlns:a16="http://schemas.microsoft.com/office/drawing/2014/main" id="{BEA5EE93-62CA-4263-ADAF-561BB98BDB7E}"/>
               </a:ext>
             </a:extLst>
           </p:cNvPr>
@@ -12429,7 +12429,7 @@
           <p:cNvPr id="16" name="text">
             <a:extLst xmlns:a="http://schemas.openxmlformats.org/drawingml/2006/main">
               <a:ext uri="{FF2B5EF4-FFF2-40B4-BE49-F238E27FC236}">
-                <a16:creationId xmlns:a16="http://schemas.microsoft.com/office/drawing/2014/main" id="{AE143005-896F-4233-AAB8-60FDEAD26425}"/>
+                <a16:creationId xmlns:a16="http://schemas.microsoft.com/office/drawing/2014/main" id="{42040397-7717-4221-924A-C517D7AAF8DD}"/>
               </a:ext>
             </a:extLst>
           </p:cNvPr>
@@ -12487,7 +12487,7 @@
           <p:cNvPr id="17" name="pain-1">
             <a:extLst xmlns:a="http://schemas.openxmlformats.org/drawingml/2006/main">
               <a:ext uri="{FF2B5EF4-FFF2-40B4-BE49-F238E27FC236}">
-                <a16:creationId xmlns:a16="http://schemas.microsoft.com/office/drawing/2014/main" id="{FBC50A52-1058-4F9D-825D-F2B5ABF1237F}"/>
+                <a16:creationId xmlns:a16="http://schemas.microsoft.com/office/drawing/2014/main" id="{6BEF74CC-073F-4BD8-B7D2-D25E8FA5B569}"/>
               </a:ext>
             </a:extLst>
           </p:cNvPr>
@@ -12522,7 +12522,7 @@
           <p:cNvPr id="18" name="text">
             <a:extLst xmlns:a="http://schemas.openxmlformats.org/drawingml/2006/main">
               <a:ext uri="{FF2B5EF4-FFF2-40B4-BE49-F238E27FC236}">
-                <a16:creationId xmlns:a16="http://schemas.microsoft.com/office/drawing/2014/main" id="{526416B7-7062-487A-96EB-4FC3F054FC2B}"/>
+                <a16:creationId xmlns:a16="http://schemas.microsoft.com/office/drawing/2014/main" id="{55C0FEFE-B1EB-4B20-BA46-0E3E1A3A1C79}"/>
               </a:ext>
             </a:extLst>
           </p:cNvPr>
@@ -12580,7 +12580,7 @@
           <p:cNvPr id="19" name="text">
             <a:extLst xmlns:a="http://schemas.openxmlformats.org/drawingml/2006/main">
               <a:ext uri="{FF2B5EF4-FFF2-40B4-BE49-F238E27FC236}">
-                <a16:creationId xmlns:a16="http://schemas.microsoft.com/office/drawing/2014/main" id="{7F4B88C4-B631-4E08-BB21-274EEF3E3893}"/>
+                <a16:creationId xmlns:a16="http://schemas.microsoft.com/office/drawing/2014/main" id="{F3658B31-27D9-4B3A-B73E-DE49D64087DC}"/>
               </a:ext>
             </a:extLst>
           </p:cNvPr>
@@ -12638,7 +12638,7 @@
           <p:cNvPr id="20" name="text">
             <a:extLst xmlns:a="http://schemas.openxmlformats.org/drawingml/2006/main">
               <a:ext uri="{FF2B5EF4-FFF2-40B4-BE49-F238E27FC236}">
-                <a16:creationId xmlns:a16="http://schemas.microsoft.com/office/drawing/2014/main" id="{A038A6C7-0962-453C-A036-5E05F9E0DBD5}"/>
+                <a16:creationId xmlns:a16="http://schemas.microsoft.com/office/drawing/2014/main" id="{BBB91F37-BF7F-4C48-A16E-69BE7CC448CB}"/>
               </a:ext>
             </a:extLst>
           </p:cNvPr>
@@ -12696,7 +12696,7 @@
           <p:cNvPr id="21" name="pain-2">
             <a:extLst xmlns:a="http://schemas.openxmlformats.org/drawingml/2006/main">
               <a:ext uri="{FF2B5EF4-FFF2-40B4-BE49-F238E27FC236}">
-                <a16:creationId xmlns:a16="http://schemas.microsoft.com/office/drawing/2014/main" id="{2BFD6DD4-1284-42FA-8AC6-94F8F99D2580}"/>
+                <a16:creationId xmlns:a16="http://schemas.microsoft.com/office/drawing/2014/main" id="{16EB8AB9-8629-453C-B5A1-8720C8F60171}"/>
               </a:ext>
             </a:extLst>
           </p:cNvPr>
@@ -12731,7 +12731,7 @@
           <p:cNvPr id="22" name="text">
             <a:extLst xmlns:a="http://schemas.openxmlformats.org/drawingml/2006/main">
               <a:ext uri="{FF2B5EF4-FFF2-40B4-BE49-F238E27FC236}">
-                <a16:creationId xmlns:a16="http://schemas.microsoft.com/office/drawing/2014/main" id="{657B155F-5AB5-42AD-B51E-2AC7D8A32A60}"/>
+                <a16:creationId xmlns:a16="http://schemas.microsoft.com/office/drawing/2014/main" id="{40ACE304-C175-470B-9197-7EF0DC1143D1}"/>
               </a:ext>
             </a:extLst>
           </p:cNvPr>
@@ -12789,7 +12789,7 @@
           <p:cNvPr id="23" name="text">
             <a:extLst xmlns:a="http://schemas.openxmlformats.org/drawingml/2006/main">
               <a:ext uri="{FF2B5EF4-FFF2-40B4-BE49-F238E27FC236}">
-                <a16:creationId xmlns:a16="http://schemas.microsoft.com/office/drawing/2014/main" id="{78C2B87E-F227-4AB1-B180-4F64EFEF8846}"/>
+                <a16:creationId xmlns:a16="http://schemas.microsoft.com/office/drawing/2014/main" id="{A4459F55-43D7-48A7-9445-04981224C891}"/>
               </a:ext>
             </a:extLst>
           </p:cNvPr>
@@ -12847,7 +12847,7 @@
           <p:cNvPr id="24" name="text">
             <a:extLst xmlns:a="http://schemas.openxmlformats.org/drawingml/2006/main">
               <a:ext uri="{FF2B5EF4-FFF2-40B4-BE49-F238E27FC236}">
-                <a16:creationId xmlns:a16="http://schemas.microsoft.com/office/drawing/2014/main" id="{39844C7C-24BE-4BD4-8530-5D09DDC93211}"/>
+                <a16:creationId xmlns:a16="http://schemas.microsoft.com/office/drawing/2014/main" id="{DCEDA3D6-36AF-4902-B86E-148F63D1594F}"/>
               </a:ext>
             </a:extLst>
           </p:cNvPr>
@@ -12903,7 +12903,7 @@
     </p:spTree>
     <p:extLst>
       <p:ext uri="{BB962C8B-B14F-4D97-AF65-F5344CB8AC3E}">
-        <p14:creationId xmlns:p14="http://schemas.microsoft.com/office/powerpoint/2010/main" val="1384905752"/>
+        <p14:creationId xmlns:p14="http://schemas.microsoft.com/office/powerpoint/2010/main" val="1439239938"/>
       </p:ext>
     </p:extLst>
   </p:cSld>
@@ -12934,7 +12934,7 @@
           <p:cNvPr id="1" name="eyebrow-3">
             <a:extLst xmlns:a="http://schemas.openxmlformats.org/drawingml/2006/main">
               <a:ext uri="{FF2B5EF4-FFF2-40B4-BE49-F238E27FC236}">
-                <a16:creationId xmlns:a16="http://schemas.microsoft.com/office/drawing/2014/main" id="{5739C469-ED22-401E-A719-36F576200666}"/>
+                <a16:creationId xmlns:a16="http://schemas.microsoft.com/office/drawing/2014/main" id="{D427D416-66B0-48F0-8215-19F12B7A17E2}"/>
               </a:ext>
             </a:extLst>
           </p:cNvPr>
@@ -12992,7 +12992,7 @@
           <p:cNvPr id="2" name="slide-title-3">
             <a:extLst xmlns:a="http://schemas.openxmlformats.org/drawingml/2006/main">
               <a:ext uri="{FF2B5EF4-FFF2-40B4-BE49-F238E27FC236}">
-                <a16:creationId xmlns:a16="http://schemas.microsoft.com/office/drawing/2014/main" id="{3AEDD966-919E-4691-8F9C-D5BA75494B93}"/>
+                <a16:creationId xmlns:a16="http://schemas.microsoft.com/office/drawing/2014/main" id="{00539AFD-59DA-4396-94C5-79C2947A2905}"/>
               </a:ext>
             </a:extLst>
           </p:cNvPr>
@@ -13050,7 +13050,7 @@
           <p:cNvPr id="3" name="title-rule-3">
             <a:extLst xmlns:a="http://schemas.openxmlformats.org/drawingml/2006/main">
               <a:ext uri="{FF2B5EF4-FFF2-40B4-BE49-F238E27FC236}">
-                <a16:creationId xmlns:a16="http://schemas.microsoft.com/office/drawing/2014/main" id="{B4D13BDA-6A87-48C6-A81E-8108B2DEA4B7}"/>
+                <a16:creationId xmlns:a16="http://schemas.microsoft.com/office/drawing/2014/main" id="{0C84CFFE-001F-4BA9-B9B0-91CC0ECC2BDE}"/>
               </a:ext>
             </a:extLst>
           </p:cNvPr>
@@ -13081,7 +13081,7 @@
           <p:cNvPr id="4" name="page-number-3">
             <a:extLst xmlns:a="http://schemas.openxmlformats.org/drawingml/2006/main">
               <a:ext uri="{FF2B5EF4-FFF2-40B4-BE49-F238E27FC236}">
-                <a16:creationId xmlns:a16="http://schemas.microsoft.com/office/drawing/2014/main" id="{5939AEEF-49F6-40A6-A514-A5DB5A20728B}"/>
+                <a16:creationId xmlns:a16="http://schemas.microsoft.com/office/drawing/2014/main" id="{500BF4CA-CFED-4D4D-9483-452D0122F4F1}"/>
               </a:ext>
             </a:extLst>
           </p:cNvPr>
@@ -13139,7 +13139,7 @@
           <p:cNvPr id="5" name="loop-0">
             <a:extLst xmlns:a="http://schemas.openxmlformats.org/drawingml/2006/main">
               <a:ext uri="{FF2B5EF4-FFF2-40B4-BE49-F238E27FC236}">
-                <a16:creationId xmlns:a16="http://schemas.microsoft.com/office/drawing/2014/main" id="{7E8C2C2D-C4ED-42A1-A339-9AFFFC83A2A5}"/>
+                <a16:creationId xmlns:a16="http://schemas.microsoft.com/office/drawing/2014/main" id="{2D26F5B9-2665-4777-9DC5-6B2F60BE52CA}"/>
               </a:ext>
             </a:extLst>
           </p:cNvPr>
@@ -13174,7 +13174,7 @@
           <p:cNvPr id="6" name="text">
             <a:extLst xmlns:a="http://schemas.openxmlformats.org/drawingml/2006/main">
               <a:ext uri="{FF2B5EF4-FFF2-40B4-BE49-F238E27FC236}">
-                <a16:creationId xmlns:a16="http://schemas.microsoft.com/office/drawing/2014/main" id="{477C8EB3-E169-4F66-B83A-D9481506200E}"/>
+                <a16:creationId xmlns:a16="http://schemas.microsoft.com/office/drawing/2014/main" id="{4BB4C499-7F9C-4E88-BE63-470F73AF5B19}"/>
               </a:ext>
             </a:extLst>
           </p:cNvPr>
@@ -13232,7 +13232,7 @@
           <p:cNvPr id="7" name="text">
             <a:extLst xmlns:a="http://schemas.openxmlformats.org/drawingml/2006/main">
               <a:ext uri="{FF2B5EF4-FFF2-40B4-BE49-F238E27FC236}">
-                <a16:creationId xmlns:a16="http://schemas.microsoft.com/office/drawing/2014/main" id="{76A7B398-083B-4482-B1C0-D170937CD55F}"/>
+                <a16:creationId xmlns:a16="http://schemas.microsoft.com/office/drawing/2014/main" id="{362AD693-31ED-4BC9-997E-A588AF307CFC}"/>
               </a:ext>
             </a:extLst>
           </p:cNvPr>
@@ -13290,7 +13290,7 @@
           <p:cNvPr id="8" name="text">
             <a:extLst xmlns:a="http://schemas.openxmlformats.org/drawingml/2006/main">
               <a:ext uri="{FF2B5EF4-FFF2-40B4-BE49-F238E27FC236}">
-                <a16:creationId xmlns:a16="http://schemas.microsoft.com/office/drawing/2014/main" id="{8361070B-0FE6-4629-9455-42FF88E8F4DE}"/>
+                <a16:creationId xmlns:a16="http://schemas.microsoft.com/office/drawing/2014/main" id="{2CF12315-2343-4995-815F-FC16B8049E98}"/>
               </a:ext>
             </a:extLst>
           </p:cNvPr>
@@ -13348,7 +13348,7 @@
           <p:cNvPr id="9" name="arrow">
             <a:extLst xmlns:a="http://schemas.openxmlformats.org/drawingml/2006/main">
               <a:ext uri="{FF2B5EF4-FFF2-40B4-BE49-F238E27FC236}">
-                <a16:creationId xmlns:a16="http://schemas.microsoft.com/office/drawing/2014/main" id="{FA898550-4F97-4EAD-AE01-077BB89FBAF0}"/>
+                <a16:creationId xmlns:a16="http://schemas.microsoft.com/office/drawing/2014/main" id="{297946F5-4E7B-4816-B262-9F95ADFF06D2}"/>
               </a:ext>
             </a:extLst>
           </p:cNvPr>
@@ -13406,7 +13406,7 @@
           <p:cNvPr id="10" name="loop-1">
             <a:extLst xmlns:a="http://schemas.openxmlformats.org/drawingml/2006/main">
               <a:ext uri="{FF2B5EF4-FFF2-40B4-BE49-F238E27FC236}">
-                <a16:creationId xmlns:a16="http://schemas.microsoft.com/office/drawing/2014/main" id="{91317720-E127-4EB3-A22C-002281F25860}"/>
+                <a16:creationId xmlns:a16="http://schemas.microsoft.com/office/drawing/2014/main" id="{2C8FBF45-3EE0-48EB-B00D-88B31047DB9F}"/>
               </a:ext>
             </a:extLst>
           </p:cNvPr>
@@ -13441,7 +13441,7 @@
           <p:cNvPr id="11" name="text">
             <a:extLst xmlns:a="http://schemas.openxmlformats.org/drawingml/2006/main">
               <a:ext uri="{FF2B5EF4-FFF2-40B4-BE49-F238E27FC236}">
-                <a16:creationId xmlns:a16="http://schemas.microsoft.com/office/drawing/2014/main" id="{D789E025-02F6-4E8B-9946-DF4DA6704A29}"/>
+                <a16:creationId xmlns:a16="http://schemas.microsoft.com/office/drawing/2014/main" id="{D135B618-4F32-456B-9523-2CD114CACC6B}"/>
               </a:ext>
             </a:extLst>
           </p:cNvPr>
@@ -13499,7 +13499,7 @@
           <p:cNvPr id="12" name="text">
             <a:extLst xmlns:a="http://schemas.openxmlformats.org/drawingml/2006/main">
               <a:ext uri="{FF2B5EF4-FFF2-40B4-BE49-F238E27FC236}">
-                <a16:creationId xmlns:a16="http://schemas.microsoft.com/office/drawing/2014/main" id="{5D5A501E-0F91-405D-ACE1-EFBBDD7DF6C6}"/>
+                <a16:creationId xmlns:a16="http://schemas.microsoft.com/office/drawing/2014/main" id="{A7990CC0-F6E8-4934-9D53-CB2FE5AC46C0}"/>
               </a:ext>
             </a:extLst>
           </p:cNvPr>
@@ -13557,7 +13557,7 @@
           <p:cNvPr id="13" name="text">
             <a:extLst xmlns:a="http://schemas.openxmlformats.org/drawingml/2006/main">
               <a:ext uri="{FF2B5EF4-FFF2-40B4-BE49-F238E27FC236}">
-                <a16:creationId xmlns:a16="http://schemas.microsoft.com/office/drawing/2014/main" id="{F09B5680-A99C-41BA-9428-002AAFED22F7}"/>
+                <a16:creationId xmlns:a16="http://schemas.microsoft.com/office/drawing/2014/main" id="{B6A4FEC8-B325-4AF4-A94B-A04DBF854F00}"/>
               </a:ext>
             </a:extLst>
           </p:cNvPr>
@@ -13615,7 +13615,7 @@
           <p:cNvPr id="14" name="arrow">
             <a:extLst xmlns:a="http://schemas.openxmlformats.org/drawingml/2006/main">
               <a:ext uri="{FF2B5EF4-FFF2-40B4-BE49-F238E27FC236}">
-                <a16:creationId xmlns:a16="http://schemas.microsoft.com/office/drawing/2014/main" id="{6A64CF60-0F38-4F71-9E5C-83C3B11ECC43}"/>
+                <a16:creationId xmlns:a16="http://schemas.microsoft.com/office/drawing/2014/main" id="{594E3E02-DF29-43EC-B336-E826EC06A75D}"/>
               </a:ext>
             </a:extLst>
           </p:cNvPr>
@@ -13673,7 +13673,7 @@
           <p:cNvPr id="15" name="loop-2">
             <a:extLst xmlns:a="http://schemas.openxmlformats.org/drawingml/2006/main">
               <a:ext uri="{FF2B5EF4-FFF2-40B4-BE49-F238E27FC236}">
-                <a16:creationId xmlns:a16="http://schemas.microsoft.com/office/drawing/2014/main" id="{D1889FCA-1000-43ED-A9F6-6313D8583EAB}"/>
+                <a16:creationId xmlns:a16="http://schemas.microsoft.com/office/drawing/2014/main" id="{DE8379C7-8716-4BB4-A56C-A22FA087F3B6}"/>
               </a:ext>
             </a:extLst>
           </p:cNvPr>
@@ -13708,7 +13708,7 @@
           <p:cNvPr id="16" name="text">
             <a:extLst xmlns:a="http://schemas.openxmlformats.org/drawingml/2006/main">
               <a:ext uri="{FF2B5EF4-FFF2-40B4-BE49-F238E27FC236}">
-                <a16:creationId xmlns:a16="http://schemas.microsoft.com/office/drawing/2014/main" id="{D9F01555-1C93-4125-8701-DF544DE6A497}"/>
+                <a16:creationId xmlns:a16="http://schemas.microsoft.com/office/drawing/2014/main" id="{78B745B5-3CAA-4200-A6C2-C3B5B206B337}"/>
               </a:ext>
             </a:extLst>
           </p:cNvPr>
@@ -13766,7 +13766,7 @@
           <p:cNvPr id="17" name="text">
             <a:extLst xmlns:a="http://schemas.openxmlformats.org/drawingml/2006/main">
               <a:ext uri="{FF2B5EF4-FFF2-40B4-BE49-F238E27FC236}">
-                <a16:creationId xmlns:a16="http://schemas.microsoft.com/office/drawing/2014/main" id="{91AE5F7D-C798-4A0F-AF94-7DAC955949BC}"/>
+                <a16:creationId xmlns:a16="http://schemas.microsoft.com/office/drawing/2014/main" id="{6A0DAD5C-AACB-4246-B6A1-069A6E2F81B4}"/>
               </a:ext>
             </a:extLst>
           </p:cNvPr>
@@ -13824,7 +13824,7 @@
           <p:cNvPr id="18" name="text">
             <a:extLst xmlns:a="http://schemas.openxmlformats.org/drawingml/2006/main">
               <a:ext uri="{FF2B5EF4-FFF2-40B4-BE49-F238E27FC236}">
-                <a16:creationId xmlns:a16="http://schemas.microsoft.com/office/drawing/2014/main" id="{AB3FDD43-D023-4A42-8DD3-12B4670ECEBC}"/>
+                <a16:creationId xmlns:a16="http://schemas.microsoft.com/office/drawing/2014/main" id="{EAC6FE56-EF48-49BC-832D-0C569B750F05}"/>
               </a:ext>
             </a:extLst>
           </p:cNvPr>
@@ -13882,7 +13882,7 @@
           <p:cNvPr id="19" name="arrow">
             <a:extLst xmlns:a="http://schemas.openxmlformats.org/drawingml/2006/main">
               <a:ext uri="{FF2B5EF4-FFF2-40B4-BE49-F238E27FC236}">
-                <a16:creationId xmlns:a16="http://schemas.microsoft.com/office/drawing/2014/main" id="{2FEB8FBF-140A-453C-871A-5E4E4A407717}"/>
+                <a16:creationId xmlns:a16="http://schemas.microsoft.com/office/drawing/2014/main" id="{93CBF8EC-FFD3-46D1-82AB-71E7AA41CC91}"/>
               </a:ext>
             </a:extLst>
           </p:cNvPr>
@@ -13940,7 +13940,7 @@
           <p:cNvPr id="20" name="loop-3">
             <a:extLst xmlns:a="http://schemas.openxmlformats.org/drawingml/2006/main">
               <a:ext uri="{FF2B5EF4-FFF2-40B4-BE49-F238E27FC236}">
-                <a16:creationId xmlns:a16="http://schemas.microsoft.com/office/drawing/2014/main" id="{34346C90-C93F-4020-A00A-E758F0A4ABE1}"/>
+                <a16:creationId xmlns:a16="http://schemas.microsoft.com/office/drawing/2014/main" id="{C3188F54-653B-4286-BC37-23D65AB640E1}"/>
               </a:ext>
             </a:extLst>
           </p:cNvPr>
@@ -13975,7 +13975,7 @@
           <p:cNvPr id="21" name="text">
             <a:extLst xmlns:a="http://schemas.openxmlformats.org/drawingml/2006/main">
               <a:ext uri="{FF2B5EF4-FFF2-40B4-BE49-F238E27FC236}">
-                <a16:creationId xmlns:a16="http://schemas.microsoft.com/office/drawing/2014/main" id="{F76FAA7D-EB5B-4BB4-A2B6-FF89899F4595}"/>
+                <a16:creationId xmlns:a16="http://schemas.microsoft.com/office/drawing/2014/main" id="{D3A69E04-D87D-47D3-955E-DAB3CE9CFC77}"/>
               </a:ext>
             </a:extLst>
           </p:cNvPr>
@@ -14033,7 +14033,7 @@
           <p:cNvPr id="22" name="text">
             <a:extLst xmlns:a="http://schemas.openxmlformats.org/drawingml/2006/main">
               <a:ext uri="{FF2B5EF4-FFF2-40B4-BE49-F238E27FC236}">
-                <a16:creationId xmlns:a16="http://schemas.microsoft.com/office/drawing/2014/main" id="{0855B55C-DB57-4D98-B384-989A31109046}"/>
+                <a16:creationId xmlns:a16="http://schemas.microsoft.com/office/drawing/2014/main" id="{AC64F5FA-40EE-4BBE-B35C-C4FB6AD43D6D}"/>
               </a:ext>
             </a:extLst>
           </p:cNvPr>
@@ -14091,7 +14091,7 @@
           <p:cNvPr id="23" name="text">
             <a:extLst xmlns:a="http://schemas.openxmlformats.org/drawingml/2006/main">
               <a:ext uri="{FF2B5EF4-FFF2-40B4-BE49-F238E27FC236}">
-                <a16:creationId xmlns:a16="http://schemas.microsoft.com/office/drawing/2014/main" id="{E0D3BA6F-7AB7-4385-92E0-EECD305DFA45}"/>
+                <a16:creationId xmlns:a16="http://schemas.microsoft.com/office/drawing/2014/main" id="{256A8355-96D8-4E88-8B08-7E0FE9888057}"/>
               </a:ext>
             </a:extLst>
           </p:cNvPr>
@@ -14149,7 +14149,7 @@
           <p:cNvPr id="24" name="arrow">
             <a:extLst xmlns:a="http://schemas.openxmlformats.org/drawingml/2006/main">
               <a:ext uri="{FF2B5EF4-FFF2-40B4-BE49-F238E27FC236}">
-                <a16:creationId xmlns:a16="http://schemas.microsoft.com/office/drawing/2014/main" id="{1FEAE618-FA6D-4FD3-BD3D-7D464F25E505}"/>
+                <a16:creationId xmlns:a16="http://schemas.microsoft.com/office/drawing/2014/main" id="{390B58E6-2738-49AD-AF71-1FDA3547C6ED}"/>
               </a:ext>
             </a:extLst>
           </p:cNvPr>
@@ -14207,7 +14207,7 @@
           <p:cNvPr id="25" name="loop-4">
             <a:extLst xmlns:a="http://schemas.openxmlformats.org/drawingml/2006/main">
               <a:ext uri="{FF2B5EF4-FFF2-40B4-BE49-F238E27FC236}">
-                <a16:creationId xmlns:a16="http://schemas.microsoft.com/office/drawing/2014/main" id="{547B7DA9-CCF4-4C47-913F-4279FD8AF710}"/>
+                <a16:creationId xmlns:a16="http://schemas.microsoft.com/office/drawing/2014/main" id="{30559721-3100-4285-8C35-18CFDCC1A442}"/>
               </a:ext>
             </a:extLst>
           </p:cNvPr>
@@ -14242,7 +14242,7 @@
           <p:cNvPr id="26" name="text">
             <a:extLst xmlns:a="http://schemas.openxmlformats.org/drawingml/2006/main">
               <a:ext uri="{FF2B5EF4-FFF2-40B4-BE49-F238E27FC236}">
-                <a16:creationId xmlns:a16="http://schemas.microsoft.com/office/drawing/2014/main" id="{2FF596BC-E73A-4DE3-989A-22DD5F6933EC}"/>
+                <a16:creationId xmlns:a16="http://schemas.microsoft.com/office/drawing/2014/main" id="{474324DB-A247-4CC8-8DF5-AC64BCBAEE0B}"/>
               </a:ext>
             </a:extLst>
           </p:cNvPr>
@@ -14300,7 +14300,7 @@
           <p:cNvPr id="27" name="text">
             <a:extLst xmlns:a="http://schemas.openxmlformats.org/drawingml/2006/main">
               <a:ext uri="{FF2B5EF4-FFF2-40B4-BE49-F238E27FC236}">
-                <a16:creationId xmlns:a16="http://schemas.microsoft.com/office/drawing/2014/main" id="{AF926B48-E84C-4B63-A389-179AB1077E4D}"/>
+                <a16:creationId xmlns:a16="http://schemas.microsoft.com/office/drawing/2014/main" id="{FF2C2802-F612-4650-9E59-AB34C0EA1FFF}"/>
               </a:ext>
             </a:extLst>
           </p:cNvPr>
@@ -14358,7 +14358,7 @@
           <p:cNvPr id="28" name="text">
             <a:extLst xmlns:a="http://schemas.openxmlformats.org/drawingml/2006/main">
               <a:ext uri="{FF2B5EF4-FFF2-40B4-BE49-F238E27FC236}">
-                <a16:creationId xmlns:a16="http://schemas.microsoft.com/office/drawing/2014/main" id="{BC31A600-95F3-4D3F-899A-DD9488C8D803}"/>
+                <a16:creationId xmlns:a16="http://schemas.microsoft.com/office/drawing/2014/main" id="{A1553773-D7A7-4572-8094-A79D9DEBAC2A}"/>
               </a:ext>
             </a:extLst>
           </p:cNvPr>
@@ -14416,7 +14416,7 @@
           <p:cNvPr id="29" name="arrow">
             <a:extLst xmlns:a="http://schemas.openxmlformats.org/drawingml/2006/main">
               <a:ext uri="{FF2B5EF4-FFF2-40B4-BE49-F238E27FC236}">
-                <a16:creationId xmlns:a16="http://schemas.microsoft.com/office/drawing/2014/main" id="{9E7918DD-F661-458A-8A4D-42F2BCA5EB31}"/>
+                <a16:creationId xmlns:a16="http://schemas.microsoft.com/office/drawing/2014/main" id="{689A306C-0F65-4A7A-B451-521C6712293A}"/>
               </a:ext>
             </a:extLst>
           </p:cNvPr>
@@ -14474,7 +14474,7 @@
           <p:cNvPr id="30" name="loop-5">
             <a:extLst xmlns:a="http://schemas.openxmlformats.org/drawingml/2006/main">
               <a:ext uri="{FF2B5EF4-FFF2-40B4-BE49-F238E27FC236}">
-                <a16:creationId xmlns:a16="http://schemas.microsoft.com/office/drawing/2014/main" id="{5CDBAF21-9B21-4F8C-93BB-BAE2E81736DE}"/>
+                <a16:creationId xmlns:a16="http://schemas.microsoft.com/office/drawing/2014/main" id="{FB6556E2-2F30-485E-898F-70136FE82166}"/>
               </a:ext>
             </a:extLst>
           </p:cNvPr>
@@ -14509,7 +14509,7 @@
           <p:cNvPr id="31" name="text">
             <a:extLst xmlns:a="http://schemas.openxmlformats.org/drawingml/2006/main">
               <a:ext uri="{FF2B5EF4-FFF2-40B4-BE49-F238E27FC236}">
-                <a16:creationId xmlns:a16="http://schemas.microsoft.com/office/drawing/2014/main" id="{9E2E218E-309E-4A4B-9776-E96E3A63E016}"/>
+                <a16:creationId xmlns:a16="http://schemas.microsoft.com/office/drawing/2014/main" id="{8C6DCAF1-52D2-4A6F-A958-ABD52644147D}"/>
               </a:ext>
             </a:extLst>
           </p:cNvPr>
@@ -14567,7 +14567,7 @@
           <p:cNvPr id="32" name="text">
             <a:extLst xmlns:a="http://schemas.openxmlformats.org/drawingml/2006/main">
               <a:ext uri="{FF2B5EF4-FFF2-40B4-BE49-F238E27FC236}">
-                <a16:creationId xmlns:a16="http://schemas.microsoft.com/office/drawing/2014/main" id="{066EEB30-21FB-4D09-830C-D6C7E01F6E58}"/>
+                <a16:creationId xmlns:a16="http://schemas.microsoft.com/office/drawing/2014/main" id="{DCA71AA0-1B4B-425F-96B6-FF2E541ECDFB}"/>
               </a:ext>
             </a:extLst>
           </p:cNvPr>
@@ -14625,7 +14625,7 @@
           <p:cNvPr id="33" name="text">
             <a:extLst xmlns:a="http://schemas.openxmlformats.org/drawingml/2006/main">
               <a:ext uri="{FF2B5EF4-FFF2-40B4-BE49-F238E27FC236}">
-                <a16:creationId xmlns:a16="http://schemas.microsoft.com/office/drawing/2014/main" id="{4449CB89-A6E4-4ABD-839D-F292F107380B}"/>
+                <a16:creationId xmlns:a16="http://schemas.microsoft.com/office/drawing/2014/main" id="{FABE8223-EF33-48FE-B74B-08D22E1BAC01}"/>
               </a:ext>
             </a:extLst>
           </p:cNvPr>
@@ -14683,7 +14683,7 @@
           <p:cNvPr id="34" name="text">
             <a:extLst xmlns:a="http://schemas.openxmlformats.org/drawingml/2006/main">
               <a:ext uri="{FF2B5EF4-FFF2-40B4-BE49-F238E27FC236}">
-                <a16:creationId xmlns:a16="http://schemas.microsoft.com/office/drawing/2014/main" id="{A8AD3ABD-4287-42C1-A5C0-35356F89CB96}"/>
+                <a16:creationId xmlns:a16="http://schemas.microsoft.com/office/drawing/2014/main" id="{75C4DFD7-C752-4664-A2E8-A11EDDD9D07B}"/>
               </a:ext>
             </a:extLst>
           </p:cNvPr>
@@ -14741,7 +14741,7 @@
           <p:cNvPr id="35" name="text">
             <a:extLst xmlns:a="http://schemas.openxmlformats.org/drawingml/2006/main">
               <a:ext uri="{FF2B5EF4-FFF2-40B4-BE49-F238E27FC236}">
-                <a16:creationId xmlns:a16="http://schemas.microsoft.com/office/drawing/2014/main" id="{41774052-DD09-42A5-BFF8-3491BC3F227C}"/>
+                <a16:creationId xmlns:a16="http://schemas.microsoft.com/office/drawing/2014/main" id="{B9AF53C6-3108-492E-BFB7-5D81E68A5C50}"/>
               </a:ext>
             </a:extLst>
           </p:cNvPr>
@@ -14797,7 +14797,7 @@
     </p:spTree>
     <p:extLst>
       <p:ext uri="{BB962C8B-B14F-4D97-AF65-F5344CB8AC3E}">
-        <p14:creationId xmlns:p14="http://schemas.microsoft.com/office/powerpoint/2010/main" val="1356738715"/>
+        <p14:creationId xmlns:p14="http://schemas.microsoft.com/office/powerpoint/2010/main" val="697677308"/>
       </p:ext>
     </p:extLst>
   </p:cSld>
@@ -14828,7 +14828,7 @@
           <p:cNvPr id="1" name="eyebrow-4">
             <a:extLst xmlns:a="http://schemas.openxmlformats.org/drawingml/2006/main">
               <a:ext uri="{FF2B5EF4-FFF2-40B4-BE49-F238E27FC236}">
-                <a16:creationId xmlns:a16="http://schemas.microsoft.com/office/drawing/2014/main" id="{51444706-8F89-46B2-9271-ADCF78108980}"/>
+                <a16:creationId xmlns:a16="http://schemas.microsoft.com/office/drawing/2014/main" id="{EE450B8F-6C67-4B80-A4DB-AF4BC3432DDF}"/>
               </a:ext>
             </a:extLst>
           </p:cNvPr>
@@ -14886,7 +14886,7 @@
           <p:cNvPr id="2" name="slide-title-4">
             <a:extLst xmlns:a="http://schemas.openxmlformats.org/drawingml/2006/main">
               <a:ext uri="{FF2B5EF4-FFF2-40B4-BE49-F238E27FC236}">
-                <a16:creationId xmlns:a16="http://schemas.microsoft.com/office/drawing/2014/main" id="{C6F4C125-09B3-41D5-B901-DFCD484D03EA}"/>
+                <a16:creationId xmlns:a16="http://schemas.microsoft.com/office/drawing/2014/main" id="{70EC4141-0681-4E7E-B3A5-05664BBBE11B}"/>
               </a:ext>
             </a:extLst>
           </p:cNvPr>
@@ -14944,7 +14944,7 @@
           <p:cNvPr id="3" name="title-rule-4">
             <a:extLst xmlns:a="http://schemas.openxmlformats.org/drawingml/2006/main">
               <a:ext uri="{FF2B5EF4-FFF2-40B4-BE49-F238E27FC236}">
-                <a16:creationId xmlns:a16="http://schemas.microsoft.com/office/drawing/2014/main" id="{53D88DBC-3613-439C-B58F-B52A625E6713}"/>
+                <a16:creationId xmlns:a16="http://schemas.microsoft.com/office/drawing/2014/main" id="{D1AF232A-7E3E-4112-A603-228075B8C383}"/>
               </a:ext>
             </a:extLst>
           </p:cNvPr>
@@ -14975,7 +14975,7 @@
           <p:cNvPr id="4" name="page-number-4">
             <a:extLst xmlns:a="http://schemas.openxmlformats.org/drawingml/2006/main">
               <a:ext uri="{FF2B5EF4-FFF2-40B4-BE49-F238E27FC236}">
-                <a16:creationId xmlns:a16="http://schemas.microsoft.com/office/drawing/2014/main" id="{57F05E0C-29D3-406C-84C3-1AF00C0BAD8C}"/>
+                <a16:creationId xmlns:a16="http://schemas.microsoft.com/office/drawing/2014/main" id="{29C657C1-8AED-499F-AFBB-C917BA00D4AA}"/>
               </a:ext>
             </a:extLst>
           </p:cNvPr>
@@ -15033,7 +15033,7 @@
           <p:cNvPr id="5" name="stack-0">
             <a:extLst xmlns:a="http://schemas.openxmlformats.org/drawingml/2006/main">
               <a:ext uri="{FF2B5EF4-FFF2-40B4-BE49-F238E27FC236}">
-                <a16:creationId xmlns:a16="http://schemas.microsoft.com/office/drawing/2014/main" id="{AEDC15EF-91C1-4566-9211-09E070AB7991}"/>
+                <a16:creationId xmlns:a16="http://schemas.microsoft.com/office/drawing/2014/main" id="{77639DD1-70D9-473A-923E-254394002332}"/>
               </a:ext>
             </a:extLst>
           </p:cNvPr>
@@ -15068,7 +15068,7 @@
           <p:cNvPr id="6" name="stack-accent-0">
             <a:extLst xmlns:a="http://schemas.openxmlformats.org/drawingml/2006/main">
               <a:ext uri="{FF2B5EF4-FFF2-40B4-BE49-F238E27FC236}">
-                <a16:creationId xmlns:a16="http://schemas.microsoft.com/office/drawing/2014/main" id="{99099C54-DF11-4B7C-BFCA-96C47B98EAAA}"/>
+                <a16:creationId xmlns:a16="http://schemas.microsoft.com/office/drawing/2014/main" id="{CC2E52D5-5216-44A7-9D12-22853A5C864B}"/>
               </a:ext>
             </a:extLst>
           </p:cNvPr>
@@ -15099,7 +15099,7 @@
           <p:cNvPr id="7" name="text">
             <a:extLst xmlns:a="http://schemas.openxmlformats.org/drawingml/2006/main">
               <a:ext uri="{FF2B5EF4-FFF2-40B4-BE49-F238E27FC236}">
-                <a16:creationId xmlns:a16="http://schemas.microsoft.com/office/drawing/2014/main" id="{AC0E7CF9-36FE-4328-9935-9D64833AB84E}"/>
+                <a16:creationId xmlns:a16="http://schemas.microsoft.com/office/drawing/2014/main" id="{71CB9F8D-346A-4122-9416-649F4666CFA9}"/>
               </a:ext>
             </a:extLst>
           </p:cNvPr>
@@ -15157,7 +15157,7 @@
           <p:cNvPr id="8" name="text">
             <a:extLst xmlns:a="http://schemas.openxmlformats.org/drawingml/2006/main">
               <a:ext uri="{FF2B5EF4-FFF2-40B4-BE49-F238E27FC236}">
-                <a16:creationId xmlns:a16="http://schemas.microsoft.com/office/drawing/2014/main" id="{C37A4317-71CC-40D1-8DB0-A8978881B6BD}"/>
+                <a16:creationId xmlns:a16="http://schemas.microsoft.com/office/drawing/2014/main" id="{02CD25C8-E918-4EFC-8627-263BAB8E136D}"/>
               </a:ext>
             </a:extLst>
           </p:cNvPr>
@@ -15215,7 +15215,7 @@
           <p:cNvPr id="9" name="text">
             <a:extLst xmlns:a="http://schemas.openxmlformats.org/drawingml/2006/main">
               <a:ext uri="{FF2B5EF4-FFF2-40B4-BE49-F238E27FC236}">
-                <a16:creationId xmlns:a16="http://schemas.microsoft.com/office/drawing/2014/main" id="{6A864DD2-FFF2-4276-9179-4AF848CA5B8C}"/>
+                <a16:creationId xmlns:a16="http://schemas.microsoft.com/office/drawing/2014/main" id="{C7BB0C8E-D8E5-4920-A4E0-EB383E95ED80}"/>
               </a:ext>
             </a:extLst>
           </p:cNvPr>
@@ -15273,7 +15273,7 @@
           <p:cNvPr id="10" name="stack-1">
             <a:extLst xmlns:a="http://schemas.openxmlformats.org/drawingml/2006/main">
               <a:ext uri="{FF2B5EF4-FFF2-40B4-BE49-F238E27FC236}">
-                <a16:creationId xmlns:a16="http://schemas.microsoft.com/office/drawing/2014/main" id="{2796F496-033A-478C-BE74-397C08E46570}"/>
+                <a16:creationId xmlns:a16="http://schemas.microsoft.com/office/drawing/2014/main" id="{2B5317BC-7484-4CEA-8543-980ABE863C4B}"/>
               </a:ext>
             </a:extLst>
           </p:cNvPr>
@@ -15308,7 +15308,7 @@
           <p:cNvPr id="11" name="stack-accent-1">
             <a:extLst xmlns:a="http://schemas.openxmlformats.org/drawingml/2006/main">
               <a:ext uri="{FF2B5EF4-FFF2-40B4-BE49-F238E27FC236}">
-                <a16:creationId xmlns:a16="http://schemas.microsoft.com/office/drawing/2014/main" id="{BDF894A3-768F-4DD9-B820-F18AD4E9E46B}"/>
+                <a16:creationId xmlns:a16="http://schemas.microsoft.com/office/drawing/2014/main" id="{3A0F1EEB-844F-4B2E-B89C-04D80C5FDC3F}"/>
               </a:ext>
             </a:extLst>
           </p:cNvPr>
@@ -15339,7 +15339,7 @@
           <p:cNvPr id="12" name="text">
             <a:extLst xmlns:a="http://schemas.openxmlformats.org/drawingml/2006/main">
               <a:ext uri="{FF2B5EF4-FFF2-40B4-BE49-F238E27FC236}">
-                <a16:creationId xmlns:a16="http://schemas.microsoft.com/office/drawing/2014/main" id="{9DA2A312-87CE-4ABE-86C9-3BCBC7737100}"/>
+                <a16:creationId xmlns:a16="http://schemas.microsoft.com/office/drawing/2014/main" id="{34461180-3EE4-4CC8-A9D6-093E994064A4}"/>
               </a:ext>
             </a:extLst>
           </p:cNvPr>
@@ -15397,7 +15397,7 @@
           <p:cNvPr id="13" name="text">
             <a:extLst xmlns:a="http://schemas.openxmlformats.org/drawingml/2006/main">
               <a:ext uri="{FF2B5EF4-FFF2-40B4-BE49-F238E27FC236}">
-                <a16:creationId xmlns:a16="http://schemas.microsoft.com/office/drawing/2014/main" id="{E2CEEAA9-07EC-4B23-874F-966FD7F03D40}"/>
+                <a16:creationId xmlns:a16="http://schemas.microsoft.com/office/drawing/2014/main" id="{EE6474D2-87BA-444D-A407-75D3B6290DEA}"/>
               </a:ext>
             </a:extLst>
           </p:cNvPr>
@@ -15455,7 +15455,7 @@
           <p:cNvPr id="14" name="text">
             <a:extLst xmlns:a="http://schemas.openxmlformats.org/drawingml/2006/main">
               <a:ext uri="{FF2B5EF4-FFF2-40B4-BE49-F238E27FC236}">
-                <a16:creationId xmlns:a16="http://schemas.microsoft.com/office/drawing/2014/main" id="{DA7324FF-CE92-40AA-94E5-49CB027F22B6}"/>
+                <a16:creationId xmlns:a16="http://schemas.microsoft.com/office/drawing/2014/main" id="{A99FCD10-2062-4823-B7EA-62A1614A0653}"/>
               </a:ext>
             </a:extLst>
           </p:cNvPr>
@@ -15513,7 +15513,7 @@
           <p:cNvPr id="15" name="stack-2">
             <a:extLst xmlns:a="http://schemas.openxmlformats.org/drawingml/2006/main">
               <a:ext uri="{FF2B5EF4-FFF2-40B4-BE49-F238E27FC236}">
-                <a16:creationId xmlns:a16="http://schemas.microsoft.com/office/drawing/2014/main" id="{95536C6B-A692-4510-9916-3ABA0F6B426C}"/>
+                <a16:creationId xmlns:a16="http://schemas.microsoft.com/office/drawing/2014/main" id="{EFD05D5B-D289-41FB-B807-50C496912310}"/>
               </a:ext>
             </a:extLst>
           </p:cNvPr>
@@ -15548,7 +15548,7 @@
           <p:cNvPr id="16" name="stack-accent-2">
             <a:extLst xmlns:a="http://schemas.openxmlformats.org/drawingml/2006/main">
               <a:ext uri="{FF2B5EF4-FFF2-40B4-BE49-F238E27FC236}">
-                <a16:creationId xmlns:a16="http://schemas.microsoft.com/office/drawing/2014/main" id="{C03A5B64-5424-4F31-8321-29F2FEB27A5E}"/>
+                <a16:creationId xmlns:a16="http://schemas.microsoft.com/office/drawing/2014/main" id="{A6A88987-505E-467B-96EB-9572ED570A1C}"/>
               </a:ext>
             </a:extLst>
           </p:cNvPr>
@@ -15579,7 +15579,7 @@
           <p:cNvPr id="17" name="text">
             <a:extLst xmlns:a="http://schemas.openxmlformats.org/drawingml/2006/main">
               <a:ext uri="{FF2B5EF4-FFF2-40B4-BE49-F238E27FC236}">
-                <a16:creationId xmlns:a16="http://schemas.microsoft.com/office/drawing/2014/main" id="{6FFE6DD4-3E95-42C6-BD9A-0F73F301BEC6}"/>
+                <a16:creationId xmlns:a16="http://schemas.microsoft.com/office/drawing/2014/main" id="{24BE6247-02E8-4B33-8979-00E47ED4127F}"/>
               </a:ext>
             </a:extLst>
           </p:cNvPr>
@@ -15637,7 +15637,7 @@
           <p:cNvPr id="18" name="text">
             <a:extLst xmlns:a="http://schemas.openxmlformats.org/drawingml/2006/main">
               <a:ext uri="{FF2B5EF4-FFF2-40B4-BE49-F238E27FC236}">
-                <a16:creationId xmlns:a16="http://schemas.microsoft.com/office/drawing/2014/main" id="{72913388-A709-4619-A40F-E3610806C07F}"/>
+                <a16:creationId xmlns:a16="http://schemas.microsoft.com/office/drawing/2014/main" id="{1B2F3494-B258-4C10-95B8-DC654494C40A}"/>
               </a:ext>
             </a:extLst>
           </p:cNvPr>
@@ -15695,7 +15695,7 @@
           <p:cNvPr id="19" name="text">
             <a:extLst xmlns:a="http://schemas.openxmlformats.org/drawingml/2006/main">
               <a:ext uri="{FF2B5EF4-FFF2-40B4-BE49-F238E27FC236}">
-                <a16:creationId xmlns:a16="http://schemas.microsoft.com/office/drawing/2014/main" id="{1BE38AEE-DCFA-4DEA-8C5B-B1D29DC1A67E}"/>
+                <a16:creationId xmlns:a16="http://schemas.microsoft.com/office/drawing/2014/main" id="{EF4BDD11-6FD2-44C0-A202-F10DE46E1D9B}"/>
               </a:ext>
             </a:extLst>
           </p:cNvPr>
@@ -15753,7 +15753,7 @@
           <p:cNvPr id="20" name="stack-3">
             <a:extLst xmlns:a="http://schemas.openxmlformats.org/drawingml/2006/main">
               <a:ext uri="{FF2B5EF4-FFF2-40B4-BE49-F238E27FC236}">
-                <a16:creationId xmlns:a16="http://schemas.microsoft.com/office/drawing/2014/main" id="{8342EB0D-32D8-4A10-A9F4-9D88524706E7}"/>
+                <a16:creationId xmlns:a16="http://schemas.microsoft.com/office/drawing/2014/main" id="{334F6D2C-0EC6-4992-A605-0E2FD7914F54}"/>
               </a:ext>
             </a:extLst>
           </p:cNvPr>
@@ -15788,7 +15788,7 @@
           <p:cNvPr id="21" name="stack-accent-3">
             <a:extLst xmlns:a="http://schemas.openxmlformats.org/drawingml/2006/main">
               <a:ext uri="{FF2B5EF4-FFF2-40B4-BE49-F238E27FC236}">
-                <a16:creationId xmlns:a16="http://schemas.microsoft.com/office/drawing/2014/main" id="{32626BFB-4168-44FC-AC40-555686FB0674}"/>
+                <a16:creationId xmlns:a16="http://schemas.microsoft.com/office/drawing/2014/main" id="{96210765-7B61-41C6-B7AD-888021B3C191}"/>
               </a:ext>
             </a:extLst>
           </p:cNvPr>
@@ -15819,7 +15819,7 @@
           <p:cNvPr id="22" name="text">
             <a:extLst xmlns:a="http://schemas.openxmlformats.org/drawingml/2006/main">
               <a:ext uri="{FF2B5EF4-FFF2-40B4-BE49-F238E27FC236}">
-                <a16:creationId xmlns:a16="http://schemas.microsoft.com/office/drawing/2014/main" id="{DB4E1649-FA09-4C88-91D9-FF122E3B3B37}"/>
+                <a16:creationId xmlns:a16="http://schemas.microsoft.com/office/drawing/2014/main" id="{EAF8EF49-66F7-4DD2-A3CA-2FB0C58FC8F4}"/>
               </a:ext>
             </a:extLst>
           </p:cNvPr>
@@ -15877,7 +15877,7 @@
           <p:cNvPr id="23" name="text">
             <a:extLst xmlns:a="http://schemas.openxmlformats.org/drawingml/2006/main">
               <a:ext uri="{FF2B5EF4-FFF2-40B4-BE49-F238E27FC236}">
-                <a16:creationId xmlns:a16="http://schemas.microsoft.com/office/drawing/2014/main" id="{100ACC53-940F-4BA9-99D0-20D22F6E70FB}"/>
+                <a16:creationId xmlns:a16="http://schemas.microsoft.com/office/drawing/2014/main" id="{98D2B75F-8B73-46E8-966C-EE9D00D9D24E}"/>
               </a:ext>
             </a:extLst>
           </p:cNvPr>
@@ -15935,7 +15935,7 @@
           <p:cNvPr id="24" name="text">
             <a:extLst xmlns:a="http://schemas.openxmlformats.org/drawingml/2006/main">
               <a:ext uri="{FF2B5EF4-FFF2-40B4-BE49-F238E27FC236}">
-                <a16:creationId xmlns:a16="http://schemas.microsoft.com/office/drawing/2014/main" id="{7EEB3053-206E-43C0-B74C-508DCB7ECD0B}"/>
+                <a16:creationId xmlns:a16="http://schemas.microsoft.com/office/drawing/2014/main" id="{30817807-5187-4E0C-AA3D-D437437D8DD2}"/>
               </a:ext>
             </a:extLst>
           </p:cNvPr>
@@ -15993,7 +15993,7 @@
           <p:cNvPr id="25" name="text">
             <a:extLst xmlns:a="http://schemas.openxmlformats.org/drawingml/2006/main">
               <a:ext uri="{FF2B5EF4-FFF2-40B4-BE49-F238E27FC236}">
-                <a16:creationId xmlns:a16="http://schemas.microsoft.com/office/drawing/2014/main" id="{B37833EC-2B2D-45D9-A362-3C5185DF6C66}"/>
+                <a16:creationId xmlns:a16="http://schemas.microsoft.com/office/drawing/2014/main" id="{31392FAF-A0FE-487D-8901-BCC6282D35DD}"/>
               </a:ext>
             </a:extLst>
           </p:cNvPr>
@@ -16049,7 +16049,7 @@
     </p:spTree>
     <p:extLst>
       <p:ext uri="{BB962C8B-B14F-4D97-AF65-F5344CB8AC3E}">
-        <p14:creationId xmlns:p14="http://schemas.microsoft.com/office/powerpoint/2010/main" val="14976773"/>
+        <p14:creationId xmlns:p14="http://schemas.microsoft.com/office/powerpoint/2010/main" val="614428849"/>
       </p:ext>
     </p:extLst>
   </p:cSld>
@@ -16080,7 +16080,7 @@
           <p:cNvPr id="1" name="eyebrow-5">
             <a:extLst xmlns:a="http://schemas.openxmlformats.org/drawingml/2006/main">
               <a:ext uri="{FF2B5EF4-FFF2-40B4-BE49-F238E27FC236}">
-                <a16:creationId xmlns:a16="http://schemas.microsoft.com/office/drawing/2014/main" id="{448062E7-90C0-4011-A54F-1D2323AD4BFD}"/>
+                <a16:creationId xmlns:a16="http://schemas.microsoft.com/office/drawing/2014/main" id="{E6AE6F28-9C19-4388-A245-3D53097227DA}"/>
               </a:ext>
             </a:extLst>
           </p:cNvPr>
@@ -16138,7 +16138,7 @@
           <p:cNvPr id="2" name="slide-title-5">
             <a:extLst xmlns:a="http://schemas.openxmlformats.org/drawingml/2006/main">
               <a:ext uri="{FF2B5EF4-FFF2-40B4-BE49-F238E27FC236}">
-                <a16:creationId xmlns:a16="http://schemas.microsoft.com/office/drawing/2014/main" id="{9ADC1108-92AF-4EBA-A3CF-6ED907A1FA8D}"/>
+                <a16:creationId xmlns:a16="http://schemas.microsoft.com/office/drawing/2014/main" id="{0FA6ED8D-7F6E-47E3-B797-5CD99D1CCEE0}"/>
               </a:ext>
             </a:extLst>
           </p:cNvPr>
@@ -16196,7 +16196,7 @@
           <p:cNvPr id="3" name="title-rule-5">
             <a:extLst xmlns:a="http://schemas.openxmlformats.org/drawingml/2006/main">
               <a:ext uri="{FF2B5EF4-FFF2-40B4-BE49-F238E27FC236}">
-                <a16:creationId xmlns:a16="http://schemas.microsoft.com/office/drawing/2014/main" id="{E0D7E62C-C1D5-4A7F-899C-8BA947833002}"/>
+                <a16:creationId xmlns:a16="http://schemas.microsoft.com/office/drawing/2014/main" id="{B0E15F32-3DF0-432A-B156-8B64F67E2DBB}"/>
               </a:ext>
             </a:extLst>
           </p:cNvPr>
@@ -16227,7 +16227,7 @@
           <p:cNvPr id="4" name="page-number-5">
             <a:extLst xmlns:a="http://schemas.openxmlformats.org/drawingml/2006/main">
               <a:ext uri="{FF2B5EF4-FFF2-40B4-BE49-F238E27FC236}">
-                <a16:creationId xmlns:a16="http://schemas.microsoft.com/office/drawing/2014/main" id="{10A8536E-90C2-4E9E-9E82-AEA20F5C301F}"/>
+                <a16:creationId xmlns:a16="http://schemas.microsoft.com/office/drawing/2014/main" id="{E54FF51A-3902-45CB-B0A1-741FFFA1281C}"/>
               </a:ext>
             </a:extLst>
           </p:cNvPr>
@@ -16285,7 +16285,7 @@
           <p:cNvPr id="5" name="frontend">
             <a:extLst xmlns:a="http://schemas.openxmlformats.org/drawingml/2006/main">
               <a:ext uri="{FF2B5EF4-FFF2-40B4-BE49-F238E27FC236}">
-                <a16:creationId xmlns:a16="http://schemas.microsoft.com/office/drawing/2014/main" id="{A1166EF6-D1C4-42BF-A592-87FF500B9BA7}"/>
+                <a16:creationId xmlns:a16="http://schemas.microsoft.com/office/drawing/2014/main" id="{171C0AAF-F4A2-4AFD-BB4B-DC30B289919E}"/>
               </a:ext>
             </a:extLst>
           </p:cNvPr>
@@ -16320,7 +16320,7 @@
           <p:cNvPr id="6" name="text">
             <a:extLst xmlns:a="http://schemas.openxmlformats.org/drawingml/2006/main">
               <a:ext uri="{FF2B5EF4-FFF2-40B4-BE49-F238E27FC236}">
-                <a16:creationId xmlns:a16="http://schemas.microsoft.com/office/drawing/2014/main" id="{F6FC8DEF-32B9-4747-8334-8A1BA3741D31}"/>
+                <a16:creationId xmlns:a16="http://schemas.microsoft.com/office/drawing/2014/main" id="{57A2A90D-2CB8-4592-856B-728B63AEB475}"/>
               </a:ext>
             </a:extLst>
           </p:cNvPr>
@@ -16378,7 +16378,7 @@
           <p:cNvPr id="7" name="text">
             <a:extLst xmlns:a="http://schemas.openxmlformats.org/drawingml/2006/main">
               <a:ext uri="{FF2B5EF4-FFF2-40B4-BE49-F238E27FC236}">
-                <a16:creationId xmlns:a16="http://schemas.microsoft.com/office/drawing/2014/main" id="{9ED2B0E8-13D9-494F-8003-9CA9BB3A62F8}"/>
+                <a16:creationId xmlns:a16="http://schemas.microsoft.com/office/drawing/2014/main" id="{A7154739-149B-439B-BC7E-7850E8FA707B}"/>
               </a:ext>
             </a:extLst>
           </p:cNvPr>
@@ -16436,7 +16436,7 @@
           <p:cNvPr id="8" name="arrow">
             <a:extLst xmlns:a="http://schemas.openxmlformats.org/drawingml/2006/main">
               <a:ext uri="{FF2B5EF4-FFF2-40B4-BE49-F238E27FC236}">
-                <a16:creationId xmlns:a16="http://schemas.microsoft.com/office/drawing/2014/main" id="{B0C2B682-9A91-4E28-BFA6-D5CD9F3D80BE}"/>
+                <a16:creationId xmlns:a16="http://schemas.microsoft.com/office/drawing/2014/main" id="{EEBD6023-862E-4291-ABFE-8933501D93BC}"/>
               </a:ext>
             </a:extLst>
           </p:cNvPr>
@@ -16494,7 +16494,7 @@
           <p:cNvPr id="9" name="gateway">
             <a:extLst xmlns:a="http://schemas.openxmlformats.org/drawingml/2006/main">
               <a:ext uri="{FF2B5EF4-FFF2-40B4-BE49-F238E27FC236}">
-                <a16:creationId xmlns:a16="http://schemas.microsoft.com/office/drawing/2014/main" id="{282B34CC-B206-4DCA-8385-71EB4A1ABB07}"/>
+                <a16:creationId xmlns:a16="http://schemas.microsoft.com/office/drawing/2014/main" id="{57F63529-C5EB-4698-98C3-F751866AA743}"/>
               </a:ext>
             </a:extLst>
           </p:cNvPr>
@@ -16529,7 +16529,7 @@
           <p:cNvPr id="10" name="text">
             <a:extLst xmlns:a="http://schemas.openxmlformats.org/drawingml/2006/main">
               <a:ext uri="{FF2B5EF4-FFF2-40B4-BE49-F238E27FC236}">
-                <a16:creationId xmlns:a16="http://schemas.microsoft.com/office/drawing/2014/main" id="{4C41D855-5FE3-4670-A24B-C120CDDAFAB4}"/>
+                <a16:creationId xmlns:a16="http://schemas.microsoft.com/office/drawing/2014/main" id="{36C44DC3-C7F2-4EE9-B554-7C1524798F04}"/>
               </a:ext>
             </a:extLst>
           </p:cNvPr>
@@ -16587,7 +16587,7 @@
           <p:cNvPr id="11" name="text">
             <a:extLst xmlns:a="http://schemas.openxmlformats.org/drawingml/2006/main">
               <a:ext uri="{FF2B5EF4-FFF2-40B4-BE49-F238E27FC236}">
-                <a16:creationId xmlns:a16="http://schemas.microsoft.com/office/drawing/2014/main" id="{E18AAC33-6931-4ADB-AA17-C87B68A6853D}"/>
+                <a16:creationId xmlns:a16="http://schemas.microsoft.com/office/drawing/2014/main" id="{F6C4AF78-C793-4621-9590-80E5F99AB879}"/>
               </a:ext>
             </a:extLst>
           </p:cNvPr>
@@ -16645,7 +16645,7 @@
           <p:cNvPr id="12" name="arrow">
             <a:extLst xmlns:a="http://schemas.openxmlformats.org/drawingml/2006/main">
               <a:ext uri="{FF2B5EF4-FFF2-40B4-BE49-F238E27FC236}">
-                <a16:creationId xmlns:a16="http://schemas.microsoft.com/office/drawing/2014/main" id="{AA74A0D1-05A3-46AE-8D07-5F51EDE2E09D}"/>
+                <a16:creationId xmlns:a16="http://schemas.microsoft.com/office/drawing/2014/main" id="{ECFE338F-F47D-499C-BCD5-F4F5330221AC}"/>
               </a:ext>
             </a:extLst>
           </p:cNvPr>
@@ -16703,7 +16703,7 @@
           <p:cNvPr id="13" name="services">
             <a:extLst xmlns:a="http://schemas.openxmlformats.org/drawingml/2006/main">
               <a:ext uri="{FF2B5EF4-FFF2-40B4-BE49-F238E27FC236}">
-                <a16:creationId xmlns:a16="http://schemas.microsoft.com/office/drawing/2014/main" id="{6C69C3D6-E8A0-4EBF-B8CA-50B57561276A}"/>
+                <a16:creationId xmlns:a16="http://schemas.microsoft.com/office/drawing/2014/main" id="{CEA0E838-146B-49D5-BD1A-ADC034E4E2A3}"/>
               </a:ext>
             </a:extLst>
           </p:cNvPr>
@@ -16738,7 +16738,7 @@
           <p:cNvPr id="14" name="text">
             <a:extLst xmlns:a="http://schemas.openxmlformats.org/drawingml/2006/main">
               <a:ext uri="{FF2B5EF4-FFF2-40B4-BE49-F238E27FC236}">
-                <a16:creationId xmlns:a16="http://schemas.microsoft.com/office/drawing/2014/main" id="{103C37FA-1CAA-49AD-854C-4A14EBAD9049}"/>
+                <a16:creationId xmlns:a16="http://schemas.microsoft.com/office/drawing/2014/main" id="{B9C34AD7-9A68-49AD-B2B0-BCCE708E86D3}"/>
               </a:ext>
             </a:extLst>
           </p:cNvPr>
@@ -16796,7 +16796,7 @@
           <p:cNvPr id="15" name="svc-0">
             <a:extLst xmlns:a="http://schemas.openxmlformats.org/drawingml/2006/main">
               <a:ext uri="{FF2B5EF4-FFF2-40B4-BE49-F238E27FC236}">
-                <a16:creationId xmlns:a16="http://schemas.microsoft.com/office/drawing/2014/main" id="{C37F4840-D454-41DE-BE43-A341C6996BF2}"/>
+                <a16:creationId xmlns:a16="http://schemas.microsoft.com/office/drawing/2014/main" id="{EBF36066-C833-4577-BD31-16C6E975AA17}"/>
               </a:ext>
             </a:extLst>
           </p:cNvPr>
@@ -16831,7 +16831,7 @@
           <p:cNvPr id="16" name="text">
             <a:extLst xmlns:a="http://schemas.openxmlformats.org/drawingml/2006/main">
               <a:ext uri="{FF2B5EF4-FFF2-40B4-BE49-F238E27FC236}">
-                <a16:creationId xmlns:a16="http://schemas.microsoft.com/office/drawing/2014/main" id="{1DB7505F-2B3F-4654-A726-C4BDBB04988F}"/>
+                <a16:creationId xmlns:a16="http://schemas.microsoft.com/office/drawing/2014/main" id="{58060DA4-6DF1-4ADD-B9EE-7AE7812CB28F}"/>
               </a:ext>
             </a:extLst>
           </p:cNvPr>
@@ -16889,7 +16889,7 @@
           <p:cNvPr id="17" name="svc-1">
             <a:extLst xmlns:a="http://schemas.openxmlformats.org/drawingml/2006/main">
               <a:ext uri="{FF2B5EF4-FFF2-40B4-BE49-F238E27FC236}">
-                <a16:creationId xmlns:a16="http://schemas.microsoft.com/office/drawing/2014/main" id="{29B88697-7C2E-4918-87C1-4F93AAB21379}"/>
+                <a16:creationId xmlns:a16="http://schemas.microsoft.com/office/drawing/2014/main" id="{2CE8FCFC-8720-4217-898A-8554F9E0D543}"/>
               </a:ext>
             </a:extLst>
           </p:cNvPr>
@@ -16924,7 +16924,7 @@
           <p:cNvPr id="18" name="text">
             <a:extLst xmlns:a="http://schemas.openxmlformats.org/drawingml/2006/main">
               <a:ext uri="{FF2B5EF4-FFF2-40B4-BE49-F238E27FC236}">
-                <a16:creationId xmlns:a16="http://schemas.microsoft.com/office/drawing/2014/main" id="{100C6DB9-9831-457D-82CC-92CFF9687964}"/>
+                <a16:creationId xmlns:a16="http://schemas.microsoft.com/office/drawing/2014/main" id="{1FE205BB-DD98-4C5B-AFE0-916D7852580E}"/>
               </a:ext>
             </a:extLst>
           </p:cNvPr>
@@ -16982,7 +16982,7 @@
           <p:cNvPr id="19" name="svc-2">
             <a:extLst xmlns:a="http://schemas.openxmlformats.org/drawingml/2006/main">
               <a:ext uri="{FF2B5EF4-FFF2-40B4-BE49-F238E27FC236}">
-                <a16:creationId xmlns:a16="http://schemas.microsoft.com/office/drawing/2014/main" id="{FCA12BC6-18D4-4897-A0FB-CFE00120CDA1}"/>
+                <a16:creationId xmlns:a16="http://schemas.microsoft.com/office/drawing/2014/main" id="{D0316B4D-5166-4391-927F-44085E1C70D4}"/>
               </a:ext>
             </a:extLst>
           </p:cNvPr>
@@ -17017,7 +17017,7 @@
           <p:cNvPr id="20" name="text">
             <a:extLst xmlns:a="http://schemas.openxmlformats.org/drawingml/2006/main">
               <a:ext uri="{FF2B5EF4-FFF2-40B4-BE49-F238E27FC236}">
-                <a16:creationId xmlns:a16="http://schemas.microsoft.com/office/drawing/2014/main" id="{92E77AFF-700D-46D0-B37E-66CE1E7E1A3D}"/>
+                <a16:creationId xmlns:a16="http://schemas.microsoft.com/office/drawing/2014/main" id="{F8039CF3-CEB3-454D-8C13-93EA1507887F}"/>
               </a:ext>
             </a:extLst>
           </p:cNvPr>
@@ -17075,7 +17075,7 @@
           <p:cNvPr id="21" name="svc-3">
             <a:extLst xmlns:a="http://schemas.openxmlformats.org/drawingml/2006/main">
               <a:ext uri="{FF2B5EF4-FFF2-40B4-BE49-F238E27FC236}">
-                <a16:creationId xmlns:a16="http://schemas.microsoft.com/office/drawing/2014/main" id="{5324F200-8BDC-4313-9CF9-06591B367E90}"/>
+                <a16:creationId xmlns:a16="http://schemas.microsoft.com/office/drawing/2014/main" id="{1A3C3605-039E-47F3-AB00-52340FFB77CE}"/>
               </a:ext>
             </a:extLst>
           </p:cNvPr>
@@ -17110,7 +17110,7 @@
           <p:cNvPr id="22" name="text">
             <a:extLst xmlns:a="http://schemas.openxmlformats.org/drawingml/2006/main">
               <a:ext uri="{FF2B5EF4-FFF2-40B4-BE49-F238E27FC236}">
-                <a16:creationId xmlns:a16="http://schemas.microsoft.com/office/drawing/2014/main" id="{E88E5609-65B6-4D4E-876F-96A22C246EFA}"/>
+                <a16:creationId xmlns:a16="http://schemas.microsoft.com/office/drawing/2014/main" id="{9A644A46-638E-42A5-89E6-845B7EFAEB99}"/>
               </a:ext>
             </a:extLst>
           </p:cNvPr>
@@ -17168,7 +17168,7 @@
           <p:cNvPr id="23" name="svc-4">
             <a:extLst xmlns:a="http://schemas.openxmlformats.org/drawingml/2006/main">
               <a:ext uri="{FF2B5EF4-FFF2-40B4-BE49-F238E27FC236}">
-                <a16:creationId xmlns:a16="http://schemas.microsoft.com/office/drawing/2014/main" id="{A187ABC0-F2CB-48D7-87C0-8A9C9465EDB3}"/>
+                <a16:creationId xmlns:a16="http://schemas.microsoft.com/office/drawing/2014/main" id="{7B0C7CD7-4D53-4A34-83E0-A8DEB7A740EE}"/>
               </a:ext>
             </a:extLst>
           </p:cNvPr>
@@ -17203,7 +17203,7 @@
           <p:cNvPr id="24" name="text">
             <a:extLst xmlns:a="http://schemas.openxmlformats.org/drawingml/2006/main">
               <a:ext uri="{FF2B5EF4-FFF2-40B4-BE49-F238E27FC236}">
-                <a16:creationId xmlns:a16="http://schemas.microsoft.com/office/drawing/2014/main" id="{2E5C008F-3367-4584-8F06-7BA720EF85B8}"/>
+                <a16:creationId xmlns:a16="http://schemas.microsoft.com/office/drawing/2014/main" id="{EB4BD990-CE79-4BCE-9B44-F17542E87187}"/>
               </a:ext>
             </a:extLst>
           </p:cNvPr>
@@ -17261,7 +17261,7 @@
           <p:cNvPr id="25" name="svc-5">
             <a:extLst xmlns:a="http://schemas.openxmlformats.org/drawingml/2006/main">
               <a:ext uri="{FF2B5EF4-FFF2-40B4-BE49-F238E27FC236}">
-                <a16:creationId xmlns:a16="http://schemas.microsoft.com/office/drawing/2014/main" id="{37FBD6F5-7E08-4D77-8D95-5176EE037742}"/>
+                <a16:creationId xmlns:a16="http://schemas.microsoft.com/office/drawing/2014/main" id="{A60D16FB-52F2-4A0A-A648-BC39A5EED3D2}"/>
               </a:ext>
             </a:extLst>
           </p:cNvPr>
@@ -17296,7 +17296,7 @@
           <p:cNvPr id="26" name="text">
             <a:extLst xmlns:a="http://schemas.openxmlformats.org/drawingml/2006/main">
               <a:ext uri="{FF2B5EF4-FFF2-40B4-BE49-F238E27FC236}">
-                <a16:creationId xmlns:a16="http://schemas.microsoft.com/office/drawing/2014/main" id="{ABFFB977-94C7-4524-BAF7-7A095A282AF2}"/>
+                <a16:creationId xmlns:a16="http://schemas.microsoft.com/office/drawing/2014/main" id="{A95058CF-335F-4F6A-B23A-7572D075F5B5}"/>
               </a:ext>
             </a:extLst>
           </p:cNvPr>
@@ -17354,7 +17354,7 @@
           <p:cNvPr id="27" name="text">
             <a:extLst xmlns:a="http://schemas.openxmlformats.org/drawingml/2006/main">
               <a:ext uri="{FF2B5EF4-FFF2-40B4-BE49-F238E27FC236}">
-                <a16:creationId xmlns:a16="http://schemas.microsoft.com/office/drawing/2014/main" id="{55FFA33A-174B-43F5-AC8F-5BB320880DD5}"/>
+                <a16:creationId xmlns:a16="http://schemas.microsoft.com/office/drawing/2014/main" id="{2B265F40-003F-4AF2-A56F-B2ED837A995D}"/>
               </a:ext>
             </a:extLst>
           </p:cNvPr>
@@ -17412,7 +17412,7 @@
           <p:cNvPr id="28" name="data-0">
             <a:extLst xmlns:a="http://schemas.openxmlformats.org/drawingml/2006/main">
               <a:ext uri="{FF2B5EF4-FFF2-40B4-BE49-F238E27FC236}">
-                <a16:creationId xmlns:a16="http://schemas.microsoft.com/office/drawing/2014/main" id="{32D5ABFA-077B-4FC4-A579-AB0EDA9EB84C}"/>
+                <a16:creationId xmlns:a16="http://schemas.microsoft.com/office/drawing/2014/main" id="{6CF877EC-D5B2-4A7C-8C0E-8099D379B237}"/>
               </a:ext>
             </a:extLst>
           </p:cNvPr>
@@ -17447,7 +17447,7 @@
           <p:cNvPr id="29" name="text">
             <a:extLst xmlns:a="http://schemas.openxmlformats.org/drawingml/2006/main">
               <a:ext uri="{FF2B5EF4-FFF2-40B4-BE49-F238E27FC236}">
-                <a16:creationId xmlns:a16="http://schemas.microsoft.com/office/drawing/2014/main" id="{27365362-EA55-4D7E-B72C-7CB276BBA397}"/>
+                <a16:creationId xmlns:a16="http://schemas.microsoft.com/office/drawing/2014/main" id="{FF1D6E30-67EF-4F20-9A0E-21AA3EE5D065}"/>
               </a:ext>
             </a:extLst>
           </p:cNvPr>
@@ -17505,7 +17505,7 @@
           <p:cNvPr id="30" name="data-1">
             <a:extLst xmlns:a="http://schemas.openxmlformats.org/drawingml/2006/main">
               <a:ext uri="{FF2B5EF4-FFF2-40B4-BE49-F238E27FC236}">
-                <a16:creationId xmlns:a16="http://schemas.microsoft.com/office/drawing/2014/main" id="{D0599B9F-C4F7-4B18-960A-AA50CF1B3F48}"/>
+                <a16:creationId xmlns:a16="http://schemas.microsoft.com/office/drawing/2014/main" id="{27EE8E5A-755F-41E3-A4C5-440C25FF5F1C}"/>
               </a:ext>
             </a:extLst>
           </p:cNvPr>
@@ -17540,7 +17540,7 @@
           <p:cNvPr id="31" name="text">
             <a:extLst xmlns:a="http://schemas.openxmlformats.org/drawingml/2006/main">
               <a:ext uri="{FF2B5EF4-FFF2-40B4-BE49-F238E27FC236}">
-                <a16:creationId xmlns:a16="http://schemas.microsoft.com/office/drawing/2014/main" id="{3301F2B2-84B9-455C-99F7-3DCD0542E761}"/>
+                <a16:creationId xmlns:a16="http://schemas.microsoft.com/office/drawing/2014/main" id="{7A3DB6F4-BAF1-430A-A412-51FCCA88111B}"/>
               </a:ext>
             </a:extLst>
           </p:cNvPr>
@@ -17598,7 +17598,7 @@
           <p:cNvPr id="32" name="data-2">
             <a:extLst xmlns:a="http://schemas.openxmlformats.org/drawingml/2006/main">
               <a:ext uri="{FF2B5EF4-FFF2-40B4-BE49-F238E27FC236}">
-                <a16:creationId xmlns:a16="http://schemas.microsoft.com/office/drawing/2014/main" id="{3E797FA3-7FFE-4776-9DBD-5A81F94A810B}"/>
+                <a16:creationId xmlns:a16="http://schemas.microsoft.com/office/drawing/2014/main" id="{2761D84E-CE7A-4132-ACD7-71D68A665EE4}"/>
               </a:ext>
             </a:extLst>
           </p:cNvPr>
@@ -17633,7 +17633,7 @@
           <p:cNvPr id="33" name="text">
             <a:extLst xmlns:a="http://schemas.openxmlformats.org/drawingml/2006/main">
               <a:ext uri="{FF2B5EF4-FFF2-40B4-BE49-F238E27FC236}">
-                <a16:creationId xmlns:a16="http://schemas.microsoft.com/office/drawing/2014/main" id="{D774F07D-6707-49CA-9D6D-4727CC342CFB}"/>
+                <a16:creationId xmlns:a16="http://schemas.microsoft.com/office/drawing/2014/main" id="{6A0EE304-A456-4189-9CE5-B8FDB83C5AAF}"/>
               </a:ext>
             </a:extLst>
           </p:cNvPr>
@@ -17691,7 +17691,7 @@
           <p:cNvPr id="34" name="text">
             <a:extLst xmlns:a="http://schemas.openxmlformats.org/drawingml/2006/main">
               <a:ext uri="{FF2B5EF4-FFF2-40B4-BE49-F238E27FC236}">
-                <a16:creationId xmlns:a16="http://schemas.microsoft.com/office/drawing/2014/main" id="{4B78C3DE-6AE3-4D7F-85A6-9540EDB70D0E}"/>
+                <a16:creationId xmlns:a16="http://schemas.microsoft.com/office/drawing/2014/main" id="{741E5C89-20F0-4F1A-8D85-DEA150B9AC6E}"/>
               </a:ext>
             </a:extLst>
           </p:cNvPr>
@@ -17749,7 +17749,7 @@
           <p:cNvPr id="35" name="text">
             <a:extLst xmlns:a="http://schemas.openxmlformats.org/drawingml/2006/main">
               <a:ext uri="{FF2B5EF4-FFF2-40B4-BE49-F238E27FC236}">
-                <a16:creationId xmlns:a16="http://schemas.microsoft.com/office/drawing/2014/main" id="{F977EA74-7069-422D-94A4-EB17033D849E}"/>
+                <a16:creationId xmlns:a16="http://schemas.microsoft.com/office/drawing/2014/main" id="{068A6239-ACD5-4A34-BF8B-A26726BF9C84}"/>
               </a:ext>
             </a:extLst>
           </p:cNvPr>
@@ -17807,7 +17807,7 @@
           <p:cNvPr id="36" name="text">
             <a:extLst xmlns:a="http://schemas.openxmlformats.org/drawingml/2006/main">
               <a:ext uri="{FF2B5EF4-FFF2-40B4-BE49-F238E27FC236}">
-                <a16:creationId xmlns:a16="http://schemas.microsoft.com/office/drawing/2014/main" id="{9A7EFE9D-CC73-4A51-A906-694D48F8D9C3}"/>
+                <a16:creationId xmlns:a16="http://schemas.microsoft.com/office/drawing/2014/main" id="{D4EA686A-B9C3-467E-A7B1-59D45FC7FE0A}"/>
               </a:ext>
             </a:extLst>
           </p:cNvPr>
@@ -17863,7 +17863,7 @@
     </p:spTree>
     <p:extLst>
       <p:ext uri="{BB962C8B-B14F-4D97-AF65-F5344CB8AC3E}">
-        <p14:creationId xmlns:p14="http://schemas.microsoft.com/office/powerpoint/2010/main" val="935583183"/>
+        <p14:creationId xmlns:p14="http://schemas.microsoft.com/office/powerpoint/2010/main" val="735434829"/>
       </p:ext>
     </p:extLst>
   </p:cSld>
@@ -17894,7 +17894,7 @@
           <p:cNvPr id="1" name="eyebrow-6">
             <a:extLst xmlns:a="http://schemas.openxmlformats.org/drawingml/2006/main">
               <a:ext uri="{FF2B5EF4-FFF2-40B4-BE49-F238E27FC236}">
-                <a16:creationId xmlns:a16="http://schemas.microsoft.com/office/drawing/2014/main" id="{7C4624EF-4924-4D66-AC55-3D0D336B50FC}"/>
+                <a16:creationId xmlns:a16="http://schemas.microsoft.com/office/drawing/2014/main" id="{01FF97B6-A064-4A89-ACEB-1EA7ECAA1042}"/>
               </a:ext>
             </a:extLst>
           </p:cNvPr>
@@ -17952,7 +17952,7 @@
           <p:cNvPr id="2" name="slide-title-6">
             <a:extLst xmlns:a="http://schemas.openxmlformats.org/drawingml/2006/main">
               <a:ext uri="{FF2B5EF4-FFF2-40B4-BE49-F238E27FC236}">
-                <a16:creationId xmlns:a16="http://schemas.microsoft.com/office/drawing/2014/main" id="{866B7FA2-068E-46F1-BC89-384F32D3EBC0}"/>
+                <a16:creationId xmlns:a16="http://schemas.microsoft.com/office/drawing/2014/main" id="{8C63B1AE-FF50-444D-AB2E-9ED7A9CD2469}"/>
               </a:ext>
             </a:extLst>
           </p:cNvPr>
@@ -18010,7 +18010,7 @@
           <p:cNvPr id="3" name="title-rule-6">
             <a:extLst xmlns:a="http://schemas.openxmlformats.org/drawingml/2006/main">
               <a:ext uri="{FF2B5EF4-FFF2-40B4-BE49-F238E27FC236}">
-                <a16:creationId xmlns:a16="http://schemas.microsoft.com/office/drawing/2014/main" id="{F964DAC0-574D-43FB-A883-D3A95EB1C714}"/>
+                <a16:creationId xmlns:a16="http://schemas.microsoft.com/office/drawing/2014/main" id="{295DCBC0-C6E8-49FC-95EA-313487D078FE}"/>
               </a:ext>
             </a:extLst>
           </p:cNvPr>
@@ -18041,7 +18041,7 @@
           <p:cNvPr id="4" name="page-number-6">
             <a:extLst xmlns:a="http://schemas.openxmlformats.org/drawingml/2006/main">
               <a:ext uri="{FF2B5EF4-FFF2-40B4-BE49-F238E27FC236}">
-                <a16:creationId xmlns:a16="http://schemas.microsoft.com/office/drawing/2014/main" id="{881C5828-A81E-4C9B-82A8-2D38549E63A8}"/>
+                <a16:creationId xmlns:a16="http://schemas.microsoft.com/office/drawing/2014/main" id="{720ABC27-6640-4E92-8AF3-5881BF43A64E}"/>
               </a:ext>
             </a:extLst>
           </p:cNvPr>
@@ -18099,7 +18099,7 @@
           <p:cNvPr id="5" name="module-0">
             <a:extLst xmlns:a="http://schemas.openxmlformats.org/drawingml/2006/main">
               <a:ext uri="{FF2B5EF4-FFF2-40B4-BE49-F238E27FC236}">
-                <a16:creationId xmlns:a16="http://schemas.microsoft.com/office/drawing/2014/main" id="{4E79F905-FC55-4709-B818-FA4E9177BC21}"/>
+                <a16:creationId xmlns:a16="http://schemas.microsoft.com/office/drawing/2014/main" id="{D71B00D1-DC65-4570-B183-20572542EDBF}"/>
               </a:ext>
             </a:extLst>
           </p:cNvPr>
@@ -18134,7 +18134,7 @@
           <p:cNvPr id="6" name="module-accent-0">
             <a:extLst xmlns:a="http://schemas.openxmlformats.org/drawingml/2006/main">
               <a:ext uri="{FF2B5EF4-FFF2-40B4-BE49-F238E27FC236}">
-                <a16:creationId xmlns:a16="http://schemas.microsoft.com/office/drawing/2014/main" id="{1853F04C-6979-44C7-B78E-235C2F99F891}"/>
+                <a16:creationId xmlns:a16="http://schemas.microsoft.com/office/drawing/2014/main" id="{C3AEE24A-17E4-475D-BAD8-61E44817F38B}"/>
               </a:ext>
             </a:extLst>
           </p:cNvPr>
@@ -18165,7 +18165,7 @@
           <p:cNvPr id="7" name="text">
             <a:extLst xmlns:a="http://schemas.openxmlformats.org/drawingml/2006/main">
               <a:ext uri="{FF2B5EF4-FFF2-40B4-BE49-F238E27FC236}">
-                <a16:creationId xmlns:a16="http://schemas.microsoft.com/office/drawing/2014/main" id="{3BE1ECBD-104B-4588-BA36-616F1DBB235F}"/>
+                <a16:creationId xmlns:a16="http://schemas.microsoft.com/office/drawing/2014/main" id="{8FECA71F-158A-43E1-8CBC-FAC181D75751}"/>
               </a:ext>
             </a:extLst>
           </p:cNvPr>
@@ -18223,7 +18223,7 @@
           <p:cNvPr id="8" name="text">
             <a:extLst xmlns:a="http://schemas.openxmlformats.org/drawingml/2006/main">
               <a:ext uri="{FF2B5EF4-FFF2-40B4-BE49-F238E27FC236}">
-                <a16:creationId xmlns:a16="http://schemas.microsoft.com/office/drawing/2014/main" id="{9A480C9A-64C2-4B52-BE6A-122612F409BA}"/>
+                <a16:creationId xmlns:a16="http://schemas.microsoft.com/office/drawing/2014/main" id="{EAA82A44-29B5-4E8A-8604-C43700B85404}"/>
               </a:ext>
             </a:extLst>
           </p:cNvPr>
@@ -18281,7 +18281,7 @@
           <p:cNvPr id="9" name="text">
             <a:extLst xmlns:a="http://schemas.openxmlformats.org/drawingml/2006/main">
               <a:ext uri="{FF2B5EF4-FFF2-40B4-BE49-F238E27FC236}">
-                <a16:creationId xmlns:a16="http://schemas.microsoft.com/office/drawing/2014/main" id="{4FE51CF9-694C-4968-BAA5-DECFC26F4CB8}"/>
+                <a16:creationId xmlns:a16="http://schemas.microsoft.com/office/drawing/2014/main" id="{3EA02513-18C8-4F6C-BFEB-0EF37C7BA2E8}"/>
               </a:ext>
             </a:extLst>
           </p:cNvPr>
@@ -18339,7 +18339,7 @@
           <p:cNvPr id="10" name="module-1">
             <a:extLst xmlns:a="http://schemas.openxmlformats.org/drawingml/2006/main">
               <a:ext uri="{FF2B5EF4-FFF2-40B4-BE49-F238E27FC236}">
-                <a16:creationId xmlns:a16="http://schemas.microsoft.com/office/drawing/2014/main" id="{6F0A4327-C2CD-4187-9992-CB63496DEC53}"/>
+                <a16:creationId xmlns:a16="http://schemas.microsoft.com/office/drawing/2014/main" id="{91A2AEAD-1A73-4BC7-A64E-9950BD115672}"/>
               </a:ext>
             </a:extLst>
           </p:cNvPr>
@@ -18374,7 +18374,7 @@
           <p:cNvPr id="11" name="module-accent-1">
             <a:extLst xmlns:a="http://schemas.openxmlformats.org/drawingml/2006/main">
               <a:ext uri="{FF2B5EF4-FFF2-40B4-BE49-F238E27FC236}">
-                <a16:creationId xmlns:a16="http://schemas.microsoft.com/office/drawing/2014/main" id="{0CE90E5D-0DE0-43F1-82A9-CF8A40F940DB}"/>
+                <a16:creationId xmlns:a16="http://schemas.microsoft.com/office/drawing/2014/main" id="{5DC0F5DC-3C58-430D-8654-A26EBEA16D3B}"/>
               </a:ext>
             </a:extLst>
           </p:cNvPr>
@@ -18405,7 +18405,7 @@
           <p:cNvPr id="12" name="text">
             <a:extLst xmlns:a="http://schemas.openxmlformats.org/drawingml/2006/main">
               <a:ext uri="{FF2B5EF4-FFF2-40B4-BE49-F238E27FC236}">
-                <a16:creationId xmlns:a16="http://schemas.microsoft.com/office/drawing/2014/main" id="{3763CAB6-BAA1-48BE-9587-F828A63156B0}"/>
+                <a16:creationId xmlns:a16="http://schemas.microsoft.com/office/drawing/2014/main" id="{566E95A4-C4D5-49D4-A15B-AE8EEE6F83C5}"/>
               </a:ext>
             </a:extLst>
           </p:cNvPr>
@@ -18463,7 +18463,7 @@
           <p:cNvPr id="13" name="text">
             <a:extLst xmlns:a="http://schemas.openxmlformats.org/drawingml/2006/main">
               <a:ext uri="{FF2B5EF4-FFF2-40B4-BE49-F238E27FC236}">
-                <a16:creationId xmlns:a16="http://schemas.microsoft.com/office/drawing/2014/main" id="{B667C023-B02B-4CD1-9516-02CF36203AE4}"/>
+                <a16:creationId xmlns:a16="http://schemas.microsoft.com/office/drawing/2014/main" id="{E5495CDB-5CAB-43C0-89B8-D8C9533E019F}"/>
               </a:ext>
             </a:extLst>
           </p:cNvPr>
@@ -18521,7 +18521,7 @@
           <p:cNvPr id="14" name="text">
             <a:extLst xmlns:a="http://schemas.openxmlformats.org/drawingml/2006/main">
               <a:ext uri="{FF2B5EF4-FFF2-40B4-BE49-F238E27FC236}">
-                <a16:creationId xmlns:a16="http://schemas.microsoft.com/office/drawing/2014/main" id="{DD71E331-A8BF-48B9-B19C-24758AACCBFE}"/>
+                <a16:creationId xmlns:a16="http://schemas.microsoft.com/office/drawing/2014/main" id="{6BB8C0D6-2C51-49E1-8477-2A42609C2305}"/>
               </a:ext>
             </a:extLst>
           </p:cNvPr>
@@ -18579,7 +18579,7 @@
           <p:cNvPr id="15" name="module-2">
             <a:extLst xmlns:a="http://schemas.openxmlformats.org/drawingml/2006/main">
               <a:ext uri="{FF2B5EF4-FFF2-40B4-BE49-F238E27FC236}">
-                <a16:creationId xmlns:a16="http://schemas.microsoft.com/office/drawing/2014/main" id="{00E2E252-E192-4988-BB0E-FED57FC59608}"/>
+                <a16:creationId xmlns:a16="http://schemas.microsoft.com/office/drawing/2014/main" id="{2FDDD82D-0186-42B7-84F3-C27395FEA3F0}"/>
               </a:ext>
             </a:extLst>
           </p:cNvPr>
@@ -18614,7 +18614,7 @@
           <p:cNvPr id="16" name="module-accent-2">
             <a:extLst xmlns:a="http://schemas.openxmlformats.org/drawingml/2006/main">
               <a:ext uri="{FF2B5EF4-FFF2-40B4-BE49-F238E27FC236}">
-                <a16:creationId xmlns:a16="http://schemas.microsoft.com/office/drawing/2014/main" id="{44DC402D-7E33-4E0F-9F54-3E9AE63A169B}"/>
+                <a16:creationId xmlns:a16="http://schemas.microsoft.com/office/drawing/2014/main" id="{8695AEB4-286A-4505-8E95-F3BF285AB8C0}"/>
               </a:ext>
             </a:extLst>
           </p:cNvPr>
@@ -18645,7 +18645,7 @@
           <p:cNvPr id="17" name="text">
             <a:extLst xmlns:a="http://schemas.openxmlformats.org/drawingml/2006/main">
               <a:ext uri="{FF2B5EF4-FFF2-40B4-BE49-F238E27FC236}">
-                <a16:creationId xmlns:a16="http://schemas.microsoft.com/office/drawing/2014/main" id="{834F3CB2-A8F7-49D4-AEEF-DB8D1898B893}"/>
+                <a16:creationId xmlns:a16="http://schemas.microsoft.com/office/drawing/2014/main" id="{2DDBDF84-7655-4082-B27C-4AF45FD218C7}"/>
               </a:ext>
             </a:extLst>
           </p:cNvPr>
@@ -18703,7 +18703,7 @@
           <p:cNvPr id="18" name="text">
             <a:extLst xmlns:a="http://schemas.openxmlformats.org/drawingml/2006/main">
               <a:ext uri="{FF2B5EF4-FFF2-40B4-BE49-F238E27FC236}">
-                <a16:creationId xmlns:a16="http://schemas.microsoft.com/office/drawing/2014/main" id="{FA8C8CAE-CD87-4E69-BF42-E18E2975F73F}"/>
+                <a16:creationId xmlns:a16="http://schemas.microsoft.com/office/drawing/2014/main" id="{E8D3EEF0-0B84-4FE4-9147-6AFEE6DD50DD}"/>
               </a:ext>
             </a:extLst>
           </p:cNvPr>
@@ -18761,7 +18761,7 @@
           <p:cNvPr id="19" name="text">
             <a:extLst xmlns:a="http://schemas.openxmlformats.org/drawingml/2006/main">
               <a:ext uri="{FF2B5EF4-FFF2-40B4-BE49-F238E27FC236}">
-                <a16:creationId xmlns:a16="http://schemas.microsoft.com/office/drawing/2014/main" id="{9D32AB8C-94C8-43C4-877F-9A291D2F51FC}"/>
+                <a16:creationId xmlns:a16="http://schemas.microsoft.com/office/drawing/2014/main" id="{C30816B0-03EB-4433-B1EC-6E3C0FBC9727}"/>
               </a:ext>
             </a:extLst>
           </p:cNvPr>
@@ -18819,7 +18819,7 @@
           <p:cNvPr id="20" name="module-3">
             <a:extLst xmlns:a="http://schemas.openxmlformats.org/drawingml/2006/main">
               <a:ext uri="{FF2B5EF4-FFF2-40B4-BE49-F238E27FC236}">
-                <a16:creationId xmlns:a16="http://schemas.microsoft.com/office/drawing/2014/main" id="{772EDE16-1428-4D61-8870-A1038AAB561C}"/>
+                <a16:creationId xmlns:a16="http://schemas.microsoft.com/office/drawing/2014/main" id="{3247CACA-23E9-4C81-AB68-219E3A520949}"/>
               </a:ext>
             </a:extLst>
           </p:cNvPr>
@@ -18854,7 +18854,7 @@
           <p:cNvPr id="21" name="module-accent-3">
             <a:extLst xmlns:a="http://schemas.openxmlformats.org/drawingml/2006/main">
               <a:ext uri="{FF2B5EF4-FFF2-40B4-BE49-F238E27FC236}">
-                <a16:creationId xmlns:a16="http://schemas.microsoft.com/office/drawing/2014/main" id="{2653484C-A558-4476-825A-5254FCD3373A}"/>
+                <a16:creationId xmlns:a16="http://schemas.microsoft.com/office/drawing/2014/main" id="{7B29F22D-9513-42DE-BE6E-EFA77693A5E6}"/>
               </a:ext>
             </a:extLst>
           </p:cNvPr>
@@ -18885,7 +18885,7 @@
           <p:cNvPr id="22" name="text">
             <a:extLst xmlns:a="http://schemas.openxmlformats.org/drawingml/2006/main">
               <a:ext uri="{FF2B5EF4-FFF2-40B4-BE49-F238E27FC236}">
-                <a16:creationId xmlns:a16="http://schemas.microsoft.com/office/drawing/2014/main" id="{F03CA5B7-DEF6-45A8-9A93-B08E59A0684B}"/>
+                <a16:creationId xmlns:a16="http://schemas.microsoft.com/office/drawing/2014/main" id="{2A65C7BE-7890-4AB8-ACEB-EA396FA39EA3}"/>
               </a:ext>
             </a:extLst>
           </p:cNvPr>
@@ -18943,7 +18943,7 @@
           <p:cNvPr id="23" name="text">
             <a:extLst xmlns:a="http://schemas.openxmlformats.org/drawingml/2006/main">
               <a:ext uri="{FF2B5EF4-FFF2-40B4-BE49-F238E27FC236}">
-                <a16:creationId xmlns:a16="http://schemas.microsoft.com/office/drawing/2014/main" id="{3C306510-154C-4632-8D8D-2F9E04880FEA}"/>
+                <a16:creationId xmlns:a16="http://schemas.microsoft.com/office/drawing/2014/main" id="{D36733CA-CC91-4DA3-BFE3-516299598AF4}"/>
               </a:ext>
             </a:extLst>
           </p:cNvPr>
@@ -19001,7 +19001,7 @@
           <p:cNvPr id="24" name="text">
             <a:extLst xmlns:a="http://schemas.openxmlformats.org/drawingml/2006/main">
               <a:ext uri="{FF2B5EF4-FFF2-40B4-BE49-F238E27FC236}">
-                <a16:creationId xmlns:a16="http://schemas.microsoft.com/office/drawing/2014/main" id="{83A246F1-64A8-413D-AD73-3B2E84ED8A86}"/>
+                <a16:creationId xmlns:a16="http://schemas.microsoft.com/office/drawing/2014/main" id="{439D03B6-3680-4BF8-B53F-02ACB6CE4DA5}"/>
               </a:ext>
             </a:extLst>
           </p:cNvPr>
@@ -19059,7 +19059,7 @@
           <p:cNvPr id="25" name="module-4">
             <a:extLst xmlns:a="http://schemas.openxmlformats.org/drawingml/2006/main">
               <a:ext uri="{FF2B5EF4-FFF2-40B4-BE49-F238E27FC236}">
-                <a16:creationId xmlns:a16="http://schemas.microsoft.com/office/drawing/2014/main" id="{975238BF-8633-4207-93F1-522D4601FE7D}"/>
+                <a16:creationId xmlns:a16="http://schemas.microsoft.com/office/drawing/2014/main" id="{CFB56D99-DF1A-4E9E-8A65-624BA4FDFCB3}"/>
               </a:ext>
             </a:extLst>
           </p:cNvPr>
@@ -19094,7 +19094,7 @@
           <p:cNvPr id="26" name="module-accent-4">
             <a:extLst xmlns:a="http://schemas.openxmlformats.org/drawingml/2006/main">
               <a:ext uri="{FF2B5EF4-FFF2-40B4-BE49-F238E27FC236}">
-                <a16:creationId xmlns:a16="http://schemas.microsoft.com/office/drawing/2014/main" id="{8BAB3407-9149-4023-9684-04413EF888BF}"/>
+                <a16:creationId xmlns:a16="http://schemas.microsoft.com/office/drawing/2014/main" id="{30A44368-3A6C-463F-8B3C-60D9A3D2EB97}"/>
               </a:ext>
             </a:extLst>
           </p:cNvPr>
@@ -19125,7 +19125,7 @@
           <p:cNvPr id="27" name="text">
             <a:extLst xmlns:a="http://schemas.openxmlformats.org/drawingml/2006/main">
               <a:ext uri="{FF2B5EF4-FFF2-40B4-BE49-F238E27FC236}">
-                <a16:creationId xmlns:a16="http://schemas.microsoft.com/office/drawing/2014/main" id="{EF08D345-F797-4233-86A9-06EB11BB9D97}"/>
+                <a16:creationId xmlns:a16="http://schemas.microsoft.com/office/drawing/2014/main" id="{98F8ACEE-4010-4DAB-AB59-B3F05934FFB2}"/>
               </a:ext>
             </a:extLst>
           </p:cNvPr>
@@ -19183,7 +19183,7 @@
           <p:cNvPr id="28" name="text">
             <a:extLst xmlns:a="http://schemas.openxmlformats.org/drawingml/2006/main">
               <a:ext uri="{FF2B5EF4-FFF2-40B4-BE49-F238E27FC236}">
-                <a16:creationId xmlns:a16="http://schemas.microsoft.com/office/drawing/2014/main" id="{FB019C88-986A-4E69-BC68-81ED33C679CA}"/>
+                <a16:creationId xmlns:a16="http://schemas.microsoft.com/office/drawing/2014/main" id="{0AFBB962-3B04-4C60-BA5E-4BA8C616F1DA}"/>
               </a:ext>
             </a:extLst>
           </p:cNvPr>
@@ -19241,7 +19241,7 @@
           <p:cNvPr id="29" name="text">
             <a:extLst xmlns:a="http://schemas.openxmlformats.org/drawingml/2006/main">
               <a:ext uri="{FF2B5EF4-FFF2-40B4-BE49-F238E27FC236}">
-                <a16:creationId xmlns:a16="http://schemas.microsoft.com/office/drawing/2014/main" id="{B40F0D98-30B5-46BE-A13F-F90DA5E4684B}"/>
+                <a16:creationId xmlns:a16="http://schemas.microsoft.com/office/drawing/2014/main" id="{371C2620-907B-46CD-A438-104246A54501}"/>
               </a:ext>
             </a:extLst>
           </p:cNvPr>
@@ -19299,7 +19299,7 @@
           <p:cNvPr id="30" name="module-5">
             <a:extLst xmlns:a="http://schemas.openxmlformats.org/drawingml/2006/main">
               <a:ext uri="{FF2B5EF4-FFF2-40B4-BE49-F238E27FC236}">
-                <a16:creationId xmlns:a16="http://schemas.microsoft.com/office/drawing/2014/main" id="{4E857076-45F6-4B69-952B-696BEF3E5D97}"/>
+                <a16:creationId xmlns:a16="http://schemas.microsoft.com/office/drawing/2014/main" id="{22408E11-EC2A-4395-B35D-BFA5BD3F3393}"/>
               </a:ext>
             </a:extLst>
           </p:cNvPr>
@@ -19334,7 +19334,7 @@
           <p:cNvPr id="31" name="module-accent-5">
             <a:extLst xmlns:a="http://schemas.openxmlformats.org/drawingml/2006/main">
               <a:ext uri="{FF2B5EF4-FFF2-40B4-BE49-F238E27FC236}">
-                <a16:creationId xmlns:a16="http://schemas.microsoft.com/office/drawing/2014/main" id="{9ED42FA6-2A47-4BDE-8410-5CADC3616991}"/>
+                <a16:creationId xmlns:a16="http://schemas.microsoft.com/office/drawing/2014/main" id="{B61A980E-E002-40FF-9917-26749873A7E5}"/>
               </a:ext>
             </a:extLst>
           </p:cNvPr>
@@ -19365,7 +19365,7 @@
           <p:cNvPr id="32" name="text">
             <a:extLst xmlns:a="http://schemas.openxmlformats.org/drawingml/2006/main">
               <a:ext uri="{FF2B5EF4-FFF2-40B4-BE49-F238E27FC236}">
-                <a16:creationId xmlns:a16="http://schemas.microsoft.com/office/drawing/2014/main" id="{9DC18429-FB9E-4D72-A671-5625059C1C6D}"/>
+                <a16:creationId xmlns:a16="http://schemas.microsoft.com/office/drawing/2014/main" id="{C25AE41E-1041-43FC-9131-CD9984E2FEF9}"/>
               </a:ext>
             </a:extLst>
           </p:cNvPr>
@@ -19423,7 +19423,7 @@
           <p:cNvPr id="33" name="text">
             <a:extLst xmlns:a="http://schemas.openxmlformats.org/drawingml/2006/main">
               <a:ext uri="{FF2B5EF4-FFF2-40B4-BE49-F238E27FC236}">
-                <a16:creationId xmlns:a16="http://schemas.microsoft.com/office/drawing/2014/main" id="{D1375CCA-49F6-4CEF-95EF-69A5F6494B2C}"/>
+                <a16:creationId xmlns:a16="http://schemas.microsoft.com/office/drawing/2014/main" id="{D418FBF0-ACCC-422A-B91B-1F4551426106}"/>
               </a:ext>
             </a:extLst>
           </p:cNvPr>
@@ -19481,7 +19481,7 @@
           <p:cNvPr id="34" name="text">
             <a:extLst xmlns:a="http://schemas.openxmlformats.org/drawingml/2006/main">
               <a:ext uri="{FF2B5EF4-FFF2-40B4-BE49-F238E27FC236}">
-                <a16:creationId xmlns:a16="http://schemas.microsoft.com/office/drawing/2014/main" id="{E3DDEF6B-3CAE-472B-9D86-3265B8E5AD8A}"/>
+                <a16:creationId xmlns:a16="http://schemas.microsoft.com/office/drawing/2014/main" id="{BC51982C-BB39-4F55-B47C-A99A4415D4E6}"/>
               </a:ext>
             </a:extLst>
           </p:cNvPr>
@@ -19539,7 +19539,7 @@
           <p:cNvPr id="35" name="text">
             <a:extLst xmlns:a="http://schemas.openxmlformats.org/drawingml/2006/main">
               <a:ext uri="{FF2B5EF4-FFF2-40B4-BE49-F238E27FC236}">
-                <a16:creationId xmlns:a16="http://schemas.microsoft.com/office/drawing/2014/main" id="{0FC676A0-9922-465C-9E63-C65825B05626}"/>
+                <a16:creationId xmlns:a16="http://schemas.microsoft.com/office/drawing/2014/main" id="{CD7FEF52-1ADD-4D94-84F1-81A8E1A9BF33}"/>
               </a:ext>
             </a:extLst>
           </p:cNvPr>
@@ -19595,7 +19595,7 @@
     </p:spTree>
     <p:extLst>
       <p:ext uri="{BB962C8B-B14F-4D97-AF65-F5344CB8AC3E}">
-        <p14:creationId xmlns:p14="http://schemas.microsoft.com/office/powerpoint/2010/main" val="587556647"/>
+        <p14:creationId xmlns:p14="http://schemas.microsoft.com/office/powerpoint/2010/main" val="570879834"/>
       </p:ext>
     </p:extLst>
   </p:cSld>
@@ -19626,7 +19626,7 @@
           <p:cNvPr id="1" name="eyebrow-7">
             <a:extLst xmlns:a="http://schemas.openxmlformats.org/drawingml/2006/main">
               <a:ext uri="{FF2B5EF4-FFF2-40B4-BE49-F238E27FC236}">
-                <a16:creationId xmlns:a16="http://schemas.microsoft.com/office/drawing/2014/main" id="{22E953C9-FEBB-4D4B-8100-D9FB06C7D3A8}"/>
+                <a16:creationId xmlns:a16="http://schemas.microsoft.com/office/drawing/2014/main" id="{1410C158-6AE8-4C50-BBEA-997475DF6503}"/>
               </a:ext>
             </a:extLst>
           </p:cNvPr>
@@ -19684,7 +19684,7 @@
           <p:cNvPr id="2" name="slide-title-7">
             <a:extLst xmlns:a="http://schemas.openxmlformats.org/drawingml/2006/main">
               <a:ext uri="{FF2B5EF4-FFF2-40B4-BE49-F238E27FC236}">
-                <a16:creationId xmlns:a16="http://schemas.microsoft.com/office/drawing/2014/main" id="{1828A44D-5B79-43D7-A564-59FBEB6D3423}"/>
+                <a16:creationId xmlns:a16="http://schemas.microsoft.com/office/drawing/2014/main" id="{ACE6EED0-3C54-40D7-AC65-36E42423C13B}"/>
               </a:ext>
             </a:extLst>
           </p:cNvPr>
@@ -19742,7 +19742,7 @@
           <p:cNvPr id="3" name="title-rule-7">
             <a:extLst xmlns:a="http://schemas.openxmlformats.org/drawingml/2006/main">
               <a:ext uri="{FF2B5EF4-FFF2-40B4-BE49-F238E27FC236}">
-                <a16:creationId xmlns:a16="http://schemas.microsoft.com/office/drawing/2014/main" id="{98950AED-3BDF-4CF8-9FBD-0E74AC2403F0}"/>
+                <a16:creationId xmlns:a16="http://schemas.microsoft.com/office/drawing/2014/main" id="{A7A5AE36-9FC2-45C7-97AF-FDF759A24F62}"/>
               </a:ext>
             </a:extLst>
           </p:cNvPr>
@@ -19773,7 +19773,7 @@
           <p:cNvPr id="4" name="page-number-7">
             <a:extLst xmlns:a="http://schemas.openxmlformats.org/drawingml/2006/main">
               <a:ext uri="{FF2B5EF4-FFF2-40B4-BE49-F238E27FC236}">
-                <a16:creationId xmlns:a16="http://schemas.microsoft.com/office/drawing/2014/main" id="{D9A88554-BB95-44B3-87C2-939ADDB6BBA4}"/>
+                <a16:creationId xmlns:a16="http://schemas.microsoft.com/office/drawing/2014/main" id="{27888651-1EB9-4728-AC93-A5C17B8E7F9A}"/>
               </a:ext>
             </a:extLst>
           </p:cNvPr>
@@ -19831,7 +19831,7 @@
           <p:cNvPr id="5" name="职位雷达页面-frame">
             <a:extLst xmlns:a="http://schemas.openxmlformats.org/drawingml/2006/main">
               <a:ext uri="{FF2B5EF4-FFF2-40B4-BE49-F238E27FC236}">
-                <a16:creationId xmlns:a16="http://schemas.microsoft.com/office/drawing/2014/main" id="{1C7280E4-168A-4A0B-8DE3-736BE12D71DE}"/>
+                <a16:creationId xmlns:a16="http://schemas.microsoft.com/office/drawing/2014/main" id="{738D059D-8868-4EB2-BE42-580D1A7EBD9A}"/>
               </a:ext>
             </a:extLst>
           </p:cNvPr>
@@ -19870,7 +19870,7 @@
           <p:nvPr/>
         </p:nvPicPr>
         <p:blipFill>
-          <a:blip xmlns:r="http://schemas.openxmlformats.org/officeDocument/2006/relationships" xmlns:a="http://schemas.openxmlformats.org/drawingml/2006/main" r:embed="Rc672fe6c01ca49dc"/>
+          <a:blip xmlns:r="http://schemas.openxmlformats.org/officeDocument/2006/relationships" xmlns:a="http://schemas.openxmlformats.org/drawingml/2006/main" r:embed="Rd8ffd2ac85ed4d71"/>
           <a:stretch xmlns:a="http://schemas.openxmlformats.org/drawingml/2006/main"/>
         </p:blipFill>
         <p:spPr>
@@ -19890,7 +19890,7 @@
           <p:cNvPr id="7" name="text">
             <a:extLst xmlns:a="http://schemas.openxmlformats.org/drawingml/2006/main">
               <a:ext uri="{FF2B5EF4-FFF2-40B4-BE49-F238E27FC236}">
-                <a16:creationId xmlns:a16="http://schemas.microsoft.com/office/drawing/2014/main" id="{1E1E4805-F6FE-4DA3-8D6F-8FCBA6FBA32E}"/>
+                <a16:creationId xmlns:a16="http://schemas.microsoft.com/office/drawing/2014/main" id="{6AEA3B20-144C-4C94-83E5-F22B957537C3}"/>
               </a:ext>
             </a:extLst>
           </p:cNvPr>
@@ -19948,7 +19948,7 @@
           <p:cNvPr id="8" name="四题模拟面试-frame">
             <a:extLst xmlns:a="http://schemas.openxmlformats.org/drawingml/2006/main">
               <a:ext uri="{FF2B5EF4-FFF2-40B4-BE49-F238E27FC236}">
-                <a16:creationId xmlns:a16="http://schemas.microsoft.com/office/drawing/2014/main" id="{DD947DDF-3B26-4E6F-A5C6-15B5751F50CE}"/>
+                <a16:creationId xmlns:a16="http://schemas.microsoft.com/office/drawing/2014/main" id="{0F0AB618-8985-44C7-ACB7-12C76C239D13}"/>
               </a:ext>
             </a:extLst>
           </p:cNvPr>
@@ -19987,7 +19987,7 @@
           <p:nvPr/>
         </p:nvPicPr>
         <p:blipFill>
-          <a:blip xmlns:r="http://schemas.openxmlformats.org/officeDocument/2006/relationships" xmlns:a="http://schemas.openxmlformats.org/drawingml/2006/main" r:embed="R43ed7d8818f24987"/>
+          <a:blip xmlns:r="http://schemas.openxmlformats.org/officeDocument/2006/relationships" xmlns:a="http://schemas.openxmlformats.org/drawingml/2006/main" r:embed="Rb383ba4e456e4675"/>
           <a:stretch xmlns:a="http://schemas.openxmlformats.org/drawingml/2006/main"/>
         </p:blipFill>
         <p:spPr>
@@ -20007,7 +20007,7 @@
           <p:cNvPr id="10" name="text">
             <a:extLst xmlns:a="http://schemas.openxmlformats.org/drawingml/2006/main">
               <a:ext uri="{FF2B5EF4-FFF2-40B4-BE49-F238E27FC236}">
-                <a16:creationId xmlns:a16="http://schemas.microsoft.com/office/drawing/2014/main" id="{155E3EC4-DED9-45D0-B301-233593C72629}"/>
+                <a16:creationId xmlns:a16="http://schemas.microsoft.com/office/drawing/2014/main" id="{21943D5D-DFC3-453E-8F76-BFDAD8673BBE}"/>
               </a:ext>
             </a:extLst>
           </p:cNvPr>
@@ -20065,7 +20065,7 @@
           <p:cNvPr id="11" name="消息中心-frame">
             <a:extLst xmlns:a="http://schemas.openxmlformats.org/drawingml/2006/main">
               <a:ext uri="{FF2B5EF4-FFF2-40B4-BE49-F238E27FC236}">
-                <a16:creationId xmlns:a16="http://schemas.microsoft.com/office/drawing/2014/main" id="{023CAF62-F997-4794-8390-3A9B58CFE79C}"/>
+                <a16:creationId xmlns:a16="http://schemas.microsoft.com/office/drawing/2014/main" id="{D1EEEFE5-8E4B-4C74-A489-3368C620B261}"/>
               </a:ext>
             </a:extLst>
           </p:cNvPr>
@@ -20104,7 +20104,7 @@
           <p:nvPr/>
         </p:nvPicPr>
         <p:blipFill>
-          <a:blip xmlns:r="http://schemas.openxmlformats.org/officeDocument/2006/relationships" xmlns:a="http://schemas.openxmlformats.org/drawingml/2006/main" r:embed="R040a3895ddef48a0"/>
+          <a:blip xmlns:r="http://schemas.openxmlformats.org/officeDocument/2006/relationships" xmlns:a="http://schemas.openxmlformats.org/drawingml/2006/main" r:embed="R2f9b8874dadb4a9e"/>
           <a:stretch xmlns:a="http://schemas.openxmlformats.org/drawingml/2006/main"/>
         </p:blipFill>
         <p:spPr>
@@ -20124,7 +20124,7 @@
           <p:cNvPr id="13" name="text">
             <a:extLst xmlns:a="http://schemas.openxmlformats.org/drawingml/2006/main">
               <a:ext uri="{FF2B5EF4-FFF2-40B4-BE49-F238E27FC236}">
-                <a16:creationId xmlns:a16="http://schemas.microsoft.com/office/drawing/2014/main" id="{9AE80ACD-D8BC-49C9-920D-86C8261EE11B}"/>
+                <a16:creationId xmlns:a16="http://schemas.microsoft.com/office/drawing/2014/main" id="{774EAC42-D0AC-46B0-BF02-C1BB1D7684C5}"/>
               </a:ext>
             </a:extLst>
           </p:cNvPr>
@@ -20180,7 +20180,7 @@
     </p:spTree>
     <p:extLst>
       <p:ext uri="{BB962C8B-B14F-4D97-AF65-F5344CB8AC3E}">
-        <p14:creationId xmlns:p14="http://schemas.microsoft.com/office/powerpoint/2010/main" val="1041439573"/>
+        <p14:creationId xmlns:p14="http://schemas.microsoft.com/office/powerpoint/2010/main" val="37767191"/>
       </p:ext>
     </p:extLst>
   </p:cSld>
@@ -20211,7 +20211,7 @@
           <p:cNvPr id="1" name="eyebrow-8">
             <a:extLst xmlns:a="http://schemas.openxmlformats.org/drawingml/2006/main">
               <a:ext uri="{FF2B5EF4-FFF2-40B4-BE49-F238E27FC236}">
-                <a16:creationId xmlns:a16="http://schemas.microsoft.com/office/drawing/2014/main" id="{3D299375-CDD2-41EB-9B16-77AFBF94E87C}"/>
+                <a16:creationId xmlns:a16="http://schemas.microsoft.com/office/drawing/2014/main" id="{01BC6B82-4D91-4F1E-9217-333102E4295D}"/>
               </a:ext>
             </a:extLst>
           </p:cNvPr>
@@ -20269,7 +20269,7 @@
           <p:cNvPr id="2" name="slide-title-8">
             <a:extLst xmlns:a="http://schemas.openxmlformats.org/drawingml/2006/main">
               <a:ext uri="{FF2B5EF4-FFF2-40B4-BE49-F238E27FC236}">
-                <a16:creationId xmlns:a16="http://schemas.microsoft.com/office/drawing/2014/main" id="{FAAE0AF5-24B2-4606-B42C-E35CF478C335}"/>
+                <a16:creationId xmlns:a16="http://schemas.microsoft.com/office/drawing/2014/main" id="{B203A861-8AC4-4C93-B864-5C35C94D4206}"/>
               </a:ext>
             </a:extLst>
           </p:cNvPr>
@@ -20327,7 +20327,7 @@
           <p:cNvPr id="3" name="title-rule-8">
             <a:extLst xmlns:a="http://schemas.openxmlformats.org/drawingml/2006/main">
               <a:ext uri="{FF2B5EF4-FFF2-40B4-BE49-F238E27FC236}">
-                <a16:creationId xmlns:a16="http://schemas.microsoft.com/office/drawing/2014/main" id="{DD237B76-5AD0-4E2E-B80C-0B1F42C7CD37}"/>
+                <a16:creationId xmlns:a16="http://schemas.microsoft.com/office/drawing/2014/main" id="{98F3AF96-9960-456D-9EC7-8BEFAF51A012}"/>
               </a:ext>
             </a:extLst>
           </p:cNvPr>
@@ -20358,7 +20358,7 @@
           <p:cNvPr id="4" name="page-number-8">
             <a:extLst xmlns:a="http://schemas.openxmlformats.org/drawingml/2006/main">
               <a:ext uri="{FF2B5EF4-FFF2-40B4-BE49-F238E27FC236}">
-                <a16:creationId xmlns:a16="http://schemas.microsoft.com/office/drawing/2014/main" id="{80DF27CC-BA08-4CDC-B07D-BD8221BA546F}"/>
+                <a16:creationId xmlns:a16="http://schemas.microsoft.com/office/drawing/2014/main" id="{7DCF58CF-19F6-428C-93F6-C9A634426275}"/>
               </a:ext>
             </a:extLst>
           </p:cNvPr>
@@ -20416,7 +20416,7 @@
           <p:cNvPr id="5" name="redis-node-0">
             <a:extLst xmlns:a="http://schemas.openxmlformats.org/drawingml/2006/main">
               <a:ext uri="{FF2B5EF4-FFF2-40B4-BE49-F238E27FC236}">
-                <a16:creationId xmlns:a16="http://schemas.microsoft.com/office/drawing/2014/main" id="{CC76FF31-9938-4233-88C1-A646FEE6C738}"/>
+                <a16:creationId xmlns:a16="http://schemas.microsoft.com/office/drawing/2014/main" id="{F6079A8B-80C6-4541-8C25-BB2FF4C276D4}"/>
               </a:ext>
             </a:extLst>
           </p:cNvPr>
@@ -20451,7 +20451,7 @@
           <p:cNvPr id="6" name="text">
             <a:extLst xmlns:a="http://schemas.openxmlformats.org/drawingml/2006/main">
               <a:ext uri="{FF2B5EF4-FFF2-40B4-BE49-F238E27FC236}">
-                <a16:creationId xmlns:a16="http://schemas.microsoft.com/office/drawing/2014/main" id="{8840770A-894F-4A70-815E-F445B8AD4B6B}"/>
+                <a16:creationId xmlns:a16="http://schemas.microsoft.com/office/drawing/2014/main" id="{E906D038-6193-429F-A9DF-8BF07A6BD2D9}"/>
               </a:ext>
             </a:extLst>
           </p:cNvPr>
@@ -20509,7 +20509,7 @@
           <p:cNvPr id="7" name="text">
             <a:extLst xmlns:a="http://schemas.openxmlformats.org/drawingml/2006/main">
               <a:ext uri="{FF2B5EF4-FFF2-40B4-BE49-F238E27FC236}">
-                <a16:creationId xmlns:a16="http://schemas.microsoft.com/office/drawing/2014/main" id="{4889E2DA-287B-4964-A7AA-5D927851C311}"/>
+                <a16:creationId xmlns:a16="http://schemas.microsoft.com/office/drawing/2014/main" id="{6388ECF1-5DE7-4FA7-BACC-A7718107AA72}"/>
               </a:ext>
             </a:extLst>
           </p:cNvPr>
@@ -20567,7 +20567,7 @@
           <p:cNvPr id="8" name="arrow">
             <a:extLst xmlns:a="http://schemas.openxmlformats.org/drawingml/2006/main">
               <a:ext uri="{FF2B5EF4-FFF2-40B4-BE49-F238E27FC236}">
-                <a16:creationId xmlns:a16="http://schemas.microsoft.com/office/drawing/2014/main" id="{431879AA-A123-43C6-A69A-23E762497354}"/>
+                <a16:creationId xmlns:a16="http://schemas.microsoft.com/office/drawing/2014/main" id="{F8B75B64-9DF6-42AC-98C3-95FCD56CADDE}"/>
               </a:ext>
             </a:extLst>
           </p:cNvPr>
@@ -20625,7 +20625,7 @@
           <p:cNvPr id="9" name="redis-node-1">
             <a:extLst xmlns:a="http://schemas.openxmlformats.org/drawingml/2006/main">
               <a:ext uri="{FF2B5EF4-FFF2-40B4-BE49-F238E27FC236}">
-                <a16:creationId xmlns:a16="http://schemas.microsoft.com/office/drawing/2014/main" id="{2BEF1F4B-BC8D-4317-9451-2DC893695107}"/>
+                <a16:creationId xmlns:a16="http://schemas.microsoft.com/office/drawing/2014/main" id="{3C7F1010-39BD-427E-9347-39B4EEE5ABC9}"/>
               </a:ext>
             </a:extLst>
           </p:cNvPr>
@@ -20660,7 +20660,7 @@
           <p:cNvPr id="10" name="text">
             <a:extLst xmlns:a="http://schemas.openxmlformats.org/drawingml/2006/main">
               <a:ext uri="{FF2B5EF4-FFF2-40B4-BE49-F238E27FC236}">
-                <a16:creationId xmlns:a16="http://schemas.microsoft.com/office/drawing/2014/main" id="{503F10E1-DF62-4AE4-99FF-243503B1B021}"/>
+                <a16:creationId xmlns:a16="http://schemas.microsoft.com/office/drawing/2014/main" id="{66F02919-EE1C-4595-BA7A-F331C30D6DD4}"/>
               </a:ext>
             </a:extLst>
           </p:cNvPr>
@@ -20718,7 +20718,7 @@
           <p:cNvPr id="11" name="text">
             <a:extLst xmlns:a="http://schemas.openxmlformats.org/drawingml/2006/main">
               <a:ext uri="{FF2B5EF4-FFF2-40B4-BE49-F238E27FC236}">
-                <a16:creationId xmlns:a16="http://schemas.microsoft.com/office/drawing/2014/main" id="{D55823FB-2451-4CAF-A315-A89D1AC96CB0}"/>
+                <a16:creationId xmlns:a16="http://schemas.microsoft.com/office/drawing/2014/main" id="{0E40D326-94BD-4F44-AA7D-0039A9E0BD76}"/>
               </a:ext>
             </a:extLst>
           </p:cNvPr>
@@ -20776,7 +20776,7 @@
           <p:cNvPr id="12" name="arrow">
             <a:extLst xmlns:a="http://schemas.openxmlformats.org/drawingml/2006/main">
               <a:ext uri="{FF2B5EF4-FFF2-40B4-BE49-F238E27FC236}">
-                <a16:creationId xmlns:a16="http://schemas.microsoft.com/office/drawing/2014/main" id="{CB386994-4670-42E6-8BEE-D3E11CCEB84F}"/>
+                <a16:creationId xmlns:a16="http://schemas.microsoft.com/office/drawing/2014/main" id="{C0DC5C19-C1EB-460E-BDE8-0A9130F2A1B7}"/>
               </a:ext>
             </a:extLst>
           </p:cNvPr>
@@ -20834,7 +20834,7 @@
           <p:cNvPr id="13" name="redis-node-2">
             <a:extLst xmlns:a="http://schemas.openxmlformats.org/drawingml/2006/main">
               <a:ext uri="{FF2B5EF4-FFF2-40B4-BE49-F238E27FC236}">
-                <a16:creationId xmlns:a16="http://schemas.microsoft.com/office/drawing/2014/main" id="{D1F87EC8-77CD-4314-81AB-583B8EC848C7}"/>
+                <a16:creationId xmlns:a16="http://schemas.microsoft.com/office/drawing/2014/main" id="{0FB6E5AF-53C9-483B-A196-A86CDE44086C}"/>
               </a:ext>
             </a:extLst>
           </p:cNvPr>
@@ -20869,7 +20869,7 @@
           <p:cNvPr id="14" name="text">
             <a:extLst xmlns:a="http://schemas.openxmlformats.org/drawingml/2006/main">
               <a:ext uri="{FF2B5EF4-FFF2-40B4-BE49-F238E27FC236}">
-                <a16:creationId xmlns:a16="http://schemas.microsoft.com/office/drawing/2014/main" id="{636A8F3D-229A-45EC-A3B6-B89274BAAA6C}"/>
+                <a16:creationId xmlns:a16="http://schemas.microsoft.com/office/drawing/2014/main" id="{E2433AA0-8DC9-4279-B6FD-A00C523A4AC4}"/>
               </a:ext>
             </a:extLst>
           </p:cNvPr>
@@ -20927,7 +20927,7 @@
           <p:cNvPr id="15" name="text">
             <a:extLst xmlns:a="http://schemas.openxmlformats.org/drawingml/2006/main">
               <a:ext uri="{FF2B5EF4-FFF2-40B4-BE49-F238E27FC236}">
-                <a16:creationId xmlns:a16="http://schemas.microsoft.com/office/drawing/2014/main" id="{CC297035-F13F-4649-B799-A68F6673354E}"/>
+                <a16:creationId xmlns:a16="http://schemas.microsoft.com/office/drawing/2014/main" id="{A7E53E91-0F33-4A48-A678-71659E3FB84B}"/>
               </a:ext>
             </a:extLst>
           </p:cNvPr>
@@ -20985,7 +20985,7 @@
           <p:cNvPr id="16" name="arrow">
             <a:extLst xmlns:a="http://schemas.openxmlformats.org/drawingml/2006/main">
               <a:ext uri="{FF2B5EF4-FFF2-40B4-BE49-F238E27FC236}">
-                <a16:creationId xmlns:a16="http://schemas.microsoft.com/office/drawing/2014/main" id="{0F303894-DFB9-42B4-B57C-E2579103374E}"/>
+                <a16:creationId xmlns:a16="http://schemas.microsoft.com/office/drawing/2014/main" id="{CC6E449A-960A-459E-846B-149C8CEEF021}"/>
               </a:ext>
             </a:extLst>
           </p:cNvPr>
@@ -21043,7 +21043,7 @@
           <p:cNvPr id="17" name="redis-node-3">
             <a:extLst xmlns:a="http://schemas.openxmlformats.org/drawingml/2006/main">
               <a:ext uri="{FF2B5EF4-FFF2-40B4-BE49-F238E27FC236}">
-                <a16:creationId xmlns:a16="http://schemas.microsoft.com/office/drawing/2014/main" id="{8726815D-1287-4CB7-9497-4E33A8EDBC0D}"/>
+                <a16:creationId xmlns:a16="http://schemas.microsoft.com/office/drawing/2014/main" id="{192AB7B3-C9B6-4E20-BAC6-1C097F24A70A}"/>
               </a:ext>
             </a:extLst>
           </p:cNvPr>
@@ -21078,7 +21078,7 @@
           <p:cNvPr id="18" name="text">
             <a:extLst xmlns:a="http://schemas.openxmlformats.org/drawingml/2006/main">
               <a:ext uri="{FF2B5EF4-FFF2-40B4-BE49-F238E27FC236}">
-                <a16:creationId xmlns:a16="http://schemas.microsoft.com/office/drawing/2014/main" id="{8E5D1113-19CF-4C7A-B451-B8B4DC5D40C6}"/>
+                <a16:creationId xmlns:a16="http://schemas.microsoft.com/office/drawing/2014/main" id="{9AD46C1A-F136-460E-9864-49238A32CEE0}"/>
               </a:ext>
             </a:extLst>
           </p:cNvPr>
@@ -21136,7 +21136,7 @@
           <p:cNvPr id="19" name="text">
             <a:extLst xmlns:a="http://schemas.openxmlformats.org/drawingml/2006/main">
               <a:ext uri="{FF2B5EF4-FFF2-40B4-BE49-F238E27FC236}">
-                <a16:creationId xmlns:a16="http://schemas.microsoft.com/office/drawing/2014/main" id="{2A7BC655-CD3F-408C-AF9E-E470B626BD8D}"/>
+                <a16:creationId xmlns:a16="http://schemas.microsoft.com/office/drawing/2014/main" id="{63E7EF43-25AC-4668-88DB-669A9A4A66F9}"/>
               </a:ext>
             </a:extLst>
           </p:cNvPr>
@@ -21194,7 +21194,7 @@
           <p:cNvPr id="20" name="stat-JSON 缓存过期时间">
             <a:extLst xmlns:a="http://schemas.openxmlformats.org/drawingml/2006/main">
               <a:ext uri="{FF2B5EF4-FFF2-40B4-BE49-F238E27FC236}">
-                <a16:creationId xmlns:a16="http://schemas.microsoft.com/office/drawing/2014/main" id="{96EBE4C5-1CE1-4E76-A4F2-3FF1C5FD01CB}"/>
+                <a16:creationId xmlns:a16="http://schemas.microsoft.com/office/drawing/2014/main" id="{436256C9-06D3-455F-9B57-AE2FF970E96F}"/>
               </a:ext>
             </a:extLst>
           </p:cNvPr>
@@ -21229,7 +21229,7 @@
           <p:cNvPr id="21" name="stat-accent-JSON 缓存过期时间">
             <a:extLst xmlns:a="http://schemas.openxmlformats.org/drawingml/2006/main">
               <a:ext uri="{FF2B5EF4-FFF2-40B4-BE49-F238E27FC236}">
-                <a16:creationId xmlns:a16="http://schemas.microsoft.com/office/drawing/2014/main" id="{A3F12568-37D6-4B58-AABF-99935D6142E5}"/>
+                <a16:creationId xmlns:a16="http://schemas.microsoft.com/office/drawing/2014/main" id="{18F640A8-8C10-412D-B6CA-137BDD1531AB}"/>
               </a:ext>
             </a:extLst>
           </p:cNvPr>
@@ -21260,7 +21260,7 @@
           <p:cNvPr id="22" name="stat-value-JSON 缓存过期时间">
             <a:extLst xmlns:a="http://schemas.openxmlformats.org/drawingml/2006/main">
               <a:ext uri="{FF2B5EF4-FFF2-40B4-BE49-F238E27FC236}">
-                <a16:creationId xmlns:a16="http://schemas.microsoft.com/office/drawing/2014/main" id="{6B34EBD0-EA3A-4FD5-B6ED-887A8635D63D}"/>
+                <a16:creationId xmlns:a16="http://schemas.microsoft.com/office/drawing/2014/main" id="{CA7798E8-ACA8-43D6-A2B7-547EFE5BE213}"/>
               </a:ext>
             </a:extLst>
           </p:cNvPr>
@@ -21318,7 +21318,7 @@
           <p:cNvPr id="23" name="stat-label-JSON 缓存过期时间">
             <a:extLst xmlns:a="http://schemas.openxmlformats.org/drawingml/2006/main">
               <a:ext uri="{FF2B5EF4-FFF2-40B4-BE49-F238E27FC236}">
-                <a16:creationId xmlns:a16="http://schemas.microsoft.com/office/drawing/2014/main" id="{3EC2213B-74D8-4BE5-85C6-418A26FE3A7E}"/>
+                <a16:creationId xmlns:a16="http://schemas.microsoft.com/office/drawing/2014/main" id="{227F812A-B908-4555-A197-28CAFC9CE814}"/>
               </a:ext>
             </a:extLst>
           </p:cNvPr>
@@ -21376,7 +21376,7 @@
           <p:cNvPr id="24" name="stat-列表与详情缓存">
             <a:extLst xmlns:a="http://schemas.openxmlformats.org/drawingml/2006/main">
               <a:ext uri="{FF2B5EF4-FFF2-40B4-BE49-F238E27FC236}">
-                <a16:creationId xmlns:a16="http://schemas.microsoft.com/office/drawing/2014/main" id="{AE58C325-1DED-4366-89EA-6ECD473B8A4E}"/>
+                <a16:creationId xmlns:a16="http://schemas.microsoft.com/office/drawing/2014/main" id="{CA4473D7-AA38-4DF3-A3C6-2BCDEE11BDB1}"/>
               </a:ext>
             </a:extLst>
           </p:cNvPr>
@@ -21411,7 +21411,7 @@
           <p:cNvPr id="25" name="stat-accent-列表与详情缓存">
             <a:extLst xmlns:a="http://schemas.openxmlformats.org/drawingml/2006/main">
               <a:ext uri="{FF2B5EF4-FFF2-40B4-BE49-F238E27FC236}">
-                <a16:creationId xmlns:a16="http://schemas.microsoft.com/office/drawing/2014/main" id="{9A217569-4681-4EE7-834D-44BB17D3E042}"/>
+                <a16:creationId xmlns:a16="http://schemas.microsoft.com/office/drawing/2014/main" id="{AA56E4E3-00FF-4A5D-B70B-6170BDAF07DD}"/>
               </a:ext>
             </a:extLst>
           </p:cNvPr>
@@ -21442,7 +21442,7 @@
           <p:cNvPr id="26" name="stat-value-列表与详情缓存">
             <a:extLst xmlns:a="http://schemas.openxmlformats.org/drawingml/2006/main">
               <a:ext uri="{FF2B5EF4-FFF2-40B4-BE49-F238E27FC236}">
-                <a16:creationId xmlns:a16="http://schemas.microsoft.com/office/drawing/2014/main" id="{1C030BCD-1949-4E42-A9C1-80F3983E00DE}"/>
+                <a16:creationId xmlns:a16="http://schemas.microsoft.com/office/drawing/2014/main" id="{F5F32903-FA05-465A-96ED-9C09FB25CC16}"/>
               </a:ext>
             </a:extLst>
           </p:cNvPr>
@@ -21500,7 +21500,7 @@
           <p:cNvPr id="27" name="stat-label-列表与详情缓存">
             <a:extLst xmlns:a="http://schemas.openxmlformats.org/drawingml/2006/main">
               <a:ext uri="{FF2B5EF4-FFF2-40B4-BE49-F238E27FC236}">
-                <a16:creationId xmlns:a16="http://schemas.microsoft.com/office/drawing/2014/main" id="{C2C5DC0B-9B7E-424C-99AC-7D8F2B91D658}"/>
+                <a16:creationId xmlns:a16="http://schemas.microsoft.com/office/drawing/2014/main" id="{780FF8D1-C6A9-456A-B185-083290F72757}"/>
               </a:ext>
             </a:extLst>
           </p:cNvPr>
@@ -21558,7 +21558,7 @@
           <p:cNvPr id="28" name="stat-radar: 便于课堂演示">
             <a:extLst xmlns:a="http://schemas.openxmlformats.org/drawingml/2006/main">
               <a:ext uri="{FF2B5EF4-FFF2-40B4-BE49-F238E27FC236}">
-                <a16:creationId xmlns:a16="http://schemas.microsoft.com/office/drawing/2014/main" id="{49DE4BCF-ADF2-4306-A0BE-788771FC6C76}"/>
+                <a16:creationId xmlns:a16="http://schemas.microsoft.com/office/drawing/2014/main" id="{431408CE-ECF5-4DF7-9393-939955EF546D}"/>
               </a:ext>
             </a:extLst>
           </p:cNvPr>
@@ -21593,7 +21593,7 @@
           <p:cNvPr id="29" name="stat-accent-radar: 便于课堂演示">
             <a:extLst xmlns:a="http://schemas.openxmlformats.org/drawingml/2006/main">
               <a:ext uri="{FF2B5EF4-FFF2-40B4-BE49-F238E27FC236}">
-                <a16:creationId xmlns:a16="http://schemas.microsoft.com/office/drawing/2014/main" id="{D7F2E90E-70D6-43B9-9ECE-3196CA13A148}"/>
+                <a16:creationId xmlns:a16="http://schemas.microsoft.com/office/drawing/2014/main" id="{91B6DEDE-7C64-4E92-8010-BAE29B4C2B1A}"/>
               </a:ext>
             </a:extLst>
           </p:cNvPr>
@@ -21624,7 +21624,7 @@
           <p:cNvPr id="30" name="stat-value-radar: 便于课堂演示">
             <a:extLst xmlns:a="http://schemas.openxmlformats.org/drawingml/2006/main">
               <a:ext uri="{FF2B5EF4-FFF2-40B4-BE49-F238E27FC236}">
-                <a16:creationId xmlns:a16="http://schemas.microsoft.com/office/drawing/2014/main" id="{20F9C164-98FA-4B20-BAC6-771D0F89A460}"/>
+                <a16:creationId xmlns:a16="http://schemas.microsoft.com/office/drawing/2014/main" id="{817B995E-76D4-47FD-BEC8-CEA68B217EA7}"/>
               </a:ext>
             </a:extLst>
           </p:cNvPr>
@@ -21682,7 +21682,7 @@
           <p:cNvPr id="31" name="stat-label-radar: 便于课堂演示">
             <a:extLst xmlns:a="http://schemas.openxmlformats.org/drawingml/2006/main">
               <a:ext uri="{FF2B5EF4-FFF2-40B4-BE49-F238E27FC236}">
-                <a16:creationId xmlns:a16="http://schemas.microsoft.com/office/drawing/2014/main" id="{4CCDE5F5-DE35-421E-8C4F-53235265B07C}"/>
+                <a16:creationId xmlns:a16="http://schemas.microsoft.com/office/drawing/2014/main" id="{6FEED567-8B10-4764-B857-012A5F1A56D5}"/>
               </a:ext>
             </a:extLst>
           </p:cNvPr>
@@ -21740,7 +21740,7 @@
           <p:cNvPr id="32" name="text">
             <a:extLst xmlns:a="http://schemas.openxmlformats.org/drawingml/2006/main">
               <a:ext uri="{FF2B5EF4-FFF2-40B4-BE49-F238E27FC236}">
-                <a16:creationId xmlns:a16="http://schemas.microsoft.com/office/drawing/2014/main" id="{71A3E81B-5977-420A-A043-CC1B25F81CC3}"/>
+                <a16:creationId xmlns:a16="http://schemas.microsoft.com/office/drawing/2014/main" id="{E00BAC31-4ADF-4BCD-A29A-D003F79A8582}"/>
               </a:ext>
             </a:extLst>
           </p:cNvPr>
@@ -21796,7 +21796,7 @@
     </p:spTree>
     <p:extLst>
       <p:ext uri="{BB962C8B-B14F-4D97-AF65-F5344CB8AC3E}">
-        <p14:creationId xmlns:p14="http://schemas.microsoft.com/office/powerpoint/2010/main" val="741466721"/>
+        <p14:creationId xmlns:p14="http://schemas.microsoft.com/office/powerpoint/2010/main" val="750370329"/>
       </p:ext>
     </p:extLst>
   </p:cSld>
@@ -21827,7 +21827,7 @@
           <p:cNvPr id="1" name="eyebrow-9">
             <a:extLst xmlns:a="http://schemas.openxmlformats.org/drawingml/2006/main">
               <a:ext uri="{FF2B5EF4-FFF2-40B4-BE49-F238E27FC236}">
-                <a16:creationId xmlns:a16="http://schemas.microsoft.com/office/drawing/2014/main" id="{1B3CA9DA-FE08-4A8B-8665-B6A9AFF213A1}"/>
+                <a16:creationId xmlns:a16="http://schemas.microsoft.com/office/drawing/2014/main" id="{60F69DCC-88CA-4437-9202-73146D966224}"/>
               </a:ext>
             </a:extLst>
           </p:cNvPr>
@@ -21885,7 +21885,7 @@
           <p:cNvPr id="2" name="slide-title-9">
             <a:extLst xmlns:a="http://schemas.openxmlformats.org/drawingml/2006/main">
               <a:ext uri="{FF2B5EF4-FFF2-40B4-BE49-F238E27FC236}">
-                <a16:creationId xmlns:a16="http://schemas.microsoft.com/office/drawing/2014/main" id="{6787FABB-9554-4D92-B288-47AE370A0FDD}"/>
+                <a16:creationId xmlns:a16="http://schemas.microsoft.com/office/drawing/2014/main" id="{41C08D3A-5433-4665-BC54-CD0EF972F80A}"/>
               </a:ext>
             </a:extLst>
           </p:cNvPr>
@@ -21943,7 +21943,7 @@
           <p:cNvPr id="3" name="title-rule-9">
             <a:extLst xmlns:a="http://schemas.openxmlformats.org/drawingml/2006/main">
               <a:ext uri="{FF2B5EF4-FFF2-40B4-BE49-F238E27FC236}">
-                <a16:creationId xmlns:a16="http://schemas.microsoft.com/office/drawing/2014/main" id="{15D10EA6-4699-4DA6-B702-A5283BB9B54D}"/>
+                <a16:creationId xmlns:a16="http://schemas.microsoft.com/office/drawing/2014/main" id="{AD225829-5421-43D1-8311-08FC32D433AC}"/>
               </a:ext>
             </a:extLst>
           </p:cNvPr>
@@ -21974,7 +21974,7 @@
           <p:cNvPr id="4" name="page-number-9">
             <a:extLst xmlns:a="http://schemas.openxmlformats.org/drawingml/2006/main">
               <a:ext uri="{FF2B5EF4-FFF2-40B4-BE49-F238E27FC236}">
-                <a16:creationId xmlns:a16="http://schemas.microsoft.com/office/drawing/2014/main" id="{2FDB9613-F8E2-47D2-B360-C79CB8A73848}"/>
+                <a16:creationId xmlns:a16="http://schemas.microsoft.com/office/drawing/2014/main" id="{ED083390-3750-4C6E-BFE6-FEDACF09189B}"/>
               </a:ext>
             </a:extLst>
           </p:cNvPr>
@@ -22032,7 +22032,7 @@
           <p:cNvPr id="5" name="mq-0">
             <a:extLst xmlns:a="http://schemas.openxmlformats.org/drawingml/2006/main">
               <a:ext uri="{FF2B5EF4-FFF2-40B4-BE49-F238E27FC236}">
-                <a16:creationId xmlns:a16="http://schemas.microsoft.com/office/drawing/2014/main" id="{3C0C59CA-C7B4-4573-89ED-9F5156B04631}"/>
+                <a16:creationId xmlns:a16="http://schemas.microsoft.com/office/drawing/2014/main" id="{3D4AC9DB-C858-4653-8A41-02C0FFC932D8}"/>
               </a:ext>
             </a:extLst>
           </p:cNvPr>
@@ -22067,7 +22067,7 @@
           <p:cNvPr id="6" name="text">
             <a:extLst xmlns:a="http://schemas.openxmlformats.org/drawingml/2006/main">
               <a:ext uri="{FF2B5EF4-FFF2-40B4-BE49-F238E27FC236}">
-                <a16:creationId xmlns:a16="http://schemas.microsoft.com/office/drawing/2014/main" id="{5C1BADC3-8419-4C07-89F3-DD6E3E31DF65}"/>
+                <a16:creationId xmlns:a16="http://schemas.microsoft.com/office/drawing/2014/main" id="{C61D4AA1-248D-44C2-AD75-CA5082C15F19}"/>
               </a:ext>
             </a:extLst>
           </p:cNvPr>
@@ -22125,7 +22125,7 @@
           <p:cNvPr id="7" name="text">
             <a:extLst xmlns:a="http://schemas.openxmlformats.org/drawingml/2006/main">
               <a:ext uri="{FF2B5EF4-FFF2-40B4-BE49-F238E27FC236}">
-                <a16:creationId xmlns:a16="http://schemas.microsoft.com/office/drawing/2014/main" id="{CCFF84A9-D35F-4C75-B3E9-E8E8473B7FAA}"/>
+                <a16:creationId xmlns:a16="http://schemas.microsoft.com/office/drawing/2014/main" id="{E562E997-708B-4976-B23F-5AC5FDD0E275}"/>
               </a:ext>
             </a:extLst>
           </p:cNvPr>
@@ -22183,7 +22183,7 @@
           <p:cNvPr id="8" name="arrow">
             <a:extLst xmlns:a="http://schemas.openxmlformats.org/drawingml/2006/main">
               <a:ext uri="{FF2B5EF4-FFF2-40B4-BE49-F238E27FC236}">
-                <a16:creationId xmlns:a16="http://schemas.microsoft.com/office/drawing/2014/main" id="{501E4DB5-B9F9-4C08-AE48-60F297CA0CF9}"/>
+                <a16:creationId xmlns:a16="http://schemas.microsoft.com/office/drawing/2014/main" id="{9754A8A7-D79A-4643-9E4C-F5C12FBA5822}"/>
               </a:ext>
             </a:extLst>
           </p:cNvPr>
@@ -22241,7 +22241,7 @@
           <p:cNvPr id="9" name="mq-1">
             <a:extLst xmlns:a="http://schemas.openxmlformats.org/drawingml/2006/main">
               <a:ext uri="{FF2B5EF4-FFF2-40B4-BE49-F238E27FC236}">
-                <a16:creationId xmlns:a16="http://schemas.microsoft.com/office/drawing/2014/main" id="{37162BE4-F4B2-428E-8C91-9CEFAAE95617}"/>
+                <a16:creationId xmlns:a16="http://schemas.microsoft.com/office/drawing/2014/main" id="{E2E2E045-50AF-4E81-B00C-3E62ACBF1EEA}"/>
               </a:ext>
             </a:extLst>
           </p:cNvPr>
@@ -22276,7 +22276,7 @@
           <p:cNvPr id="10" name="text">
             <a:extLst xmlns:a="http://schemas.openxmlformats.org/drawingml/2006/main">
               <a:ext uri="{FF2B5EF4-FFF2-40B4-BE49-F238E27FC236}">
-                <a16:creationId xmlns:a16="http://schemas.microsoft.com/office/drawing/2014/main" id="{79A16154-114F-4FA3-AB6C-192A5045A8D6}"/>
+                <a16:creationId xmlns:a16="http://schemas.microsoft.com/office/drawing/2014/main" id="{62181A07-D045-4BE1-8580-CA831D6BD0C7}"/>
               </a:ext>
             </a:extLst>
           </p:cNvPr>
@@ -22334,7 +22334,7 @@
           <p:cNvPr id="11" name="text">
             <a:extLst xmlns:a="http://schemas.openxmlformats.org/drawingml/2006/main">
               <a:ext uri="{FF2B5EF4-FFF2-40B4-BE49-F238E27FC236}">
-                <a16:creationId xmlns:a16="http://schemas.microsoft.com/office/drawing/2014/main" id="{8F18F257-283B-49B3-8047-234DB36627A8}"/>
+                <a16:creationId xmlns:a16="http://schemas.microsoft.com/office/drawing/2014/main" id="{83427DAA-E710-4DA0-9A38-2EFE1FAEC774}"/>
               </a:ext>
             </a:extLst>
           </p:cNvPr>
@@ -22392,7 +22392,7 @@
           <p:cNvPr id="12" name="arrow">
             <a:extLst xmlns:a="http://schemas.openxmlformats.org/drawingml/2006/main">
               <a:ext uri="{FF2B5EF4-FFF2-40B4-BE49-F238E27FC236}">
-                <a16:creationId xmlns:a16="http://schemas.microsoft.com/office/drawing/2014/main" id="{A4014DEB-9F97-4290-94AB-0E98718D5FC3}"/>
+                <a16:creationId xmlns:a16="http://schemas.microsoft.com/office/drawing/2014/main" id="{75B3A915-3525-4607-AC39-681D4FC18A14}"/>
               </a:ext>
             </a:extLst>
           </p:cNvPr>
@@ -22450,7 +22450,7 @@
           <p:cNvPr id="13" name="mq-2">
             <a:extLst xmlns:a="http://schemas.openxmlformats.org/drawingml/2006/main">
               <a:ext uri="{FF2B5EF4-FFF2-40B4-BE49-F238E27FC236}">
-                <a16:creationId xmlns:a16="http://schemas.microsoft.com/office/drawing/2014/main" id="{114F640B-C390-46D6-B34E-B3C036EAA7AA}"/>
+                <a16:creationId xmlns:a16="http://schemas.microsoft.com/office/drawing/2014/main" id="{53DADE2C-7C90-4A50-93C9-0EF0C819656F}"/>
               </a:ext>
             </a:extLst>
           </p:cNvPr>
@@ -22485,7 +22485,7 @@
           <p:cNvPr id="14" name="text">
             <a:extLst xmlns:a="http://schemas.openxmlformats.org/drawingml/2006/main">
               <a:ext uri="{FF2B5EF4-FFF2-40B4-BE49-F238E27FC236}">
-                <a16:creationId xmlns:a16="http://schemas.microsoft.com/office/drawing/2014/main" id="{BEE7B6DC-42E6-49E4-860B-376891D05784}"/>
+                <a16:creationId xmlns:a16="http://schemas.microsoft.com/office/drawing/2014/main" id="{6D4F2486-00F7-42D6-99BD-0E1CC86C2D5B}"/>
               </a:ext>
             </a:extLst>
           </p:cNvPr>
@@ -22543,7 +22543,7 @@
           <p:cNvPr id="15" name="text">
             <a:extLst xmlns:a="http://schemas.openxmlformats.org/drawingml/2006/main">
               <a:ext uri="{FF2B5EF4-FFF2-40B4-BE49-F238E27FC236}">
-                <a16:creationId xmlns:a16="http://schemas.microsoft.com/office/drawing/2014/main" id="{44B15640-6747-40A7-B242-9D869675D52F}"/>
+                <a16:creationId xmlns:a16="http://schemas.microsoft.com/office/drawing/2014/main" id="{E98097CA-69A7-43BC-ABB9-7717E6B31011}"/>
               </a:ext>
             </a:extLst>
           </p:cNvPr>
@@ -22601,7 +22601,7 @@
           <p:cNvPr id="16" name="arrow">
             <a:extLst xmlns:a="http://schemas.openxmlformats.org/drawingml/2006/main">
               <a:ext uri="{FF2B5EF4-FFF2-40B4-BE49-F238E27FC236}">
-                <a16:creationId xmlns:a16="http://schemas.microsoft.com/office/drawing/2014/main" id="{5BD88079-D4E2-40A4-8937-8F39327EBB16}"/>
+                <a16:creationId xmlns:a16="http://schemas.microsoft.com/office/drawing/2014/main" id="{36579D46-CEA2-478F-AB9E-EF801639FE0B}"/>
               </a:ext>
             </a:extLst>
           </p:cNvPr>
@@ -22659,7 +22659,7 @@
           <p:cNvPr id="17" name="mq-3">
             <a:extLst xmlns:a="http://schemas.openxmlformats.org/drawingml/2006/main">
               <a:ext uri="{FF2B5EF4-FFF2-40B4-BE49-F238E27FC236}">
-                <a16:creationId xmlns:a16="http://schemas.microsoft.com/office/drawing/2014/main" id="{1813C85A-158E-45EC-9E9B-E769AD1C569D}"/>
+                <a16:creationId xmlns:a16="http://schemas.microsoft.com/office/drawing/2014/main" id="{1D90F234-F1F6-49DE-B472-9D6B655C8409}"/>
               </a:ext>
             </a:extLst>
           </p:cNvPr>
@@ -22694,7 +22694,7 @@
           <p:cNvPr id="18" name="text">
             <a:extLst xmlns:a="http://schemas.openxmlformats.org/drawingml/2006/main">
               <a:ext uri="{FF2B5EF4-FFF2-40B4-BE49-F238E27FC236}">
-                <a16:creationId xmlns:a16="http://schemas.microsoft.com/office/drawing/2014/main" id="{94F1C39C-CEA6-467A-80BA-45C1CC82AE46}"/>
+                <a16:creationId xmlns:a16="http://schemas.microsoft.com/office/drawing/2014/main" id="{AABFE3B4-D961-4668-9148-3F2C7904AD0B}"/>
               </a:ext>
             </a:extLst>
           </p:cNvPr>
@@ -22752,7 +22752,7 @@
           <p:cNvPr id="19" name="text">
             <a:extLst xmlns:a="http://schemas.openxmlformats.org/drawingml/2006/main">
               <a:ext uri="{FF2B5EF4-FFF2-40B4-BE49-F238E27FC236}">
-                <a16:creationId xmlns:a16="http://schemas.microsoft.com/office/drawing/2014/main" id="{19E070D7-C4ED-4082-A280-9D9CBFC441EA}"/>
+                <a16:creationId xmlns:a16="http://schemas.microsoft.com/office/drawing/2014/main" id="{F0B3A6DD-3D8B-4C85-B86A-5BAC20812B50}"/>
               </a:ext>
             </a:extLst>
           </p:cNvPr>
@@ -22810,7 +22810,7 @@
           <p:cNvPr id="20" name="mq-point-0">
             <a:extLst xmlns:a="http://schemas.openxmlformats.org/drawingml/2006/main">
               <a:ext uri="{FF2B5EF4-FFF2-40B4-BE49-F238E27FC236}">
-                <a16:creationId xmlns:a16="http://schemas.microsoft.com/office/drawing/2014/main" id="{7195468D-092C-4B83-93C2-B985105C2135}"/>
+                <a16:creationId xmlns:a16="http://schemas.microsoft.com/office/drawing/2014/main" id="{ABB1F499-EEBB-409C-A936-2C2455348148}"/>
               </a:ext>
             </a:extLst>
           </p:cNvPr>
@@ -22845,7 +22845,7 @@
           <p:cNvPr id="21" name="text">
             <a:extLst xmlns:a="http://schemas.openxmlformats.org/drawingml/2006/main">
               <a:ext uri="{FF2B5EF4-FFF2-40B4-BE49-F238E27FC236}">
-                <a16:creationId xmlns:a16="http://schemas.microsoft.com/office/drawing/2014/main" id="{ECB6323F-25FE-468E-A087-12EDFB4FF747}"/>
+                <a16:creationId xmlns:a16="http://schemas.microsoft.com/office/drawing/2014/main" id="{6154755A-E92E-469B-8BC8-0D1C93407B4B}"/>
               </a:ext>
             </a:extLst>
           </p:cNvPr>
@@ -22903,7 +22903,7 @@
           <p:cNvPr id="22" name="text">
             <a:extLst xmlns:a="http://schemas.openxmlformats.org/drawingml/2006/main">
               <a:ext uri="{FF2B5EF4-FFF2-40B4-BE49-F238E27FC236}">
-                <a16:creationId xmlns:a16="http://schemas.microsoft.com/office/drawing/2014/main" id="{EF011878-271C-4B5F-B83D-75DA95042600}"/>
+                <a16:creationId xmlns:a16="http://schemas.microsoft.com/office/drawing/2014/main" id="{7DD27286-79CB-4201-B8F0-DDB65652EDC3}"/>
               </a:ext>
             </a:extLst>
           </p:cNvPr>
@@ -22961,7 +22961,7 @@
           <p:cNvPr id="23" name="mq-point-1">
             <a:extLst xmlns:a="http://schemas.openxmlformats.org/drawingml/2006/main">
               <a:ext uri="{FF2B5EF4-FFF2-40B4-BE49-F238E27FC236}">
-                <a16:creationId xmlns:a16="http://schemas.microsoft.com/office/drawing/2014/main" id="{51023953-6E77-4B55-AA0A-440F7D283AF3}"/>
+                <a16:creationId xmlns:a16="http://schemas.microsoft.com/office/drawing/2014/main" id="{077DAD4E-4309-475F-8E0C-7D434BF642DA}"/>
               </a:ext>
             </a:extLst>
           </p:cNvPr>
@@ -22996,7 +22996,7 @@
           <p:cNvPr id="24" name="text">
             <a:extLst xmlns:a="http://schemas.openxmlformats.org/drawingml/2006/main">
               <a:ext uri="{FF2B5EF4-FFF2-40B4-BE49-F238E27FC236}">
-                <a16:creationId xmlns:a16="http://schemas.microsoft.com/office/drawing/2014/main" id="{88DF95BB-A4D8-4A25-80FA-4D3FE5CCDD23}"/>
+                <a16:creationId xmlns:a16="http://schemas.microsoft.com/office/drawing/2014/main" id="{71DBFF3F-2A77-41E2-8767-540A1CDAE746}"/>
               </a:ext>
             </a:extLst>
           </p:cNvPr>
@@ -23054,7 +23054,7 @@
           <p:cNvPr id="25" name="text">
             <a:extLst xmlns:a="http://schemas.openxmlformats.org/drawingml/2006/main">
               <a:ext uri="{FF2B5EF4-FFF2-40B4-BE49-F238E27FC236}">
-                <a16:creationId xmlns:a16="http://schemas.microsoft.com/office/drawing/2014/main" id="{CBB47967-AB5B-44F8-AD51-572E9DB96709}"/>
+                <a16:creationId xmlns:a16="http://schemas.microsoft.com/office/drawing/2014/main" id="{A6493B32-975E-456B-99FB-6DE5567DA93A}"/>
               </a:ext>
             </a:extLst>
           </p:cNvPr>
@@ -23112,7 +23112,7 @@
           <p:cNvPr id="26" name="mq-point-2">
             <a:extLst xmlns:a="http://schemas.openxmlformats.org/drawingml/2006/main">
               <a:ext uri="{FF2B5EF4-FFF2-40B4-BE49-F238E27FC236}">
-                <a16:creationId xmlns:a16="http://schemas.microsoft.com/office/drawing/2014/main" id="{AD1C3643-F18D-4667-AAB5-1ECE5E231EB2}"/>
+                <a16:creationId xmlns:a16="http://schemas.microsoft.com/office/drawing/2014/main" id="{DA4963A3-DF13-41CC-ABD6-2335E5AF6B33}"/>
               </a:ext>
             </a:extLst>
           </p:cNvPr>
@@ -23147,7 +23147,7 @@
           <p:cNvPr id="27" name="text">
             <a:extLst xmlns:a="http://schemas.openxmlformats.org/drawingml/2006/main">
               <a:ext uri="{FF2B5EF4-FFF2-40B4-BE49-F238E27FC236}">
-                <a16:creationId xmlns:a16="http://schemas.microsoft.com/office/drawing/2014/main" id="{B8FC3917-3F4F-4DF9-98BF-2C81DD5DD6AD}"/>
+                <a16:creationId xmlns:a16="http://schemas.microsoft.com/office/drawing/2014/main" id="{8FE2ABB6-6F9C-4A3C-815A-104C1D45D00C}"/>
               </a:ext>
             </a:extLst>
           </p:cNvPr>
@@ -23205,7 +23205,7 @@
           <p:cNvPr id="28" name="text">
             <a:extLst xmlns:a="http://schemas.openxmlformats.org/drawingml/2006/main">
               <a:ext uri="{FF2B5EF4-FFF2-40B4-BE49-F238E27FC236}">
-                <a16:creationId xmlns:a16="http://schemas.microsoft.com/office/drawing/2014/main" id="{CC6DE92F-74A5-4A7B-B394-FBE32250576A}"/>
+                <a16:creationId xmlns:a16="http://schemas.microsoft.com/office/drawing/2014/main" id="{F1E180B5-BB9A-4FB2-9B4C-AFA46DF04BD6}"/>
               </a:ext>
             </a:extLst>
           </p:cNvPr>
@@ -23263,7 +23263,7 @@
           <p:cNvPr id="29" name="text">
             <a:extLst xmlns:a="http://schemas.openxmlformats.org/drawingml/2006/main">
               <a:ext uri="{FF2B5EF4-FFF2-40B4-BE49-F238E27FC236}">
-                <a16:creationId xmlns:a16="http://schemas.microsoft.com/office/drawing/2014/main" id="{BF467645-F25B-415A-942E-938285A15ED3}"/>
+                <a16:creationId xmlns:a16="http://schemas.microsoft.com/office/drawing/2014/main" id="{87DF64D1-B706-4FE0-BA4B-B650D8B46ADF}"/>
               </a:ext>
             </a:extLst>
           </p:cNvPr>
@@ -23319,7 +23319,7 @@
     </p:spTree>
     <p:extLst>
       <p:ext uri="{BB962C8B-B14F-4D97-AF65-F5344CB8AC3E}">
-        <p14:creationId xmlns:p14="http://schemas.microsoft.com/office/powerpoint/2010/main" val="830577734"/>
+        <p14:creationId xmlns:p14="http://schemas.microsoft.com/office/powerpoint/2010/main" val="409614956"/>
       </p:ext>
     </p:extLst>
   </p:cSld>

</xml_diff>

<commit_message>
fix: support Java time in RabbitMQ events
</commit_message>
<xml_diff>
--- a/docs/AI求职雷达课程项目答辩.pptx
+++ b/docs/AI求职雷达课程项目答辩.pptx
@@ -2,27 +2,27 @@
 <file path=ppt/presentation.xml><?xml version="1.0" encoding="utf-8"?>
 <p:presentation xmlns:p="http://schemas.openxmlformats.org/presentationml/2006/main">
   <p:sldMasterIdLst>
-    <p:sldMasterId xmlns:r="http://schemas.openxmlformats.org/officeDocument/2006/relationships" id="2147483648" r:id="R4466c7e726ca486c"/>
+    <p:sldMasterId xmlns:r="http://schemas.openxmlformats.org/officeDocument/2006/relationships" id="2147483648" r:id="R01145311ccba4e3a"/>
   </p:sldMasterIdLst>
   <p:notesMasterIdLst>
-    <p:notesMasterId xmlns:r="http://schemas.openxmlformats.org/officeDocument/2006/relationships" r:id="R6d13a50b3214430e"/>
+    <p:notesMasterId xmlns:r="http://schemas.openxmlformats.org/officeDocument/2006/relationships" r:id="Rbbe4aa758de245a0"/>
   </p:notesMasterIdLst>
   <p:sldIdLst>
-    <p:sldId xmlns:r="http://schemas.openxmlformats.org/officeDocument/2006/relationships" id="256" r:id="R4477f3193b8b4c32"/>
-    <p:sldId xmlns:r="http://schemas.openxmlformats.org/officeDocument/2006/relationships" id="257" r:id="R5521e2670db04323"/>
-    <p:sldId xmlns:r="http://schemas.openxmlformats.org/officeDocument/2006/relationships" id="258" r:id="R401254d0185646c4"/>
-    <p:sldId xmlns:r="http://schemas.openxmlformats.org/officeDocument/2006/relationships" id="259" r:id="Rc10fd2799efc4d48"/>
-    <p:sldId xmlns:r="http://schemas.openxmlformats.org/officeDocument/2006/relationships" id="260" r:id="Rb8b0140987cb4173"/>
-    <p:sldId xmlns:r="http://schemas.openxmlformats.org/officeDocument/2006/relationships" id="261" r:id="R377ca72f90ea4849"/>
-    <p:sldId xmlns:r="http://schemas.openxmlformats.org/officeDocument/2006/relationships" id="262" r:id="R365483fefa9f44e4"/>
-    <p:sldId xmlns:r="http://schemas.openxmlformats.org/officeDocument/2006/relationships" id="263" r:id="Re9fc2e42ab6349fb"/>
-    <p:sldId xmlns:r="http://schemas.openxmlformats.org/officeDocument/2006/relationships" id="264" r:id="R38673a3f73054705"/>
-    <p:sldId xmlns:r="http://schemas.openxmlformats.org/officeDocument/2006/relationships" id="265" r:id="R652a925fc7a841fe"/>
-    <p:sldId xmlns:r="http://schemas.openxmlformats.org/officeDocument/2006/relationships" id="266" r:id="R3349a40e5da94580"/>
-    <p:sldId xmlns:r="http://schemas.openxmlformats.org/officeDocument/2006/relationships" id="267" r:id="R1813c8003b954925"/>
-    <p:sldId xmlns:r="http://schemas.openxmlformats.org/officeDocument/2006/relationships" id="268" r:id="R0e4284a5462a41b1"/>
-    <p:sldId xmlns:r="http://schemas.openxmlformats.org/officeDocument/2006/relationships" id="269" r:id="R78f575ea341a431f"/>
-    <p:sldId xmlns:r="http://schemas.openxmlformats.org/officeDocument/2006/relationships" id="270" r:id="R0b46c8d579ea49fc"/>
+    <p:sldId xmlns:r="http://schemas.openxmlformats.org/officeDocument/2006/relationships" id="256" r:id="R61b28309591f46e7"/>
+    <p:sldId xmlns:r="http://schemas.openxmlformats.org/officeDocument/2006/relationships" id="257" r:id="Rf6f3c4cd5d0c4000"/>
+    <p:sldId xmlns:r="http://schemas.openxmlformats.org/officeDocument/2006/relationships" id="258" r:id="R69b88630c37c42af"/>
+    <p:sldId xmlns:r="http://schemas.openxmlformats.org/officeDocument/2006/relationships" id="259" r:id="R4020d0ba31cd4da5"/>
+    <p:sldId xmlns:r="http://schemas.openxmlformats.org/officeDocument/2006/relationships" id="260" r:id="R3bbfa3258d114f05"/>
+    <p:sldId xmlns:r="http://schemas.openxmlformats.org/officeDocument/2006/relationships" id="261" r:id="R79fef01aea614d52"/>
+    <p:sldId xmlns:r="http://schemas.openxmlformats.org/officeDocument/2006/relationships" id="262" r:id="R2af203616f344c95"/>
+    <p:sldId xmlns:r="http://schemas.openxmlformats.org/officeDocument/2006/relationships" id="263" r:id="Ra12d7f8c91b64052"/>
+    <p:sldId xmlns:r="http://schemas.openxmlformats.org/officeDocument/2006/relationships" id="264" r:id="R750d905c938941be"/>
+    <p:sldId xmlns:r="http://schemas.openxmlformats.org/officeDocument/2006/relationships" id="265" r:id="R6c05201c47bb4e86"/>
+    <p:sldId xmlns:r="http://schemas.openxmlformats.org/officeDocument/2006/relationships" id="266" r:id="Ra3e298513e924770"/>
+    <p:sldId xmlns:r="http://schemas.openxmlformats.org/officeDocument/2006/relationships" id="267" r:id="Rcf423b6033a24aa8"/>
+    <p:sldId xmlns:r="http://schemas.openxmlformats.org/officeDocument/2006/relationships" id="268" r:id="R023f0f6063024067"/>
+    <p:sldId xmlns:r="http://schemas.openxmlformats.org/officeDocument/2006/relationships" id="269" r:id="Rcc1c63323dc74233"/>
+    <p:sldId xmlns:r="http://schemas.openxmlformats.org/officeDocument/2006/relationships" id="270" r:id="R79fceae7396b4d4f"/>
   </p:sldIdLst>
   <p:sldSz cx="12192000" cy="6858000"/>
   <p:notesSz cx="6858000" cy="9144000"/>
@@ -1539,7 +1539,7 @@
   </p:cSld>
   <p:clrMap bg1="lt1" tx1="dk1" bg2="lt2" tx2="dk2" accent1="accent1" accent2="accent2" accent3="accent3" accent4="accent4" accent5="accent5" accent6="accent6" hlink="hlink" folHlink="folHlink"/>
   <p:sldLayoutIdLst>
-    <p:sldLayoutId xmlns:r="http://schemas.openxmlformats.org/officeDocument/2006/relationships" id="2147483649" r:id="Rf23847fbc92d4509"/>
+    <p:sldLayoutId xmlns:r="http://schemas.openxmlformats.org/officeDocument/2006/relationships" id="2147483649" r:id="Rbedfbcb503ae4f9c"/>
   </p:sldLayoutIdLst>
   <p:txStyles>
     <p:titleStyle>
@@ -2090,7 +2090,7 @@
           <p:cNvPr id="1" name="cover-eyebrow">
             <a:extLst xmlns:a="http://schemas.openxmlformats.org/drawingml/2006/main">
               <a:ext uri="{FF2B5EF4-FFF2-40B4-BE49-F238E27FC236}">
-                <a16:creationId xmlns:a16="http://schemas.microsoft.com/office/drawing/2014/main" id="{E596D452-33B1-4740-85BD-FC919AA66DF2}"/>
+                <a16:creationId xmlns:a16="http://schemas.microsoft.com/office/drawing/2014/main" id="{57F03F6E-B54C-4305-A1EC-1E98FCB22ED0}"/>
               </a:ext>
             </a:extLst>
           </p:cNvPr>
@@ -2148,7 +2148,7 @@
           <p:cNvPr id="2" name="cover-accent">
             <a:extLst xmlns:a="http://schemas.openxmlformats.org/drawingml/2006/main">
               <a:ext uri="{FF2B5EF4-FFF2-40B4-BE49-F238E27FC236}">
-                <a16:creationId xmlns:a16="http://schemas.microsoft.com/office/drawing/2014/main" id="{99ACEAF6-9D47-48FB-A67A-B8BB67404EA1}"/>
+                <a16:creationId xmlns:a16="http://schemas.microsoft.com/office/drawing/2014/main" id="{7B8668EA-723E-4BBA-8832-65020F8360EE}"/>
               </a:ext>
             </a:extLst>
           </p:cNvPr>
@@ -2179,7 +2179,7 @@
           <p:cNvPr id="3" name="cover-title">
             <a:extLst xmlns:a="http://schemas.openxmlformats.org/drawingml/2006/main">
               <a:ext uri="{FF2B5EF4-FFF2-40B4-BE49-F238E27FC236}">
-                <a16:creationId xmlns:a16="http://schemas.microsoft.com/office/drawing/2014/main" id="{267DB346-4236-4E3C-BBE7-9E631D600C78}"/>
+                <a16:creationId xmlns:a16="http://schemas.microsoft.com/office/drawing/2014/main" id="{377D849A-4557-413B-BFCE-121CC0BF5C26}"/>
               </a:ext>
             </a:extLst>
           </p:cNvPr>
@@ -2237,7 +2237,7 @@
           <p:cNvPr id="4" name="cover-subtitle">
             <a:extLst xmlns:a="http://schemas.openxmlformats.org/drawingml/2006/main">
               <a:ext uri="{FF2B5EF4-FFF2-40B4-BE49-F238E27FC236}">
-                <a16:creationId xmlns:a16="http://schemas.microsoft.com/office/drawing/2014/main" id="{C355593A-4B46-4F6B-BEBE-1C92A07F4F00}"/>
+                <a16:creationId xmlns:a16="http://schemas.microsoft.com/office/drawing/2014/main" id="{97D6D94A-599A-4429-AF5B-880E60A037AB}"/>
               </a:ext>
             </a:extLst>
           </p:cNvPr>
@@ -2295,7 +2295,7 @@
           <p:cNvPr id="5" name="cover-desc">
             <a:extLst xmlns:a="http://schemas.openxmlformats.org/drawingml/2006/main">
               <a:ext uri="{FF2B5EF4-FFF2-40B4-BE49-F238E27FC236}">
-                <a16:creationId xmlns:a16="http://schemas.microsoft.com/office/drawing/2014/main" id="{355E1A6B-676C-41B4-BF83-0D4EBFBC07C1}"/>
+                <a16:creationId xmlns:a16="http://schemas.microsoft.com/office/drawing/2014/main" id="{0CC5C68E-D9DB-4D18-8F31-570DCA87D412}"/>
               </a:ext>
             </a:extLst>
           </p:cNvPr>
@@ -2353,7 +2353,7 @@
           <p:cNvPr id="6" name="pill-7 个微服务">
             <a:extLst xmlns:a="http://schemas.openxmlformats.org/drawingml/2006/main">
               <a:ext uri="{FF2B5EF4-FFF2-40B4-BE49-F238E27FC236}">
-                <a16:creationId xmlns:a16="http://schemas.microsoft.com/office/drawing/2014/main" id="{1D9D363B-9E3F-4445-9997-FF4C3A406C61}"/>
+                <a16:creationId xmlns:a16="http://schemas.microsoft.com/office/drawing/2014/main" id="{F078BF39-07B1-437E-B7D1-F61B3FD55D6F}"/>
               </a:ext>
             </a:extLst>
           </p:cNvPr>
@@ -2386,7 +2386,7 @@
           <p:cNvPr id="7" name="pill-text-7 个微服务">
             <a:extLst xmlns:a="http://schemas.openxmlformats.org/drawingml/2006/main">
               <a:ext uri="{FF2B5EF4-FFF2-40B4-BE49-F238E27FC236}">
-                <a16:creationId xmlns:a16="http://schemas.microsoft.com/office/drawing/2014/main" id="{755A404F-2B54-4044-8938-1C602CD7A280}"/>
+                <a16:creationId xmlns:a16="http://schemas.microsoft.com/office/drawing/2014/main" id="{F29AFCDF-0A3A-4A72-80F5-96D460103440}"/>
               </a:ext>
             </a:extLst>
           </p:cNvPr>
@@ -2444,7 +2444,7 @@
           <p:cNvPr id="8" name="pill-6 个业务模块">
             <a:extLst xmlns:a="http://schemas.openxmlformats.org/drawingml/2006/main">
               <a:ext uri="{FF2B5EF4-FFF2-40B4-BE49-F238E27FC236}">
-                <a16:creationId xmlns:a16="http://schemas.microsoft.com/office/drawing/2014/main" id="{7BB3EBC5-C199-45D3-A934-2D65B35EB48B}"/>
+                <a16:creationId xmlns:a16="http://schemas.microsoft.com/office/drawing/2014/main" id="{5E547821-21E2-4A5B-A74C-F724BC82A349}"/>
               </a:ext>
             </a:extLst>
           </p:cNvPr>
@@ -2477,7 +2477,7 @@
           <p:cNvPr id="9" name="pill-text-6 个业务模块">
             <a:extLst xmlns:a="http://schemas.openxmlformats.org/drawingml/2006/main">
               <a:ext uri="{FF2B5EF4-FFF2-40B4-BE49-F238E27FC236}">
-                <a16:creationId xmlns:a16="http://schemas.microsoft.com/office/drawing/2014/main" id="{5ACFD9AA-3A06-485E-90CF-5C6AD1E5179F}"/>
+                <a16:creationId xmlns:a16="http://schemas.microsoft.com/office/drawing/2014/main" id="{018EC4BA-A1A0-4157-AF35-86197E0E029D}"/>
               </a:ext>
             </a:extLst>
           </p:cNvPr>
@@ -2532,10 +2532,10 @@
       </p:sp>
       <p:sp>
         <p:nvSpPr>
-          <p:cNvPr id="10" name="pill-36 项自动化测试">
-            <a:extLst xmlns:a="http://schemas.openxmlformats.org/drawingml/2006/main">
-              <a:ext uri="{FF2B5EF4-FFF2-40B4-BE49-F238E27FC236}">
-                <a16:creationId xmlns:a16="http://schemas.microsoft.com/office/drawing/2014/main" id="{0F7D14A7-FEE9-4394-B39F-D974D92B181C}"/>
+          <p:cNvPr id="10" name="pill-38 项自动化测试">
+            <a:extLst xmlns:a="http://schemas.openxmlformats.org/drawingml/2006/main">
+              <a:ext uri="{FF2B5EF4-FFF2-40B4-BE49-F238E27FC236}">
+                <a16:creationId xmlns:a16="http://schemas.microsoft.com/office/drawing/2014/main" id="{C34083D0-34D7-4AEF-9BB6-107C4A764699}"/>
               </a:ext>
             </a:extLst>
           </p:cNvPr>
@@ -2565,10 +2565,10 @@
       </p:sp>
       <p:sp>
         <p:nvSpPr>
-          <p:cNvPr id="11" name="pill-text-36 项自动化测试">
-            <a:extLst xmlns:a="http://schemas.openxmlformats.org/drawingml/2006/main">
-              <a:ext uri="{FF2B5EF4-FFF2-40B4-BE49-F238E27FC236}">
-                <a16:creationId xmlns:a16="http://schemas.microsoft.com/office/drawing/2014/main" id="{D6A4D6DF-110E-4997-8625-452AA18D8D5F}"/>
+          <p:cNvPr id="11" name="pill-text-38 项自动化测试">
+            <a:extLst xmlns:a="http://schemas.openxmlformats.org/drawingml/2006/main">
+              <a:ext uri="{FF2B5EF4-FFF2-40B4-BE49-F238E27FC236}">
+                <a16:creationId xmlns:a16="http://schemas.microsoft.com/office/drawing/2014/main" id="{F185B819-3AD7-4E59-BE90-EB9A833F69D2}"/>
               </a:ext>
             </a:extLst>
           </p:cNvPr>
@@ -2616,7 +2616,7 @@
                 <a:ea typeface="Microsoft YaHei"/>
                 <a:cs typeface="Microsoft YaHei"/>
               </a:rPr>
-              <a:t>36 项自动化测试</a:t>
+              <a:t>38 项自动化测试</a:t>
             </a:r>
           </a:p>
         </p:txBody>
@@ -2626,7 +2626,7 @@
           <p:cNvPr id="12" name="cover-team">
             <a:extLst xmlns:a="http://schemas.openxmlformats.org/drawingml/2006/main">
               <a:ext uri="{FF2B5EF4-FFF2-40B4-BE49-F238E27FC236}">
-                <a16:creationId xmlns:a16="http://schemas.microsoft.com/office/drawing/2014/main" id="{283AFDEF-5FBB-4A21-872E-5CD916013F74}"/>
+                <a16:creationId xmlns:a16="http://schemas.microsoft.com/office/drawing/2014/main" id="{40C77376-6B22-443A-9E10-36C62EDE7EED}"/>
               </a:ext>
             </a:extLst>
           </p:cNvPr>
@@ -2682,7 +2682,7 @@
     </p:spTree>
     <p:extLst>
       <p:ext uri="{BB962C8B-B14F-4D97-AF65-F5344CB8AC3E}">
-        <p14:creationId xmlns:p14="http://schemas.microsoft.com/office/powerpoint/2010/main" val="35242144"/>
+        <p14:creationId xmlns:p14="http://schemas.microsoft.com/office/powerpoint/2010/main" val="1047643090"/>
       </p:ext>
     </p:extLst>
   </p:cSld>
@@ -2713,7 +2713,7 @@
           <p:cNvPr id="1" name="eyebrow-10">
             <a:extLst xmlns:a="http://schemas.openxmlformats.org/drawingml/2006/main">
               <a:ext uri="{FF2B5EF4-FFF2-40B4-BE49-F238E27FC236}">
-                <a16:creationId xmlns:a16="http://schemas.microsoft.com/office/drawing/2014/main" id="{02607151-A753-4604-8A29-B70FA6CDDA4B}"/>
+                <a16:creationId xmlns:a16="http://schemas.microsoft.com/office/drawing/2014/main" id="{2EA02F42-B232-41BE-AD56-DE39B687B0E8}"/>
               </a:ext>
             </a:extLst>
           </p:cNvPr>
@@ -2771,7 +2771,7 @@
           <p:cNvPr id="2" name="slide-title-10">
             <a:extLst xmlns:a="http://schemas.openxmlformats.org/drawingml/2006/main">
               <a:ext uri="{FF2B5EF4-FFF2-40B4-BE49-F238E27FC236}">
-                <a16:creationId xmlns:a16="http://schemas.microsoft.com/office/drawing/2014/main" id="{8FA40704-90D6-4994-9F0E-5E4C0CA37224}"/>
+                <a16:creationId xmlns:a16="http://schemas.microsoft.com/office/drawing/2014/main" id="{3C478BAA-94BB-41B2-A252-68F406A2994F}"/>
               </a:ext>
             </a:extLst>
           </p:cNvPr>
@@ -2829,7 +2829,7 @@
           <p:cNvPr id="3" name="title-rule-10">
             <a:extLst xmlns:a="http://schemas.openxmlformats.org/drawingml/2006/main">
               <a:ext uri="{FF2B5EF4-FFF2-40B4-BE49-F238E27FC236}">
-                <a16:creationId xmlns:a16="http://schemas.microsoft.com/office/drawing/2014/main" id="{B2895226-446A-40A1-85FE-7569D5130B3F}"/>
+                <a16:creationId xmlns:a16="http://schemas.microsoft.com/office/drawing/2014/main" id="{BB108D78-3768-4993-84BA-7063648AA994}"/>
               </a:ext>
             </a:extLst>
           </p:cNvPr>
@@ -2860,7 +2860,7 @@
           <p:cNvPr id="4" name="page-number-10">
             <a:extLst xmlns:a="http://schemas.openxmlformats.org/drawingml/2006/main">
               <a:ext uri="{FF2B5EF4-FFF2-40B4-BE49-F238E27FC236}">
-                <a16:creationId xmlns:a16="http://schemas.microsoft.com/office/drawing/2014/main" id="{D7D18EF7-ED3A-47CD-A12D-2A68981B656B}"/>
+                <a16:creationId xmlns:a16="http://schemas.microsoft.com/office/drawing/2014/main" id="{F3686D52-1C98-437A-9FFC-E39249DA07FA}"/>
               </a:ext>
             </a:extLst>
           </p:cNvPr>
@@ -2918,7 +2918,7 @@
           <p:cNvPr id="5" name="eng-0">
             <a:extLst xmlns:a="http://schemas.openxmlformats.org/drawingml/2006/main">
               <a:ext uri="{FF2B5EF4-FFF2-40B4-BE49-F238E27FC236}">
-                <a16:creationId xmlns:a16="http://schemas.microsoft.com/office/drawing/2014/main" id="{91B9A7BF-0C10-4E5C-ACE2-57847BA20521}"/>
+                <a16:creationId xmlns:a16="http://schemas.microsoft.com/office/drawing/2014/main" id="{5C15F2CC-D852-4A23-AD78-655FC6C800DB}"/>
               </a:ext>
             </a:extLst>
           </p:cNvPr>
@@ -2953,7 +2953,7 @@
           <p:cNvPr id="6" name="text">
             <a:extLst xmlns:a="http://schemas.openxmlformats.org/drawingml/2006/main">
               <a:ext uri="{FF2B5EF4-FFF2-40B4-BE49-F238E27FC236}">
-                <a16:creationId xmlns:a16="http://schemas.microsoft.com/office/drawing/2014/main" id="{A349C722-B743-444E-853B-4CC5813FAB15}"/>
+                <a16:creationId xmlns:a16="http://schemas.microsoft.com/office/drawing/2014/main" id="{12AD88B4-11AA-42FE-90F9-8061E388238A}"/>
               </a:ext>
             </a:extLst>
           </p:cNvPr>
@@ -3011,7 +3011,7 @@
           <p:cNvPr id="7" name="text">
             <a:extLst xmlns:a="http://schemas.openxmlformats.org/drawingml/2006/main">
               <a:ext uri="{FF2B5EF4-FFF2-40B4-BE49-F238E27FC236}">
-                <a16:creationId xmlns:a16="http://schemas.microsoft.com/office/drawing/2014/main" id="{3CD84B85-426E-44EB-A378-876E1CDD27FB}"/>
+                <a16:creationId xmlns:a16="http://schemas.microsoft.com/office/drawing/2014/main" id="{F0074DFE-E328-4DF1-89A8-C14FF8C795A8}"/>
               </a:ext>
             </a:extLst>
           </p:cNvPr>
@@ -3069,7 +3069,7 @@
           <p:cNvPr id="8" name="text">
             <a:extLst xmlns:a="http://schemas.openxmlformats.org/drawingml/2006/main">
               <a:ext uri="{FF2B5EF4-FFF2-40B4-BE49-F238E27FC236}">
-                <a16:creationId xmlns:a16="http://schemas.microsoft.com/office/drawing/2014/main" id="{D3E9B5F1-15C5-46B8-892C-5118BCA38A3C}"/>
+                <a16:creationId xmlns:a16="http://schemas.microsoft.com/office/drawing/2014/main" id="{222AAC1D-5662-47B0-ADCF-B0FB5A387128}"/>
               </a:ext>
             </a:extLst>
           </p:cNvPr>
@@ -3127,7 +3127,7 @@
           <p:cNvPr id="9" name="eng-1">
             <a:extLst xmlns:a="http://schemas.openxmlformats.org/drawingml/2006/main">
               <a:ext uri="{FF2B5EF4-FFF2-40B4-BE49-F238E27FC236}">
-                <a16:creationId xmlns:a16="http://schemas.microsoft.com/office/drawing/2014/main" id="{129A270A-F9D9-40B4-BA6B-800467B2D0E6}"/>
+                <a16:creationId xmlns:a16="http://schemas.microsoft.com/office/drawing/2014/main" id="{D0E36B5B-8017-45F6-B0F0-1A9CEFDE46CC}"/>
               </a:ext>
             </a:extLst>
           </p:cNvPr>
@@ -3162,7 +3162,7 @@
           <p:cNvPr id="10" name="text">
             <a:extLst xmlns:a="http://schemas.openxmlformats.org/drawingml/2006/main">
               <a:ext uri="{FF2B5EF4-FFF2-40B4-BE49-F238E27FC236}">
-                <a16:creationId xmlns:a16="http://schemas.microsoft.com/office/drawing/2014/main" id="{918DDEE5-80B6-4A2C-9407-1A27DF561159}"/>
+                <a16:creationId xmlns:a16="http://schemas.microsoft.com/office/drawing/2014/main" id="{B4A9DAAC-7C63-41C9-878C-473B2FC29565}"/>
               </a:ext>
             </a:extLst>
           </p:cNvPr>
@@ -3220,7 +3220,7 @@
           <p:cNvPr id="11" name="text">
             <a:extLst xmlns:a="http://schemas.openxmlformats.org/drawingml/2006/main">
               <a:ext uri="{FF2B5EF4-FFF2-40B4-BE49-F238E27FC236}">
-                <a16:creationId xmlns:a16="http://schemas.microsoft.com/office/drawing/2014/main" id="{38A83979-FC38-4F48-8DAE-E9C828F7C92C}"/>
+                <a16:creationId xmlns:a16="http://schemas.microsoft.com/office/drawing/2014/main" id="{9AA85C15-45B3-4A43-8DB1-637BD4DFAF55}"/>
               </a:ext>
             </a:extLst>
           </p:cNvPr>
@@ -3278,7 +3278,7 @@
           <p:cNvPr id="12" name="text">
             <a:extLst xmlns:a="http://schemas.openxmlformats.org/drawingml/2006/main">
               <a:ext uri="{FF2B5EF4-FFF2-40B4-BE49-F238E27FC236}">
-                <a16:creationId xmlns:a16="http://schemas.microsoft.com/office/drawing/2014/main" id="{64032703-AC6F-4343-8FC6-C989924B707A}"/>
+                <a16:creationId xmlns:a16="http://schemas.microsoft.com/office/drawing/2014/main" id="{A7E2DE46-16B7-4F3C-83B9-7B34353D95DF}"/>
               </a:ext>
             </a:extLst>
           </p:cNvPr>
@@ -3336,7 +3336,7 @@
           <p:cNvPr id="13" name="eng-2">
             <a:extLst xmlns:a="http://schemas.openxmlformats.org/drawingml/2006/main">
               <a:ext uri="{FF2B5EF4-FFF2-40B4-BE49-F238E27FC236}">
-                <a16:creationId xmlns:a16="http://schemas.microsoft.com/office/drawing/2014/main" id="{190C03F3-8FC2-42ED-9D13-6446A7607F06}"/>
+                <a16:creationId xmlns:a16="http://schemas.microsoft.com/office/drawing/2014/main" id="{84AF1CEA-9C90-4E1A-99A4-340B5F7013B9}"/>
               </a:ext>
             </a:extLst>
           </p:cNvPr>
@@ -3371,7 +3371,7 @@
           <p:cNvPr id="14" name="text">
             <a:extLst xmlns:a="http://schemas.openxmlformats.org/drawingml/2006/main">
               <a:ext uri="{FF2B5EF4-FFF2-40B4-BE49-F238E27FC236}">
-                <a16:creationId xmlns:a16="http://schemas.microsoft.com/office/drawing/2014/main" id="{89CB50B5-4AF5-4395-BA4D-6BD6C27F8B5B}"/>
+                <a16:creationId xmlns:a16="http://schemas.microsoft.com/office/drawing/2014/main" id="{63224238-78E1-429D-A4EF-C833686D4A3D}"/>
               </a:ext>
             </a:extLst>
           </p:cNvPr>
@@ -3429,7 +3429,7 @@
           <p:cNvPr id="15" name="text">
             <a:extLst xmlns:a="http://schemas.openxmlformats.org/drawingml/2006/main">
               <a:ext uri="{FF2B5EF4-FFF2-40B4-BE49-F238E27FC236}">
-                <a16:creationId xmlns:a16="http://schemas.microsoft.com/office/drawing/2014/main" id="{CF765286-D33C-425C-A766-D55A851FBA10}"/>
+                <a16:creationId xmlns:a16="http://schemas.microsoft.com/office/drawing/2014/main" id="{5461C5D7-3190-4FC3-AB0C-5F381588EDC4}"/>
               </a:ext>
             </a:extLst>
           </p:cNvPr>
@@ -3487,7 +3487,7 @@
           <p:cNvPr id="16" name="text">
             <a:extLst xmlns:a="http://schemas.openxmlformats.org/drawingml/2006/main">
               <a:ext uri="{FF2B5EF4-FFF2-40B4-BE49-F238E27FC236}">
-                <a16:creationId xmlns:a16="http://schemas.microsoft.com/office/drawing/2014/main" id="{2F965A47-1CAB-4177-88DF-B422830914CA}"/>
+                <a16:creationId xmlns:a16="http://schemas.microsoft.com/office/drawing/2014/main" id="{8054A9E5-F03B-4575-BDBA-DCC5757CC652}"/>
               </a:ext>
             </a:extLst>
           </p:cNvPr>
@@ -3545,7 +3545,7 @@
           <p:cNvPr id="17" name="eng-3">
             <a:extLst xmlns:a="http://schemas.openxmlformats.org/drawingml/2006/main">
               <a:ext uri="{FF2B5EF4-FFF2-40B4-BE49-F238E27FC236}">
-                <a16:creationId xmlns:a16="http://schemas.microsoft.com/office/drawing/2014/main" id="{67B68EEE-0AF6-4745-B9C1-0C91A87B3986}"/>
+                <a16:creationId xmlns:a16="http://schemas.microsoft.com/office/drawing/2014/main" id="{4CAF71CC-8B07-40FD-B46D-490FD9D4CE66}"/>
               </a:ext>
             </a:extLst>
           </p:cNvPr>
@@ -3580,7 +3580,7 @@
           <p:cNvPr id="18" name="text">
             <a:extLst xmlns:a="http://schemas.openxmlformats.org/drawingml/2006/main">
               <a:ext uri="{FF2B5EF4-FFF2-40B4-BE49-F238E27FC236}">
-                <a16:creationId xmlns:a16="http://schemas.microsoft.com/office/drawing/2014/main" id="{13087AF3-F06C-43C2-A5DE-FEFCF7581463}"/>
+                <a16:creationId xmlns:a16="http://schemas.microsoft.com/office/drawing/2014/main" id="{F1F2D152-4220-4F16-8FD2-9AC0C2454237}"/>
               </a:ext>
             </a:extLst>
           </p:cNvPr>
@@ -3638,7 +3638,7 @@
           <p:cNvPr id="19" name="text">
             <a:extLst xmlns:a="http://schemas.openxmlformats.org/drawingml/2006/main">
               <a:ext uri="{FF2B5EF4-FFF2-40B4-BE49-F238E27FC236}">
-                <a16:creationId xmlns:a16="http://schemas.microsoft.com/office/drawing/2014/main" id="{1852DBB8-AF9B-4EAF-8D6B-539004FE9C5B}"/>
+                <a16:creationId xmlns:a16="http://schemas.microsoft.com/office/drawing/2014/main" id="{3E2490B5-4307-49A2-B3E8-6D56E8B63E10}"/>
               </a:ext>
             </a:extLst>
           </p:cNvPr>
@@ -3696,7 +3696,7 @@
           <p:cNvPr id="20" name="text">
             <a:extLst xmlns:a="http://schemas.openxmlformats.org/drawingml/2006/main">
               <a:ext uri="{FF2B5EF4-FFF2-40B4-BE49-F238E27FC236}">
-                <a16:creationId xmlns:a16="http://schemas.microsoft.com/office/drawing/2014/main" id="{768B70CE-42D9-41F0-99F3-95537A7E58B0}"/>
+                <a16:creationId xmlns:a16="http://schemas.microsoft.com/office/drawing/2014/main" id="{494E115C-4C42-4AD0-9597-50FD8BFE1C02}"/>
               </a:ext>
             </a:extLst>
           </p:cNvPr>
@@ -3752,7 +3752,7 @@
     </p:spTree>
     <p:extLst>
       <p:ext uri="{BB962C8B-B14F-4D97-AF65-F5344CB8AC3E}">
-        <p14:creationId xmlns:p14="http://schemas.microsoft.com/office/powerpoint/2010/main" val="1339436533"/>
+        <p14:creationId xmlns:p14="http://schemas.microsoft.com/office/powerpoint/2010/main" val="1517846346"/>
       </p:ext>
     </p:extLst>
   </p:cSld>
@@ -3783,7 +3783,7 @@
           <p:cNvPr id="1" name="eyebrow-11">
             <a:extLst xmlns:a="http://schemas.openxmlformats.org/drawingml/2006/main">
               <a:ext uri="{FF2B5EF4-FFF2-40B4-BE49-F238E27FC236}">
-                <a16:creationId xmlns:a16="http://schemas.microsoft.com/office/drawing/2014/main" id="{34D93353-1AC5-4047-B6BF-FB6F4A73D2FF}"/>
+                <a16:creationId xmlns:a16="http://schemas.microsoft.com/office/drawing/2014/main" id="{9345F2E0-EFD1-4EA4-A932-B147DF26176B}"/>
               </a:ext>
             </a:extLst>
           </p:cNvPr>
@@ -3841,7 +3841,7 @@
           <p:cNvPr id="2" name="slide-title-11">
             <a:extLst xmlns:a="http://schemas.openxmlformats.org/drawingml/2006/main">
               <a:ext uri="{FF2B5EF4-FFF2-40B4-BE49-F238E27FC236}">
-                <a16:creationId xmlns:a16="http://schemas.microsoft.com/office/drawing/2014/main" id="{52847A74-77D9-4EB9-B3BB-B5A47FFD71CE}"/>
+                <a16:creationId xmlns:a16="http://schemas.microsoft.com/office/drawing/2014/main" id="{BB1411AD-1154-4710-A03C-C12A59C12597}"/>
               </a:ext>
             </a:extLst>
           </p:cNvPr>
@@ -3899,7 +3899,7 @@
           <p:cNvPr id="3" name="title-rule-11">
             <a:extLst xmlns:a="http://schemas.openxmlformats.org/drawingml/2006/main">
               <a:ext uri="{FF2B5EF4-FFF2-40B4-BE49-F238E27FC236}">
-                <a16:creationId xmlns:a16="http://schemas.microsoft.com/office/drawing/2014/main" id="{2E2E8241-6BC1-4452-BD22-3AE402147941}"/>
+                <a16:creationId xmlns:a16="http://schemas.microsoft.com/office/drawing/2014/main" id="{8ACB45E3-B598-4197-9A85-C59E1A816972}"/>
               </a:ext>
             </a:extLst>
           </p:cNvPr>
@@ -3930,7 +3930,7 @@
           <p:cNvPr id="4" name="page-number-11">
             <a:extLst xmlns:a="http://schemas.openxmlformats.org/drawingml/2006/main">
               <a:ext uri="{FF2B5EF4-FFF2-40B4-BE49-F238E27FC236}">
-                <a16:creationId xmlns:a16="http://schemas.microsoft.com/office/drawing/2014/main" id="{574C7F67-9AB2-412B-A4A9-D24FB5CC2CA9}"/>
+                <a16:creationId xmlns:a16="http://schemas.microsoft.com/office/drawing/2014/main" id="{E9300076-741E-44EB-A939-540EE573B1C3}"/>
               </a:ext>
             </a:extLst>
           </p:cNvPr>
@@ -3988,7 +3988,7 @@
           <p:cNvPr id="5" name="timeline-line">
             <a:extLst xmlns:a="http://schemas.openxmlformats.org/drawingml/2006/main">
               <a:ext uri="{FF2B5EF4-FFF2-40B4-BE49-F238E27FC236}">
-                <a16:creationId xmlns:a16="http://schemas.microsoft.com/office/drawing/2014/main" id="{0749A7F4-4727-4346-BD7B-E1174AF42988}"/>
+                <a16:creationId xmlns:a16="http://schemas.microsoft.com/office/drawing/2014/main" id="{3D10AEC5-2238-47DF-8126-641999EBA163}"/>
               </a:ext>
             </a:extLst>
           </p:cNvPr>
@@ -4019,7 +4019,7 @@
           <p:cNvPr id="6" name="timeline-dot-0">
             <a:extLst xmlns:a="http://schemas.openxmlformats.org/drawingml/2006/main">
               <a:ext uri="{FF2B5EF4-FFF2-40B4-BE49-F238E27FC236}">
-                <a16:creationId xmlns:a16="http://schemas.microsoft.com/office/drawing/2014/main" id="{327D8379-D181-40C4-81B2-4D968ED3CE64}"/>
+                <a16:creationId xmlns:a16="http://schemas.microsoft.com/office/drawing/2014/main" id="{4D7BFEB3-36F9-4B49-BD8C-538AF35EA2C8}"/>
               </a:ext>
             </a:extLst>
           </p:cNvPr>
@@ -4052,7 +4052,7 @@
           <p:cNvPr id="7" name="text">
             <a:extLst xmlns:a="http://schemas.openxmlformats.org/drawingml/2006/main">
               <a:ext uri="{FF2B5EF4-FFF2-40B4-BE49-F238E27FC236}">
-                <a16:creationId xmlns:a16="http://schemas.microsoft.com/office/drawing/2014/main" id="{6EF037A5-3574-4AF1-96E4-AF9EEF74EFA3}"/>
+                <a16:creationId xmlns:a16="http://schemas.microsoft.com/office/drawing/2014/main" id="{87299E03-DE65-4EC8-99F6-0EF447ABE18E}"/>
               </a:ext>
             </a:extLst>
           </p:cNvPr>
@@ -4110,7 +4110,7 @@
           <p:cNvPr id="8" name="text">
             <a:extLst xmlns:a="http://schemas.openxmlformats.org/drawingml/2006/main">
               <a:ext uri="{FF2B5EF4-FFF2-40B4-BE49-F238E27FC236}">
-                <a16:creationId xmlns:a16="http://schemas.microsoft.com/office/drawing/2014/main" id="{3983D3BF-79CB-4B96-A816-3B263BF8D43D}"/>
+                <a16:creationId xmlns:a16="http://schemas.microsoft.com/office/drawing/2014/main" id="{846A6030-2D7E-4F98-88C5-1C7B31601295}"/>
               </a:ext>
             </a:extLst>
           </p:cNvPr>
@@ -4168,7 +4168,7 @@
           <p:cNvPr id="9" name="text">
             <a:extLst xmlns:a="http://schemas.openxmlformats.org/drawingml/2006/main">
               <a:ext uri="{FF2B5EF4-FFF2-40B4-BE49-F238E27FC236}">
-                <a16:creationId xmlns:a16="http://schemas.microsoft.com/office/drawing/2014/main" id="{D934DFB6-99B5-456A-AE55-ED20A084032D}"/>
+                <a16:creationId xmlns:a16="http://schemas.microsoft.com/office/drawing/2014/main" id="{D6BB71C2-8EFD-46A8-9F79-C56AE75C69EF}"/>
               </a:ext>
             </a:extLst>
           </p:cNvPr>
@@ -4226,7 +4226,7 @@
           <p:cNvPr id="10" name="text">
             <a:extLst xmlns:a="http://schemas.openxmlformats.org/drawingml/2006/main">
               <a:ext uri="{FF2B5EF4-FFF2-40B4-BE49-F238E27FC236}">
-                <a16:creationId xmlns:a16="http://schemas.microsoft.com/office/drawing/2014/main" id="{C61AF556-4336-4571-AEF9-E5EA9D012419}"/>
+                <a16:creationId xmlns:a16="http://schemas.microsoft.com/office/drawing/2014/main" id="{806AD559-85E7-4CE7-8DD6-DA65EB7102B9}"/>
               </a:ext>
             </a:extLst>
           </p:cNvPr>
@@ -4284,7 +4284,7 @@
           <p:cNvPr id="11" name="timeline-dot-1">
             <a:extLst xmlns:a="http://schemas.openxmlformats.org/drawingml/2006/main">
               <a:ext uri="{FF2B5EF4-FFF2-40B4-BE49-F238E27FC236}">
-                <a16:creationId xmlns:a16="http://schemas.microsoft.com/office/drawing/2014/main" id="{AF850392-12E5-4C7F-B7B2-595E04A6FEE5}"/>
+                <a16:creationId xmlns:a16="http://schemas.microsoft.com/office/drawing/2014/main" id="{16802B4C-FAB4-4651-84EA-CCC3EE23587D}"/>
               </a:ext>
             </a:extLst>
           </p:cNvPr>
@@ -4317,7 +4317,7 @@
           <p:cNvPr id="12" name="text">
             <a:extLst xmlns:a="http://schemas.openxmlformats.org/drawingml/2006/main">
               <a:ext uri="{FF2B5EF4-FFF2-40B4-BE49-F238E27FC236}">
-                <a16:creationId xmlns:a16="http://schemas.microsoft.com/office/drawing/2014/main" id="{EEECF991-2AD8-4403-9EDF-C97CAC3D0A53}"/>
+                <a16:creationId xmlns:a16="http://schemas.microsoft.com/office/drawing/2014/main" id="{C59216E2-88CD-4341-AAA4-D712F7538184}"/>
               </a:ext>
             </a:extLst>
           </p:cNvPr>
@@ -4375,7 +4375,7 @@
           <p:cNvPr id="13" name="text">
             <a:extLst xmlns:a="http://schemas.openxmlformats.org/drawingml/2006/main">
               <a:ext uri="{FF2B5EF4-FFF2-40B4-BE49-F238E27FC236}">
-                <a16:creationId xmlns:a16="http://schemas.microsoft.com/office/drawing/2014/main" id="{6FF55457-FA79-4DEC-8212-FFA5AC58E7D2}"/>
+                <a16:creationId xmlns:a16="http://schemas.microsoft.com/office/drawing/2014/main" id="{70C95331-9BC2-4B7D-B4D0-8FC40A515760}"/>
               </a:ext>
             </a:extLst>
           </p:cNvPr>
@@ -4433,7 +4433,7 @@
           <p:cNvPr id="14" name="text">
             <a:extLst xmlns:a="http://schemas.openxmlformats.org/drawingml/2006/main">
               <a:ext uri="{FF2B5EF4-FFF2-40B4-BE49-F238E27FC236}">
-                <a16:creationId xmlns:a16="http://schemas.microsoft.com/office/drawing/2014/main" id="{7DA8DA0D-4B01-4933-A196-59AE9421FA71}"/>
+                <a16:creationId xmlns:a16="http://schemas.microsoft.com/office/drawing/2014/main" id="{6BC69D7C-8CC7-4E76-B701-C547EB7EC0CB}"/>
               </a:ext>
             </a:extLst>
           </p:cNvPr>
@@ -4491,7 +4491,7 @@
           <p:cNvPr id="15" name="text">
             <a:extLst xmlns:a="http://schemas.openxmlformats.org/drawingml/2006/main">
               <a:ext uri="{FF2B5EF4-FFF2-40B4-BE49-F238E27FC236}">
-                <a16:creationId xmlns:a16="http://schemas.microsoft.com/office/drawing/2014/main" id="{3C418680-4B2B-43D5-ACEC-13EBD6445B6D}"/>
+                <a16:creationId xmlns:a16="http://schemas.microsoft.com/office/drawing/2014/main" id="{B2FE55AD-AEB4-4BE2-9176-7E48BC918D27}"/>
               </a:ext>
             </a:extLst>
           </p:cNvPr>
@@ -4549,7 +4549,7 @@
           <p:cNvPr id="16" name="timeline-dot-2">
             <a:extLst xmlns:a="http://schemas.openxmlformats.org/drawingml/2006/main">
               <a:ext uri="{FF2B5EF4-FFF2-40B4-BE49-F238E27FC236}">
-                <a16:creationId xmlns:a16="http://schemas.microsoft.com/office/drawing/2014/main" id="{2F0A3612-2E46-4D72-9962-4AF9EBE485DA}"/>
+                <a16:creationId xmlns:a16="http://schemas.microsoft.com/office/drawing/2014/main" id="{C455CC61-9944-4B2C-9B64-046DA3BCEF8B}"/>
               </a:ext>
             </a:extLst>
           </p:cNvPr>
@@ -4582,7 +4582,7 @@
           <p:cNvPr id="17" name="text">
             <a:extLst xmlns:a="http://schemas.openxmlformats.org/drawingml/2006/main">
               <a:ext uri="{FF2B5EF4-FFF2-40B4-BE49-F238E27FC236}">
-                <a16:creationId xmlns:a16="http://schemas.microsoft.com/office/drawing/2014/main" id="{4992C274-132F-4DBB-9606-F4BEAB16629B}"/>
+                <a16:creationId xmlns:a16="http://schemas.microsoft.com/office/drawing/2014/main" id="{9044E2B1-28C4-4B6C-9EB5-E8769A0CC3BC}"/>
               </a:ext>
             </a:extLst>
           </p:cNvPr>
@@ -4640,7 +4640,7 @@
           <p:cNvPr id="18" name="text">
             <a:extLst xmlns:a="http://schemas.openxmlformats.org/drawingml/2006/main">
               <a:ext uri="{FF2B5EF4-FFF2-40B4-BE49-F238E27FC236}">
-                <a16:creationId xmlns:a16="http://schemas.microsoft.com/office/drawing/2014/main" id="{A3128F6A-64DF-4DD2-B68E-35F0B19576E8}"/>
+                <a16:creationId xmlns:a16="http://schemas.microsoft.com/office/drawing/2014/main" id="{526B09F8-02E6-46F9-A68E-48564A0D8726}"/>
               </a:ext>
             </a:extLst>
           </p:cNvPr>
@@ -4698,7 +4698,7 @@
           <p:cNvPr id="19" name="text">
             <a:extLst xmlns:a="http://schemas.openxmlformats.org/drawingml/2006/main">
               <a:ext uri="{FF2B5EF4-FFF2-40B4-BE49-F238E27FC236}">
-                <a16:creationId xmlns:a16="http://schemas.microsoft.com/office/drawing/2014/main" id="{1FBD7100-9BA1-4C0F-9267-0F879129F111}"/>
+                <a16:creationId xmlns:a16="http://schemas.microsoft.com/office/drawing/2014/main" id="{39C1B602-D2F7-426E-9DF5-6F135F460C3C}"/>
               </a:ext>
             </a:extLst>
           </p:cNvPr>
@@ -4756,7 +4756,7 @@
           <p:cNvPr id="20" name="text">
             <a:extLst xmlns:a="http://schemas.openxmlformats.org/drawingml/2006/main">
               <a:ext uri="{FF2B5EF4-FFF2-40B4-BE49-F238E27FC236}">
-                <a16:creationId xmlns:a16="http://schemas.microsoft.com/office/drawing/2014/main" id="{8E4DA30F-5BA9-4D66-85B5-07DA122977F1}"/>
+                <a16:creationId xmlns:a16="http://schemas.microsoft.com/office/drawing/2014/main" id="{831027C7-A35D-4081-A438-12CFB683B2CF}"/>
               </a:ext>
             </a:extLst>
           </p:cNvPr>
@@ -4814,7 +4814,7 @@
           <p:cNvPr id="21" name="timeline-dot-3">
             <a:extLst xmlns:a="http://schemas.openxmlformats.org/drawingml/2006/main">
               <a:ext uri="{FF2B5EF4-FFF2-40B4-BE49-F238E27FC236}">
-                <a16:creationId xmlns:a16="http://schemas.microsoft.com/office/drawing/2014/main" id="{1D2279AA-B7D6-4150-9433-5E33B2A821C6}"/>
+                <a16:creationId xmlns:a16="http://schemas.microsoft.com/office/drawing/2014/main" id="{B4D13538-3D57-47F6-9B72-F314A8B80208}"/>
               </a:ext>
             </a:extLst>
           </p:cNvPr>
@@ -4847,7 +4847,7 @@
           <p:cNvPr id="22" name="text">
             <a:extLst xmlns:a="http://schemas.openxmlformats.org/drawingml/2006/main">
               <a:ext uri="{FF2B5EF4-FFF2-40B4-BE49-F238E27FC236}">
-                <a16:creationId xmlns:a16="http://schemas.microsoft.com/office/drawing/2014/main" id="{80758210-767B-4510-8D3A-61D46C839936}"/>
+                <a16:creationId xmlns:a16="http://schemas.microsoft.com/office/drawing/2014/main" id="{FABFC7FE-4BC0-4E8E-81BD-5B3E469EC9EA}"/>
               </a:ext>
             </a:extLst>
           </p:cNvPr>
@@ -4905,7 +4905,7 @@
           <p:cNvPr id="23" name="text">
             <a:extLst xmlns:a="http://schemas.openxmlformats.org/drawingml/2006/main">
               <a:ext uri="{FF2B5EF4-FFF2-40B4-BE49-F238E27FC236}">
-                <a16:creationId xmlns:a16="http://schemas.microsoft.com/office/drawing/2014/main" id="{CC91B2E7-88DF-47B8-BCAA-D660CF9F32CD}"/>
+                <a16:creationId xmlns:a16="http://schemas.microsoft.com/office/drawing/2014/main" id="{8AF7F263-F979-45D0-AA26-74C965AFFDDD}"/>
               </a:ext>
             </a:extLst>
           </p:cNvPr>
@@ -4963,7 +4963,7 @@
           <p:cNvPr id="24" name="text">
             <a:extLst xmlns:a="http://schemas.openxmlformats.org/drawingml/2006/main">
               <a:ext uri="{FF2B5EF4-FFF2-40B4-BE49-F238E27FC236}">
-                <a16:creationId xmlns:a16="http://schemas.microsoft.com/office/drawing/2014/main" id="{7665163C-005D-4886-B4FA-D603A32114DE}"/>
+                <a16:creationId xmlns:a16="http://schemas.microsoft.com/office/drawing/2014/main" id="{59D7D239-467C-46B9-9659-9B519B439AC7}"/>
               </a:ext>
             </a:extLst>
           </p:cNvPr>
@@ -5021,7 +5021,7 @@
           <p:cNvPr id="25" name="text">
             <a:extLst xmlns:a="http://schemas.openxmlformats.org/drawingml/2006/main">
               <a:ext uri="{FF2B5EF4-FFF2-40B4-BE49-F238E27FC236}">
-                <a16:creationId xmlns:a16="http://schemas.microsoft.com/office/drawing/2014/main" id="{6A9BD779-060F-4314-B800-B0308A9D942A}"/>
+                <a16:creationId xmlns:a16="http://schemas.microsoft.com/office/drawing/2014/main" id="{40ABA085-5B42-4041-9DA8-8F557EFDBE5F}"/>
               </a:ext>
             </a:extLst>
           </p:cNvPr>
@@ -5079,7 +5079,7 @@
           <p:cNvPr id="26" name="timeline-dot-4">
             <a:extLst xmlns:a="http://schemas.openxmlformats.org/drawingml/2006/main">
               <a:ext uri="{FF2B5EF4-FFF2-40B4-BE49-F238E27FC236}">
-                <a16:creationId xmlns:a16="http://schemas.microsoft.com/office/drawing/2014/main" id="{7B1D70D8-7161-4D7D-B47F-0E20F5A3B8B1}"/>
+                <a16:creationId xmlns:a16="http://schemas.microsoft.com/office/drawing/2014/main" id="{73D4E0A2-5D7C-4C45-9F90-39959C694FAB}"/>
               </a:ext>
             </a:extLst>
           </p:cNvPr>
@@ -5112,7 +5112,7 @@
           <p:cNvPr id="27" name="text">
             <a:extLst xmlns:a="http://schemas.openxmlformats.org/drawingml/2006/main">
               <a:ext uri="{FF2B5EF4-FFF2-40B4-BE49-F238E27FC236}">
-                <a16:creationId xmlns:a16="http://schemas.microsoft.com/office/drawing/2014/main" id="{1AF6E6D0-AE06-4079-87A3-01D31504C2E0}"/>
+                <a16:creationId xmlns:a16="http://schemas.microsoft.com/office/drawing/2014/main" id="{5152D426-597D-400C-B228-DAE77BAD7C83}"/>
               </a:ext>
             </a:extLst>
           </p:cNvPr>
@@ -5170,7 +5170,7 @@
           <p:cNvPr id="28" name="text">
             <a:extLst xmlns:a="http://schemas.openxmlformats.org/drawingml/2006/main">
               <a:ext uri="{FF2B5EF4-FFF2-40B4-BE49-F238E27FC236}">
-                <a16:creationId xmlns:a16="http://schemas.microsoft.com/office/drawing/2014/main" id="{B0CB3B88-26B9-493D-B212-58E02C7795B4}"/>
+                <a16:creationId xmlns:a16="http://schemas.microsoft.com/office/drawing/2014/main" id="{DF9E2364-6D9C-4060-948E-7E19C5878ACC}"/>
               </a:ext>
             </a:extLst>
           </p:cNvPr>
@@ -5228,7 +5228,7 @@
           <p:cNvPr id="29" name="text">
             <a:extLst xmlns:a="http://schemas.openxmlformats.org/drawingml/2006/main">
               <a:ext uri="{FF2B5EF4-FFF2-40B4-BE49-F238E27FC236}">
-                <a16:creationId xmlns:a16="http://schemas.microsoft.com/office/drawing/2014/main" id="{02F1F6CF-5EE8-4E44-9AAD-41DE76A98E34}"/>
+                <a16:creationId xmlns:a16="http://schemas.microsoft.com/office/drawing/2014/main" id="{CF68F469-AE1C-4C40-8628-1BCBA5995961}"/>
               </a:ext>
             </a:extLst>
           </p:cNvPr>
@@ -5286,7 +5286,7 @@
           <p:cNvPr id="30" name="text">
             <a:extLst xmlns:a="http://schemas.openxmlformats.org/drawingml/2006/main">
               <a:ext uri="{FF2B5EF4-FFF2-40B4-BE49-F238E27FC236}">
-                <a16:creationId xmlns:a16="http://schemas.microsoft.com/office/drawing/2014/main" id="{369D977A-66E3-4325-90EE-09F5091AC009}"/>
+                <a16:creationId xmlns:a16="http://schemas.microsoft.com/office/drawing/2014/main" id="{3ACE7746-14EF-4445-8103-99245161BDCF}"/>
               </a:ext>
             </a:extLst>
           </p:cNvPr>
@@ -5344,7 +5344,7 @@
           <p:cNvPr id="31" name="timeline-dot-5">
             <a:extLst xmlns:a="http://schemas.openxmlformats.org/drawingml/2006/main">
               <a:ext uri="{FF2B5EF4-FFF2-40B4-BE49-F238E27FC236}">
-                <a16:creationId xmlns:a16="http://schemas.microsoft.com/office/drawing/2014/main" id="{58741568-E0B9-4000-8649-9F3AF7E6B1CD}"/>
+                <a16:creationId xmlns:a16="http://schemas.microsoft.com/office/drawing/2014/main" id="{347EE76D-12A6-4483-BDBB-D3836AB353C5}"/>
               </a:ext>
             </a:extLst>
           </p:cNvPr>
@@ -5377,7 +5377,7 @@
           <p:cNvPr id="32" name="text">
             <a:extLst xmlns:a="http://schemas.openxmlformats.org/drawingml/2006/main">
               <a:ext uri="{FF2B5EF4-FFF2-40B4-BE49-F238E27FC236}">
-                <a16:creationId xmlns:a16="http://schemas.microsoft.com/office/drawing/2014/main" id="{4E6E042B-F3AE-4125-AA4B-1CF7C33D2746}"/>
+                <a16:creationId xmlns:a16="http://schemas.microsoft.com/office/drawing/2014/main" id="{8695B6CB-AA91-48AB-A026-B7568D1773D7}"/>
               </a:ext>
             </a:extLst>
           </p:cNvPr>
@@ -5435,7 +5435,7 @@
           <p:cNvPr id="33" name="text">
             <a:extLst xmlns:a="http://schemas.openxmlformats.org/drawingml/2006/main">
               <a:ext uri="{FF2B5EF4-FFF2-40B4-BE49-F238E27FC236}">
-                <a16:creationId xmlns:a16="http://schemas.microsoft.com/office/drawing/2014/main" id="{BC1F91C1-F024-48D5-87A9-70FFFDC67B1F}"/>
+                <a16:creationId xmlns:a16="http://schemas.microsoft.com/office/drawing/2014/main" id="{C297290C-C242-4953-941A-6FF4886BE2C9}"/>
               </a:ext>
             </a:extLst>
           </p:cNvPr>
@@ -5493,7 +5493,7 @@
           <p:cNvPr id="34" name="text">
             <a:extLst xmlns:a="http://schemas.openxmlformats.org/drawingml/2006/main">
               <a:ext uri="{FF2B5EF4-FFF2-40B4-BE49-F238E27FC236}">
-                <a16:creationId xmlns:a16="http://schemas.microsoft.com/office/drawing/2014/main" id="{93A8E779-8A20-419A-B993-05E46AEF60F3}"/>
+                <a16:creationId xmlns:a16="http://schemas.microsoft.com/office/drawing/2014/main" id="{176FEE32-121A-4A2D-8EEB-003258C740F6}"/>
               </a:ext>
             </a:extLst>
           </p:cNvPr>
@@ -5551,7 +5551,7 @@
           <p:cNvPr id="35" name="text">
             <a:extLst xmlns:a="http://schemas.openxmlformats.org/drawingml/2006/main">
               <a:ext uri="{FF2B5EF4-FFF2-40B4-BE49-F238E27FC236}">
-                <a16:creationId xmlns:a16="http://schemas.microsoft.com/office/drawing/2014/main" id="{2032C5A2-BEC5-4440-A376-A6265CD352BC}"/>
+                <a16:creationId xmlns:a16="http://schemas.microsoft.com/office/drawing/2014/main" id="{A73FBD87-C583-4EAD-AA45-3C801F9A46BD}"/>
               </a:ext>
             </a:extLst>
           </p:cNvPr>
@@ -5607,7 +5607,7 @@
     </p:spTree>
     <p:extLst>
       <p:ext uri="{BB962C8B-B14F-4D97-AF65-F5344CB8AC3E}">
-        <p14:creationId xmlns:p14="http://schemas.microsoft.com/office/powerpoint/2010/main" val="130180256"/>
+        <p14:creationId xmlns:p14="http://schemas.microsoft.com/office/powerpoint/2010/main" val="1411693080"/>
       </p:ext>
     </p:extLst>
   </p:cSld>
@@ -5638,7 +5638,7 @@
           <p:cNvPr id="1" name="eyebrow-12">
             <a:extLst xmlns:a="http://schemas.openxmlformats.org/drawingml/2006/main">
               <a:ext uri="{FF2B5EF4-FFF2-40B4-BE49-F238E27FC236}">
-                <a16:creationId xmlns:a16="http://schemas.microsoft.com/office/drawing/2014/main" id="{BF7C95B0-FAB8-4609-A55F-4CB8B5708F6E}"/>
+                <a16:creationId xmlns:a16="http://schemas.microsoft.com/office/drawing/2014/main" id="{F09E43EA-9EDA-4CA4-86E6-1E6D0184D151}"/>
               </a:ext>
             </a:extLst>
           </p:cNvPr>
@@ -5696,7 +5696,7 @@
           <p:cNvPr id="2" name="slide-title-12">
             <a:extLst xmlns:a="http://schemas.openxmlformats.org/drawingml/2006/main">
               <a:ext uri="{FF2B5EF4-FFF2-40B4-BE49-F238E27FC236}">
-                <a16:creationId xmlns:a16="http://schemas.microsoft.com/office/drawing/2014/main" id="{146B1581-7A7B-46D1-86EC-1A5C99533A0E}"/>
+                <a16:creationId xmlns:a16="http://schemas.microsoft.com/office/drawing/2014/main" id="{D054B9D5-BB5A-49F9-B39F-9CD0B0BCDF30}"/>
               </a:ext>
             </a:extLst>
           </p:cNvPr>
@@ -5754,7 +5754,7 @@
           <p:cNvPr id="3" name="title-rule-12">
             <a:extLst xmlns:a="http://schemas.openxmlformats.org/drawingml/2006/main">
               <a:ext uri="{FF2B5EF4-FFF2-40B4-BE49-F238E27FC236}">
-                <a16:creationId xmlns:a16="http://schemas.microsoft.com/office/drawing/2014/main" id="{2C8369C1-AB84-4A22-8061-CCB356BA0A7A}"/>
+                <a16:creationId xmlns:a16="http://schemas.microsoft.com/office/drawing/2014/main" id="{E906FC20-70B1-4121-94D6-35FE44AC9044}"/>
               </a:ext>
             </a:extLst>
           </p:cNvPr>
@@ -5785,7 +5785,7 @@
           <p:cNvPr id="4" name="page-number-12">
             <a:extLst xmlns:a="http://schemas.openxmlformats.org/drawingml/2006/main">
               <a:ext uri="{FF2B5EF4-FFF2-40B4-BE49-F238E27FC236}">
-                <a16:creationId xmlns:a16="http://schemas.microsoft.com/office/drawing/2014/main" id="{5628742E-F6CF-42C5-8EC7-00D577F4FE71}"/>
+                <a16:creationId xmlns:a16="http://schemas.microsoft.com/office/drawing/2014/main" id="{E918249F-F94A-40A5-AD7E-FEE23EAC06B9}"/>
               </a:ext>
             </a:extLst>
           </p:cNvPr>
@@ -5843,7 +5843,7 @@
           <p:cNvPr id="5" name="stat-后端测试 · 0 失败">
             <a:extLst xmlns:a="http://schemas.openxmlformats.org/drawingml/2006/main">
               <a:ext uri="{FF2B5EF4-FFF2-40B4-BE49-F238E27FC236}">
-                <a16:creationId xmlns:a16="http://schemas.microsoft.com/office/drawing/2014/main" id="{8A856683-F997-4888-B9D1-DB8FF6648721}"/>
+                <a16:creationId xmlns:a16="http://schemas.microsoft.com/office/drawing/2014/main" id="{C7912E71-BB97-4318-A647-CEF0B3EA2E59}"/>
               </a:ext>
             </a:extLst>
           </p:cNvPr>
@@ -5878,7 +5878,7 @@
           <p:cNvPr id="6" name="stat-accent-后端测试 · 0 失败">
             <a:extLst xmlns:a="http://schemas.openxmlformats.org/drawingml/2006/main">
               <a:ext uri="{FF2B5EF4-FFF2-40B4-BE49-F238E27FC236}">
-                <a16:creationId xmlns:a16="http://schemas.microsoft.com/office/drawing/2014/main" id="{96C5F1B6-2124-424C-8C11-441E8DC712AA}"/>
+                <a16:creationId xmlns:a16="http://schemas.microsoft.com/office/drawing/2014/main" id="{DE5F7560-0F02-41C4-8AE0-221F07DC426E}"/>
               </a:ext>
             </a:extLst>
           </p:cNvPr>
@@ -5909,7 +5909,7 @@
           <p:cNvPr id="7" name="stat-value-后端测试 · 0 失败">
             <a:extLst xmlns:a="http://schemas.openxmlformats.org/drawingml/2006/main">
               <a:ext uri="{FF2B5EF4-FFF2-40B4-BE49-F238E27FC236}">
-                <a16:creationId xmlns:a16="http://schemas.microsoft.com/office/drawing/2014/main" id="{342225CF-4245-4D00-9684-8851EED1C3CF}"/>
+                <a16:creationId xmlns:a16="http://schemas.microsoft.com/office/drawing/2014/main" id="{05A78629-F4D6-489A-A509-943BEA8BD5B8}"/>
               </a:ext>
             </a:extLst>
           </p:cNvPr>
@@ -5957,7 +5957,7 @@
                 <a:ea typeface="Microsoft YaHei"/>
                 <a:cs typeface="Microsoft YaHei"/>
               </a:rPr>
-              <a:t>31</a:t>
+              <a:t>33</a:t>
             </a:r>
           </a:p>
         </p:txBody>
@@ -5967,7 +5967,7 @@
           <p:cNvPr id="8" name="stat-label-后端测试 · 0 失败">
             <a:extLst xmlns:a="http://schemas.openxmlformats.org/drawingml/2006/main">
               <a:ext uri="{FF2B5EF4-FFF2-40B4-BE49-F238E27FC236}">
-                <a16:creationId xmlns:a16="http://schemas.microsoft.com/office/drawing/2014/main" id="{55906881-9A2F-4CAD-8DA7-7A7233A66270}"/>
+                <a16:creationId xmlns:a16="http://schemas.microsoft.com/office/drawing/2014/main" id="{C23F95C0-4E60-4510-A2DB-2700AB93C54F}"/>
               </a:ext>
             </a:extLst>
           </p:cNvPr>
@@ -6025,7 +6025,7 @@
           <p:cNvPr id="9" name="stat-前端测试 · 0 失败">
             <a:extLst xmlns:a="http://schemas.openxmlformats.org/drawingml/2006/main">
               <a:ext uri="{FF2B5EF4-FFF2-40B4-BE49-F238E27FC236}">
-                <a16:creationId xmlns:a16="http://schemas.microsoft.com/office/drawing/2014/main" id="{094B4CAA-346B-4E33-B4A6-FB6D280646CB}"/>
+                <a16:creationId xmlns:a16="http://schemas.microsoft.com/office/drawing/2014/main" id="{777ED24C-C8AE-4C28-8C9B-EA2C5069B511}"/>
               </a:ext>
             </a:extLst>
           </p:cNvPr>
@@ -6060,7 +6060,7 @@
           <p:cNvPr id="10" name="stat-accent-前端测试 · 0 失败">
             <a:extLst xmlns:a="http://schemas.openxmlformats.org/drawingml/2006/main">
               <a:ext uri="{FF2B5EF4-FFF2-40B4-BE49-F238E27FC236}">
-                <a16:creationId xmlns:a16="http://schemas.microsoft.com/office/drawing/2014/main" id="{FB017D6F-F73D-43F0-BA1F-A2B2CE25CD16}"/>
+                <a16:creationId xmlns:a16="http://schemas.microsoft.com/office/drawing/2014/main" id="{C708E4F1-0C1C-4A40-8273-70EE3FBEC950}"/>
               </a:ext>
             </a:extLst>
           </p:cNvPr>
@@ -6091,7 +6091,7 @@
           <p:cNvPr id="11" name="stat-value-前端测试 · 0 失败">
             <a:extLst xmlns:a="http://schemas.openxmlformats.org/drawingml/2006/main">
               <a:ext uri="{FF2B5EF4-FFF2-40B4-BE49-F238E27FC236}">
-                <a16:creationId xmlns:a16="http://schemas.microsoft.com/office/drawing/2014/main" id="{20B04A6C-4F8B-49A5-B220-79CD41645F8A}"/>
+                <a16:creationId xmlns:a16="http://schemas.microsoft.com/office/drawing/2014/main" id="{83EB30D4-5EAC-46FA-9A18-C4E75B8EAAB5}"/>
               </a:ext>
             </a:extLst>
           </p:cNvPr>
@@ -6149,7 +6149,7 @@
           <p:cNvPr id="12" name="stat-label-前端测试 · 0 失败">
             <a:extLst xmlns:a="http://schemas.openxmlformats.org/drawingml/2006/main">
               <a:ext uri="{FF2B5EF4-FFF2-40B4-BE49-F238E27FC236}">
-                <a16:creationId xmlns:a16="http://schemas.microsoft.com/office/drawing/2014/main" id="{EE2449F9-B5A1-42D8-B037-8800125F2DBC}"/>
+                <a16:creationId xmlns:a16="http://schemas.microsoft.com/office/drawing/2014/main" id="{AC4DE60C-0D38-4334-986D-279DFE2C8B2B}"/>
               </a:ext>
             </a:extLst>
           </p:cNvPr>
@@ -6207,7 +6207,7 @@
           <p:cNvPr id="13" name="stat-后端服务端口 9000–9006">
             <a:extLst xmlns:a="http://schemas.openxmlformats.org/drawingml/2006/main">
               <a:ext uri="{FF2B5EF4-FFF2-40B4-BE49-F238E27FC236}">
-                <a16:creationId xmlns:a16="http://schemas.microsoft.com/office/drawing/2014/main" id="{148F675E-6DAB-4354-9F54-67FC4B694CC9}"/>
+                <a16:creationId xmlns:a16="http://schemas.microsoft.com/office/drawing/2014/main" id="{BDAA164C-0A08-429B-9D1C-956B3635474D}"/>
               </a:ext>
             </a:extLst>
           </p:cNvPr>
@@ -6242,7 +6242,7 @@
           <p:cNvPr id="14" name="stat-accent-后端服务端口 9000–9006">
             <a:extLst xmlns:a="http://schemas.openxmlformats.org/drawingml/2006/main">
               <a:ext uri="{FF2B5EF4-FFF2-40B4-BE49-F238E27FC236}">
-                <a16:creationId xmlns:a16="http://schemas.microsoft.com/office/drawing/2014/main" id="{A654FCA4-0411-4A20-BE6A-FB5198852F42}"/>
+                <a16:creationId xmlns:a16="http://schemas.microsoft.com/office/drawing/2014/main" id="{62396B79-6900-46F7-A701-8F873E2A8ED1}"/>
               </a:ext>
             </a:extLst>
           </p:cNvPr>
@@ -6273,7 +6273,7 @@
           <p:cNvPr id="15" name="stat-value-后端服务端口 9000–9006">
             <a:extLst xmlns:a="http://schemas.openxmlformats.org/drawingml/2006/main">
               <a:ext uri="{FF2B5EF4-FFF2-40B4-BE49-F238E27FC236}">
-                <a16:creationId xmlns:a16="http://schemas.microsoft.com/office/drawing/2014/main" id="{FE58D1E7-AA41-4994-B001-6EBC538F666A}"/>
+                <a16:creationId xmlns:a16="http://schemas.microsoft.com/office/drawing/2014/main" id="{DAE11C59-A701-43D2-805F-8429CB559F34}"/>
               </a:ext>
             </a:extLst>
           </p:cNvPr>
@@ -6331,7 +6331,7 @@
           <p:cNvPr id="16" name="stat-label-后端服务端口 9000–9006">
             <a:extLst xmlns:a="http://schemas.openxmlformats.org/drawingml/2006/main">
               <a:ext uri="{FF2B5EF4-FFF2-40B4-BE49-F238E27FC236}">
-                <a16:creationId xmlns:a16="http://schemas.microsoft.com/office/drawing/2014/main" id="{DC0D646B-0D4C-4E51-9190-5463B18421B1}"/>
+                <a16:creationId xmlns:a16="http://schemas.microsoft.com/office/drawing/2014/main" id="{691E9BE6-6033-4E1D-A130-38813EA4159C}"/>
               </a:ext>
             </a:extLst>
           </p:cNvPr>
@@ -6389,7 +6389,7 @@
           <p:cNvPr id="17" name="stat-演示职位数据">
             <a:extLst xmlns:a="http://schemas.openxmlformats.org/drawingml/2006/main">
               <a:ext uri="{FF2B5EF4-FFF2-40B4-BE49-F238E27FC236}">
-                <a16:creationId xmlns:a16="http://schemas.microsoft.com/office/drawing/2014/main" id="{3C1A49C7-05FF-4906-9126-09CE1503E927}"/>
+                <a16:creationId xmlns:a16="http://schemas.microsoft.com/office/drawing/2014/main" id="{9A0E8416-9C70-4C7D-BAFB-48DE42B57E30}"/>
               </a:ext>
             </a:extLst>
           </p:cNvPr>
@@ -6424,7 +6424,7 @@
           <p:cNvPr id="18" name="stat-accent-演示职位数据">
             <a:extLst xmlns:a="http://schemas.openxmlformats.org/drawingml/2006/main">
               <a:ext uri="{FF2B5EF4-FFF2-40B4-BE49-F238E27FC236}">
-                <a16:creationId xmlns:a16="http://schemas.microsoft.com/office/drawing/2014/main" id="{984294FC-C19C-4165-A3EC-5285212173D1}"/>
+                <a16:creationId xmlns:a16="http://schemas.microsoft.com/office/drawing/2014/main" id="{76BC017B-B80C-425C-8357-9734DDB83742}"/>
               </a:ext>
             </a:extLst>
           </p:cNvPr>
@@ -6455,7 +6455,7 @@
           <p:cNvPr id="19" name="stat-value-演示职位数据">
             <a:extLst xmlns:a="http://schemas.openxmlformats.org/drawingml/2006/main">
               <a:ext uri="{FF2B5EF4-FFF2-40B4-BE49-F238E27FC236}">
-                <a16:creationId xmlns:a16="http://schemas.microsoft.com/office/drawing/2014/main" id="{56AC708F-945E-4031-AF14-F413FF5C4C4D}"/>
+                <a16:creationId xmlns:a16="http://schemas.microsoft.com/office/drawing/2014/main" id="{8B5B1C6B-5949-4AD4-B45D-667D7CA4B3D3}"/>
               </a:ext>
             </a:extLst>
           </p:cNvPr>
@@ -6513,7 +6513,7 @@
           <p:cNvPr id="20" name="stat-label-演示职位数据">
             <a:extLst xmlns:a="http://schemas.openxmlformats.org/drawingml/2006/main">
               <a:ext uri="{FF2B5EF4-FFF2-40B4-BE49-F238E27FC236}">
-                <a16:creationId xmlns:a16="http://schemas.microsoft.com/office/drawing/2014/main" id="{096D01C3-0EB3-43CA-AC3C-407C2C6C0514}"/>
+                <a16:creationId xmlns:a16="http://schemas.microsoft.com/office/drawing/2014/main" id="{317737F8-7224-4512-94AF-77A21133D270}"/>
               </a:ext>
             </a:extLst>
           </p:cNvPr>
@@ -6571,7 +6571,7 @@
           <p:cNvPr id="21" name="text">
             <a:extLst xmlns:a="http://schemas.openxmlformats.org/drawingml/2006/main">
               <a:ext uri="{FF2B5EF4-FFF2-40B4-BE49-F238E27FC236}">
-                <a16:creationId xmlns:a16="http://schemas.microsoft.com/office/drawing/2014/main" id="{1CD3EEA6-0632-4A39-A0D8-0F0B4F83A67D}"/>
+                <a16:creationId xmlns:a16="http://schemas.microsoft.com/office/drawing/2014/main" id="{4C221400-4167-4200-A2CC-C5A52CE8DE72}"/>
               </a:ext>
             </a:extLst>
           </p:cNvPr>
@@ -6629,7 +6629,7 @@
           <p:cNvPr id="22" name="dep-0">
             <a:extLst xmlns:a="http://schemas.openxmlformats.org/drawingml/2006/main">
               <a:ext uri="{FF2B5EF4-FFF2-40B4-BE49-F238E27FC236}">
-                <a16:creationId xmlns:a16="http://schemas.microsoft.com/office/drawing/2014/main" id="{AC313300-9758-42DA-869D-2CACEA58969C}"/>
+                <a16:creationId xmlns:a16="http://schemas.microsoft.com/office/drawing/2014/main" id="{3A176518-2D05-43F0-AD38-058774769ABE}"/>
               </a:ext>
             </a:extLst>
           </p:cNvPr>
@@ -6664,7 +6664,7 @@
           <p:cNvPr id="23" name="text">
             <a:extLst xmlns:a="http://schemas.openxmlformats.org/drawingml/2006/main">
               <a:ext uri="{FF2B5EF4-FFF2-40B4-BE49-F238E27FC236}">
-                <a16:creationId xmlns:a16="http://schemas.microsoft.com/office/drawing/2014/main" id="{3A3E4BC3-3402-4E5F-812E-7F565085E96B}"/>
+                <a16:creationId xmlns:a16="http://schemas.microsoft.com/office/drawing/2014/main" id="{821C80FD-30BD-4E40-BC79-8EA9137DB359}"/>
               </a:ext>
             </a:extLst>
           </p:cNvPr>
@@ -6722,7 +6722,7 @@
           <p:cNvPr id="24" name="text">
             <a:extLst xmlns:a="http://schemas.openxmlformats.org/drawingml/2006/main">
               <a:ext uri="{FF2B5EF4-FFF2-40B4-BE49-F238E27FC236}">
-                <a16:creationId xmlns:a16="http://schemas.microsoft.com/office/drawing/2014/main" id="{F761A297-0B6C-4D54-85F6-1AD88E355AEF}"/>
+                <a16:creationId xmlns:a16="http://schemas.microsoft.com/office/drawing/2014/main" id="{CADF9D9D-2D91-4D6D-88FF-8167CB5C797C}"/>
               </a:ext>
             </a:extLst>
           </p:cNvPr>
@@ -6780,7 +6780,7 @@
           <p:cNvPr id="25" name="dep-1">
             <a:extLst xmlns:a="http://schemas.openxmlformats.org/drawingml/2006/main">
               <a:ext uri="{FF2B5EF4-FFF2-40B4-BE49-F238E27FC236}">
-                <a16:creationId xmlns:a16="http://schemas.microsoft.com/office/drawing/2014/main" id="{13D07CB6-30F0-4501-8FBE-6E262B37D293}"/>
+                <a16:creationId xmlns:a16="http://schemas.microsoft.com/office/drawing/2014/main" id="{1F5BF4D0-F6FD-48E5-BF26-DBA43050A33B}"/>
               </a:ext>
             </a:extLst>
           </p:cNvPr>
@@ -6815,7 +6815,7 @@
           <p:cNvPr id="26" name="text">
             <a:extLst xmlns:a="http://schemas.openxmlformats.org/drawingml/2006/main">
               <a:ext uri="{FF2B5EF4-FFF2-40B4-BE49-F238E27FC236}">
-                <a16:creationId xmlns:a16="http://schemas.microsoft.com/office/drawing/2014/main" id="{68BAE013-BFC0-4E8E-A56A-4B62CD91B678}"/>
+                <a16:creationId xmlns:a16="http://schemas.microsoft.com/office/drawing/2014/main" id="{6F95A967-DCFC-4A7A-9F46-73F93951755F}"/>
               </a:ext>
             </a:extLst>
           </p:cNvPr>
@@ -6873,7 +6873,7 @@
           <p:cNvPr id="27" name="text">
             <a:extLst xmlns:a="http://schemas.openxmlformats.org/drawingml/2006/main">
               <a:ext uri="{FF2B5EF4-FFF2-40B4-BE49-F238E27FC236}">
-                <a16:creationId xmlns:a16="http://schemas.microsoft.com/office/drawing/2014/main" id="{08D133BF-A085-453A-A70D-B9BB67BCB38B}"/>
+                <a16:creationId xmlns:a16="http://schemas.microsoft.com/office/drawing/2014/main" id="{EF3A4A64-FAA1-4A17-82D0-9143250709CB}"/>
               </a:ext>
             </a:extLst>
           </p:cNvPr>
@@ -6931,7 +6931,7 @@
           <p:cNvPr id="28" name="dep-2">
             <a:extLst xmlns:a="http://schemas.openxmlformats.org/drawingml/2006/main">
               <a:ext uri="{FF2B5EF4-FFF2-40B4-BE49-F238E27FC236}">
-                <a16:creationId xmlns:a16="http://schemas.microsoft.com/office/drawing/2014/main" id="{3CFDC510-EEFF-4A61-B3E4-B83C48BBD6F3}"/>
+                <a16:creationId xmlns:a16="http://schemas.microsoft.com/office/drawing/2014/main" id="{C42B56A9-6720-4726-9612-273FFE5E0466}"/>
               </a:ext>
             </a:extLst>
           </p:cNvPr>
@@ -6966,7 +6966,7 @@
           <p:cNvPr id="29" name="text">
             <a:extLst xmlns:a="http://schemas.openxmlformats.org/drawingml/2006/main">
               <a:ext uri="{FF2B5EF4-FFF2-40B4-BE49-F238E27FC236}">
-                <a16:creationId xmlns:a16="http://schemas.microsoft.com/office/drawing/2014/main" id="{4BB5149B-0364-4322-B33A-BF507D016A51}"/>
+                <a16:creationId xmlns:a16="http://schemas.microsoft.com/office/drawing/2014/main" id="{4A6322E2-CDE9-42F7-953F-D56DBC44DE6D}"/>
               </a:ext>
             </a:extLst>
           </p:cNvPr>
@@ -7024,7 +7024,7 @@
           <p:cNvPr id="30" name="text">
             <a:extLst xmlns:a="http://schemas.openxmlformats.org/drawingml/2006/main">
               <a:ext uri="{FF2B5EF4-FFF2-40B4-BE49-F238E27FC236}">
-                <a16:creationId xmlns:a16="http://schemas.microsoft.com/office/drawing/2014/main" id="{180E7270-112F-4934-AF20-BD0993D4138E}"/>
+                <a16:creationId xmlns:a16="http://schemas.microsoft.com/office/drawing/2014/main" id="{8C993F57-451C-495F-ADBD-F6D48EE0CD69}"/>
               </a:ext>
             </a:extLst>
           </p:cNvPr>
@@ -7082,7 +7082,7 @@
           <p:cNvPr id="31" name="dep-3">
             <a:extLst xmlns:a="http://schemas.openxmlformats.org/drawingml/2006/main">
               <a:ext uri="{FF2B5EF4-FFF2-40B4-BE49-F238E27FC236}">
-                <a16:creationId xmlns:a16="http://schemas.microsoft.com/office/drawing/2014/main" id="{A6330AB7-85D0-46F9-AEDF-C272C2B8EF71}"/>
+                <a16:creationId xmlns:a16="http://schemas.microsoft.com/office/drawing/2014/main" id="{40EDEF9B-0E01-45C7-9436-A67E4DF14854}"/>
               </a:ext>
             </a:extLst>
           </p:cNvPr>
@@ -7117,7 +7117,7 @@
           <p:cNvPr id="32" name="text">
             <a:extLst xmlns:a="http://schemas.openxmlformats.org/drawingml/2006/main">
               <a:ext uri="{FF2B5EF4-FFF2-40B4-BE49-F238E27FC236}">
-                <a16:creationId xmlns:a16="http://schemas.microsoft.com/office/drawing/2014/main" id="{B3DFFC86-208E-4EE6-9E9C-64308A1E4CFF}"/>
+                <a16:creationId xmlns:a16="http://schemas.microsoft.com/office/drawing/2014/main" id="{B156179D-79FC-456B-A914-E9913E7A5BCB}"/>
               </a:ext>
             </a:extLst>
           </p:cNvPr>
@@ -7165,7 +7165,7 @@
                 <a:ea typeface="Microsoft YaHei"/>
                 <a:cs typeface="Microsoft YaHei"/>
               </a:rPr>
-              <a:t>RabbitMQ</a:t>
+              <a:t>RabbitMQ 4.3.2</a:t>
             </a:r>
           </a:p>
         </p:txBody>
@@ -7175,7 +7175,7 @@
           <p:cNvPr id="33" name="text">
             <a:extLst xmlns:a="http://schemas.openxmlformats.org/drawingml/2006/main">
               <a:ext uri="{FF2B5EF4-FFF2-40B4-BE49-F238E27FC236}">
-                <a16:creationId xmlns:a16="http://schemas.microsoft.com/office/drawing/2014/main" id="{C662B7BD-2823-41FB-9C25-3B2D45670EC8}"/>
+                <a16:creationId xmlns:a16="http://schemas.microsoft.com/office/drawing/2014/main" id="{B82B80F9-0489-419A-A55F-C93B136E0640}"/>
               </a:ext>
             </a:extLst>
           </p:cNvPr>
@@ -7207,7 +7207,7 @@
             <a:pPr algn="r">
               <a:defRPr sz="1125" b="1">
                 <a:solidFill>
-                  <a:srgbClr val="F79009"/>
+                  <a:srgbClr val="12B76A"/>
                 </a:solidFill>
                 <a:latin typeface="Microsoft YaHei"/>
                 <a:ea typeface="Microsoft YaHei"/>
@@ -7217,13 +7217,13 @@
             <a:r>
               <a:rPr sz="1125" b="1">
                 <a:solidFill>
-                  <a:srgbClr val="F79009"/>
-                </a:solidFill>
-                <a:latin typeface="Microsoft YaHei"/>
-                <a:ea typeface="Microsoft YaHei"/>
-                <a:cs typeface="Microsoft YaHei"/>
-              </a:rPr>
-              <a:t>代码链路完成；现场需启动</a:t>
+                  <a:srgbClr val="12B76A"/>
+                </a:solidFill>
+                <a:latin typeface="Microsoft YaHei"/>
+                <a:ea typeface="Microsoft YaHei"/>
+                <a:cs typeface="Microsoft YaHei"/>
+              </a:rPr>
+              <a:t>READY</a:t>
             </a:r>
           </a:p>
         </p:txBody>
@@ -7233,7 +7233,7 @@
           <p:cNvPr id="34" name="verification-box">
             <a:extLst xmlns:a="http://schemas.openxmlformats.org/drawingml/2006/main">
               <a:ext uri="{FF2B5EF4-FFF2-40B4-BE49-F238E27FC236}">
-                <a16:creationId xmlns:a16="http://schemas.microsoft.com/office/drawing/2014/main" id="{BC3870C0-E6EE-41D9-8DD3-AEA2E7758D5C}"/>
+                <a16:creationId xmlns:a16="http://schemas.microsoft.com/office/drawing/2014/main" id="{E2F33889-9D48-404A-A4DD-3576F72D33BF}"/>
               </a:ext>
             </a:extLst>
           </p:cNvPr>
@@ -7268,7 +7268,7 @@
           <p:cNvPr id="35" name="text">
             <a:extLst xmlns:a="http://schemas.openxmlformats.org/drawingml/2006/main">
               <a:ext uri="{FF2B5EF4-FFF2-40B4-BE49-F238E27FC236}">
-                <a16:creationId xmlns:a16="http://schemas.microsoft.com/office/drawing/2014/main" id="{02F9ED24-12F5-472E-97CB-C0D3AD928BF2}"/>
+                <a16:creationId xmlns:a16="http://schemas.microsoft.com/office/drawing/2014/main" id="{179F171E-94F3-481C-A107-D8FC0D6800B3}"/>
               </a:ext>
             </a:extLst>
           </p:cNvPr>
@@ -7326,19 +7326,19 @@
           <p:cNvPr id="36" name="text">
             <a:extLst xmlns:a="http://schemas.openxmlformats.org/drawingml/2006/main">
               <a:ext uri="{FF2B5EF4-FFF2-40B4-BE49-F238E27FC236}">
-                <a16:creationId xmlns:a16="http://schemas.microsoft.com/office/drawing/2014/main" id="{BE45E10D-1CA5-40F1-BEE8-59BCCD952C56}"/>
-              </a:ext>
-            </a:extLst>
-          </p:cNvPr>
-          <p:cNvSpPr>
-            <a:spLocks xmlns:a="http://schemas.openxmlformats.org/drawingml/2006/main" noGrp="1"/>
-          </p:cNvSpPr>
-          <p:nvPr/>
-        </p:nvSpPr>
-        <p:spPr>
-          <a:xfrm xmlns:a="http://schemas.openxmlformats.org/drawingml/2006/main">
-            <a:off x="6343650" y="4267200"/>
-            <a:ext cx="4953000" cy="1200150"/>
+                <a16:creationId xmlns:a16="http://schemas.microsoft.com/office/drawing/2014/main" id="{C29B9D96-EA01-463D-B2DF-67364A66B98F}"/>
+              </a:ext>
+            </a:extLst>
+          </p:cNvPr>
+          <p:cNvSpPr>
+            <a:spLocks xmlns:a="http://schemas.openxmlformats.org/drawingml/2006/main" noGrp="1"/>
+          </p:cNvSpPr>
+          <p:nvPr/>
+        </p:nvSpPr>
+        <p:spPr>
+          <a:xfrm xmlns:a="http://schemas.openxmlformats.org/drawingml/2006/main">
+            <a:off x="6343650" y="4171950"/>
+            <a:ext cx="4953000" cy="1352550"/>
           </a:xfrm>
           <a:prstGeom xmlns:a="http://schemas.openxmlformats.org/drawingml/2006/main" prst="rect">
             <a:avLst/>
@@ -7356,7 +7356,7 @@
           <a:lstStyle xmlns:a="http://schemas.openxmlformats.org/drawingml/2006/main"/>
           <a:p xmlns:a="http://schemas.openxmlformats.org/drawingml/2006/main">
             <a:pPr algn="l">
-              <a:defRPr sz="1500" b="0">
+              <a:defRPr sz="1350" b="0">
                 <a:solidFill>
                   <a:srgbClr val="667085"/>
                 </a:solidFill>
@@ -7366,7 +7366,7 @@
               </a:defRPr>
             </a:pPr>
             <a:r>
-              <a:rPr sz="1500" b="0">
+              <a:rPr sz="1350" b="0">
                 <a:solidFill>
                   <a:srgbClr val="667085"/>
                 </a:solidFill>
@@ -7374,12 +7374,12 @@
                 <a:ea typeface="Microsoft YaHei"/>
                 <a:cs typeface="Microsoft YaHei"/>
               </a:rPr>
-              <a:t>1. scripts/check-environment.ps1</a:t>
+              <a:t>1. scripts/start-rabbitmq.ps1</a:t>
             </a:r>
           </a:p>
           <a:p xmlns:a="http://schemas.openxmlformats.org/drawingml/2006/main">
             <a:pPr algn="l">
-              <a:defRPr sz="1500" b="0">
+              <a:defRPr sz="1350" b="0">
                 <a:solidFill>
                   <a:srgbClr val="667085"/>
                 </a:solidFill>
@@ -7389,7 +7389,7 @@
               </a:defRPr>
             </a:pPr>
             <a:r>
-              <a:rPr sz="1500" b="0">
+              <a:rPr sz="1350" b="0">
                 <a:solidFill>
                   <a:srgbClr val="667085"/>
                 </a:solidFill>
@@ -7397,12 +7397,12 @@
                 <a:ea typeface="Microsoft YaHei"/>
                 <a:cs typeface="Microsoft YaHei"/>
               </a:rPr>
-              <a:t>2. 导入 sql/ai_job_radar.sql</a:t>
+              <a:t>2. scripts/check-environment.ps1</a:t>
             </a:r>
           </a:p>
           <a:p xmlns:a="http://schemas.openxmlformats.org/drawingml/2006/main">
             <a:pPr algn="l">
-              <a:defRPr sz="1500" b="0">
+              <a:defRPr sz="1350" b="0">
                 <a:solidFill>
                   <a:srgbClr val="667085"/>
                 </a:solidFill>
@@ -7412,7 +7412,7 @@
               </a:defRPr>
             </a:pPr>
             <a:r>
-              <a:rPr sz="1500" b="0">
+              <a:rPr sz="1350" b="0">
                 <a:solidFill>
                   <a:srgbClr val="667085"/>
                 </a:solidFill>
@@ -7420,12 +7420,12 @@
                 <a:ea typeface="Microsoft YaHei"/>
                 <a:cs typeface="Microsoft YaHei"/>
               </a:rPr>
-              <a:t>3. scripts/start-backend.ps1</a:t>
+              <a:t>3. 导入 sql/ai_job_radar.sql</a:t>
             </a:r>
           </a:p>
           <a:p xmlns:a="http://schemas.openxmlformats.org/drawingml/2006/main">
             <a:pPr algn="l">
-              <a:defRPr sz="1500" b="0">
+              <a:defRPr sz="1350" b="0">
                 <a:solidFill>
                   <a:srgbClr val="667085"/>
                 </a:solidFill>
@@ -7435,7 +7435,7 @@
               </a:defRPr>
             </a:pPr>
             <a:r>
-              <a:rPr sz="1500" b="0">
+              <a:rPr sz="1350" b="0">
                 <a:solidFill>
                   <a:srgbClr val="667085"/>
                 </a:solidFill>
@@ -7443,7 +7443,30 @@
                 <a:ea typeface="Microsoft YaHei"/>
                 <a:cs typeface="Microsoft YaHei"/>
               </a:rPr>
-              <a:t>4. npm install &amp;&amp; npm run dev</a:t>
+              <a:t>4. scripts/start-backend.ps1</a:t>
+            </a:r>
+          </a:p>
+          <a:p xmlns:a="http://schemas.openxmlformats.org/drawingml/2006/main">
+            <a:pPr algn="l">
+              <a:defRPr sz="1350" b="0">
+                <a:solidFill>
+                  <a:srgbClr val="667085"/>
+                </a:solidFill>
+                <a:latin typeface="Microsoft YaHei"/>
+                <a:ea typeface="Microsoft YaHei"/>
+                <a:cs typeface="Microsoft YaHei"/>
+              </a:defRPr>
+            </a:pPr>
+            <a:r>
+              <a:rPr sz="1350" b="0">
+                <a:solidFill>
+                  <a:srgbClr val="667085"/>
+                </a:solidFill>
+                <a:latin typeface="Microsoft YaHei"/>
+                <a:ea typeface="Microsoft YaHei"/>
+                <a:cs typeface="Microsoft YaHei"/>
+              </a:rPr>
+              <a:t>5. npm install &amp;&amp; npm run dev</a:t>
             </a:r>
           </a:p>
         </p:txBody>
@@ -7453,7 +7476,7 @@
           <p:cNvPr id="37" name="pill-mvn test ✓">
             <a:extLst xmlns:a="http://schemas.openxmlformats.org/drawingml/2006/main">
               <a:ext uri="{FF2B5EF4-FFF2-40B4-BE49-F238E27FC236}">
-                <a16:creationId xmlns:a16="http://schemas.microsoft.com/office/drawing/2014/main" id="{5B94C1A7-236C-4B43-B849-04876D88065E}"/>
+                <a16:creationId xmlns:a16="http://schemas.microsoft.com/office/drawing/2014/main" id="{818E2FEB-CB51-4708-8BDE-655CAA588A16}"/>
               </a:ext>
             </a:extLst>
           </p:cNvPr>
@@ -7486,7 +7509,7 @@
           <p:cNvPr id="38" name="pill-text-mvn test ✓">
             <a:extLst xmlns:a="http://schemas.openxmlformats.org/drawingml/2006/main">
               <a:ext uri="{FF2B5EF4-FFF2-40B4-BE49-F238E27FC236}">
-                <a16:creationId xmlns:a16="http://schemas.microsoft.com/office/drawing/2014/main" id="{A8B72EF3-7075-4AA8-AE84-A197A1B84D37}"/>
+                <a16:creationId xmlns:a16="http://schemas.microsoft.com/office/drawing/2014/main" id="{4C247305-2EC3-44A4-9E0C-6EC45F3B66B5}"/>
               </a:ext>
             </a:extLst>
           </p:cNvPr>
@@ -7544,7 +7567,7 @@
           <p:cNvPr id="39" name="pill-npm test ✓">
             <a:extLst xmlns:a="http://schemas.openxmlformats.org/drawingml/2006/main">
               <a:ext uri="{FF2B5EF4-FFF2-40B4-BE49-F238E27FC236}">
-                <a16:creationId xmlns:a16="http://schemas.microsoft.com/office/drawing/2014/main" id="{9F234CC7-D630-48C5-9848-1E323D5E16D2}"/>
+                <a16:creationId xmlns:a16="http://schemas.microsoft.com/office/drawing/2014/main" id="{7AD4B65B-5513-4B06-B5DA-367EC051BB6C}"/>
               </a:ext>
             </a:extLst>
           </p:cNvPr>
@@ -7577,7 +7600,7 @@
           <p:cNvPr id="40" name="pill-text-npm test ✓">
             <a:extLst xmlns:a="http://schemas.openxmlformats.org/drawingml/2006/main">
               <a:ext uri="{FF2B5EF4-FFF2-40B4-BE49-F238E27FC236}">
-                <a16:creationId xmlns:a16="http://schemas.microsoft.com/office/drawing/2014/main" id="{BF2D6864-FC87-4BBA-8DEE-3E05E81BA329}"/>
+                <a16:creationId xmlns:a16="http://schemas.microsoft.com/office/drawing/2014/main" id="{299910C7-9723-47B6-A3D6-8B4291010B54}"/>
               </a:ext>
             </a:extLst>
           </p:cNvPr>
@@ -7635,7 +7658,7 @@
           <p:cNvPr id="41" name="pill-vite build ✓">
             <a:extLst xmlns:a="http://schemas.openxmlformats.org/drawingml/2006/main">
               <a:ext uri="{FF2B5EF4-FFF2-40B4-BE49-F238E27FC236}">
-                <a16:creationId xmlns:a16="http://schemas.microsoft.com/office/drawing/2014/main" id="{BD63D3E9-B600-4A0B-AD67-7E0FA61E04D9}"/>
+                <a16:creationId xmlns:a16="http://schemas.microsoft.com/office/drawing/2014/main" id="{D8752B2B-0CC9-48DF-ABE9-FAF575C716C6}"/>
               </a:ext>
             </a:extLst>
           </p:cNvPr>
@@ -7668,7 +7691,7 @@
           <p:cNvPr id="42" name="pill-text-vite build ✓">
             <a:extLst xmlns:a="http://schemas.openxmlformats.org/drawingml/2006/main">
               <a:ext uri="{FF2B5EF4-FFF2-40B4-BE49-F238E27FC236}">
-                <a16:creationId xmlns:a16="http://schemas.microsoft.com/office/drawing/2014/main" id="{EA46A191-52E6-439A-9D5C-4D0C70403BE8}"/>
+                <a16:creationId xmlns:a16="http://schemas.microsoft.com/office/drawing/2014/main" id="{D377B55D-80E4-4848-A868-A385C25F3D04}"/>
               </a:ext>
             </a:extLst>
           </p:cNvPr>
@@ -7724,7 +7747,7 @@
     </p:spTree>
     <p:extLst>
       <p:ext uri="{BB962C8B-B14F-4D97-AF65-F5344CB8AC3E}">
-        <p14:creationId xmlns:p14="http://schemas.microsoft.com/office/powerpoint/2010/main" val="119618974"/>
+        <p14:creationId xmlns:p14="http://schemas.microsoft.com/office/powerpoint/2010/main" val="831698303"/>
       </p:ext>
     </p:extLst>
   </p:cSld>
@@ -7755,7 +7778,7 @@
           <p:cNvPr id="1" name="eyebrow-13">
             <a:extLst xmlns:a="http://schemas.openxmlformats.org/drawingml/2006/main">
               <a:ext uri="{FF2B5EF4-FFF2-40B4-BE49-F238E27FC236}">
-                <a16:creationId xmlns:a16="http://schemas.microsoft.com/office/drawing/2014/main" id="{BE61ECC5-F4F9-40E3-A5E7-505895F1B4FD}"/>
+                <a16:creationId xmlns:a16="http://schemas.microsoft.com/office/drawing/2014/main" id="{ECC6B7E8-18D4-4344-A358-26898C694E54}"/>
               </a:ext>
             </a:extLst>
           </p:cNvPr>
@@ -7813,7 +7836,7 @@
           <p:cNvPr id="2" name="slide-title-13">
             <a:extLst xmlns:a="http://schemas.openxmlformats.org/drawingml/2006/main">
               <a:ext uri="{FF2B5EF4-FFF2-40B4-BE49-F238E27FC236}">
-                <a16:creationId xmlns:a16="http://schemas.microsoft.com/office/drawing/2014/main" id="{63DF0040-FAAF-4E11-9CDA-66184AE553E9}"/>
+                <a16:creationId xmlns:a16="http://schemas.microsoft.com/office/drawing/2014/main" id="{F359EE73-9877-4461-A4E8-50374C58643D}"/>
               </a:ext>
             </a:extLst>
           </p:cNvPr>
@@ -7871,7 +7894,7 @@
           <p:cNvPr id="3" name="title-rule-13">
             <a:extLst xmlns:a="http://schemas.openxmlformats.org/drawingml/2006/main">
               <a:ext uri="{FF2B5EF4-FFF2-40B4-BE49-F238E27FC236}">
-                <a16:creationId xmlns:a16="http://schemas.microsoft.com/office/drawing/2014/main" id="{9F999EB2-6F1C-4A16-B2A2-D00041341998}"/>
+                <a16:creationId xmlns:a16="http://schemas.microsoft.com/office/drawing/2014/main" id="{252D4C65-90C6-4A90-9F14-59A54A24C3C9}"/>
               </a:ext>
             </a:extLst>
           </p:cNvPr>
@@ -7902,7 +7925,7 @@
           <p:cNvPr id="4" name="page-number-13">
             <a:extLst xmlns:a="http://schemas.openxmlformats.org/drawingml/2006/main">
               <a:ext uri="{FF2B5EF4-FFF2-40B4-BE49-F238E27FC236}">
-                <a16:creationId xmlns:a16="http://schemas.microsoft.com/office/drawing/2014/main" id="{CD6079CA-4F74-4E7C-8940-303B0B7D8D87}"/>
+                <a16:creationId xmlns:a16="http://schemas.microsoft.com/office/drawing/2014/main" id="{17F12FFB-4EA7-462B-B03D-8A6E3D2B7A72}"/>
               </a:ext>
             </a:extLst>
           </p:cNvPr>
@@ -7960,7 +7983,7 @@
           <p:cNvPr id="5" name="GitHub 提交记录-frame">
             <a:extLst xmlns:a="http://schemas.openxmlformats.org/drawingml/2006/main">
               <a:ext uri="{FF2B5EF4-FFF2-40B4-BE49-F238E27FC236}">
-                <a16:creationId xmlns:a16="http://schemas.microsoft.com/office/drawing/2014/main" id="{DA5B3724-9C3E-4CB9-A831-13CBE863482B}"/>
+                <a16:creationId xmlns:a16="http://schemas.microsoft.com/office/drawing/2014/main" id="{60E40D1A-5126-4026-AE4F-87B8111F7AA8}"/>
               </a:ext>
             </a:extLst>
           </p:cNvPr>
@@ -7999,7 +8022,7 @@
           <p:nvPr/>
         </p:nvPicPr>
         <p:blipFill>
-          <a:blip xmlns:r="http://schemas.openxmlformats.org/officeDocument/2006/relationships" xmlns:a="http://schemas.openxmlformats.org/drawingml/2006/main" r:embed="Rc00799c2010c43f3"/>
+          <a:blip xmlns:r="http://schemas.openxmlformats.org/officeDocument/2006/relationships" xmlns:a="http://schemas.openxmlformats.org/drawingml/2006/main" r:embed="Rcd12b7a7b2764d9e"/>
           <a:srcRect xmlns:a="http://schemas.openxmlformats.org/drawingml/2006/main" l="0" t="8604" r="0" b="8604"/>
           <a:stretch xmlns:a="http://schemas.openxmlformats.org/drawingml/2006/main">
             <a:fillRect l="0" t="0" r="0" b="0"/>
@@ -8022,7 +8045,7 @@
           <p:cNvPr id="7" name="git-notes">
             <a:extLst xmlns:a="http://schemas.openxmlformats.org/drawingml/2006/main">
               <a:ext uri="{FF2B5EF4-FFF2-40B4-BE49-F238E27FC236}">
-                <a16:creationId xmlns:a16="http://schemas.microsoft.com/office/drawing/2014/main" id="{E293C083-3305-4D7D-969E-57382CE39CC0}"/>
+                <a16:creationId xmlns:a16="http://schemas.microsoft.com/office/drawing/2014/main" id="{3C9335FA-8D8A-4041-8211-89B67A5A7FEA}"/>
               </a:ext>
             </a:extLst>
           </p:cNvPr>
@@ -8057,7 +8080,7 @@
           <p:cNvPr id="8" name="text">
             <a:extLst xmlns:a="http://schemas.openxmlformats.org/drawingml/2006/main">
               <a:ext uri="{FF2B5EF4-FFF2-40B4-BE49-F238E27FC236}">
-                <a16:creationId xmlns:a16="http://schemas.microsoft.com/office/drawing/2014/main" id="{16C09234-DD15-4DEA-8DA6-960041E4EDBA}"/>
+                <a16:creationId xmlns:a16="http://schemas.microsoft.com/office/drawing/2014/main" id="{71F26B70-4AB1-4F4F-B7CA-5D65B8072A8D}"/>
               </a:ext>
             </a:extLst>
           </p:cNvPr>
@@ -8115,7 +8138,7 @@
           <p:cNvPr id="9" name="text">
             <a:extLst xmlns:a="http://schemas.openxmlformats.org/drawingml/2006/main">
               <a:ext uri="{FF2B5EF4-FFF2-40B4-BE49-F238E27FC236}">
-                <a16:creationId xmlns:a16="http://schemas.microsoft.com/office/drawing/2014/main" id="{E83D2703-0099-416B-B2B8-CEF9718AB15B}"/>
+                <a16:creationId xmlns:a16="http://schemas.microsoft.com/office/drawing/2014/main" id="{6C759250-D79F-43E5-9FDC-B3AA37C4A272}"/>
               </a:ext>
             </a:extLst>
           </p:cNvPr>
@@ -8173,7 +8196,7 @@
           <p:cNvPr id="10" name="text">
             <a:extLst xmlns:a="http://schemas.openxmlformats.org/drawingml/2006/main">
               <a:ext uri="{FF2B5EF4-FFF2-40B4-BE49-F238E27FC236}">
-                <a16:creationId xmlns:a16="http://schemas.microsoft.com/office/drawing/2014/main" id="{33F1E858-2279-467A-91BC-240CEA090BB7}"/>
+                <a16:creationId xmlns:a16="http://schemas.microsoft.com/office/drawing/2014/main" id="{4DF82A72-0580-4E9F-BA05-894156401539}"/>
               </a:ext>
             </a:extLst>
           </p:cNvPr>
@@ -8231,7 +8254,7 @@
           <p:cNvPr id="11" name="text">
             <a:extLst xmlns:a="http://schemas.openxmlformats.org/drawingml/2006/main">
               <a:ext uri="{FF2B5EF4-FFF2-40B4-BE49-F238E27FC236}">
-                <a16:creationId xmlns:a16="http://schemas.microsoft.com/office/drawing/2014/main" id="{15913C5B-2EE0-419B-BFBB-1365EE2C9A49}"/>
+                <a16:creationId xmlns:a16="http://schemas.microsoft.com/office/drawing/2014/main" id="{C78AC420-4607-407E-9725-0BC9A01334AE}"/>
               </a:ext>
             </a:extLst>
           </p:cNvPr>
@@ -8289,7 +8312,7 @@
           <p:cNvPr id="12" name="text">
             <a:extLst xmlns:a="http://schemas.openxmlformats.org/drawingml/2006/main">
               <a:ext uri="{FF2B5EF4-FFF2-40B4-BE49-F238E27FC236}">
-                <a16:creationId xmlns:a16="http://schemas.microsoft.com/office/drawing/2014/main" id="{97745CE8-5A87-4B3E-9612-A4FFA66852F2}"/>
+                <a16:creationId xmlns:a16="http://schemas.microsoft.com/office/drawing/2014/main" id="{802CA01B-BF90-4676-AAA6-38AC672999EB}"/>
               </a:ext>
             </a:extLst>
           </p:cNvPr>
@@ -8347,7 +8370,7 @@
           <p:cNvPr id="13" name="text">
             <a:extLst xmlns:a="http://schemas.openxmlformats.org/drawingml/2006/main">
               <a:ext uri="{FF2B5EF4-FFF2-40B4-BE49-F238E27FC236}">
-                <a16:creationId xmlns:a16="http://schemas.microsoft.com/office/drawing/2014/main" id="{65204B6E-BFB8-4A2B-B0C5-CAAD0A7971CC}"/>
+                <a16:creationId xmlns:a16="http://schemas.microsoft.com/office/drawing/2014/main" id="{B78E2E06-0BF0-458B-A25D-CB62BF3593D2}"/>
               </a:ext>
             </a:extLst>
           </p:cNvPr>
@@ -8405,7 +8428,7 @@
           <p:cNvPr id="14" name="text">
             <a:extLst xmlns:a="http://schemas.openxmlformats.org/drawingml/2006/main">
               <a:ext uri="{FF2B5EF4-FFF2-40B4-BE49-F238E27FC236}">
-                <a16:creationId xmlns:a16="http://schemas.microsoft.com/office/drawing/2014/main" id="{E09665CF-1B60-42FC-B2B7-430A19512CE5}"/>
+                <a16:creationId xmlns:a16="http://schemas.microsoft.com/office/drawing/2014/main" id="{E64DB253-2BA3-4B1C-A4E5-CF7D63C422F2}"/>
               </a:ext>
             </a:extLst>
           </p:cNvPr>
@@ -8463,7 +8486,7 @@
           <p:cNvPr id="15" name="text">
             <a:extLst xmlns:a="http://schemas.openxmlformats.org/drawingml/2006/main">
               <a:ext uri="{FF2B5EF4-FFF2-40B4-BE49-F238E27FC236}">
-                <a16:creationId xmlns:a16="http://schemas.microsoft.com/office/drawing/2014/main" id="{436AECCA-1349-44C0-AB71-100CA0D36D75}"/>
+                <a16:creationId xmlns:a16="http://schemas.microsoft.com/office/drawing/2014/main" id="{41BAA72A-2319-485A-AB61-84A230A99DBF}"/>
               </a:ext>
             </a:extLst>
           </p:cNvPr>
@@ -8521,7 +8544,7 @@
           <p:cNvPr id="16" name="text">
             <a:extLst xmlns:a="http://schemas.openxmlformats.org/drawingml/2006/main">
               <a:ext uri="{FF2B5EF4-FFF2-40B4-BE49-F238E27FC236}">
-                <a16:creationId xmlns:a16="http://schemas.microsoft.com/office/drawing/2014/main" id="{4A404210-F832-4A20-A52C-BA895EE9FB55}"/>
+                <a16:creationId xmlns:a16="http://schemas.microsoft.com/office/drawing/2014/main" id="{0A724D94-DBD4-4145-9867-43B184C115A6}"/>
               </a:ext>
             </a:extLst>
           </p:cNvPr>
@@ -8579,7 +8602,7 @@
           <p:cNvPr id="17" name="pill-Public">
             <a:extLst xmlns:a="http://schemas.openxmlformats.org/drawingml/2006/main">
               <a:ext uri="{FF2B5EF4-FFF2-40B4-BE49-F238E27FC236}">
-                <a16:creationId xmlns:a16="http://schemas.microsoft.com/office/drawing/2014/main" id="{12EC945F-5361-4EBD-A042-B4ED8E79ACF5}"/>
+                <a16:creationId xmlns:a16="http://schemas.microsoft.com/office/drawing/2014/main" id="{0082E053-8CFD-4AA7-82E2-C8E1C8A62842}"/>
               </a:ext>
             </a:extLst>
           </p:cNvPr>
@@ -8612,7 +8635,7 @@
           <p:cNvPr id="18" name="pill-text-Public">
             <a:extLst xmlns:a="http://schemas.openxmlformats.org/drawingml/2006/main">
               <a:ext uri="{FF2B5EF4-FFF2-40B4-BE49-F238E27FC236}">
-                <a16:creationId xmlns:a16="http://schemas.microsoft.com/office/drawing/2014/main" id="{FD47ADAB-94D5-423C-8382-317D6237896D}"/>
+                <a16:creationId xmlns:a16="http://schemas.microsoft.com/office/drawing/2014/main" id="{2E4E33AE-3FAE-4857-B88B-140F567F2F00}"/>
               </a:ext>
             </a:extLst>
           </p:cNvPr>
@@ -8670,7 +8693,7 @@
           <p:cNvPr id="19" name="pill-main">
             <a:extLst xmlns:a="http://schemas.openxmlformats.org/drawingml/2006/main">
               <a:ext uri="{FF2B5EF4-FFF2-40B4-BE49-F238E27FC236}">
-                <a16:creationId xmlns:a16="http://schemas.microsoft.com/office/drawing/2014/main" id="{ADB81162-AE26-432A-AFA6-9DB9123D247A}"/>
+                <a16:creationId xmlns:a16="http://schemas.microsoft.com/office/drawing/2014/main" id="{D2978F7A-C1DA-44F9-992E-B3DEF7AAC923}"/>
               </a:ext>
             </a:extLst>
           </p:cNvPr>
@@ -8703,7 +8726,7 @@
           <p:cNvPr id="20" name="pill-text-main">
             <a:extLst xmlns:a="http://schemas.openxmlformats.org/drawingml/2006/main">
               <a:ext uri="{FF2B5EF4-FFF2-40B4-BE49-F238E27FC236}">
-                <a16:creationId xmlns:a16="http://schemas.microsoft.com/office/drawing/2014/main" id="{EAD27308-4546-4F92-AAA0-992C62DB4A75}"/>
+                <a16:creationId xmlns:a16="http://schemas.microsoft.com/office/drawing/2014/main" id="{7D19641B-4174-4D4E-B8C2-2BB528B04CC7}"/>
               </a:ext>
             </a:extLst>
           </p:cNvPr>
@@ -8759,7 +8782,7 @@
     </p:spTree>
     <p:extLst>
       <p:ext uri="{BB962C8B-B14F-4D97-AF65-F5344CB8AC3E}">
-        <p14:creationId xmlns:p14="http://schemas.microsoft.com/office/powerpoint/2010/main" val="982762868"/>
+        <p14:creationId xmlns:p14="http://schemas.microsoft.com/office/powerpoint/2010/main" val="1683597059"/>
       </p:ext>
     </p:extLst>
   </p:cSld>
@@ -8790,7 +8813,7 @@
           <p:cNvPr id="1" name="eyebrow-14">
             <a:extLst xmlns:a="http://schemas.openxmlformats.org/drawingml/2006/main">
               <a:ext uri="{FF2B5EF4-FFF2-40B4-BE49-F238E27FC236}">
-                <a16:creationId xmlns:a16="http://schemas.microsoft.com/office/drawing/2014/main" id="{C7C9397D-6243-4AD7-AD39-E98B79D983BD}"/>
+                <a16:creationId xmlns:a16="http://schemas.microsoft.com/office/drawing/2014/main" id="{433B82A7-0C40-4435-A627-A4B403CDFF2A}"/>
               </a:ext>
             </a:extLst>
           </p:cNvPr>
@@ -8848,7 +8871,7 @@
           <p:cNvPr id="2" name="slide-title-14">
             <a:extLst xmlns:a="http://schemas.openxmlformats.org/drawingml/2006/main">
               <a:ext uri="{FF2B5EF4-FFF2-40B4-BE49-F238E27FC236}">
-                <a16:creationId xmlns:a16="http://schemas.microsoft.com/office/drawing/2014/main" id="{C0989FF0-A331-4F16-A78F-AE31E17BFC7B}"/>
+                <a16:creationId xmlns:a16="http://schemas.microsoft.com/office/drawing/2014/main" id="{4629C502-854A-4F10-88FD-827618237622}"/>
               </a:ext>
             </a:extLst>
           </p:cNvPr>
@@ -8906,7 +8929,7 @@
           <p:cNvPr id="3" name="title-rule-14">
             <a:extLst xmlns:a="http://schemas.openxmlformats.org/drawingml/2006/main">
               <a:ext uri="{FF2B5EF4-FFF2-40B4-BE49-F238E27FC236}">
-                <a16:creationId xmlns:a16="http://schemas.microsoft.com/office/drawing/2014/main" id="{2FBD610F-7EB6-4144-9F48-833E4C803920}"/>
+                <a16:creationId xmlns:a16="http://schemas.microsoft.com/office/drawing/2014/main" id="{F8975D86-97AB-493B-80B9-5AC912BF3470}"/>
               </a:ext>
             </a:extLst>
           </p:cNvPr>
@@ -8937,7 +8960,7 @@
           <p:cNvPr id="4" name="page-number-14">
             <a:extLst xmlns:a="http://schemas.openxmlformats.org/drawingml/2006/main">
               <a:ext uri="{FF2B5EF4-FFF2-40B4-BE49-F238E27FC236}">
-                <a16:creationId xmlns:a16="http://schemas.microsoft.com/office/drawing/2014/main" id="{E13EECCE-FE29-4E97-A66A-027F3D991E59}"/>
+                <a16:creationId xmlns:a16="http://schemas.microsoft.com/office/drawing/2014/main" id="{BC4254C4-3B6E-4CD3-A488-6196F0CF0C7B}"/>
               </a:ext>
             </a:extLst>
           </p:cNvPr>
@@ -8995,7 +9018,7 @@
           <p:cNvPr id="5" name="team-header">
             <a:extLst xmlns:a="http://schemas.openxmlformats.org/drawingml/2006/main">
               <a:ext uri="{FF2B5EF4-FFF2-40B4-BE49-F238E27FC236}">
-                <a16:creationId xmlns:a16="http://schemas.microsoft.com/office/drawing/2014/main" id="{4A635FFF-E1C8-4AA6-9DFB-2D4F246E7EFB}"/>
+                <a16:creationId xmlns:a16="http://schemas.microsoft.com/office/drawing/2014/main" id="{D58C5228-1A55-404E-8065-B55A133771D3}"/>
               </a:ext>
             </a:extLst>
           </p:cNvPr>
@@ -9028,7 +9051,7 @@
           <p:cNvPr id="6" name="text">
             <a:extLst xmlns:a="http://schemas.openxmlformats.org/drawingml/2006/main">
               <a:ext uri="{FF2B5EF4-FFF2-40B4-BE49-F238E27FC236}">
-                <a16:creationId xmlns:a16="http://schemas.microsoft.com/office/drawing/2014/main" id="{AE0756B4-9B57-4438-A5E5-1A6BA194DFED}"/>
+                <a16:creationId xmlns:a16="http://schemas.microsoft.com/office/drawing/2014/main" id="{48E1E068-2FE4-48A2-8626-4632AB8EFF66}"/>
               </a:ext>
             </a:extLst>
           </p:cNvPr>
@@ -9086,7 +9109,7 @@
           <p:cNvPr id="7" name="text">
             <a:extLst xmlns:a="http://schemas.openxmlformats.org/drawingml/2006/main">
               <a:ext uri="{FF2B5EF4-FFF2-40B4-BE49-F238E27FC236}">
-                <a16:creationId xmlns:a16="http://schemas.microsoft.com/office/drawing/2014/main" id="{117F7311-85D5-4888-8AE8-A00F6D4CF2F8}"/>
+                <a16:creationId xmlns:a16="http://schemas.microsoft.com/office/drawing/2014/main" id="{7DDACF51-77C8-4883-B7A2-20B92C0A978E}"/>
               </a:ext>
             </a:extLst>
           </p:cNvPr>
@@ -9144,7 +9167,7 @@
           <p:cNvPr id="8" name="text">
             <a:extLst xmlns:a="http://schemas.openxmlformats.org/drawingml/2006/main">
               <a:ext uri="{FF2B5EF4-FFF2-40B4-BE49-F238E27FC236}">
-                <a16:creationId xmlns:a16="http://schemas.microsoft.com/office/drawing/2014/main" id="{54DF03C0-7066-42F3-84F2-4B0AFD9D7D7A}"/>
+                <a16:creationId xmlns:a16="http://schemas.microsoft.com/office/drawing/2014/main" id="{10CADF9E-30A3-47A6-A9E1-B9A49F6C3DD6}"/>
               </a:ext>
             </a:extLst>
           </p:cNvPr>
@@ -9202,7 +9225,7 @@
           <p:cNvPr id="9" name="text">
             <a:extLst xmlns:a="http://schemas.openxmlformats.org/drawingml/2006/main">
               <a:ext uri="{FF2B5EF4-FFF2-40B4-BE49-F238E27FC236}">
-                <a16:creationId xmlns:a16="http://schemas.microsoft.com/office/drawing/2014/main" id="{D0883870-8847-4E73-A7AF-936ED11A5EB3}"/>
+                <a16:creationId xmlns:a16="http://schemas.microsoft.com/office/drawing/2014/main" id="{99BEA15A-23B1-4BEC-BC4F-39375BDA7AC6}"/>
               </a:ext>
             </a:extLst>
           </p:cNvPr>
@@ -9260,7 +9283,7 @@
           <p:cNvPr id="10" name="team-row-0">
             <a:extLst xmlns:a="http://schemas.openxmlformats.org/drawingml/2006/main">
               <a:ext uri="{FF2B5EF4-FFF2-40B4-BE49-F238E27FC236}">
-                <a16:creationId xmlns:a16="http://schemas.microsoft.com/office/drawing/2014/main" id="{78139A51-0EB9-4F34-A45C-1A9EA54437AB}"/>
+                <a16:creationId xmlns:a16="http://schemas.microsoft.com/office/drawing/2014/main" id="{9A98760D-6ACC-49C8-B3AA-FC4F884E69F5}"/>
               </a:ext>
             </a:extLst>
           </p:cNvPr>
@@ -9293,7 +9316,7 @@
           <p:cNvPr id="11" name="text">
             <a:extLst xmlns:a="http://schemas.openxmlformats.org/drawingml/2006/main">
               <a:ext uri="{FF2B5EF4-FFF2-40B4-BE49-F238E27FC236}">
-                <a16:creationId xmlns:a16="http://schemas.microsoft.com/office/drawing/2014/main" id="{16793791-35B6-48B4-B324-39F2DAE389E0}"/>
+                <a16:creationId xmlns:a16="http://schemas.microsoft.com/office/drawing/2014/main" id="{2D9F3EED-7E93-4A11-BFCB-8DD46875AC41}"/>
               </a:ext>
             </a:extLst>
           </p:cNvPr>
@@ -9351,7 +9374,7 @@
           <p:cNvPr id="12" name="text">
             <a:extLst xmlns:a="http://schemas.openxmlformats.org/drawingml/2006/main">
               <a:ext uri="{FF2B5EF4-FFF2-40B4-BE49-F238E27FC236}">
-                <a16:creationId xmlns:a16="http://schemas.microsoft.com/office/drawing/2014/main" id="{1ABD24C1-A410-4AFB-A52E-6A30CB455A8B}"/>
+                <a16:creationId xmlns:a16="http://schemas.microsoft.com/office/drawing/2014/main" id="{1BDB7E54-376A-4FA7-ACDD-1AD4EC9926E1}"/>
               </a:ext>
             </a:extLst>
           </p:cNvPr>
@@ -9409,7 +9432,7 @@
           <p:cNvPr id="13" name="text">
             <a:extLst xmlns:a="http://schemas.openxmlformats.org/drawingml/2006/main">
               <a:ext uri="{FF2B5EF4-FFF2-40B4-BE49-F238E27FC236}">
-                <a16:creationId xmlns:a16="http://schemas.microsoft.com/office/drawing/2014/main" id="{FF8A2D66-2A24-4ECF-9E1E-127EE2B6B039}"/>
+                <a16:creationId xmlns:a16="http://schemas.microsoft.com/office/drawing/2014/main" id="{49ABCBAC-29D5-4229-9A7D-F17148945DD6}"/>
               </a:ext>
             </a:extLst>
           </p:cNvPr>
@@ -9467,7 +9490,7 @@
           <p:cNvPr id="14" name="text">
             <a:extLst xmlns:a="http://schemas.openxmlformats.org/drawingml/2006/main">
               <a:ext uri="{FF2B5EF4-FFF2-40B4-BE49-F238E27FC236}">
-                <a16:creationId xmlns:a16="http://schemas.microsoft.com/office/drawing/2014/main" id="{31C358E0-AAA2-4381-AC0E-11F33B8A900E}"/>
+                <a16:creationId xmlns:a16="http://schemas.microsoft.com/office/drawing/2014/main" id="{0793BAEE-121B-4711-BF97-A54AB9834B82}"/>
               </a:ext>
             </a:extLst>
           </p:cNvPr>
@@ -9525,7 +9548,7 @@
           <p:cNvPr id="15" name="team-row-1">
             <a:extLst xmlns:a="http://schemas.openxmlformats.org/drawingml/2006/main">
               <a:ext uri="{FF2B5EF4-FFF2-40B4-BE49-F238E27FC236}">
-                <a16:creationId xmlns:a16="http://schemas.microsoft.com/office/drawing/2014/main" id="{81E725D2-182F-4BD8-A306-AE0B67D56B02}"/>
+                <a16:creationId xmlns:a16="http://schemas.microsoft.com/office/drawing/2014/main" id="{1CC83E3D-687D-401F-8275-E51740A1789B}"/>
               </a:ext>
             </a:extLst>
           </p:cNvPr>
@@ -9558,7 +9581,7 @@
           <p:cNvPr id="16" name="text">
             <a:extLst xmlns:a="http://schemas.openxmlformats.org/drawingml/2006/main">
               <a:ext uri="{FF2B5EF4-FFF2-40B4-BE49-F238E27FC236}">
-                <a16:creationId xmlns:a16="http://schemas.microsoft.com/office/drawing/2014/main" id="{A52AB309-FDE2-4EFA-B710-A00C7B55DACB}"/>
+                <a16:creationId xmlns:a16="http://schemas.microsoft.com/office/drawing/2014/main" id="{45006F0C-BD1E-4721-8C63-6EE48E53613F}"/>
               </a:ext>
             </a:extLst>
           </p:cNvPr>
@@ -9616,7 +9639,7 @@
           <p:cNvPr id="17" name="text">
             <a:extLst xmlns:a="http://schemas.openxmlformats.org/drawingml/2006/main">
               <a:ext uri="{FF2B5EF4-FFF2-40B4-BE49-F238E27FC236}">
-                <a16:creationId xmlns:a16="http://schemas.microsoft.com/office/drawing/2014/main" id="{9D06C247-A3B2-48AE-A29C-EA267CACBAA5}"/>
+                <a16:creationId xmlns:a16="http://schemas.microsoft.com/office/drawing/2014/main" id="{17D13B2E-1A80-4B86-A432-89CA9E4B5DF0}"/>
               </a:ext>
             </a:extLst>
           </p:cNvPr>
@@ -9674,7 +9697,7 @@
           <p:cNvPr id="18" name="text">
             <a:extLst xmlns:a="http://schemas.openxmlformats.org/drawingml/2006/main">
               <a:ext uri="{FF2B5EF4-FFF2-40B4-BE49-F238E27FC236}">
-                <a16:creationId xmlns:a16="http://schemas.microsoft.com/office/drawing/2014/main" id="{CDA74587-68D4-4A64-8487-A6E96FC7D730}"/>
+                <a16:creationId xmlns:a16="http://schemas.microsoft.com/office/drawing/2014/main" id="{0B854729-D6EC-4D8D-A38B-DE3242B3D07B}"/>
               </a:ext>
             </a:extLst>
           </p:cNvPr>
@@ -9732,7 +9755,7 @@
           <p:cNvPr id="19" name="text">
             <a:extLst xmlns:a="http://schemas.openxmlformats.org/drawingml/2006/main">
               <a:ext uri="{FF2B5EF4-FFF2-40B4-BE49-F238E27FC236}">
-                <a16:creationId xmlns:a16="http://schemas.microsoft.com/office/drawing/2014/main" id="{88073C0D-950A-4409-8A4B-367981D86C7A}"/>
+                <a16:creationId xmlns:a16="http://schemas.microsoft.com/office/drawing/2014/main" id="{C4EDAA2F-6AAE-41F8-97D1-F44A334AEC76}"/>
               </a:ext>
             </a:extLst>
           </p:cNvPr>
@@ -9790,7 +9813,7 @@
           <p:cNvPr id="20" name="team-row-2">
             <a:extLst xmlns:a="http://schemas.openxmlformats.org/drawingml/2006/main">
               <a:ext uri="{FF2B5EF4-FFF2-40B4-BE49-F238E27FC236}">
-                <a16:creationId xmlns:a16="http://schemas.microsoft.com/office/drawing/2014/main" id="{EE5E8726-774E-4FA4-867E-94E5F2A7A556}"/>
+                <a16:creationId xmlns:a16="http://schemas.microsoft.com/office/drawing/2014/main" id="{66E289A2-84A8-4CA4-A5C1-3D9FDF272827}"/>
               </a:ext>
             </a:extLst>
           </p:cNvPr>
@@ -9823,7 +9846,7 @@
           <p:cNvPr id="21" name="text">
             <a:extLst xmlns:a="http://schemas.openxmlformats.org/drawingml/2006/main">
               <a:ext uri="{FF2B5EF4-FFF2-40B4-BE49-F238E27FC236}">
-                <a16:creationId xmlns:a16="http://schemas.microsoft.com/office/drawing/2014/main" id="{3F212866-F289-48C6-9CEF-9C331C77B7AA}"/>
+                <a16:creationId xmlns:a16="http://schemas.microsoft.com/office/drawing/2014/main" id="{26E8DA91-C9AF-4390-A9BB-02E1549D8CFB}"/>
               </a:ext>
             </a:extLst>
           </p:cNvPr>
@@ -9881,7 +9904,7 @@
           <p:cNvPr id="22" name="text">
             <a:extLst xmlns:a="http://schemas.openxmlformats.org/drawingml/2006/main">
               <a:ext uri="{FF2B5EF4-FFF2-40B4-BE49-F238E27FC236}">
-                <a16:creationId xmlns:a16="http://schemas.microsoft.com/office/drawing/2014/main" id="{A6761DBF-3F90-4EFE-937A-E9E4E07D94DD}"/>
+                <a16:creationId xmlns:a16="http://schemas.microsoft.com/office/drawing/2014/main" id="{A4185A33-2EE7-4F9E-B38F-90E094B20110}"/>
               </a:ext>
             </a:extLst>
           </p:cNvPr>
@@ -9939,7 +9962,7 @@
           <p:cNvPr id="23" name="text">
             <a:extLst xmlns:a="http://schemas.openxmlformats.org/drawingml/2006/main">
               <a:ext uri="{FF2B5EF4-FFF2-40B4-BE49-F238E27FC236}">
-                <a16:creationId xmlns:a16="http://schemas.microsoft.com/office/drawing/2014/main" id="{72E6DBCB-A012-4A7C-8A8C-4630F1A1E74D}"/>
+                <a16:creationId xmlns:a16="http://schemas.microsoft.com/office/drawing/2014/main" id="{BECC9A48-10B3-453D-BBBE-87BC078D26F3}"/>
               </a:ext>
             </a:extLst>
           </p:cNvPr>
@@ -9997,7 +10020,7 @@
           <p:cNvPr id="24" name="text">
             <a:extLst xmlns:a="http://schemas.openxmlformats.org/drawingml/2006/main">
               <a:ext uri="{FF2B5EF4-FFF2-40B4-BE49-F238E27FC236}">
-                <a16:creationId xmlns:a16="http://schemas.microsoft.com/office/drawing/2014/main" id="{386A0ABB-95EA-43C8-9ADE-776BAD4D5B07}"/>
+                <a16:creationId xmlns:a16="http://schemas.microsoft.com/office/drawing/2014/main" id="{6A2AFFBE-FA7A-405B-A880-BBC204AA8D48}"/>
               </a:ext>
             </a:extLst>
           </p:cNvPr>
@@ -10055,7 +10078,7 @@
           <p:cNvPr id="25" name="team-row-3">
             <a:extLst xmlns:a="http://schemas.openxmlformats.org/drawingml/2006/main">
               <a:ext uri="{FF2B5EF4-FFF2-40B4-BE49-F238E27FC236}">
-                <a16:creationId xmlns:a16="http://schemas.microsoft.com/office/drawing/2014/main" id="{428B3028-5916-4B4C-B2AA-D77A06951B37}"/>
+                <a16:creationId xmlns:a16="http://schemas.microsoft.com/office/drawing/2014/main" id="{2CB5B75F-6260-4CCE-B53C-D2783E243FF4}"/>
               </a:ext>
             </a:extLst>
           </p:cNvPr>
@@ -10088,7 +10111,7 @@
           <p:cNvPr id="26" name="text">
             <a:extLst xmlns:a="http://schemas.openxmlformats.org/drawingml/2006/main">
               <a:ext uri="{FF2B5EF4-FFF2-40B4-BE49-F238E27FC236}">
-                <a16:creationId xmlns:a16="http://schemas.microsoft.com/office/drawing/2014/main" id="{CA0E39B4-F167-4102-9CCC-A72D7609C5EB}"/>
+                <a16:creationId xmlns:a16="http://schemas.microsoft.com/office/drawing/2014/main" id="{9BB044DF-5625-435D-80A6-8AB449306939}"/>
               </a:ext>
             </a:extLst>
           </p:cNvPr>
@@ -10146,7 +10169,7 @@
           <p:cNvPr id="27" name="text">
             <a:extLst xmlns:a="http://schemas.openxmlformats.org/drawingml/2006/main">
               <a:ext uri="{FF2B5EF4-FFF2-40B4-BE49-F238E27FC236}">
-                <a16:creationId xmlns:a16="http://schemas.microsoft.com/office/drawing/2014/main" id="{F86D17EB-5711-4CFC-A787-4C755B97793E}"/>
+                <a16:creationId xmlns:a16="http://schemas.microsoft.com/office/drawing/2014/main" id="{B2E782EB-BADE-426C-A9AA-58342C9630B9}"/>
               </a:ext>
             </a:extLst>
           </p:cNvPr>
@@ -10204,7 +10227,7 @@
           <p:cNvPr id="28" name="text">
             <a:extLst xmlns:a="http://schemas.openxmlformats.org/drawingml/2006/main">
               <a:ext uri="{FF2B5EF4-FFF2-40B4-BE49-F238E27FC236}">
-                <a16:creationId xmlns:a16="http://schemas.microsoft.com/office/drawing/2014/main" id="{5352A7F1-0E79-4AFA-BCBF-D402D84C05B6}"/>
+                <a16:creationId xmlns:a16="http://schemas.microsoft.com/office/drawing/2014/main" id="{B7E84BE4-29F1-4204-A069-52CF11FC8B2D}"/>
               </a:ext>
             </a:extLst>
           </p:cNvPr>
@@ -10262,7 +10285,7 @@
           <p:cNvPr id="29" name="text">
             <a:extLst xmlns:a="http://schemas.openxmlformats.org/drawingml/2006/main">
               <a:ext uri="{FF2B5EF4-FFF2-40B4-BE49-F238E27FC236}">
-                <a16:creationId xmlns:a16="http://schemas.microsoft.com/office/drawing/2014/main" id="{4BA870F9-B296-4296-AC7C-836115BB2C40}"/>
+                <a16:creationId xmlns:a16="http://schemas.microsoft.com/office/drawing/2014/main" id="{D091F92D-4E74-420F-85C6-A5CB5D9CB60B}"/>
               </a:ext>
             </a:extLst>
           </p:cNvPr>
@@ -10320,7 +10343,7 @@
           <p:cNvPr id="30" name="team-row-4">
             <a:extLst xmlns:a="http://schemas.openxmlformats.org/drawingml/2006/main">
               <a:ext uri="{FF2B5EF4-FFF2-40B4-BE49-F238E27FC236}">
-                <a16:creationId xmlns:a16="http://schemas.microsoft.com/office/drawing/2014/main" id="{E8FEFCCA-9EF2-4EDE-A7E4-8537E9B923D2}"/>
+                <a16:creationId xmlns:a16="http://schemas.microsoft.com/office/drawing/2014/main" id="{4A5B02D5-CABD-48F6-B6F6-ED0A411363A7}"/>
               </a:ext>
             </a:extLst>
           </p:cNvPr>
@@ -10353,7 +10376,7 @@
           <p:cNvPr id="31" name="text">
             <a:extLst xmlns:a="http://schemas.openxmlformats.org/drawingml/2006/main">
               <a:ext uri="{FF2B5EF4-FFF2-40B4-BE49-F238E27FC236}">
-                <a16:creationId xmlns:a16="http://schemas.microsoft.com/office/drawing/2014/main" id="{B7C64988-D96E-4C76-8B56-C3D68E75F705}"/>
+                <a16:creationId xmlns:a16="http://schemas.microsoft.com/office/drawing/2014/main" id="{E93D19B3-3507-4080-AB65-FFB99DC6B23F}"/>
               </a:ext>
             </a:extLst>
           </p:cNvPr>
@@ -10411,7 +10434,7 @@
           <p:cNvPr id="32" name="text">
             <a:extLst xmlns:a="http://schemas.openxmlformats.org/drawingml/2006/main">
               <a:ext uri="{FF2B5EF4-FFF2-40B4-BE49-F238E27FC236}">
-                <a16:creationId xmlns:a16="http://schemas.microsoft.com/office/drawing/2014/main" id="{F311F2CD-3271-49CB-BF50-3952261C90D1}"/>
+                <a16:creationId xmlns:a16="http://schemas.microsoft.com/office/drawing/2014/main" id="{2629242F-FED3-476B-9AA4-9BC090153B36}"/>
               </a:ext>
             </a:extLst>
           </p:cNvPr>
@@ -10469,7 +10492,7 @@
           <p:cNvPr id="33" name="text">
             <a:extLst xmlns:a="http://schemas.openxmlformats.org/drawingml/2006/main">
               <a:ext uri="{FF2B5EF4-FFF2-40B4-BE49-F238E27FC236}">
-                <a16:creationId xmlns:a16="http://schemas.microsoft.com/office/drawing/2014/main" id="{526620DE-BC80-4241-BA77-F09D3FCE1A7E}"/>
+                <a16:creationId xmlns:a16="http://schemas.microsoft.com/office/drawing/2014/main" id="{E0C7151E-2A59-42C7-81EB-F1B34FC36F37}"/>
               </a:ext>
             </a:extLst>
           </p:cNvPr>
@@ -10527,7 +10550,7 @@
           <p:cNvPr id="34" name="text">
             <a:extLst xmlns:a="http://schemas.openxmlformats.org/drawingml/2006/main">
               <a:ext uri="{FF2B5EF4-FFF2-40B4-BE49-F238E27FC236}">
-                <a16:creationId xmlns:a16="http://schemas.microsoft.com/office/drawing/2014/main" id="{8CD8DED3-8B32-40E8-BEF4-CAB7DD1910A8}"/>
+                <a16:creationId xmlns:a16="http://schemas.microsoft.com/office/drawing/2014/main" id="{006D7326-011B-4E32-9874-01BBCBC4384C}"/>
               </a:ext>
             </a:extLst>
           </p:cNvPr>
@@ -10585,7 +10608,7 @@
           <p:cNvPr id="35" name="team-row-5">
             <a:extLst xmlns:a="http://schemas.openxmlformats.org/drawingml/2006/main">
               <a:ext uri="{FF2B5EF4-FFF2-40B4-BE49-F238E27FC236}">
-                <a16:creationId xmlns:a16="http://schemas.microsoft.com/office/drawing/2014/main" id="{18FE5F50-3F9B-428C-B69C-0D718869E516}"/>
+                <a16:creationId xmlns:a16="http://schemas.microsoft.com/office/drawing/2014/main" id="{6F2AEB98-D347-411E-A97F-C77A656810EA}"/>
               </a:ext>
             </a:extLst>
           </p:cNvPr>
@@ -10618,7 +10641,7 @@
           <p:cNvPr id="36" name="text">
             <a:extLst xmlns:a="http://schemas.openxmlformats.org/drawingml/2006/main">
               <a:ext uri="{FF2B5EF4-FFF2-40B4-BE49-F238E27FC236}">
-                <a16:creationId xmlns:a16="http://schemas.microsoft.com/office/drawing/2014/main" id="{0D4DA361-4428-4462-8BDD-48A69EB97DEC}"/>
+                <a16:creationId xmlns:a16="http://schemas.microsoft.com/office/drawing/2014/main" id="{FC72DDBA-76E6-4A19-9D81-FC119F0DE688}"/>
               </a:ext>
             </a:extLst>
           </p:cNvPr>
@@ -10676,7 +10699,7 @@
           <p:cNvPr id="37" name="text">
             <a:extLst xmlns:a="http://schemas.openxmlformats.org/drawingml/2006/main">
               <a:ext uri="{FF2B5EF4-FFF2-40B4-BE49-F238E27FC236}">
-                <a16:creationId xmlns:a16="http://schemas.microsoft.com/office/drawing/2014/main" id="{5FD2D8F9-3199-4F4E-9835-7ADEB461AF7D}"/>
+                <a16:creationId xmlns:a16="http://schemas.microsoft.com/office/drawing/2014/main" id="{1C2FF6AD-AA16-44E8-AA0C-8A11022E6782}"/>
               </a:ext>
             </a:extLst>
           </p:cNvPr>
@@ -10734,7 +10757,7 @@
           <p:cNvPr id="38" name="text">
             <a:extLst xmlns:a="http://schemas.openxmlformats.org/drawingml/2006/main">
               <a:ext uri="{FF2B5EF4-FFF2-40B4-BE49-F238E27FC236}">
-                <a16:creationId xmlns:a16="http://schemas.microsoft.com/office/drawing/2014/main" id="{379BA4E8-724B-4245-BC47-26255DA2E82A}"/>
+                <a16:creationId xmlns:a16="http://schemas.microsoft.com/office/drawing/2014/main" id="{ACCFAD34-ECBD-46FE-87C4-97B548A69958}"/>
               </a:ext>
             </a:extLst>
           </p:cNvPr>
@@ -10792,7 +10815,7 @@
           <p:cNvPr id="39" name="text">
             <a:extLst xmlns:a="http://schemas.openxmlformats.org/drawingml/2006/main">
               <a:ext uri="{FF2B5EF4-FFF2-40B4-BE49-F238E27FC236}">
-                <a16:creationId xmlns:a16="http://schemas.microsoft.com/office/drawing/2014/main" id="{9682E425-1012-49F8-BAB3-F8D49A4C9BEE}"/>
+                <a16:creationId xmlns:a16="http://schemas.microsoft.com/office/drawing/2014/main" id="{B8DE3F4E-FB72-47F3-91A8-27ADDCCDCC43}"/>
               </a:ext>
             </a:extLst>
           </p:cNvPr>
@@ -10850,7 +10873,7 @@
           <p:cNvPr id="40" name="team-warning">
             <a:extLst xmlns:a="http://schemas.openxmlformats.org/drawingml/2006/main">
               <a:ext uri="{FF2B5EF4-FFF2-40B4-BE49-F238E27FC236}">
-                <a16:creationId xmlns:a16="http://schemas.microsoft.com/office/drawing/2014/main" id="{AA997E37-C77E-4FA9-8108-6732BE27EF15}"/>
+                <a16:creationId xmlns:a16="http://schemas.microsoft.com/office/drawing/2014/main" id="{792706A3-BB36-42E8-B4AB-74EAE3B1A227}"/>
               </a:ext>
             </a:extLst>
           </p:cNvPr>
@@ -10883,7 +10906,7 @@
           <p:cNvPr id="41" name="text">
             <a:extLst xmlns:a="http://schemas.openxmlformats.org/drawingml/2006/main">
               <a:ext uri="{FF2B5EF4-FFF2-40B4-BE49-F238E27FC236}">
-                <a16:creationId xmlns:a16="http://schemas.microsoft.com/office/drawing/2014/main" id="{2CF12FDA-DF38-4A4E-AB47-A55B3CFB99F3}"/>
+                <a16:creationId xmlns:a16="http://schemas.microsoft.com/office/drawing/2014/main" id="{831BFD42-BA60-43DC-B250-4FC4BBBE6BDA}"/>
               </a:ext>
             </a:extLst>
           </p:cNvPr>
@@ -10939,7 +10962,7 @@
     </p:spTree>
     <p:extLst>
       <p:ext uri="{BB962C8B-B14F-4D97-AF65-F5344CB8AC3E}">
-        <p14:creationId xmlns:p14="http://schemas.microsoft.com/office/powerpoint/2010/main" val="595090749"/>
+        <p14:creationId xmlns:p14="http://schemas.microsoft.com/office/powerpoint/2010/main" val="782197238"/>
       </p:ext>
     </p:extLst>
   </p:cSld>
@@ -10970,7 +10993,7 @@
           <p:cNvPr id="1" name="text">
             <a:extLst xmlns:a="http://schemas.openxmlformats.org/drawingml/2006/main">
               <a:ext uri="{FF2B5EF4-FFF2-40B4-BE49-F238E27FC236}">
-                <a16:creationId xmlns:a16="http://schemas.microsoft.com/office/drawing/2014/main" id="{0434949F-ADA1-4960-934C-40E101B475CE}"/>
+                <a16:creationId xmlns:a16="http://schemas.microsoft.com/office/drawing/2014/main" id="{A2B53315-E94F-468E-A23B-083303A7C1DA}"/>
               </a:ext>
             </a:extLst>
           </p:cNvPr>
@@ -11028,7 +11051,7 @@
           <p:cNvPr id="2" name="text">
             <a:extLst xmlns:a="http://schemas.openxmlformats.org/drawingml/2006/main">
               <a:ext uri="{FF2B5EF4-FFF2-40B4-BE49-F238E27FC236}">
-                <a16:creationId xmlns:a16="http://schemas.microsoft.com/office/drawing/2014/main" id="{4645918F-A53E-49F2-9B8B-8FAB67A78B0E}"/>
+                <a16:creationId xmlns:a16="http://schemas.microsoft.com/office/drawing/2014/main" id="{F08A1044-00F8-41B6-BDA5-643903AE27B8}"/>
               </a:ext>
             </a:extLst>
           </p:cNvPr>
@@ -11086,7 +11109,7 @@
           <p:cNvPr id="3" name="text">
             <a:extLst xmlns:a="http://schemas.openxmlformats.org/drawingml/2006/main">
               <a:ext uri="{FF2B5EF4-FFF2-40B4-BE49-F238E27FC236}">
-                <a16:creationId xmlns:a16="http://schemas.microsoft.com/office/drawing/2014/main" id="{F17DF231-A856-4776-B963-80CBB4EB6BDF}"/>
+                <a16:creationId xmlns:a16="http://schemas.microsoft.com/office/drawing/2014/main" id="{698641D0-5DCC-49A5-ACA2-54E13322E178}"/>
               </a:ext>
             </a:extLst>
           </p:cNvPr>
@@ -11144,7 +11167,7 @@
           <p:cNvPr id="4" name="text">
             <a:extLst xmlns:a="http://schemas.openxmlformats.org/drawingml/2006/main">
               <a:ext uri="{FF2B5EF4-FFF2-40B4-BE49-F238E27FC236}">
-                <a16:creationId xmlns:a16="http://schemas.microsoft.com/office/drawing/2014/main" id="{97668BB5-1830-458D-9FDF-5CE365529CA1}"/>
+                <a16:creationId xmlns:a16="http://schemas.microsoft.com/office/drawing/2014/main" id="{8AD72801-8BC2-4700-9EA6-C3F6B1630A6A}"/>
               </a:ext>
             </a:extLst>
           </p:cNvPr>
@@ -11202,7 +11225,7 @@
           <p:cNvPr id="5" name="close-accent">
             <a:extLst xmlns:a="http://schemas.openxmlformats.org/drawingml/2006/main">
               <a:ext uri="{FF2B5EF4-FFF2-40B4-BE49-F238E27FC236}">
-                <a16:creationId xmlns:a16="http://schemas.microsoft.com/office/drawing/2014/main" id="{8EF92DDD-82AE-425A-80A7-6DE4A1A7F8BF}"/>
+                <a16:creationId xmlns:a16="http://schemas.microsoft.com/office/drawing/2014/main" id="{C9E92D0B-762E-457A-BC36-B033F89961B9}"/>
               </a:ext>
             </a:extLst>
           </p:cNvPr>
@@ -11233,7 +11256,7 @@
           <p:cNvPr id="6" name="text">
             <a:extLst xmlns:a="http://schemas.openxmlformats.org/drawingml/2006/main">
               <a:ext uri="{FF2B5EF4-FFF2-40B4-BE49-F238E27FC236}">
-                <a16:creationId xmlns:a16="http://schemas.microsoft.com/office/drawing/2014/main" id="{902E3266-6C89-4C15-BD58-6E37217A2829}"/>
+                <a16:creationId xmlns:a16="http://schemas.microsoft.com/office/drawing/2014/main" id="{ABC5B4AB-DF81-4879-AB1F-B2271A66AC56}"/>
               </a:ext>
             </a:extLst>
           </p:cNvPr>
@@ -11291,7 +11314,7 @@
           <p:cNvPr id="7" name="pill-Spring Cloud">
             <a:extLst xmlns:a="http://schemas.openxmlformats.org/drawingml/2006/main">
               <a:ext uri="{FF2B5EF4-FFF2-40B4-BE49-F238E27FC236}">
-                <a16:creationId xmlns:a16="http://schemas.microsoft.com/office/drawing/2014/main" id="{8DA399DB-1618-43BA-9DA6-01E427DD0C62}"/>
+                <a16:creationId xmlns:a16="http://schemas.microsoft.com/office/drawing/2014/main" id="{F4206768-F9DF-403A-AFF2-ABAC1FF0C3E6}"/>
               </a:ext>
             </a:extLst>
           </p:cNvPr>
@@ -11324,7 +11347,7 @@
           <p:cNvPr id="8" name="pill-text-Spring Cloud">
             <a:extLst xmlns:a="http://schemas.openxmlformats.org/drawingml/2006/main">
               <a:ext uri="{FF2B5EF4-FFF2-40B4-BE49-F238E27FC236}">
-                <a16:creationId xmlns:a16="http://schemas.microsoft.com/office/drawing/2014/main" id="{B2AB62D0-783D-4106-A7A2-6D3A5B1C856B}"/>
+                <a16:creationId xmlns:a16="http://schemas.microsoft.com/office/drawing/2014/main" id="{8EA4528D-8B8C-4114-BC2A-B2DCDE9B9AD1}"/>
               </a:ext>
             </a:extLst>
           </p:cNvPr>
@@ -11382,7 +11405,7 @@
           <p:cNvPr id="9" name="pill-Vue 3">
             <a:extLst xmlns:a="http://schemas.openxmlformats.org/drawingml/2006/main">
               <a:ext uri="{FF2B5EF4-FFF2-40B4-BE49-F238E27FC236}">
-                <a16:creationId xmlns:a16="http://schemas.microsoft.com/office/drawing/2014/main" id="{7757B13B-BC66-41CD-9243-3FE2BE24A51A}"/>
+                <a16:creationId xmlns:a16="http://schemas.microsoft.com/office/drawing/2014/main" id="{C860A64D-4981-4C2E-A612-D96BABABE131}"/>
               </a:ext>
             </a:extLst>
           </p:cNvPr>
@@ -11415,7 +11438,7 @@
           <p:cNvPr id="10" name="pill-text-Vue 3">
             <a:extLst xmlns:a="http://schemas.openxmlformats.org/drawingml/2006/main">
               <a:ext uri="{FF2B5EF4-FFF2-40B4-BE49-F238E27FC236}">
-                <a16:creationId xmlns:a16="http://schemas.microsoft.com/office/drawing/2014/main" id="{19EDA701-5788-4B0F-867B-695E4813D62B}"/>
+                <a16:creationId xmlns:a16="http://schemas.microsoft.com/office/drawing/2014/main" id="{2DEA6CBC-CFF1-4B89-9E99-377E3C5EEF3F}"/>
               </a:ext>
             </a:extLst>
           </p:cNvPr>
@@ -11473,7 +11496,7 @@
           <p:cNvPr id="11" name="pill-Redis">
             <a:extLst xmlns:a="http://schemas.openxmlformats.org/drawingml/2006/main">
               <a:ext uri="{FF2B5EF4-FFF2-40B4-BE49-F238E27FC236}">
-                <a16:creationId xmlns:a16="http://schemas.microsoft.com/office/drawing/2014/main" id="{667826BA-D521-4CA6-9CB0-AEABEE3D20F4}"/>
+                <a16:creationId xmlns:a16="http://schemas.microsoft.com/office/drawing/2014/main" id="{E8E34A9B-8F1B-48F1-B35F-20C22ABB50BE}"/>
               </a:ext>
             </a:extLst>
           </p:cNvPr>
@@ -11506,7 +11529,7 @@
           <p:cNvPr id="12" name="pill-text-Redis">
             <a:extLst xmlns:a="http://schemas.openxmlformats.org/drawingml/2006/main">
               <a:ext uri="{FF2B5EF4-FFF2-40B4-BE49-F238E27FC236}">
-                <a16:creationId xmlns:a16="http://schemas.microsoft.com/office/drawing/2014/main" id="{1872B9F4-8B5B-4444-B648-26707962939A}"/>
+                <a16:creationId xmlns:a16="http://schemas.microsoft.com/office/drawing/2014/main" id="{BF761B09-1E86-42BE-9240-A779BE20CC5B}"/>
               </a:ext>
             </a:extLst>
           </p:cNvPr>
@@ -11564,7 +11587,7 @@
           <p:cNvPr id="13" name="pill-RabbitMQ">
             <a:extLst xmlns:a="http://schemas.openxmlformats.org/drawingml/2006/main">
               <a:ext uri="{FF2B5EF4-FFF2-40B4-BE49-F238E27FC236}">
-                <a16:creationId xmlns:a16="http://schemas.microsoft.com/office/drawing/2014/main" id="{CCD5B01C-C076-4A85-A505-BB8929FBF79E}"/>
+                <a16:creationId xmlns:a16="http://schemas.microsoft.com/office/drawing/2014/main" id="{1228BD42-67B6-4087-A23E-F9B6D15FACA1}"/>
               </a:ext>
             </a:extLst>
           </p:cNvPr>
@@ -11597,7 +11620,7 @@
           <p:cNvPr id="14" name="pill-text-RabbitMQ">
             <a:extLst xmlns:a="http://schemas.openxmlformats.org/drawingml/2006/main">
               <a:ext uri="{FF2B5EF4-FFF2-40B4-BE49-F238E27FC236}">
-                <a16:creationId xmlns:a16="http://schemas.microsoft.com/office/drawing/2014/main" id="{34509DE7-8CEE-4985-BD5C-F4077F1522D1}"/>
+                <a16:creationId xmlns:a16="http://schemas.microsoft.com/office/drawing/2014/main" id="{C8B96B80-8A7A-4B2D-834A-D1F6D7D2E067}"/>
               </a:ext>
             </a:extLst>
           </p:cNvPr>
@@ -11653,7 +11676,7 @@
     </p:spTree>
     <p:extLst>
       <p:ext uri="{BB962C8B-B14F-4D97-AF65-F5344CB8AC3E}">
-        <p14:creationId xmlns:p14="http://schemas.microsoft.com/office/powerpoint/2010/main" val="24106289"/>
+        <p14:creationId xmlns:p14="http://schemas.microsoft.com/office/powerpoint/2010/main" val="1300933389"/>
       </p:ext>
     </p:extLst>
   </p:cSld>
@@ -11684,7 +11707,7 @@
           <p:cNvPr id="1" name="eyebrow-2">
             <a:extLst xmlns:a="http://schemas.openxmlformats.org/drawingml/2006/main">
               <a:ext uri="{FF2B5EF4-FFF2-40B4-BE49-F238E27FC236}">
-                <a16:creationId xmlns:a16="http://schemas.microsoft.com/office/drawing/2014/main" id="{4EB05F30-7D4C-4D70-82C9-BC1BED53EF7B}"/>
+                <a16:creationId xmlns:a16="http://schemas.microsoft.com/office/drawing/2014/main" id="{846F0E35-57D1-4E72-8622-B7955E17F5B1}"/>
               </a:ext>
             </a:extLst>
           </p:cNvPr>
@@ -11742,7 +11765,7 @@
           <p:cNvPr id="2" name="slide-title-2">
             <a:extLst xmlns:a="http://schemas.openxmlformats.org/drawingml/2006/main">
               <a:ext uri="{FF2B5EF4-FFF2-40B4-BE49-F238E27FC236}">
-                <a16:creationId xmlns:a16="http://schemas.microsoft.com/office/drawing/2014/main" id="{EA624D6E-D3BC-4597-8593-0AC5D5D46D59}"/>
+                <a16:creationId xmlns:a16="http://schemas.microsoft.com/office/drawing/2014/main" id="{C54B634A-7B06-4C67-B3E5-9CEECE1BB118}"/>
               </a:ext>
             </a:extLst>
           </p:cNvPr>
@@ -11800,7 +11823,7 @@
           <p:cNvPr id="3" name="title-rule-2">
             <a:extLst xmlns:a="http://schemas.openxmlformats.org/drawingml/2006/main">
               <a:ext uri="{FF2B5EF4-FFF2-40B4-BE49-F238E27FC236}">
-                <a16:creationId xmlns:a16="http://schemas.microsoft.com/office/drawing/2014/main" id="{08B40CFC-C4D5-4F3A-A04D-DDC304B727BB}"/>
+                <a16:creationId xmlns:a16="http://schemas.microsoft.com/office/drawing/2014/main" id="{459401F1-E680-4470-AA12-228553A36BC5}"/>
               </a:ext>
             </a:extLst>
           </p:cNvPr>
@@ -11831,7 +11854,7 @@
           <p:cNvPr id="4" name="page-number-2">
             <a:extLst xmlns:a="http://schemas.openxmlformats.org/drawingml/2006/main">
               <a:ext uri="{FF2B5EF4-FFF2-40B4-BE49-F238E27FC236}">
-                <a16:creationId xmlns:a16="http://schemas.microsoft.com/office/drawing/2014/main" id="{FD4265F7-B5F3-4739-AD33-83C9A0EFC712}"/>
+                <a16:creationId xmlns:a16="http://schemas.microsoft.com/office/drawing/2014/main" id="{BA178189-00D4-4287-9495-9C5613A53D27}"/>
               </a:ext>
             </a:extLst>
           </p:cNvPr>
@@ -11889,7 +11912,7 @@
           <p:cNvPr id="5" name="text">
             <a:extLst xmlns:a="http://schemas.openxmlformats.org/drawingml/2006/main">
               <a:ext uri="{FF2B5EF4-FFF2-40B4-BE49-F238E27FC236}">
-                <a16:creationId xmlns:a16="http://schemas.microsoft.com/office/drawing/2014/main" id="{74782881-72B3-4971-85F0-A32D91FA2626}"/>
+                <a16:creationId xmlns:a16="http://schemas.microsoft.com/office/drawing/2014/main" id="{699C02B2-43AB-427B-9694-8770351B31F9}"/>
               </a:ext>
             </a:extLst>
           </p:cNvPr>
@@ -11947,7 +11970,7 @@
           <p:cNvPr id="6" name="text">
             <a:extLst xmlns:a="http://schemas.openxmlformats.org/drawingml/2006/main">
               <a:ext uri="{FF2B5EF4-FFF2-40B4-BE49-F238E27FC236}">
-                <a16:creationId xmlns:a16="http://schemas.microsoft.com/office/drawing/2014/main" id="{A92614D8-EA55-4B87-8410-7C962F08E748}"/>
+                <a16:creationId xmlns:a16="http://schemas.microsoft.com/office/drawing/2014/main" id="{0FE42B4C-71EF-414F-BEAE-CBA5D4174B61}"/>
               </a:ext>
             </a:extLst>
           </p:cNvPr>
@@ -12005,7 +12028,7 @@
           <p:cNvPr id="7" name="pill-可演示">
             <a:extLst xmlns:a="http://schemas.openxmlformats.org/drawingml/2006/main">
               <a:ext uri="{FF2B5EF4-FFF2-40B4-BE49-F238E27FC236}">
-                <a16:creationId xmlns:a16="http://schemas.microsoft.com/office/drawing/2014/main" id="{314603E9-1E49-48B0-807A-FE9A37B26BB5}"/>
+                <a16:creationId xmlns:a16="http://schemas.microsoft.com/office/drawing/2014/main" id="{2A96B83D-D524-4207-8754-0E5C0AB39935}"/>
               </a:ext>
             </a:extLst>
           </p:cNvPr>
@@ -12038,7 +12061,7 @@
           <p:cNvPr id="8" name="pill-text-可演示">
             <a:extLst xmlns:a="http://schemas.openxmlformats.org/drawingml/2006/main">
               <a:ext uri="{FF2B5EF4-FFF2-40B4-BE49-F238E27FC236}">
-                <a16:creationId xmlns:a16="http://schemas.microsoft.com/office/drawing/2014/main" id="{5E82FDA7-2CC9-4C29-ADB3-E9538F314CB7}"/>
+                <a16:creationId xmlns:a16="http://schemas.microsoft.com/office/drawing/2014/main" id="{9D47636B-85E6-46AE-A257-A07785A104F1}"/>
               </a:ext>
             </a:extLst>
           </p:cNvPr>
@@ -12096,7 +12119,7 @@
           <p:cNvPr id="9" name="pill-可解释">
             <a:extLst xmlns:a="http://schemas.openxmlformats.org/drawingml/2006/main">
               <a:ext uri="{FF2B5EF4-FFF2-40B4-BE49-F238E27FC236}">
-                <a16:creationId xmlns:a16="http://schemas.microsoft.com/office/drawing/2014/main" id="{734F9203-90F5-4BEF-BC8B-6D009375AD71}"/>
+                <a16:creationId xmlns:a16="http://schemas.microsoft.com/office/drawing/2014/main" id="{DA2A9EB5-D739-42DE-B6BF-275B5B9FA8EA}"/>
               </a:ext>
             </a:extLst>
           </p:cNvPr>
@@ -12129,7 +12152,7 @@
           <p:cNvPr id="10" name="pill-text-可解释">
             <a:extLst xmlns:a="http://schemas.openxmlformats.org/drawingml/2006/main">
               <a:ext uri="{FF2B5EF4-FFF2-40B4-BE49-F238E27FC236}">
-                <a16:creationId xmlns:a16="http://schemas.microsoft.com/office/drawing/2014/main" id="{FAD787A1-3C75-4B4A-A8F4-D368C635C3AE}"/>
+                <a16:creationId xmlns:a16="http://schemas.microsoft.com/office/drawing/2014/main" id="{129A7249-C96B-4975-932B-49E196CDA8DD}"/>
               </a:ext>
             </a:extLst>
           </p:cNvPr>
@@ -12187,7 +12210,7 @@
           <p:cNvPr id="11" name="pill-可分工">
             <a:extLst xmlns:a="http://schemas.openxmlformats.org/drawingml/2006/main">
               <a:ext uri="{FF2B5EF4-FFF2-40B4-BE49-F238E27FC236}">
-                <a16:creationId xmlns:a16="http://schemas.microsoft.com/office/drawing/2014/main" id="{054C5FFC-6765-4555-927F-BDAE854692E5}"/>
+                <a16:creationId xmlns:a16="http://schemas.microsoft.com/office/drawing/2014/main" id="{EED4F131-E4B1-453E-9252-A974BDEAE41D}"/>
               </a:ext>
             </a:extLst>
           </p:cNvPr>
@@ -12220,7 +12243,7 @@
           <p:cNvPr id="12" name="pill-text-可分工">
             <a:extLst xmlns:a="http://schemas.openxmlformats.org/drawingml/2006/main">
               <a:ext uri="{FF2B5EF4-FFF2-40B4-BE49-F238E27FC236}">
-                <a16:creationId xmlns:a16="http://schemas.microsoft.com/office/drawing/2014/main" id="{F1E9AD66-B9BC-4E50-9545-75641F96F6CF}"/>
+                <a16:creationId xmlns:a16="http://schemas.microsoft.com/office/drawing/2014/main" id="{154FBBB6-EF22-4014-961C-A916FCD0F11A}"/>
               </a:ext>
             </a:extLst>
           </p:cNvPr>
@@ -12278,7 +12301,7 @@
           <p:cNvPr id="13" name="pain-0">
             <a:extLst xmlns:a="http://schemas.openxmlformats.org/drawingml/2006/main">
               <a:ext uri="{FF2B5EF4-FFF2-40B4-BE49-F238E27FC236}">
-                <a16:creationId xmlns:a16="http://schemas.microsoft.com/office/drawing/2014/main" id="{6113BFDA-AC9D-42BF-B8E0-08979DF2CA83}"/>
+                <a16:creationId xmlns:a16="http://schemas.microsoft.com/office/drawing/2014/main" id="{22807BA3-27FA-4ABB-B4C8-98FDF00643FB}"/>
               </a:ext>
             </a:extLst>
           </p:cNvPr>
@@ -12313,7 +12336,7 @@
           <p:cNvPr id="14" name="text">
             <a:extLst xmlns:a="http://schemas.openxmlformats.org/drawingml/2006/main">
               <a:ext uri="{FF2B5EF4-FFF2-40B4-BE49-F238E27FC236}">
-                <a16:creationId xmlns:a16="http://schemas.microsoft.com/office/drawing/2014/main" id="{3E77318F-28C1-4F22-AECB-01AD92321443}"/>
+                <a16:creationId xmlns:a16="http://schemas.microsoft.com/office/drawing/2014/main" id="{41F5DCEA-DE2E-4ADD-BF24-169532047E6E}"/>
               </a:ext>
             </a:extLst>
           </p:cNvPr>
@@ -12371,7 +12394,7 @@
           <p:cNvPr id="15" name="text">
             <a:extLst xmlns:a="http://schemas.openxmlformats.org/drawingml/2006/main">
               <a:ext uri="{FF2B5EF4-FFF2-40B4-BE49-F238E27FC236}">
-                <a16:creationId xmlns:a16="http://schemas.microsoft.com/office/drawing/2014/main" id="{BEA5EE93-62CA-4263-ADAF-561BB98BDB7E}"/>
+                <a16:creationId xmlns:a16="http://schemas.microsoft.com/office/drawing/2014/main" id="{AF44FD31-44E4-4DD7-AF83-BAA3F8112A5B}"/>
               </a:ext>
             </a:extLst>
           </p:cNvPr>
@@ -12429,7 +12452,7 @@
           <p:cNvPr id="16" name="text">
             <a:extLst xmlns:a="http://schemas.openxmlformats.org/drawingml/2006/main">
               <a:ext uri="{FF2B5EF4-FFF2-40B4-BE49-F238E27FC236}">
-                <a16:creationId xmlns:a16="http://schemas.microsoft.com/office/drawing/2014/main" id="{42040397-7717-4221-924A-C517D7AAF8DD}"/>
+                <a16:creationId xmlns:a16="http://schemas.microsoft.com/office/drawing/2014/main" id="{92416A2D-DD81-47E7-98C2-8BD4D63FB1A1}"/>
               </a:ext>
             </a:extLst>
           </p:cNvPr>
@@ -12487,7 +12510,7 @@
           <p:cNvPr id="17" name="pain-1">
             <a:extLst xmlns:a="http://schemas.openxmlformats.org/drawingml/2006/main">
               <a:ext uri="{FF2B5EF4-FFF2-40B4-BE49-F238E27FC236}">
-                <a16:creationId xmlns:a16="http://schemas.microsoft.com/office/drawing/2014/main" id="{6BEF74CC-073F-4BD8-B7D2-D25E8FA5B569}"/>
+                <a16:creationId xmlns:a16="http://schemas.microsoft.com/office/drawing/2014/main" id="{C0F2939D-06FD-4FF6-80BD-2EC09DB210F7}"/>
               </a:ext>
             </a:extLst>
           </p:cNvPr>
@@ -12522,7 +12545,7 @@
           <p:cNvPr id="18" name="text">
             <a:extLst xmlns:a="http://schemas.openxmlformats.org/drawingml/2006/main">
               <a:ext uri="{FF2B5EF4-FFF2-40B4-BE49-F238E27FC236}">
-                <a16:creationId xmlns:a16="http://schemas.microsoft.com/office/drawing/2014/main" id="{55C0FEFE-B1EB-4B20-BA46-0E3E1A3A1C79}"/>
+                <a16:creationId xmlns:a16="http://schemas.microsoft.com/office/drawing/2014/main" id="{BF3AC93F-9AC4-4CCF-A36F-13868C4C7EF3}"/>
               </a:ext>
             </a:extLst>
           </p:cNvPr>
@@ -12580,7 +12603,7 @@
           <p:cNvPr id="19" name="text">
             <a:extLst xmlns:a="http://schemas.openxmlformats.org/drawingml/2006/main">
               <a:ext uri="{FF2B5EF4-FFF2-40B4-BE49-F238E27FC236}">
-                <a16:creationId xmlns:a16="http://schemas.microsoft.com/office/drawing/2014/main" id="{F3658B31-27D9-4B3A-B73E-DE49D64087DC}"/>
+                <a16:creationId xmlns:a16="http://schemas.microsoft.com/office/drawing/2014/main" id="{954A0C43-A629-4612-AE1A-8C0E1630ACF1}"/>
               </a:ext>
             </a:extLst>
           </p:cNvPr>
@@ -12638,7 +12661,7 @@
           <p:cNvPr id="20" name="text">
             <a:extLst xmlns:a="http://schemas.openxmlformats.org/drawingml/2006/main">
               <a:ext uri="{FF2B5EF4-FFF2-40B4-BE49-F238E27FC236}">
-                <a16:creationId xmlns:a16="http://schemas.microsoft.com/office/drawing/2014/main" id="{BBB91F37-BF7F-4C48-A16E-69BE7CC448CB}"/>
+                <a16:creationId xmlns:a16="http://schemas.microsoft.com/office/drawing/2014/main" id="{CF07A00D-A8D3-4001-B401-E36548BCE168}"/>
               </a:ext>
             </a:extLst>
           </p:cNvPr>
@@ -12696,7 +12719,7 @@
           <p:cNvPr id="21" name="pain-2">
             <a:extLst xmlns:a="http://schemas.openxmlformats.org/drawingml/2006/main">
               <a:ext uri="{FF2B5EF4-FFF2-40B4-BE49-F238E27FC236}">
-                <a16:creationId xmlns:a16="http://schemas.microsoft.com/office/drawing/2014/main" id="{16EB8AB9-8629-453C-B5A1-8720C8F60171}"/>
+                <a16:creationId xmlns:a16="http://schemas.microsoft.com/office/drawing/2014/main" id="{F9913849-1055-4FFC-A3F8-189D2F7793CF}"/>
               </a:ext>
             </a:extLst>
           </p:cNvPr>
@@ -12731,7 +12754,7 @@
           <p:cNvPr id="22" name="text">
             <a:extLst xmlns:a="http://schemas.openxmlformats.org/drawingml/2006/main">
               <a:ext uri="{FF2B5EF4-FFF2-40B4-BE49-F238E27FC236}">
-                <a16:creationId xmlns:a16="http://schemas.microsoft.com/office/drawing/2014/main" id="{40ACE304-C175-470B-9197-7EF0DC1143D1}"/>
+                <a16:creationId xmlns:a16="http://schemas.microsoft.com/office/drawing/2014/main" id="{B5F13405-BB8A-42D4-90A8-322479F4993E}"/>
               </a:ext>
             </a:extLst>
           </p:cNvPr>
@@ -12789,7 +12812,7 @@
           <p:cNvPr id="23" name="text">
             <a:extLst xmlns:a="http://schemas.openxmlformats.org/drawingml/2006/main">
               <a:ext uri="{FF2B5EF4-FFF2-40B4-BE49-F238E27FC236}">
-                <a16:creationId xmlns:a16="http://schemas.microsoft.com/office/drawing/2014/main" id="{A4459F55-43D7-48A7-9445-04981224C891}"/>
+                <a16:creationId xmlns:a16="http://schemas.microsoft.com/office/drawing/2014/main" id="{33D6A49B-5515-45AE-B9C8-89696C35930F}"/>
               </a:ext>
             </a:extLst>
           </p:cNvPr>
@@ -12847,7 +12870,7 @@
           <p:cNvPr id="24" name="text">
             <a:extLst xmlns:a="http://schemas.openxmlformats.org/drawingml/2006/main">
               <a:ext uri="{FF2B5EF4-FFF2-40B4-BE49-F238E27FC236}">
-                <a16:creationId xmlns:a16="http://schemas.microsoft.com/office/drawing/2014/main" id="{DCEDA3D6-36AF-4902-B86E-148F63D1594F}"/>
+                <a16:creationId xmlns:a16="http://schemas.microsoft.com/office/drawing/2014/main" id="{6E2F34CB-3231-4F38-BEEF-D9486E3522C5}"/>
               </a:ext>
             </a:extLst>
           </p:cNvPr>
@@ -12903,7 +12926,7 @@
     </p:spTree>
     <p:extLst>
       <p:ext uri="{BB962C8B-B14F-4D97-AF65-F5344CB8AC3E}">
-        <p14:creationId xmlns:p14="http://schemas.microsoft.com/office/powerpoint/2010/main" val="1439239938"/>
+        <p14:creationId xmlns:p14="http://schemas.microsoft.com/office/powerpoint/2010/main" val="1100030122"/>
       </p:ext>
     </p:extLst>
   </p:cSld>
@@ -12934,7 +12957,7 @@
           <p:cNvPr id="1" name="eyebrow-3">
             <a:extLst xmlns:a="http://schemas.openxmlformats.org/drawingml/2006/main">
               <a:ext uri="{FF2B5EF4-FFF2-40B4-BE49-F238E27FC236}">
-                <a16:creationId xmlns:a16="http://schemas.microsoft.com/office/drawing/2014/main" id="{D427D416-66B0-48F0-8215-19F12B7A17E2}"/>
+                <a16:creationId xmlns:a16="http://schemas.microsoft.com/office/drawing/2014/main" id="{813D208A-292A-4D11-91BD-56F9AC534D9C}"/>
               </a:ext>
             </a:extLst>
           </p:cNvPr>
@@ -12992,7 +13015,7 @@
           <p:cNvPr id="2" name="slide-title-3">
             <a:extLst xmlns:a="http://schemas.openxmlformats.org/drawingml/2006/main">
               <a:ext uri="{FF2B5EF4-FFF2-40B4-BE49-F238E27FC236}">
-                <a16:creationId xmlns:a16="http://schemas.microsoft.com/office/drawing/2014/main" id="{00539AFD-59DA-4396-94C5-79C2947A2905}"/>
+                <a16:creationId xmlns:a16="http://schemas.microsoft.com/office/drawing/2014/main" id="{1266F716-6709-47EB-B1C0-AD7487406491}"/>
               </a:ext>
             </a:extLst>
           </p:cNvPr>
@@ -13050,7 +13073,7 @@
           <p:cNvPr id="3" name="title-rule-3">
             <a:extLst xmlns:a="http://schemas.openxmlformats.org/drawingml/2006/main">
               <a:ext uri="{FF2B5EF4-FFF2-40B4-BE49-F238E27FC236}">
-                <a16:creationId xmlns:a16="http://schemas.microsoft.com/office/drawing/2014/main" id="{0C84CFFE-001F-4BA9-B9B0-91CC0ECC2BDE}"/>
+                <a16:creationId xmlns:a16="http://schemas.microsoft.com/office/drawing/2014/main" id="{ED11D1AC-130E-4330-81B1-13CD37ED71ED}"/>
               </a:ext>
             </a:extLst>
           </p:cNvPr>
@@ -13081,7 +13104,7 @@
           <p:cNvPr id="4" name="page-number-3">
             <a:extLst xmlns:a="http://schemas.openxmlformats.org/drawingml/2006/main">
               <a:ext uri="{FF2B5EF4-FFF2-40B4-BE49-F238E27FC236}">
-                <a16:creationId xmlns:a16="http://schemas.microsoft.com/office/drawing/2014/main" id="{500BF4CA-CFED-4D4D-9483-452D0122F4F1}"/>
+                <a16:creationId xmlns:a16="http://schemas.microsoft.com/office/drawing/2014/main" id="{B4C079C0-8135-4497-82A2-994C668352E3}"/>
               </a:ext>
             </a:extLst>
           </p:cNvPr>
@@ -13139,7 +13162,7 @@
           <p:cNvPr id="5" name="loop-0">
             <a:extLst xmlns:a="http://schemas.openxmlformats.org/drawingml/2006/main">
               <a:ext uri="{FF2B5EF4-FFF2-40B4-BE49-F238E27FC236}">
-                <a16:creationId xmlns:a16="http://schemas.microsoft.com/office/drawing/2014/main" id="{2D26F5B9-2665-4777-9DC5-6B2F60BE52CA}"/>
+                <a16:creationId xmlns:a16="http://schemas.microsoft.com/office/drawing/2014/main" id="{EA25ECBB-6189-4264-A93E-BEB4B8834FA0}"/>
               </a:ext>
             </a:extLst>
           </p:cNvPr>
@@ -13174,7 +13197,7 @@
           <p:cNvPr id="6" name="text">
             <a:extLst xmlns:a="http://schemas.openxmlformats.org/drawingml/2006/main">
               <a:ext uri="{FF2B5EF4-FFF2-40B4-BE49-F238E27FC236}">
-                <a16:creationId xmlns:a16="http://schemas.microsoft.com/office/drawing/2014/main" id="{4BB4C499-7F9C-4E88-BE63-470F73AF5B19}"/>
+                <a16:creationId xmlns:a16="http://schemas.microsoft.com/office/drawing/2014/main" id="{EE8B7054-9320-4BAE-913E-DE03B8FD6426}"/>
               </a:ext>
             </a:extLst>
           </p:cNvPr>
@@ -13232,7 +13255,7 @@
           <p:cNvPr id="7" name="text">
             <a:extLst xmlns:a="http://schemas.openxmlformats.org/drawingml/2006/main">
               <a:ext uri="{FF2B5EF4-FFF2-40B4-BE49-F238E27FC236}">
-                <a16:creationId xmlns:a16="http://schemas.microsoft.com/office/drawing/2014/main" id="{362AD693-31ED-4BC9-997E-A588AF307CFC}"/>
+                <a16:creationId xmlns:a16="http://schemas.microsoft.com/office/drawing/2014/main" id="{F98F0635-608A-40D0-8C8D-AF9774159FC0}"/>
               </a:ext>
             </a:extLst>
           </p:cNvPr>
@@ -13290,7 +13313,7 @@
           <p:cNvPr id="8" name="text">
             <a:extLst xmlns:a="http://schemas.openxmlformats.org/drawingml/2006/main">
               <a:ext uri="{FF2B5EF4-FFF2-40B4-BE49-F238E27FC236}">
-                <a16:creationId xmlns:a16="http://schemas.microsoft.com/office/drawing/2014/main" id="{2CF12315-2343-4995-815F-FC16B8049E98}"/>
+                <a16:creationId xmlns:a16="http://schemas.microsoft.com/office/drawing/2014/main" id="{C99FC0DE-E854-4A84-9293-45C1D2CB5540}"/>
               </a:ext>
             </a:extLst>
           </p:cNvPr>
@@ -13348,7 +13371,7 @@
           <p:cNvPr id="9" name="arrow">
             <a:extLst xmlns:a="http://schemas.openxmlformats.org/drawingml/2006/main">
               <a:ext uri="{FF2B5EF4-FFF2-40B4-BE49-F238E27FC236}">
-                <a16:creationId xmlns:a16="http://schemas.microsoft.com/office/drawing/2014/main" id="{297946F5-4E7B-4816-B262-9F95ADFF06D2}"/>
+                <a16:creationId xmlns:a16="http://schemas.microsoft.com/office/drawing/2014/main" id="{34FAA9B6-ACC2-47F6-8A00-FD0838478BBC}"/>
               </a:ext>
             </a:extLst>
           </p:cNvPr>
@@ -13406,7 +13429,7 @@
           <p:cNvPr id="10" name="loop-1">
             <a:extLst xmlns:a="http://schemas.openxmlformats.org/drawingml/2006/main">
               <a:ext uri="{FF2B5EF4-FFF2-40B4-BE49-F238E27FC236}">
-                <a16:creationId xmlns:a16="http://schemas.microsoft.com/office/drawing/2014/main" id="{2C8FBF45-3EE0-48EB-B00D-88B31047DB9F}"/>
+                <a16:creationId xmlns:a16="http://schemas.microsoft.com/office/drawing/2014/main" id="{2CA935A8-EF93-4504-BAE6-AF8575A7D974}"/>
               </a:ext>
             </a:extLst>
           </p:cNvPr>
@@ -13441,7 +13464,7 @@
           <p:cNvPr id="11" name="text">
             <a:extLst xmlns:a="http://schemas.openxmlformats.org/drawingml/2006/main">
               <a:ext uri="{FF2B5EF4-FFF2-40B4-BE49-F238E27FC236}">
-                <a16:creationId xmlns:a16="http://schemas.microsoft.com/office/drawing/2014/main" id="{D135B618-4F32-456B-9523-2CD114CACC6B}"/>
+                <a16:creationId xmlns:a16="http://schemas.microsoft.com/office/drawing/2014/main" id="{30F1C967-28A2-4935-93E7-ABB658706F53}"/>
               </a:ext>
             </a:extLst>
           </p:cNvPr>
@@ -13499,7 +13522,7 @@
           <p:cNvPr id="12" name="text">
             <a:extLst xmlns:a="http://schemas.openxmlformats.org/drawingml/2006/main">
               <a:ext uri="{FF2B5EF4-FFF2-40B4-BE49-F238E27FC236}">
-                <a16:creationId xmlns:a16="http://schemas.microsoft.com/office/drawing/2014/main" id="{A7990CC0-F6E8-4934-9D53-CB2FE5AC46C0}"/>
+                <a16:creationId xmlns:a16="http://schemas.microsoft.com/office/drawing/2014/main" id="{E74F4418-93D8-4949-993A-F249E557A700}"/>
               </a:ext>
             </a:extLst>
           </p:cNvPr>
@@ -13557,7 +13580,7 @@
           <p:cNvPr id="13" name="text">
             <a:extLst xmlns:a="http://schemas.openxmlformats.org/drawingml/2006/main">
               <a:ext uri="{FF2B5EF4-FFF2-40B4-BE49-F238E27FC236}">
-                <a16:creationId xmlns:a16="http://schemas.microsoft.com/office/drawing/2014/main" id="{B6A4FEC8-B325-4AF4-A94B-A04DBF854F00}"/>
+                <a16:creationId xmlns:a16="http://schemas.microsoft.com/office/drawing/2014/main" id="{9C50F05B-BCFF-4099-A11C-E8D4F8DDC841}"/>
               </a:ext>
             </a:extLst>
           </p:cNvPr>
@@ -13615,7 +13638,7 @@
           <p:cNvPr id="14" name="arrow">
             <a:extLst xmlns:a="http://schemas.openxmlformats.org/drawingml/2006/main">
               <a:ext uri="{FF2B5EF4-FFF2-40B4-BE49-F238E27FC236}">
-                <a16:creationId xmlns:a16="http://schemas.microsoft.com/office/drawing/2014/main" id="{594E3E02-DF29-43EC-B336-E826EC06A75D}"/>
+                <a16:creationId xmlns:a16="http://schemas.microsoft.com/office/drawing/2014/main" id="{9B01928A-3EF9-4017-B3C6-25BE0FC405DA}"/>
               </a:ext>
             </a:extLst>
           </p:cNvPr>
@@ -13673,7 +13696,7 @@
           <p:cNvPr id="15" name="loop-2">
             <a:extLst xmlns:a="http://schemas.openxmlformats.org/drawingml/2006/main">
               <a:ext uri="{FF2B5EF4-FFF2-40B4-BE49-F238E27FC236}">
-                <a16:creationId xmlns:a16="http://schemas.microsoft.com/office/drawing/2014/main" id="{DE8379C7-8716-4BB4-A56C-A22FA087F3B6}"/>
+                <a16:creationId xmlns:a16="http://schemas.microsoft.com/office/drawing/2014/main" id="{33D3ECA0-359E-4057-8E62-9F8E26616884}"/>
               </a:ext>
             </a:extLst>
           </p:cNvPr>
@@ -13708,7 +13731,7 @@
           <p:cNvPr id="16" name="text">
             <a:extLst xmlns:a="http://schemas.openxmlformats.org/drawingml/2006/main">
               <a:ext uri="{FF2B5EF4-FFF2-40B4-BE49-F238E27FC236}">
-                <a16:creationId xmlns:a16="http://schemas.microsoft.com/office/drawing/2014/main" id="{78B745B5-3CAA-4200-A6C2-C3B5B206B337}"/>
+                <a16:creationId xmlns:a16="http://schemas.microsoft.com/office/drawing/2014/main" id="{05478402-F585-4FBF-83FA-6011E6FDCF4E}"/>
               </a:ext>
             </a:extLst>
           </p:cNvPr>
@@ -13766,7 +13789,7 @@
           <p:cNvPr id="17" name="text">
             <a:extLst xmlns:a="http://schemas.openxmlformats.org/drawingml/2006/main">
               <a:ext uri="{FF2B5EF4-FFF2-40B4-BE49-F238E27FC236}">
-                <a16:creationId xmlns:a16="http://schemas.microsoft.com/office/drawing/2014/main" id="{6A0DAD5C-AACB-4246-B6A1-069A6E2F81B4}"/>
+                <a16:creationId xmlns:a16="http://schemas.microsoft.com/office/drawing/2014/main" id="{0F89EEFB-E781-45A3-87A8-5964F202054C}"/>
               </a:ext>
             </a:extLst>
           </p:cNvPr>
@@ -13824,7 +13847,7 @@
           <p:cNvPr id="18" name="text">
             <a:extLst xmlns:a="http://schemas.openxmlformats.org/drawingml/2006/main">
               <a:ext uri="{FF2B5EF4-FFF2-40B4-BE49-F238E27FC236}">
-                <a16:creationId xmlns:a16="http://schemas.microsoft.com/office/drawing/2014/main" id="{EAC6FE56-EF48-49BC-832D-0C569B750F05}"/>
+                <a16:creationId xmlns:a16="http://schemas.microsoft.com/office/drawing/2014/main" id="{9EB9D2E4-6ACD-41CA-BF80-9704D19273D4}"/>
               </a:ext>
             </a:extLst>
           </p:cNvPr>
@@ -13882,7 +13905,7 @@
           <p:cNvPr id="19" name="arrow">
             <a:extLst xmlns:a="http://schemas.openxmlformats.org/drawingml/2006/main">
               <a:ext uri="{FF2B5EF4-FFF2-40B4-BE49-F238E27FC236}">
-                <a16:creationId xmlns:a16="http://schemas.microsoft.com/office/drawing/2014/main" id="{93CBF8EC-FFD3-46D1-82AB-71E7AA41CC91}"/>
+                <a16:creationId xmlns:a16="http://schemas.microsoft.com/office/drawing/2014/main" id="{4CE205C2-6D42-4045-85C8-92EA0FC41AEE}"/>
               </a:ext>
             </a:extLst>
           </p:cNvPr>
@@ -13940,7 +13963,7 @@
           <p:cNvPr id="20" name="loop-3">
             <a:extLst xmlns:a="http://schemas.openxmlformats.org/drawingml/2006/main">
               <a:ext uri="{FF2B5EF4-FFF2-40B4-BE49-F238E27FC236}">
-                <a16:creationId xmlns:a16="http://schemas.microsoft.com/office/drawing/2014/main" id="{C3188F54-653B-4286-BC37-23D65AB640E1}"/>
+                <a16:creationId xmlns:a16="http://schemas.microsoft.com/office/drawing/2014/main" id="{2A6DDFDF-8D97-4A15-B44C-E54FFD6763AE}"/>
               </a:ext>
             </a:extLst>
           </p:cNvPr>
@@ -13975,7 +13998,7 @@
           <p:cNvPr id="21" name="text">
             <a:extLst xmlns:a="http://schemas.openxmlformats.org/drawingml/2006/main">
               <a:ext uri="{FF2B5EF4-FFF2-40B4-BE49-F238E27FC236}">
-                <a16:creationId xmlns:a16="http://schemas.microsoft.com/office/drawing/2014/main" id="{D3A69E04-D87D-47D3-955E-DAB3CE9CFC77}"/>
+                <a16:creationId xmlns:a16="http://schemas.microsoft.com/office/drawing/2014/main" id="{95109F71-F2DC-40DC-AC05-B8908E2BF3AF}"/>
               </a:ext>
             </a:extLst>
           </p:cNvPr>
@@ -14033,7 +14056,7 @@
           <p:cNvPr id="22" name="text">
             <a:extLst xmlns:a="http://schemas.openxmlformats.org/drawingml/2006/main">
               <a:ext uri="{FF2B5EF4-FFF2-40B4-BE49-F238E27FC236}">
-                <a16:creationId xmlns:a16="http://schemas.microsoft.com/office/drawing/2014/main" id="{AC64F5FA-40EE-4BBE-B35C-C4FB6AD43D6D}"/>
+                <a16:creationId xmlns:a16="http://schemas.microsoft.com/office/drawing/2014/main" id="{72891AA9-F14E-4765-90B8-DEF3EF543398}"/>
               </a:ext>
             </a:extLst>
           </p:cNvPr>
@@ -14091,7 +14114,7 @@
           <p:cNvPr id="23" name="text">
             <a:extLst xmlns:a="http://schemas.openxmlformats.org/drawingml/2006/main">
               <a:ext uri="{FF2B5EF4-FFF2-40B4-BE49-F238E27FC236}">
-                <a16:creationId xmlns:a16="http://schemas.microsoft.com/office/drawing/2014/main" id="{256A8355-96D8-4E88-8B08-7E0FE9888057}"/>
+                <a16:creationId xmlns:a16="http://schemas.microsoft.com/office/drawing/2014/main" id="{022A2D45-E430-4C70-8A86-7E7DEE84B726}"/>
               </a:ext>
             </a:extLst>
           </p:cNvPr>
@@ -14149,7 +14172,7 @@
           <p:cNvPr id="24" name="arrow">
             <a:extLst xmlns:a="http://schemas.openxmlformats.org/drawingml/2006/main">
               <a:ext uri="{FF2B5EF4-FFF2-40B4-BE49-F238E27FC236}">
-                <a16:creationId xmlns:a16="http://schemas.microsoft.com/office/drawing/2014/main" id="{390B58E6-2738-49AD-AF71-1FDA3547C6ED}"/>
+                <a16:creationId xmlns:a16="http://schemas.microsoft.com/office/drawing/2014/main" id="{3D3835EC-D36E-415F-B019-8880E0CF260A}"/>
               </a:ext>
             </a:extLst>
           </p:cNvPr>
@@ -14207,7 +14230,7 @@
           <p:cNvPr id="25" name="loop-4">
             <a:extLst xmlns:a="http://schemas.openxmlformats.org/drawingml/2006/main">
               <a:ext uri="{FF2B5EF4-FFF2-40B4-BE49-F238E27FC236}">
-                <a16:creationId xmlns:a16="http://schemas.microsoft.com/office/drawing/2014/main" id="{30559721-3100-4285-8C35-18CFDCC1A442}"/>
+                <a16:creationId xmlns:a16="http://schemas.microsoft.com/office/drawing/2014/main" id="{143CEFC4-8C28-44E0-B7DB-ECE6E77B7CBA}"/>
               </a:ext>
             </a:extLst>
           </p:cNvPr>
@@ -14242,7 +14265,7 @@
           <p:cNvPr id="26" name="text">
             <a:extLst xmlns:a="http://schemas.openxmlformats.org/drawingml/2006/main">
               <a:ext uri="{FF2B5EF4-FFF2-40B4-BE49-F238E27FC236}">
-                <a16:creationId xmlns:a16="http://schemas.microsoft.com/office/drawing/2014/main" id="{474324DB-A247-4CC8-8DF5-AC64BCBAEE0B}"/>
+                <a16:creationId xmlns:a16="http://schemas.microsoft.com/office/drawing/2014/main" id="{A66B0C0B-F381-4A4E-AB7B-7DEA165DC4AC}"/>
               </a:ext>
             </a:extLst>
           </p:cNvPr>
@@ -14300,7 +14323,7 @@
           <p:cNvPr id="27" name="text">
             <a:extLst xmlns:a="http://schemas.openxmlformats.org/drawingml/2006/main">
               <a:ext uri="{FF2B5EF4-FFF2-40B4-BE49-F238E27FC236}">
-                <a16:creationId xmlns:a16="http://schemas.microsoft.com/office/drawing/2014/main" id="{FF2C2802-F612-4650-9E59-AB34C0EA1FFF}"/>
+                <a16:creationId xmlns:a16="http://schemas.microsoft.com/office/drawing/2014/main" id="{B5C94991-5EA2-4BC3-B5AB-381AA22A01AA}"/>
               </a:ext>
             </a:extLst>
           </p:cNvPr>
@@ -14358,7 +14381,7 @@
           <p:cNvPr id="28" name="text">
             <a:extLst xmlns:a="http://schemas.openxmlformats.org/drawingml/2006/main">
               <a:ext uri="{FF2B5EF4-FFF2-40B4-BE49-F238E27FC236}">
-                <a16:creationId xmlns:a16="http://schemas.microsoft.com/office/drawing/2014/main" id="{A1553773-D7A7-4572-8094-A79D9DEBAC2A}"/>
+                <a16:creationId xmlns:a16="http://schemas.microsoft.com/office/drawing/2014/main" id="{AE1E19D9-B408-43D7-BB2E-82B82638F899}"/>
               </a:ext>
             </a:extLst>
           </p:cNvPr>
@@ -14416,7 +14439,7 @@
           <p:cNvPr id="29" name="arrow">
             <a:extLst xmlns:a="http://schemas.openxmlformats.org/drawingml/2006/main">
               <a:ext uri="{FF2B5EF4-FFF2-40B4-BE49-F238E27FC236}">
-                <a16:creationId xmlns:a16="http://schemas.microsoft.com/office/drawing/2014/main" id="{689A306C-0F65-4A7A-B451-521C6712293A}"/>
+                <a16:creationId xmlns:a16="http://schemas.microsoft.com/office/drawing/2014/main" id="{7B4C8658-EEB6-4F0F-9436-2157C72A15D2}"/>
               </a:ext>
             </a:extLst>
           </p:cNvPr>
@@ -14474,7 +14497,7 @@
           <p:cNvPr id="30" name="loop-5">
             <a:extLst xmlns:a="http://schemas.openxmlformats.org/drawingml/2006/main">
               <a:ext uri="{FF2B5EF4-FFF2-40B4-BE49-F238E27FC236}">
-                <a16:creationId xmlns:a16="http://schemas.microsoft.com/office/drawing/2014/main" id="{FB6556E2-2F30-485E-898F-70136FE82166}"/>
+                <a16:creationId xmlns:a16="http://schemas.microsoft.com/office/drawing/2014/main" id="{1DA59FD5-7F88-4E94-A0FA-2216E2EEE2C7}"/>
               </a:ext>
             </a:extLst>
           </p:cNvPr>
@@ -14509,7 +14532,7 @@
           <p:cNvPr id="31" name="text">
             <a:extLst xmlns:a="http://schemas.openxmlformats.org/drawingml/2006/main">
               <a:ext uri="{FF2B5EF4-FFF2-40B4-BE49-F238E27FC236}">
-                <a16:creationId xmlns:a16="http://schemas.microsoft.com/office/drawing/2014/main" id="{8C6DCAF1-52D2-4A6F-A958-ABD52644147D}"/>
+                <a16:creationId xmlns:a16="http://schemas.microsoft.com/office/drawing/2014/main" id="{E2A1795D-FEED-4CD9-9F62-1CD4AF62FEB4}"/>
               </a:ext>
             </a:extLst>
           </p:cNvPr>
@@ -14567,7 +14590,7 @@
           <p:cNvPr id="32" name="text">
             <a:extLst xmlns:a="http://schemas.openxmlformats.org/drawingml/2006/main">
               <a:ext uri="{FF2B5EF4-FFF2-40B4-BE49-F238E27FC236}">
-                <a16:creationId xmlns:a16="http://schemas.microsoft.com/office/drawing/2014/main" id="{DCA71AA0-1B4B-425F-96B6-FF2E541ECDFB}"/>
+                <a16:creationId xmlns:a16="http://schemas.microsoft.com/office/drawing/2014/main" id="{0602627D-896F-41B7-8E27-34D556983D94}"/>
               </a:ext>
             </a:extLst>
           </p:cNvPr>
@@ -14625,7 +14648,7 @@
           <p:cNvPr id="33" name="text">
             <a:extLst xmlns:a="http://schemas.openxmlformats.org/drawingml/2006/main">
               <a:ext uri="{FF2B5EF4-FFF2-40B4-BE49-F238E27FC236}">
-                <a16:creationId xmlns:a16="http://schemas.microsoft.com/office/drawing/2014/main" id="{FABE8223-EF33-48FE-B74B-08D22E1BAC01}"/>
+                <a16:creationId xmlns:a16="http://schemas.microsoft.com/office/drawing/2014/main" id="{399032E5-9D42-4E7F-9BAC-D782E1B48ABD}"/>
               </a:ext>
             </a:extLst>
           </p:cNvPr>
@@ -14683,7 +14706,7 @@
           <p:cNvPr id="34" name="text">
             <a:extLst xmlns:a="http://schemas.openxmlformats.org/drawingml/2006/main">
               <a:ext uri="{FF2B5EF4-FFF2-40B4-BE49-F238E27FC236}">
-                <a16:creationId xmlns:a16="http://schemas.microsoft.com/office/drawing/2014/main" id="{75C4DFD7-C752-4664-A2E8-A11EDDD9D07B}"/>
+                <a16:creationId xmlns:a16="http://schemas.microsoft.com/office/drawing/2014/main" id="{CE2CD665-745C-420F-9E07-F622A8F8EAC6}"/>
               </a:ext>
             </a:extLst>
           </p:cNvPr>
@@ -14741,7 +14764,7 @@
           <p:cNvPr id="35" name="text">
             <a:extLst xmlns:a="http://schemas.openxmlformats.org/drawingml/2006/main">
               <a:ext uri="{FF2B5EF4-FFF2-40B4-BE49-F238E27FC236}">
-                <a16:creationId xmlns:a16="http://schemas.microsoft.com/office/drawing/2014/main" id="{B9AF53C6-3108-492E-BFB7-5D81E68A5C50}"/>
+                <a16:creationId xmlns:a16="http://schemas.microsoft.com/office/drawing/2014/main" id="{42CF47F8-684F-499C-BF42-D1488B3B8DA1}"/>
               </a:ext>
             </a:extLst>
           </p:cNvPr>
@@ -14797,7 +14820,7 @@
     </p:spTree>
     <p:extLst>
       <p:ext uri="{BB962C8B-B14F-4D97-AF65-F5344CB8AC3E}">
-        <p14:creationId xmlns:p14="http://schemas.microsoft.com/office/powerpoint/2010/main" val="697677308"/>
+        <p14:creationId xmlns:p14="http://schemas.microsoft.com/office/powerpoint/2010/main" val="315889114"/>
       </p:ext>
     </p:extLst>
   </p:cSld>
@@ -14828,7 +14851,7 @@
           <p:cNvPr id="1" name="eyebrow-4">
             <a:extLst xmlns:a="http://schemas.openxmlformats.org/drawingml/2006/main">
               <a:ext uri="{FF2B5EF4-FFF2-40B4-BE49-F238E27FC236}">
-                <a16:creationId xmlns:a16="http://schemas.microsoft.com/office/drawing/2014/main" id="{EE450B8F-6C67-4B80-A4DB-AF4BC3432DDF}"/>
+                <a16:creationId xmlns:a16="http://schemas.microsoft.com/office/drawing/2014/main" id="{9468BDFA-8905-4F39-A176-FD45B791A82A}"/>
               </a:ext>
             </a:extLst>
           </p:cNvPr>
@@ -14886,7 +14909,7 @@
           <p:cNvPr id="2" name="slide-title-4">
             <a:extLst xmlns:a="http://schemas.openxmlformats.org/drawingml/2006/main">
               <a:ext uri="{FF2B5EF4-FFF2-40B4-BE49-F238E27FC236}">
-                <a16:creationId xmlns:a16="http://schemas.microsoft.com/office/drawing/2014/main" id="{70EC4141-0681-4E7E-B3A5-05664BBBE11B}"/>
+                <a16:creationId xmlns:a16="http://schemas.microsoft.com/office/drawing/2014/main" id="{81ADF1DA-7EFF-49F9-BA09-94B6E2444C64}"/>
               </a:ext>
             </a:extLst>
           </p:cNvPr>
@@ -14944,7 +14967,7 @@
           <p:cNvPr id="3" name="title-rule-4">
             <a:extLst xmlns:a="http://schemas.openxmlformats.org/drawingml/2006/main">
               <a:ext uri="{FF2B5EF4-FFF2-40B4-BE49-F238E27FC236}">
-                <a16:creationId xmlns:a16="http://schemas.microsoft.com/office/drawing/2014/main" id="{D1AF232A-7E3E-4112-A603-228075B8C383}"/>
+                <a16:creationId xmlns:a16="http://schemas.microsoft.com/office/drawing/2014/main" id="{57ACABA8-6B4B-4057-8AB7-CF6B604EBA89}"/>
               </a:ext>
             </a:extLst>
           </p:cNvPr>
@@ -14975,7 +14998,7 @@
           <p:cNvPr id="4" name="page-number-4">
             <a:extLst xmlns:a="http://schemas.openxmlformats.org/drawingml/2006/main">
               <a:ext uri="{FF2B5EF4-FFF2-40B4-BE49-F238E27FC236}">
-                <a16:creationId xmlns:a16="http://schemas.microsoft.com/office/drawing/2014/main" id="{29C657C1-8AED-499F-AFBB-C917BA00D4AA}"/>
+                <a16:creationId xmlns:a16="http://schemas.microsoft.com/office/drawing/2014/main" id="{A79A070E-FD4E-402F-B400-4BD92B289206}"/>
               </a:ext>
             </a:extLst>
           </p:cNvPr>
@@ -15033,7 +15056,7 @@
           <p:cNvPr id="5" name="stack-0">
             <a:extLst xmlns:a="http://schemas.openxmlformats.org/drawingml/2006/main">
               <a:ext uri="{FF2B5EF4-FFF2-40B4-BE49-F238E27FC236}">
-                <a16:creationId xmlns:a16="http://schemas.microsoft.com/office/drawing/2014/main" id="{77639DD1-70D9-473A-923E-254394002332}"/>
+                <a16:creationId xmlns:a16="http://schemas.microsoft.com/office/drawing/2014/main" id="{0371DEE0-3C7D-45B8-B2E5-154FCB1EE3F0}"/>
               </a:ext>
             </a:extLst>
           </p:cNvPr>
@@ -15068,7 +15091,7 @@
           <p:cNvPr id="6" name="stack-accent-0">
             <a:extLst xmlns:a="http://schemas.openxmlformats.org/drawingml/2006/main">
               <a:ext uri="{FF2B5EF4-FFF2-40B4-BE49-F238E27FC236}">
-                <a16:creationId xmlns:a16="http://schemas.microsoft.com/office/drawing/2014/main" id="{CC2E52D5-5216-44A7-9D12-22853A5C864B}"/>
+                <a16:creationId xmlns:a16="http://schemas.microsoft.com/office/drawing/2014/main" id="{84333EC2-7723-4642-848F-413A5A07F864}"/>
               </a:ext>
             </a:extLst>
           </p:cNvPr>
@@ -15099,7 +15122,7 @@
           <p:cNvPr id="7" name="text">
             <a:extLst xmlns:a="http://schemas.openxmlformats.org/drawingml/2006/main">
               <a:ext uri="{FF2B5EF4-FFF2-40B4-BE49-F238E27FC236}">
-                <a16:creationId xmlns:a16="http://schemas.microsoft.com/office/drawing/2014/main" id="{71CB9F8D-346A-4122-9416-649F4666CFA9}"/>
+                <a16:creationId xmlns:a16="http://schemas.microsoft.com/office/drawing/2014/main" id="{39E1827D-7722-4FF2-ABFD-1371934567AE}"/>
               </a:ext>
             </a:extLst>
           </p:cNvPr>
@@ -15157,7 +15180,7 @@
           <p:cNvPr id="8" name="text">
             <a:extLst xmlns:a="http://schemas.openxmlformats.org/drawingml/2006/main">
               <a:ext uri="{FF2B5EF4-FFF2-40B4-BE49-F238E27FC236}">
-                <a16:creationId xmlns:a16="http://schemas.microsoft.com/office/drawing/2014/main" id="{02CD25C8-E918-4EFC-8627-263BAB8E136D}"/>
+                <a16:creationId xmlns:a16="http://schemas.microsoft.com/office/drawing/2014/main" id="{647DA25F-E4D1-456A-9B02-5ADCED20B342}"/>
               </a:ext>
             </a:extLst>
           </p:cNvPr>
@@ -15215,7 +15238,7 @@
           <p:cNvPr id="9" name="text">
             <a:extLst xmlns:a="http://schemas.openxmlformats.org/drawingml/2006/main">
               <a:ext uri="{FF2B5EF4-FFF2-40B4-BE49-F238E27FC236}">
-                <a16:creationId xmlns:a16="http://schemas.microsoft.com/office/drawing/2014/main" id="{C7BB0C8E-D8E5-4920-A4E0-EB383E95ED80}"/>
+                <a16:creationId xmlns:a16="http://schemas.microsoft.com/office/drawing/2014/main" id="{FAF19688-1848-4D2C-BFD5-C5F30109C395}"/>
               </a:ext>
             </a:extLst>
           </p:cNvPr>
@@ -15273,7 +15296,7 @@
           <p:cNvPr id="10" name="stack-1">
             <a:extLst xmlns:a="http://schemas.openxmlformats.org/drawingml/2006/main">
               <a:ext uri="{FF2B5EF4-FFF2-40B4-BE49-F238E27FC236}">
-                <a16:creationId xmlns:a16="http://schemas.microsoft.com/office/drawing/2014/main" id="{2B5317BC-7484-4CEA-8543-980ABE863C4B}"/>
+                <a16:creationId xmlns:a16="http://schemas.microsoft.com/office/drawing/2014/main" id="{424957CF-E02A-4130-BDFF-47EBB40643D3}"/>
               </a:ext>
             </a:extLst>
           </p:cNvPr>
@@ -15308,7 +15331,7 @@
           <p:cNvPr id="11" name="stack-accent-1">
             <a:extLst xmlns:a="http://schemas.openxmlformats.org/drawingml/2006/main">
               <a:ext uri="{FF2B5EF4-FFF2-40B4-BE49-F238E27FC236}">
-                <a16:creationId xmlns:a16="http://schemas.microsoft.com/office/drawing/2014/main" id="{3A0F1EEB-844F-4B2E-B89C-04D80C5FDC3F}"/>
+                <a16:creationId xmlns:a16="http://schemas.microsoft.com/office/drawing/2014/main" id="{F07DE106-3C93-4268-B50F-A73F6E2BAC6C}"/>
               </a:ext>
             </a:extLst>
           </p:cNvPr>
@@ -15339,7 +15362,7 @@
           <p:cNvPr id="12" name="text">
             <a:extLst xmlns:a="http://schemas.openxmlformats.org/drawingml/2006/main">
               <a:ext uri="{FF2B5EF4-FFF2-40B4-BE49-F238E27FC236}">
-                <a16:creationId xmlns:a16="http://schemas.microsoft.com/office/drawing/2014/main" id="{34461180-3EE4-4CC8-A9D6-093E994064A4}"/>
+                <a16:creationId xmlns:a16="http://schemas.microsoft.com/office/drawing/2014/main" id="{F295513A-577B-4B0D-AF66-05F034C5F3D1}"/>
               </a:ext>
             </a:extLst>
           </p:cNvPr>
@@ -15397,7 +15420,7 @@
           <p:cNvPr id="13" name="text">
             <a:extLst xmlns:a="http://schemas.openxmlformats.org/drawingml/2006/main">
               <a:ext uri="{FF2B5EF4-FFF2-40B4-BE49-F238E27FC236}">
-                <a16:creationId xmlns:a16="http://schemas.microsoft.com/office/drawing/2014/main" id="{EE6474D2-87BA-444D-A407-75D3B6290DEA}"/>
+                <a16:creationId xmlns:a16="http://schemas.microsoft.com/office/drawing/2014/main" id="{C34B2EA0-6A20-493B-A0D6-389107B8D496}"/>
               </a:ext>
             </a:extLst>
           </p:cNvPr>
@@ -15455,7 +15478,7 @@
           <p:cNvPr id="14" name="text">
             <a:extLst xmlns:a="http://schemas.openxmlformats.org/drawingml/2006/main">
               <a:ext uri="{FF2B5EF4-FFF2-40B4-BE49-F238E27FC236}">
-                <a16:creationId xmlns:a16="http://schemas.microsoft.com/office/drawing/2014/main" id="{A99FCD10-2062-4823-B7EA-62A1614A0653}"/>
+                <a16:creationId xmlns:a16="http://schemas.microsoft.com/office/drawing/2014/main" id="{56301D3D-5A8A-41AD-A06D-2DF3AEA3E2E5}"/>
               </a:ext>
             </a:extLst>
           </p:cNvPr>
@@ -15513,7 +15536,7 @@
           <p:cNvPr id="15" name="stack-2">
             <a:extLst xmlns:a="http://schemas.openxmlformats.org/drawingml/2006/main">
               <a:ext uri="{FF2B5EF4-FFF2-40B4-BE49-F238E27FC236}">
-                <a16:creationId xmlns:a16="http://schemas.microsoft.com/office/drawing/2014/main" id="{EFD05D5B-D289-41FB-B807-50C496912310}"/>
+                <a16:creationId xmlns:a16="http://schemas.microsoft.com/office/drawing/2014/main" id="{318AC919-D7CA-49CB-AF8A-EE4D3A279460}"/>
               </a:ext>
             </a:extLst>
           </p:cNvPr>
@@ -15548,7 +15571,7 @@
           <p:cNvPr id="16" name="stack-accent-2">
             <a:extLst xmlns:a="http://schemas.openxmlformats.org/drawingml/2006/main">
               <a:ext uri="{FF2B5EF4-FFF2-40B4-BE49-F238E27FC236}">
-                <a16:creationId xmlns:a16="http://schemas.microsoft.com/office/drawing/2014/main" id="{A6A88987-505E-467B-96EB-9572ED570A1C}"/>
+                <a16:creationId xmlns:a16="http://schemas.microsoft.com/office/drawing/2014/main" id="{B0DDBA5C-05B8-4D69-9CA1-AC8D8EA276B4}"/>
               </a:ext>
             </a:extLst>
           </p:cNvPr>
@@ -15579,7 +15602,7 @@
           <p:cNvPr id="17" name="text">
             <a:extLst xmlns:a="http://schemas.openxmlformats.org/drawingml/2006/main">
               <a:ext uri="{FF2B5EF4-FFF2-40B4-BE49-F238E27FC236}">
-                <a16:creationId xmlns:a16="http://schemas.microsoft.com/office/drawing/2014/main" id="{24BE6247-02E8-4B33-8979-00E47ED4127F}"/>
+                <a16:creationId xmlns:a16="http://schemas.microsoft.com/office/drawing/2014/main" id="{9E3EEFB9-EB35-4974-A96A-67D4E401E545}"/>
               </a:ext>
             </a:extLst>
           </p:cNvPr>
@@ -15637,7 +15660,7 @@
           <p:cNvPr id="18" name="text">
             <a:extLst xmlns:a="http://schemas.openxmlformats.org/drawingml/2006/main">
               <a:ext uri="{FF2B5EF4-FFF2-40B4-BE49-F238E27FC236}">
-                <a16:creationId xmlns:a16="http://schemas.microsoft.com/office/drawing/2014/main" id="{1B2F3494-B258-4C10-95B8-DC654494C40A}"/>
+                <a16:creationId xmlns:a16="http://schemas.microsoft.com/office/drawing/2014/main" id="{BFBB4FF0-EF32-42B9-84C2-84E545B3034E}"/>
               </a:ext>
             </a:extLst>
           </p:cNvPr>
@@ -15695,7 +15718,7 @@
           <p:cNvPr id="19" name="text">
             <a:extLst xmlns:a="http://schemas.openxmlformats.org/drawingml/2006/main">
               <a:ext uri="{FF2B5EF4-FFF2-40B4-BE49-F238E27FC236}">
-                <a16:creationId xmlns:a16="http://schemas.microsoft.com/office/drawing/2014/main" id="{EF4BDD11-6FD2-44C0-A202-F10DE46E1D9B}"/>
+                <a16:creationId xmlns:a16="http://schemas.microsoft.com/office/drawing/2014/main" id="{B732D16A-F1AD-413E-8F43-1EFDFBB49E43}"/>
               </a:ext>
             </a:extLst>
           </p:cNvPr>
@@ -15753,7 +15776,7 @@
           <p:cNvPr id="20" name="stack-3">
             <a:extLst xmlns:a="http://schemas.openxmlformats.org/drawingml/2006/main">
               <a:ext uri="{FF2B5EF4-FFF2-40B4-BE49-F238E27FC236}">
-                <a16:creationId xmlns:a16="http://schemas.microsoft.com/office/drawing/2014/main" id="{334F6D2C-0EC6-4992-A605-0E2FD7914F54}"/>
+                <a16:creationId xmlns:a16="http://schemas.microsoft.com/office/drawing/2014/main" id="{B89286F4-D8D5-4BFC-922A-4DF28922E7F5}"/>
               </a:ext>
             </a:extLst>
           </p:cNvPr>
@@ -15788,7 +15811,7 @@
           <p:cNvPr id="21" name="stack-accent-3">
             <a:extLst xmlns:a="http://schemas.openxmlformats.org/drawingml/2006/main">
               <a:ext uri="{FF2B5EF4-FFF2-40B4-BE49-F238E27FC236}">
-                <a16:creationId xmlns:a16="http://schemas.microsoft.com/office/drawing/2014/main" id="{96210765-7B61-41C6-B7AD-888021B3C191}"/>
+                <a16:creationId xmlns:a16="http://schemas.microsoft.com/office/drawing/2014/main" id="{214248CB-C82E-439A-9A1E-CE7A5B1F65A6}"/>
               </a:ext>
             </a:extLst>
           </p:cNvPr>
@@ -15819,7 +15842,7 @@
           <p:cNvPr id="22" name="text">
             <a:extLst xmlns:a="http://schemas.openxmlformats.org/drawingml/2006/main">
               <a:ext uri="{FF2B5EF4-FFF2-40B4-BE49-F238E27FC236}">
-                <a16:creationId xmlns:a16="http://schemas.microsoft.com/office/drawing/2014/main" id="{EAF8EF49-66F7-4DD2-A3CA-2FB0C58FC8F4}"/>
+                <a16:creationId xmlns:a16="http://schemas.microsoft.com/office/drawing/2014/main" id="{208E9795-F4B7-45DA-BED4-CB87A33CA6AF}"/>
               </a:ext>
             </a:extLst>
           </p:cNvPr>
@@ -15877,7 +15900,7 @@
           <p:cNvPr id="23" name="text">
             <a:extLst xmlns:a="http://schemas.openxmlformats.org/drawingml/2006/main">
               <a:ext uri="{FF2B5EF4-FFF2-40B4-BE49-F238E27FC236}">
-                <a16:creationId xmlns:a16="http://schemas.microsoft.com/office/drawing/2014/main" id="{98D2B75F-8B73-46E8-966C-EE9D00D9D24E}"/>
+                <a16:creationId xmlns:a16="http://schemas.microsoft.com/office/drawing/2014/main" id="{FA14CB6E-FA96-4BEA-9C7F-46205A19D63C}"/>
               </a:ext>
             </a:extLst>
           </p:cNvPr>
@@ -15935,7 +15958,7 @@
           <p:cNvPr id="24" name="text">
             <a:extLst xmlns:a="http://schemas.openxmlformats.org/drawingml/2006/main">
               <a:ext uri="{FF2B5EF4-FFF2-40B4-BE49-F238E27FC236}">
-                <a16:creationId xmlns:a16="http://schemas.microsoft.com/office/drawing/2014/main" id="{30817807-5187-4E0C-AA3D-D437437D8DD2}"/>
+                <a16:creationId xmlns:a16="http://schemas.microsoft.com/office/drawing/2014/main" id="{F3B3E5B4-4F9D-4D02-BF1C-4082AF14FB9E}"/>
               </a:ext>
             </a:extLst>
           </p:cNvPr>
@@ -15993,7 +16016,7 @@
           <p:cNvPr id="25" name="text">
             <a:extLst xmlns:a="http://schemas.openxmlformats.org/drawingml/2006/main">
               <a:ext uri="{FF2B5EF4-FFF2-40B4-BE49-F238E27FC236}">
-                <a16:creationId xmlns:a16="http://schemas.microsoft.com/office/drawing/2014/main" id="{31392FAF-A0FE-487D-8901-BCC6282D35DD}"/>
+                <a16:creationId xmlns:a16="http://schemas.microsoft.com/office/drawing/2014/main" id="{267FDD29-7D8C-427C-817B-8897DE7EC654}"/>
               </a:ext>
             </a:extLst>
           </p:cNvPr>
@@ -16049,7 +16072,7 @@
     </p:spTree>
     <p:extLst>
       <p:ext uri="{BB962C8B-B14F-4D97-AF65-F5344CB8AC3E}">
-        <p14:creationId xmlns:p14="http://schemas.microsoft.com/office/powerpoint/2010/main" val="614428849"/>
+        <p14:creationId xmlns:p14="http://schemas.microsoft.com/office/powerpoint/2010/main" val="1083936039"/>
       </p:ext>
     </p:extLst>
   </p:cSld>
@@ -16080,7 +16103,7 @@
           <p:cNvPr id="1" name="eyebrow-5">
             <a:extLst xmlns:a="http://schemas.openxmlformats.org/drawingml/2006/main">
               <a:ext uri="{FF2B5EF4-FFF2-40B4-BE49-F238E27FC236}">
-                <a16:creationId xmlns:a16="http://schemas.microsoft.com/office/drawing/2014/main" id="{E6AE6F28-9C19-4388-A245-3D53097227DA}"/>
+                <a16:creationId xmlns:a16="http://schemas.microsoft.com/office/drawing/2014/main" id="{5B9BE40E-28DB-4212-9028-A1577FDADEE7}"/>
               </a:ext>
             </a:extLst>
           </p:cNvPr>
@@ -16138,7 +16161,7 @@
           <p:cNvPr id="2" name="slide-title-5">
             <a:extLst xmlns:a="http://schemas.openxmlformats.org/drawingml/2006/main">
               <a:ext uri="{FF2B5EF4-FFF2-40B4-BE49-F238E27FC236}">
-                <a16:creationId xmlns:a16="http://schemas.microsoft.com/office/drawing/2014/main" id="{0FA6ED8D-7F6E-47E3-B797-5CD99D1CCEE0}"/>
+                <a16:creationId xmlns:a16="http://schemas.microsoft.com/office/drawing/2014/main" id="{E575DBF8-D26E-4B1E-83A1-5230ADB23088}"/>
               </a:ext>
             </a:extLst>
           </p:cNvPr>
@@ -16196,7 +16219,7 @@
           <p:cNvPr id="3" name="title-rule-5">
             <a:extLst xmlns:a="http://schemas.openxmlformats.org/drawingml/2006/main">
               <a:ext uri="{FF2B5EF4-FFF2-40B4-BE49-F238E27FC236}">
-                <a16:creationId xmlns:a16="http://schemas.microsoft.com/office/drawing/2014/main" id="{B0E15F32-3DF0-432A-B156-8B64F67E2DBB}"/>
+                <a16:creationId xmlns:a16="http://schemas.microsoft.com/office/drawing/2014/main" id="{060B46C7-724D-43EF-A5EE-08D6DC814251}"/>
               </a:ext>
             </a:extLst>
           </p:cNvPr>
@@ -16227,7 +16250,7 @@
           <p:cNvPr id="4" name="page-number-5">
             <a:extLst xmlns:a="http://schemas.openxmlformats.org/drawingml/2006/main">
               <a:ext uri="{FF2B5EF4-FFF2-40B4-BE49-F238E27FC236}">
-                <a16:creationId xmlns:a16="http://schemas.microsoft.com/office/drawing/2014/main" id="{E54FF51A-3902-45CB-B0A1-741FFFA1281C}"/>
+                <a16:creationId xmlns:a16="http://schemas.microsoft.com/office/drawing/2014/main" id="{7140E1FC-09DD-4355-94CA-9AC5BC9D386C}"/>
               </a:ext>
             </a:extLst>
           </p:cNvPr>
@@ -16285,7 +16308,7 @@
           <p:cNvPr id="5" name="frontend">
             <a:extLst xmlns:a="http://schemas.openxmlformats.org/drawingml/2006/main">
               <a:ext uri="{FF2B5EF4-FFF2-40B4-BE49-F238E27FC236}">
-                <a16:creationId xmlns:a16="http://schemas.microsoft.com/office/drawing/2014/main" id="{171C0AAF-F4A2-4AFD-BB4B-DC30B289919E}"/>
+                <a16:creationId xmlns:a16="http://schemas.microsoft.com/office/drawing/2014/main" id="{546331CB-AA26-4236-8909-902113915679}"/>
               </a:ext>
             </a:extLst>
           </p:cNvPr>
@@ -16320,7 +16343,7 @@
           <p:cNvPr id="6" name="text">
             <a:extLst xmlns:a="http://schemas.openxmlformats.org/drawingml/2006/main">
               <a:ext uri="{FF2B5EF4-FFF2-40B4-BE49-F238E27FC236}">
-                <a16:creationId xmlns:a16="http://schemas.microsoft.com/office/drawing/2014/main" id="{57A2A90D-2CB8-4592-856B-728B63AEB475}"/>
+                <a16:creationId xmlns:a16="http://schemas.microsoft.com/office/drawing/2014/main" id="{622AB7E1-C098-4853-AD43-367FFA466165}"/>
               </a:ext>
             </a:extLst>
           </p:cNvPr>
@@ -16378,7 +16401,7 @@
           <p:cNvPr id="7" name="text">
             <a:extLst xmlns:a="http://schemas.openxmlformats.org/drawingml/2006/main">
               <a:ext uri="{FF2B5EF4-FFF2-40B4-BE49-F238E27FC236}">
-                <a16:creationId xmlns:a16="http://schemas.microsoft.com/office/drawing/2014/main" id="{A7154739-149B-439B-BC7E-7850E8FA707B}"/>
+                <a16:creationId xmlns:a16="http://schemas.microsoft.com/office/drawing/2014/main" id="{F40C005E-FB6E-4F84-9A87-360DC11242BD}"/>
               </a:ext>
             </a:extLst>
           </p:cNvPr>
@@ -16436,7 +16459,7 @@
           <p:cNvPr id="8" name="arrow">
             <a:extLst xmlns:a="http://schemas.openxmlformats.org/drawingml/2006/main">
               <a:ext uri="{FF2B5EF4-FFF2-40B4-BE49-F238E27FC236}">
-                <a16:creationId xmlns:a16="http://schemas.microsoft.com/office/drawing/2014/main" id="{EEBD6023-862E-4291-ABFE-8933501D93BC}"/>
+                <a16:creationId xmlns:a16="http://schemas.microsoft.com/office/drawing/2014/main" id="{E3F7DFC5-FF3F-4A76-96BF-D739790D34A7}"/>
               </a:ext>
             </a:extLst>
           </p:cNvPr>
@@ -16494,7 +16517,7 @@
           <p:cNvPr id="9" name="gateway">
             <a:extLst xmlns:a="http://schemas.openxmlformats.org/drawingml/2006/main">
               <a:ext uri="{FF2B5EF4-FFF2-40B4-BE49-F238E27FC236}">
-                <a16:creationId xmlns:a16="http://schemas.microsoft.com/office/drawing/2014/main" id="{57F63529-C5EB-4698-98C3-F751866AA743}"/>
+                <a16:creationId xmlns:a16="http://schemas.microsoft.com/office/drawing/2014/main" id="{21D8F865-9BA3-4AC6-A4EB-F1E413AA26CD}"/>
               </a:ext>
             </a:extLst>
           </p:cNvPr>
@@ -16529,7 +16552,7 @@
           <p:cNvPr id="10" name="text">
             <a:extLst xmlns:a="http://schemas.openxmlformats.org/drawingml/2006/main">
               <a:ext uri="{FF2B5EF4-FFF2-40B4-BE49-F238E27FC236}">
-                <a16:creationId xmlns:a16="http://schemas.microsoft.com/office/drawing/2014/main" id="{36C44DC3-C7F2-4EE9-B554-7C1524798F04}"/>
+                <a16:creationId xmlns:a16="http://schemas.microsoft.com/office/drawing/2014/main" id="{6FAC87F9-BDAE-40A7-95FD-E5097E7AC51B}"/>
               </a:ext>
             </a:extLst>
           </p:cNvPr>
@@ -16587,7 +16610,7 @@
           <p:cNvPr id="11" name="text">
             <a:extLst xmlns:a="http://schemas.openxmlformats.org/drawingml/2006/main">
               <a:ext uri="{FF2B5EF4-FFF2-40B4-BE49-F238E27FC236}">
-                <a16:creationId xmlns:a16="http://schemas.microsoft.com/office/drawing/2014/main" id="{F6C4AF78-C793-4621-9590-80E5F99AB879}"/>
+                <a16:creationId xmlns:a16="http://schemas.microsoft.com/office/drawing/2014/main" id="{75361499-8123-40F0-AD8A-F7010818BA09}"/>
               </a:ext>
             </a:extLst>
           </p:cNvPr>
@@ -16645,7 +16668,7 @@
           <p:cNvPr id="12" name="arrow">
             <a:extLst xmlns:a="http://schemas.openxmlformats.org/drawingml/2006/main">
               <a:ext uri="{FF2B5EF4-FFF2-40B4-BE49-F238E27FC236}">
-                <a16:creationId xmlns:a16="http://schemas.microsoft.com/office/drawing/2014/main" id="{ECFE338F-F47D-499C-BCD5-F4F5330221AC}"/>
+                <a16:creationId xmlns:a16="http://schemas.microsoft.com/office/drawing/2014/main" id="{514CB1BD-FAE3-434B-84C6-D06220C0AF36}"/>
               </a:ext>
             </a:extLst>
           </p:cNvPr>
@@ -16703,7 +16726,7 @@
           <p:cNvPr id="13" name="services">
             <a:extLst xmlns:a="http://schemas.openxmlformats.org/drawingml/2006/main">
               <a:ext uri="{FF2B5EF4-FFF2-40B4-BE49-F238E27FC236}">
-                <a16:creationId xmlns:a16="http://schemas.microsoft.com/office/drawing/2014/main" id="{CEA0E838-146B-49D5-BD1A-ADC034E4E2A3}"/>
+                <a16:creationId xmlns:a16="http://schemas.microsoft.com/office/drawing/2014/main" id="{A4D24C15-B37E-4BD9-964C-435CF4595F65}"/>
               </a:ext>
             </a:extLst>
           </p:cNvPr>
@@ -16738,7 +16761,7 @@
           <p:cNvPr id="14" name="text">
             <a:extLst xmlns:a="http://schemas.openxmlformats.org/drawingml/2006/main">
               <a:ext uri="{FF2B5EF4-FFF2-40B4-BE49-F238E27FC236}">
-                <a16:creationId xmlns:a16="http://schemas.microsoft.com/office/drawing/2014/main" id="{B9C34AD7-9A68-49AD-B2B0-BCCE708E86D3}"/>
+                <a16:creationId xmlns:a16="http://schemas.microsoft.com/office/drawing/2014/main" id="{8C713804-6AB1-4D38-9409-8D0A2F5DE40C}"/>
               </a:ext>
             </a:extLst>
           </p:cNvPr>
@@ -16796,7 +16819,7 @@
           <p:cNvPr id="15" name="svc-0">
             <a:extLst xmlns:a="http://schemas.openxmlformats.org/drawingml/2006/main">
               <a:ext uri="{FF2B5EF4-FFF2-40B4-BE49-F238E27FC236}">
-                <a16:creationId xmlns:a16="http://schemas.microsoft.com/office/drawing/2014/main" id="{EBF36066-C833-4577-BD31-16C6E975AA17}"/>
+                <a16:creationId xmlns:a16="http://schemas.microsoft.com/office/drawing/2014/main" id="{850E1AD0-AB87-4A24-B351-DBB4F44FE1D2}"/>
               </a:ext>
             </a:extLst>
           </p:cNvPr>
@@ -16831,7 +16854,7 @@
           <p:cNvPr id="16" name="text">
             <a:extLst xmlns:a="http://schemas.openxmlformats.org/drawingml/2006/main">
               <a:ext uri="{FF2B5EF4-FFF2-40B4-BE49-F238E27FC236}">
-                <a16:creationId xmlns:a16="http://schemas.microsoft.com/office/drawing/2014/main" id="{58060DA4-6DF1-4ADD-B9EE-7AE7812CB28F}"/>
+                <a16:creationId xmlns:a16="http://schemas.microsoft.com/office/drawing/2014/main" id="{C1E7420F-2312-4A20-B3ED-257F0C71D621}"/>
               </a:ext>
             </a:extLst>
           </p:cNvPr>
@@ -16889,7 +16912,7 @@
           <p:cNvPr id="17" name="svc-1">
             <a:extLst xmlns:a="http://schemas.openxmlformats.org/drawingml/2006/main">
               <a:ext uri="{FF2B5EF4-FFF2-40B4-BE49-F238E27FC236}">
-                <a16:creationId xmlns:a16="http://schemas.microsoft.com/office/drawing/2014/main" id="{2CE8FCFC-8720-4217-898A-8554F9E0D543}"/>
+                <a16:creationId xmlns:a16="http://schemas.microsoft.com/office/drawing/2014/main" id="{2874A7C7-D8C3-40BB-A761-D7AD4F3C7D1A}"/>
               </a:ext>
             </a:extLst>
           </p:cNvPr>
@@ -16924,7 +16947,7 @@
           <p:cNvPr id="18" name="text">
             <a:extLst xmlns:a="http://schemas.openxmlformats.org/drawingml/2006/main">
               <a:ext uri="{FF2B5EF4-FFF2-40B4-BE49-F238E27FC236}">
-                <a16:creationId xmlns:a16="http://schemas.microsoft.com/office/drawing/2014/main" id="{1FE205BB-DD98-4C5B-AFE0-916D7852580E}"/>
+                <a16:creationId xmlns:a16="http://schemas.microsoft.com/office/drawing/2014/main" id="{ECA7CA37-C2B9-4387-81F5-BE88E46E6498}"/>
               </a:ext>
             </a:extLst>
           </p:cNvPr>
@@ -16982,7 +17005,7 @@
           <p:cNvPr id="19" name="svc-2">
             <a:extLst xmlns:a="http://schemas.openxmlformats.org/drawingml/2006/main">
               <a:ext uri="{FF2B5EF4-FFF2-40B4-BE49-F238E27FC236}">
-                <a16:creationId xmlns:a16="http://schemas.microsoft.com/office/drawing/2014/main" id="{D0316B4D-5166-4391-927F-44085E1C70D4}"/>
+                <a16:creationId xmlns:a16="http://schemas.microsoft.com/office/drawing/2014/main" id="{6F3559F7-93A6-49CB-940D-8CE12D26D9CC}"/>
               </a:ext>
             </a:extLst>
           </p:cNvPr>
@@ -17017,7 +17040,7 @@
           <p:cNvPr id="20" name="text">
             <a:extLst xmlns:a="http://schemas.openxmlformats.org/drawingml/2006/main">
               <a:ext uri="{FF2B5EF4-FFF2-40B4-BE49-F238E27FC236}">
-                <a16:creationId xmlns:a16="http://schemas.microsoft.com/office/drawing/2014/main" id="{F8039CF3-CEB3-454D-8C13-93EA1507887F}"/>
+                <a16:creationId xmlns:a16="http://schemas.microsoft.com/office/drawing/2014/main" id="{9177F9DD-A613-48DD-B157-B839F5F0F51E}"/>
               </a:ext>
             </a:extLst>
           </p:cNvPr>
@@ -17075,7 +17098,7 @@
           <p:cNvPr id="21" name="svc-3">
             <a:extLst xmlns:a="http://schemas.openxmlformats.org/drawingml/2006/main">
               <a:ext uri="{FF2B5EF4-FFF2-40B4-BE49-F238E27FC236}">
-                <a16:creationId xmlns:a16="http://schemas.microsoft.com/office/drawing/2014/main" id="{1A3C3605-039E-47F3-AB00-52340FFB77CE}"/>
+                <a16:creationId xmlns:a16="http://schemas.microsoft.com/office/drawing/2014/main" id="{A8702189-F552-4904-9C55-6CAA4D77EF17}"/>
               </a:ext>
             </a:extLst>
           </p:cNvPr>
@@ -17110,7 +17133,7 @@
           <p:cNvPr id="22" name="text">
             <a:extLst xmlns:a="http://schemas.openxmlformats.org/drawingml/2006/main">
               <a:ext uri="{FF2B5EF4-FFF2-40B4-BE49-F238E27FC236}">
-                <a16:creationId xmlns:a16="http://schemas.microsoft.com/office/drawing/2014/main" id="{9A644A46-638E-42A5-89E6-845B7EFAEB99}"/>
+                <a16:creationId xmlns:a16="http://schemas.microsoft.com/office/drawing/2014/main" id="{B1D50027-A1E7-4CEE-9385-979BEAB00BBE}"/>
               </a:ext>
             </a:extLst>
           </p:cNvPr>
@@ -17168,7 +17191,7 @@
           <p:cNvPr id="23" name="svc-4">
             <a:extLst xmlns:a="http://schemas.openxmlformats.org/drawingml/2006/main">
               <a:ext uri="{FF2B5EF4-FFF2-40B4-BE49-F238E27FC236}">
-                <a16:creationId xmlns:a16="http://schemas.microsoft.com/office/drawing/2014/main" id="{7B0C7CD7-4D53-4A34-83E0-A8DEB7A740EE}"/>
+                <a16:creationId xmlns:a16="http://schemas.microsoft.com/office/drawing/2014/main" id="{7F29C5C5-5E2D-40B6-A082-AA5FA86D3C48}"/>
               </a:ext>
             </a:extLst>
           </p:cNvPr>
@@ -17203,7 +17226,7 @@
           <p:cNvPr id="24" name="text">
             <a:extLst xmlns:a="http://schemas.openxmlformats.org/drawingml/2006/main">
               <a:ext uri="{FF2B5EF4-FFF2-40B4-BE49-F238E27FC236}">
-                <a16:creationId xmlns:a16="http://schemas.microsoft.com/office/drawing/2014/main" id="{EB4BD990-CE79-4BCE-9B44-F17542E87187}"/>
+                <a16:creationId xmlns:a16="http://schemas.microsoft.com/office/drawing/2014/main" id="{9CBA433C-2214-4631-885F-462C7DAF2768}"/>
               </a:ext>
             </a:extLst>
           </p:cNvPr>
@@ -17261,7 +17284,7 @@
           <p:cNvPr id="25" name="svc-5">
             <a:extLst xmlns:a="http://schemas.openxmlformats.org/drawingml/2006/main">
               <a:ext uri="{FF2B5EF4-FFF2-40B4-BE49-F238E27FC236}">
-                <a16:creationId xmlns:a16="http://schemas.microsoft.com/office/drawing/2014/main" id="{A60D16FB-52F2-4A0A-A648-BC39A5EED3D2}"/>
+                <a16:creationId xmlns:a16="http://schemas.microsoft.com/office/drawing/2014/main" id="{D5356102-40D1-479B-8510-1CC3EC879536}"/>
               </a:ext>
             </a:extLst>
           </p:cNvPr>
@@ -17296,7 +17319,7 @@
           <p:cNvPr id="26" name="text">
             <a:extLst xmlns:a="http://schemas.openxmlformats.org/drawingml/2006/main">
               <a:ext uri="{FF2B5EF4-FFF2-40B4-BE49-F238E27FC236}">
-                <a16:creationId xmlns:a16="http://schemas.microsoft.com/office/drawing/2014/main" id="{A95058CF-335F-4F6A-B23A-7572D075F5B5}"/>
+                <a16:creationId xmlns:a16="http://schemas.microsoft.com/office/drawing/2014/main" id="{8C766F43-CC61-4325-888F-68DB13B7C762}"/>
               </a:ext>
             </a:extLst>
           </p:cNvPr>
@@ -17354,7 +17377,7 @@
           <p:cNvPr id="27" name="text">
             <a:extLst xmlns:a="http://schemas.openxmlformats.org/drawingml/2006/main">
               <a:ext uri="{FF2B5EF4-FFF2-40B4-BE49-F238E27FC236}">
-                <a16:creationId xmlns:a16="http://schemas.microsoft.com/office/drawing/2014/main" id="{2B265F40-003F-4AF2-A56F-B2ED837A995D}"/>
+                <a16:creationId xmlns:a16="http://schemas.microsoft.com/office/drawing/2014/main" id="{4C541836-2E0D-4749-9E88-286EB5F53F04}"/>
               </a:ext>
             </a:extLst>
           </p:cNvPr>
@@ -17412,7 +17435,7 @@
           <p:cNvPr id="28" name="data-0">
             <a:extLst xmlns:a="http://schemas.openxmlformats.org/drawingml/2006/main">
               <a:ext uri="{FF2B5EF4-FFF2-40B4-BE49-F238E27FC236}">
-                <a16:creationId xmlns:a16="http://schemas.microsoft.com/office/drawing/2014/main" id="{6CF877EC-D5B2-4A7C-8C0E-8099D379B237}"/>
+                <a16:creationId xmlns:a16="http://schemas.microsoft.com/office/drawing/2014/main" id="{1C8F470E-E781-4FB8-8846-B66A8B1D5B01}"/>
               </a:ext>
             </a:extLst>
           </p:cNvPr>
@@ -17447,7 +17470,7 @@
           <p:cNvPr id="29" name="text">
             <a:extLst xmlns:a="http://schemas.openxmlformats.org/drawingml/2006/main">
               <a:ext uri="{FF2B5EF4-FFF2-40B4-BE49-F238E27FC236}">
-                <a16:creationId xmlns:a16="http://schemas.microsoft.com/office/drawing/2014/main" id="{FF1D6E30-67EF-4F20-9A0E-21AA3EE5D065}"/>
+                <a16:creationId xmlns:a16="http://schemas.microsoft.com/office/drawing/2014/main" id="{816D4769-74B9-4AC8-9806-7BF2CB1F7A69}"/>
               </a:ext>
             </a:extLst>
           </p:cNvPr>
@@ -17505,7 +17528,7 @@
           <p:cNvPr id="30" name="data-1">
             <a:extLst xmlns:a="http://schemas.openxmlformats.org/drawingml/2006/main">
               <a:ext uri="{FF2B5EF4-FFF2-40B4-BE49-F238E27FC236}">
-                <a16:creationId xmlns:a16="http://schemas.microsoft.com/office/drawing/2014/main" id="{27EE8E5A-755F-41E3-A4C5-440C25FF5F1C}"/>
+                <a16:creationId xmlns:a16="http://schemas.microsoft.com/office/drawing/2014/main" id="{14806966-0E04-4CB8-BD1B-EDB2872D01EB}"/>
               </a:ext>
             </a:extLst>
           </p:cNvPr>
@@ -17540,7 +17563,7 @@
           <p:cNvPr id="31" name="text">
             <a:extLst xmlns:a="http://schemas.openxmlformats.org/drawingml/2006/main">
               <a:ext uri="{FF2B5EF4-FFF2-40B4-BE49-F238E27FC236}">
-                <a16:creationId xmlns:a16="http://schemas.microsoft.com/office/drawing/2014/main" id="{7A3DB6F4-BAF1-430A-A412-51FCCA88111B}"/>
+                <a16:creationId xmlns:a16="http://schemas.microsoft.com/office/drawing/2014/main" id="{7960EB4C-7856-48CB-843F-07DE7707B9E2}"/>
               </a:ext>
             </a:extLst>
           </p:cNvPr>
@@ -17598,7 +17621,7 @@
           <p:cNvPr id="32" name="data-2">
             <a:extLst xmlns:a="http://schemas.openxmlformats.org/drawingml/2006/main">
               <a:ext uri="{FF2B5EF4-FFF2-40B4-BE49-F238E27FC236}">
-                <a16:creationId xmlns:a16="http://schemas.microsoft.com/office/drawing/2014/main" id="{2761D84E-CE7A-4132-ACD7-71D68A665EE4}"/>
+                <a16:creationId xmlns:a16="http://schemas.microsoft.com/office/drawing/2014/main" id="{3856C806-359C-43A3-9BC4-7BDAE1829B0B}"/>
               </a:ext>
             </a:extLst>
           </p:cNvPr>
@@ -17633,7 +17656,7 @@
           <p:cNvPr id="33" name="text">
             <a:extLst xmlns:a="http://schemas.openxmlformats.org/drawingml/2006/main">
               <a:ext uri="{FF2B5EF4-FFF2-40B4-BE49-F238E27FC236}">
-                <a16:creationId xmlns:a16="http://schemas.microsoft.com/office/drawing/2014/main" id="{6A0EE304-A456-4189-9CE5-B8FDB83C5AAF}"/>
+                <a16:creationId xmlns:a16="http://schemas.microsoft.com/office/drawing/2014/main" id="{FC6BA6E5-9900-410F-BA59-90768253BF5F}"/>
               </a:ext>
             </a:extLst>
           </p:cNvPr>
@@ -17691,7 +17714,7 @@
           <p:cNvPr id="34" name="text">
             <a:extLst xmlns:a="http://schemas.openxmlformats.org/drawingml/2006/main">
               <a:ext uri="{FF2B5EF4-FFF2-40B4-BE49-F238E27FC236}">
-                <a16:creationId xmlns:a16="http://schemas.microsoft.com/office/drawing/2014/main" id="{741E5C89-20F0-4F1A-8D85-DEA150B9AC6E}"/>
+                <a16:creationId xmlns:a16="http://schemas.microsoft.com/office/drawing/2014/main" id="{111DA53E-E148-41CF-B696-A798BC3F6CE1}"/>
               </a:ext>
             </a:extLst>
           </p:cNvPr>
@@ -17749,7 +17772,7 @@
           <p:cNvPr id="35" name="text">
             <a:extLst xmlns:a="http://schemas.openxmlformats.org/drawingml/2006/main">
               <a:ext uri="{FF2B5EF4-FFF2-40B4-BE49-F238E27FC236}">
-                <a16:creationId xmlns:a16="http://schemas.microsoft.com/office/drawing/2014/main" id="{068A6239-ACD5-4A34-BF8B-A26726BF9C84}"/>
+                <a16:creationId xmlns:a16="http://schemas.microsoft.com/office/drawing/2014/main" id="{ADC91F28-56A0-46DC-AE61-EDC471A25D9C}"/>
               </a:ext>
             </a:extLst>
           </p:cNvPr>
@@ -17807,7 +17830,7 @@
           <p:cNvPr id="36" name="text">
             <a:extLst xmlns:a="http://schemas.openxmlformats.org/drawingml/2006/main">
               <a:ext uri="{FF2B5EF4-FFF2-40B4-BE49-F238E27FC236}">
-                <a16:creationId xmlns:a16="http://schemas.microsoft.com/office/drawing/2014/main" id="{D4EA686A-B9C3-467E-A7B1-59D45FC7FE0A}"/>
+                <a16:creationId xmlns:a16="http://schemas.microsoft.com/office/drawing/2014/main" id="{985A1B26-C866-476A-AFA8-50FB2E059B1E}"/>
               </a:ext>
             </a:extLst>
           </p:cNvPr>
@@ -17863,7 +17886,7 @@
     </p:spTree>
     <p:extLst>
       <p:ext uri="{BB962C8B-B14F-4D97-AF65-F5344CB8AC3E}">
-        <p14:creationId xmlns:p14="http://schemas.microsoft.com/office/powerpoint/2010/main" val="735434829"/>
+        <p14:creationId xmlns:p14="http://schemas.microsoft.com/office/powerpoint/2010/main" val="2033486422"/>
       </p:ext>
     </p:extLst>
   </p:cSld>
@@ -17894,7 +17917,7 @@
           <p:cNvPr id="1" name="eyebrow-6">
             <a:extLst xmlns:a="http://schemas.openxmlformats.org/drawingml/2006/main">
               <a:ext uri="{FF2B5EF4-FFF2-40B4-BE49-F238E27FC236}">
-                <a16:creationId xmlns:a16="http://schemas.microsoft.com/office/drawing/2014/main" id="{01FF97B6-A064-4A89-ACEB-1EA7ECAA1042}"/>
+                <a16:creationId xmlns:a16="http://schemas.microsoft.com/office/drawing/2014/main" id="{2B29BB84-C190-4EBB-9650-D40C0413C196}"/>
               </a:ext>
             </a:extLst>
           </p:cNvPr>
@@ -17952,7 +17975,7 @@
           <p:cNvPr id="2" name="slide-title-6">
             <a:extLst xmlns:a="http://schemas.openxmlformats.org/drawingml/2006/main">
               <a:ext uri="{FF2B5EF4-FFF2-40B4-BE49-F238E27FC236}">
-                <a16:creationId xmlns:a16="http://schemas.microsoft.com/office/drawing/2014/main" id="{8C63B1AE-FF50-444D-AB2E-9ED7A9CD2469}"/>
+                <a16:creationId xmlns:a16="http://schemas.microsoft.com/office/drawing/2014/main" id="{BF3BB672-8411-4218-B148-591F37D7CC06}"/>
               </a:ext>
             </a:extLst>
           </p:cNvPr>
@@ -18010,7 +18033,7 @@
           <p:cNvPr id="3" name="title-rule-6">
             <a:extLst xmlns:a="http://schemas.openxmlformats.org/drawingml/2006/main">
               <a:ext uri="{FF2B5EF4-FFF2-40B4-BE49-F238E27FC236}">
-                <a16:creationId xmlns:a16="http://schemas.microsoft.com/office/drawing/2014/main" id="{295DCBC0-C6E8-49FC-95EA-313487D078FE}"/>
+                <a16:creationId xmlns:a16="http://schemas.microsoft.com/office/drawing/2014/main" id="{F7502872-683C-48E2-BCFA-8C12DEFD23F8}"/>
               </a:ext>
             </a:extLst>
           </p:cNvPr>
@@ -18041,7 +18064,7 @@
           <p:cNvPr id="4" name="page-number-6">
             <a:extLst xmlns:a="http://schemas.openxmlformats.org/drawingml/2006/main">
               <a:ext uri="{FF2B5EF4-FFF2-40B4-BE49-F238E27FC236}">
-                <a16:creationId xmlns:a16="http://schemas.microsoft.com/office/drawing/2014/main" id="{720ABC27-6640-4E92-8AF3-5881BF43A64E}"/>
+                <a16:creationId xmlns:a16="http://schemas.microsoft.com/office/drawing/2014/main" id="{921379BD-4AE9-4D44-9673-1B519B7F6556}"/>
               </a:ext>
             </a:extLst>
           </p:cNvPr>
@@ -18099,7 +18122,7 @@
           <p:cNvPr id="5" name="module-0">
             <a:extLst xmlns:a="http://schemas.openxmlformats.org/drawingml/2006/main">
               <a:ext uri="{FF2B5EF4-FFF2-40B4-BE49-F238E27FC236}">
-                <a16:creationId xmlns:a16="http://schemas.microsoft.com/office/drawing/2014/main" id="{D71B00D1-DC65-4570-B183-20572542EDBF}"/>
+                <a16:creationId xmlns:a16="http://schemas.microsoft.com/office/drawing/2014/main" id="{4CA10E4A-3A68-42F7-A435-C703ECEEAA6B}"/>
               </a:ext>
             </a:extLst>
           </p:cNvPr>
@@ -18134,7 +18157,7 @@
           <p:cNvPr id="6" name="module-accent-0">
             <a:extLst xmlns:a="http://schemas.openxmlformats.org/drawingml/2006/main">
               <a:ext uri="{FF2B5EF4-FFF2-40B4-BE49-F238E27FC236}">
-                <a16:creationId xmlns:a16="http://schemas.microsoft.com/office/drawing/2014/main" id="{C3AEE24A-17E4-475D-BAD8-61E44817F38B}"/>
+                <a16:creationId xmlns:a16="http://schemas.microsoft.com/office/drawing/2014/main" id="{AFA4E022-E84F-4BC6-BD4A-EA281A4BC97D}"/>
               </a:ext>
             </a:extLst>
           </p:cNvPr>
@@ -18165,7 +18188,7 @@
           <p:cNvPr id="7" name="text">
             <a:extLst xmlns:a="http://schemas.openxmlformats.org/drawingml/2006/main">
               <a:ext uri="{FF2B5EF4-FFF2-40B4-BE49-F238E27FC236}">
-                <a16:creationId xmlns:a16="http://schemas.microsoft.com/office/drawing/2014/main" id="{8FECA71F-158A-43E1-8CBC-FAC181D75751}"/>
+                <a16:creationId xmlns:a16="http://schemas.microsoft.com/office/drawing/2014/main" id="{F318465D-7F42-4A94-9373-A70B68F7F435}"/>
               </a:ext>
             </a:extLst>
           </p:cNvPr>
@@ -18223,7 +18246,7 @@
           <p:cNvPr id="8" name="text">
             <a:extLst xmlns:a="http://schemas.openxmlformats.org/drawingml/2006/main">
               <a:ext uri="{FF2B5EF4-FFF2-40B4-BE49-F238E27FC236}">
-                <a16:creationId xmlns:a16="http://schemas.microsoft.com/office/drawing/2014/main" id="{EAA82A44-29B5-4E8A-8604-C43700B85404}"/>
+                <a16:creationId xmlns:a16="http://schemas.microsoft.com/office/drawing/2014/main" id="{9E16BA05-91B6-4899-9E98-3030CBC2050A}"/>
               </a:ext>
             </a:extLst>
           </p:cNvPr>
@@ -18281,7 +18304,7 @@
           <p:cNvPr id="9" name="text">
             <a:extLst xmlns:a="http://schemas.openxmlformats.org/drawingml/2006/main">
               <a:ext uri="{FF2B5EF4-FFF2-40B4-BE49-F238E27FC236}">
-                <a16:creationId xmlns:a16="http://schemas.microsoft.com/office/drawing/2014/main" id="{3EA02513-18C8-4F6C-BFEB-0EF37C7BA2E8}"/>
+                <a16:creationId xmlns:a16="http://schemas.microsoft.com/office/drawing/2014/main" id="{30120865-0A55-45AA-9F55-E0B4CA1A1728}"/>
               </a:ext>
             </a:extLst>
           </p:cNvPr>
@@ -18339,7 +18362,7 @@
           <p:cNvPr id="10" name="module-1">
             <a:extLst xmlns:a="http://schemas.openxmlformats.org/drawingml/2006/main">
               <a:ext uri="{FF2B5EF4-FFF2-40B4-BE49-F238E27FC236}">
-                <a16:creationId xmlns:a16="http://schemas.microsoft.com/office/drawing/2014/main" id="{91A2AEAD-1A73-4BC7-A64E-9950BD115672}"/>
+                <a16:creationId xmlns:a16="http://schemas.microsoft.com/office/drawing/2014/main" id="{AFB66A20-EFDA-491A-8FCF-BF35E1FDB83E}"/>
               </a:ext>
             </a:extLst>
           </p:cNvPr>
@@ -18374,7 +18397,7 @@
           <p:cNvPr id="11" name="module-accent-1">
             <a:extLst xmlns:a="http://schemas.openxmlformats.org/drawingml/2006/main">
               <a:ext uri="{FF2B5EF4-FFF2-40B4-BE49-F238E27FC236}">
-                <a16:creationId xmlns:a16="http://schemas.microsoft.com/office/drawing/2014/main" id="{5DC0F5DC-3C58-430D-8654-A26EBEA16D3B}"/>
+                <a16:creationId xmlns:a16="http://schemas.microsoft.com/office/drawing/2014/main" id="{C78EA3AD-9B6A-4841-9755-9F0EE4D20D4E}"/>
               </a:ext>
             </a:extLst>
           </p:cNvPr>
@@ -18405,7 +18428,7 @@
           <p:cNvPr id="12" name="text">
             <a:extLst xmlns:a="http://schemas.openxmlformats.org/drawingml/2006/main">
               <a:ext uri="{FF2B5EF4-FFF2-40B4-BE49-F238E27FC236}">
-                <a16:creationId xmlns:a16="http://schemas.microsoft.com/office/drawing/2014/main" id="{566E95A4-C4D5-49D4-A15B-AE8EEE6F83C5}"/>
+                <a16:creationId xmlns:a16="http://schemas.microsoft.com/office/drawing/2014/main" id="{F88AFF27-44E9-4FAB-898A-F6790B03F453}"/>
               </a:ext>
             </a:extLst>
           </p:cNvPr>
@@ -18463,7 +18486,7 @@
           <p:cNvPr id="13" name="text">
             <a:extLst xmlns:a="http://schemas.openxmlformats.org/drawingml/2006/main">
               <a:ext uri="{FF2B5EF4-FFF2-40B4-BE49-F238E27FC236}">
-                <a16:creationId xmlns:a16="http://schemas.microsoft.com/office/drawing/2014/main" id="{E5495CDB-5CAB-43C0-89B8-D8C9533E019F}"/>
+                <a16:creationId xmlns:a16="http://schemas.microsoft.com/office/drawing/2014/main" id="{E24F71BC-2767-4374-BEEC-72971E314A1D}"/>
               </a:ext>
             </a:extLst>
           </p:cNvPr>
@@ -18521,7 +18544,7 @@
           <p:cNvPr id="14" name="text">
             <a:extLst xmlns:a="http://schemas.openxmlformats.org/drawingml/2006/main">
               <a:ext uri="{FF2B5EF4-FFF2-40B4-BE49-F238E27FC236}">
-                <a16:creationId xmlns:a16="http://schemas.microsoft.com/office/drawing/2014/main" id="{6BB8C0D6-2C51-49E1-8477-2A42609C2305}"/>
+                <a16:creationId xmlns:a16="http://schemas.microsoft.com/office/drawing/2014/main" id="{183666BA-9C85-4F0A-B569-37304219FF83}"/>
               </a:ext>
             </a:extLst>
           </p:cNvPr>
@@ -18579,7 +18602,7 @@
           <p:cNvPr id="15" name="module-2">
             <a:extLst xmlns:a="http://schemas.openxmlformats.org/drawingml/2006/main">
               <a:ext uri="{FF2B5EF4-FFF2-40B4-BE49-F238E27FC236}">
-                <a16:creationId xmlns:a16="http://schemas.microsoft.com/office/drawing/2014/main" id="{2FDDD82D-0186-42B7-84F3-C27395FEA3F0}"/>
+                <a16:creationId xmlns:a16="http://schemas.microsoft.com/office/drawing/2014/main" id="{BD87E7F4-C0D6-4270-8BB8-A7631C7ACFD7}"/>
               </a:ext>
             </a:extLst>
           </p:cNvPr>
@@ -18614,7 +18637,7 @@
           <p:cNvPr id="16" name="module-accent-2">
             <a:extLst xmlns:a="http://schemas.openxmlformats.org/drawingml/2006/main">
               <a:ext uri="{FF2B5EF4-FFF2-40B4-BE49-F238E27FC236}">
-                <a16:creationId xmlns:a16="http://schemas.microsoft.com/office/drawing/2014/main" id="{8695AEB4-286A-4505-8E95-F3BF285AB8C0}"/>
+                <a16:creationId xmlns:a16="http://schemas.microsoft.com/office/drawing/2014/main" id="{D35BB94F-D844-48D4-B042-D68D821B84F4}"/>
               </a:ext>
             </a:extLst>
           </p:cNvPr>
@@ -18645,7 +18668,7 @@
           <p:cNvPr id="17" name="text">
             <a:extLst xmlns:a="http://schemas.openxmlformats.org/drawingml/2006/main">
               <a:ext uri="{FF2B5EF4-FFF2-40B4-BE49-F238E27FC236}">
-                <a16:creationId xmlns:a16="http://schemas.microsoft.com/office/drawing/2014/main" id="{2DDBDF84-7655-4082-B27C-4AF45FD218C7}"/>
+                <a16:creationId xmlns:a16="http://schemas.microsoft.com/office/drawing/2014/main" id="{8A70F0FF-EE90-43C9-99C0-8EDA9FDA40B1}"/>
               </a:ext>
             </a:extLst>
           </p:cNvPr>
@@ -18703,7 +18726,7 @@
           <p:cNvPr id="18" name="text">
             <a:extLst xmlns:a="http://schemas.openxmlformats.org/drawingml/2006/main">
               <a:ext uri="{FF2B5EF4-FFF2-40B4-BE49-F238E27FC236}">
-                <a16:creationId xmlns:a16="http://schemas.microsoft.com/office/drawing/2014/main" id="{E8D3EEF0-0B84-4FE4-9147-6AFEE6DD50DD}"/>
+                <a16:creationId xmlns:a16="http://schemas.microsoft.com/office/drawing/2014/main" id="{A97C25BE-03C0-4873-B779-1B49779A61A7}"/>
               </a:ext>
             </a:extLst>
           </p:cNvPr>
@@ -18761,7 +18784,7 @@
           <p:cNvPr id="19" name="text">
             <a:extLst xmlns:a="http://schemas.openxmlformats.org/drawingml/2006/main">
               <a:ext uri="{FF2B5EF4-FFF2-40B4-BE49-F238E27FC236}">
-                <a16:creationId xmlns:a16="http://schemas.microsoft.com/office/drawing/2014/main" id="{C30816B0-03EB-4433-B1EC-6E3C0FBC9727}"/>
+                <a16:creationId xmlns:a16="http://schemas.microsoft.com/office/drawing/2014/main" id="{3A58D8D0-3031-4798-BBB7-42C6735F5F27}"/>
               </a:ext>
             </a:extLst>
           </p:cNvPr>
@@ -18819,7 +18842,7 @@
           <p:cNvPr id="20" name="module-3">
             <a:extLst xmlns:a="http://schemas.openxmlformats.org/drawingml/2006/main">
               <a:ext uri="{FF2B5EF4-FFF2-40B4-BE49-F238E27FC236}">
-                <a16:creationId xmlns:a16="http://schemas.microsoft.com/office/drawing/2014/main" id="{3247CACA-23E9-4C81-AB68-219E3A520949}"/>
+                <a16:creationId xmlns:a16="http://schemas.microsoft.com/office/drawing/2014/main" id="{C1E4FCEE-F6F7-4630-A23A-CA3D8978A8E2}"/>
               </a:ext>
             </a:extLst>
           </p:cNvPr>
@@ -18854,7 +18877,7 @@
           <p:cNvPr id="21" name="module-accent-3">
             <a:extLst xmlns:a="http://schemas.openxmlformats.org/drawingml/2006/main">
               <a:ext uri="{FF2B5EF4-FFF2-40B4-BE49-F238E27FC236}">
-                <a16:creationId xmlns:a16="http://schemas.microsoft.com/office/drawing/2014/main" id="{7B29F22D-9513-42DE-BE6E-EFA77693A5E6}"/>
+                <a16:creationId xmlns:a16="http://schemas.microsoft.com/office/drawing/2014/main" id="{90876642-1C11-4BF9-8A6A-12ECCE070F97}"/>
               </a:ext>
             </a:extLst>
           </p:cNvPr>
@@ -18885,7 +18908,7 @@
           <p:cNvPr id="22" name="text">
             <a:extLst xmlns:a="http://schemas.openxmlformats.org/drawingml/2006/main">
               <a:ext uri="{FF2B5EF4-FFF2-40B4-BE49-F238E27FC236}">
-                <a16:creationId xmlns:a16="http://schemas.microsoft.com/office/drawing/2014/main" id="{2A65C7BE-7890-4AB8-ACEB-EA396FA39EA3}"/>
+                <a16:creationId xmlns:a16="http://schemas.microsoft.com/office/drawing/2014/main" id="{3C41D231-FFE7-405D-80E2-5665196033AC}"/>
               </a:ext>
             </a:extLst>
           </p:cNvPr>
@@ -18943,7 +18966,7 @@
           <p:cNvPr id="23" name="text">
             <a:extLst xmlns:a="http://schemas.openxmlformats.org/drawingml/2006/main">
               <a:ext uri="{FF2B5EF4-FFF2-40B4-BE49-F238E27FC236}">
-                <a16:creationId xmlns:a16="http://schemas.microsoft.com/office/drawing/2014/main" id="{D36733CA-CC91-4DA3-BFE3-516299598AF4}"/>
+                <a16:creationId xmlns:a16="http://schemas.microsoft.com/office/drawing/2014/main" id="{F19D1012-264B-49B6-8A79-72DB32692C8C}"/>
               </a:ext>
             </a:extLst>
           </p:cNvPr>
@@ -19001,7 +19024,7 @@
           <p:cNvPr id="24" name="text">
             <a:extLst xmlns:a="http://schemas.openxmlformats.org/drawingml/2006/main">
               <a:ext uri="{FF2B5EF4-FFF2-40B4-BE49-F238E27FC236}">
-                <a16:creationId xmlns:a16="http://schemas.microsoft.com/office/drawing/2014/main" id="{439D03B6-3680-4BF8-B53F-02ACB6CE4DA5}"/>
+                <a16:creationId xmlns:a16="http://schemas.microsoft.com/office/drawing/2014/main" id="{9E27AD96-60DC-4C9E-965A-CBF15B710A7C}"/>
               </a:ext>
             </a:extLst>
           </p:cNvPr>
@@ -19059,7 +19082,7 @@
           <p:cNvPr id="25" name="module-4">
             <a:extLst xmlns:a="http://schemas.openxmlformats.org/drawingml/2006/main">
               <a:ext uri="{FF2B5EF4-FFF2-40B4-BE49-F238E27FC236}">
-                <a16:creationId xmlns:a16="http://schemas.microsoft.com/office/drawing/2014/main" id="{CFB56D99-DF1A-4E9E-8A65-624BA4FDFCB3}"/>
+                <a16:creationId xmlns:a16="http://schemas.microsoft.com/office/drawing/2014/main" id="{9974CECE-4ABA-4F82-B280-23072BED9734}"/>
               </a:ext>
             </a:extLst>
           </p:cNvPr>
@@ -19094,7 +19117,7 @@
           <p:cNvPr id="26" name="module-accent-4">
             <a:extLst xmlns:a="http://schemas.openxmlformats.org/drawingml/2006/main">
               <a:ext uri="{FF2B5EF4-FFF2-40B4-BE49-F238E27FC236}">
-                <a16:creationId xmlns:a16="http://schemas.microsoft.com/office/drawing/2014/main" id="{30A44368-3A6C-463F-8B3C-60D9A3D2EB97}"/>
+                <a16:creationId xmlns:a16="http://schemas.microsoft.com/office/drawing/2014/main" id="{293D6752-ECE5-42CA-BA9A-C4EFF12D0BB5}"/>
               </a:ext>
             </a:extLst>
           </p:cNvPr>
@@ -19125,7 +19148,7 @@
           <p:cNvPr id="27" name="text">
             <a:extLst xmlns:a="http://schemas.openxmlformats.org/drawingml/2006/main">
               <a:ext uri="{FF2B5EF4-FFF2-40B4-BE49-F238E27FC236}">
-                <a16:creationId xmlns:a16="http://schemas.microsoft.com/office/drawing/2014/main" id="{98F8ACEE-4010-4DAB-AB59-B3F05934FFB2}"/>
+                <a16:creationId xmlns:a16="http://schemas.microsoft.com/office/drawing/2014/main" id="{939D738D-06A2-42B9-92D4-56E7A29CA775}"/>
               </a:ext>
             </a:extLst>
           </p:cNvPr>
@@ -19183,7 +19206,7 @@
           <p:cNvPr id="28" name="text">
             <a:extLst xmlns:a="http://schemas.openxmlformats.org/drawingml/2006/main">
               <a:ext uri="{FF2B5EF4-FFF2-40B4-BE49-F238E27FC236}">
-                <a16:creationId xmlns:a16="http://schemas.microsoft.com/office/drawing/2014/main" id="{0AFBB962-3B04-4C60-BA5E-4BA8C616F1DA}"/>
+                <a16:creationId xmlns:a16="http://schemas.microsoft.com/office/drawing/2014/main" id="{A8244A59-8A23-43CD-A025-EE3668D1659D}"/>
               </a:ext>
             </a:extLst>
           </p:cNvPr>
@@ -19241,7 +19264,7 @@
           <p:cNvPr id="29" name="text">
             <a:extLst xmlns:a="http://schemas.openxmlformats.org/drawingml/2006/main">
               <a:ext uri="{FF2B5EF4-FFF2-40B4-BE49-F238E27FC236}">
-                <a16:creationId xmlns:a16="http://schemas.microsoft.com/office/drawing/2014/main" id="{371C2620-907B-46CD-A438-104246A54501}"/>
+                <a16:creationId xmlns:a16="http://schemas.microsoft.com/office/drawing/2014/main" id="{29BEE0DE-D2B8-409F-BEFA-49665F39A56E}"/>
               </a:ext>
             </a:extLst>
           </p:cNvPr>
@@ -19299,7 +19322,7 @@
           <p:cNvPr id="30" name="module-5">
             <a:extLst xmlns:a="http://schemas.openxmlformats.org/drawingml/2006/main">
               <a:ext uri="{FF2B5EF4-FFF2-40B4-BE49-F238E27FC236}">
-                <a16:creationId xmlns:a16="http://schemas.microsoft.com/office/drawing/2014/main" id="{22408E11-EC2A-4395-B35D-BFA5BD3F3393}"/>
+                <a16:creationId xmlns:a16="http://schemas.microsoft.com/office/drawing/2014/main" id="{64DB0E08-13B2-42DE-B8A6-3205880B37DE}"/>
               </a:ext>
             </a:extLst>
           </p:cNvPr>
@@ -19334,7 +19357,7 @@
           <p:cNvPr id="31" name="module-accent-5">
             <a:extLst xmlns:a="http://schemas.openxmlformats.org/drawingml/2006/main">
               <a:ext uri="{FF2B5EF4-FFF2-40B4-BE49-F238E27FC236}">
-                <a16:creationId xmlns:a16="http://schemas.microsoft.com/office/drawing/2014/main" id="{B61A980E-E002-40FF-9917-26749873A7E5}"/>
+                <a16:creationId xmlns:a16="http://schemas.microsoft.com/office/drawing/2014/main" id="{43885CC2-46A3-414D-90A9-F9D99D396595}"/>
               </a:ext>
             </a:extLst>
           </p:cNvPr>
@@ -19365,7 +19388,7 @@
           <p:cNvPr id="32" name="text">
             <a:extLst xmlns:a="http://schemas.openxmlformats.org/drawingml/2006/main">
               <a:ext uri="{FF2B5EF4-FFF2-40B4-BE49-F238E27FC236}">
-                <a16:creationId xmlns:a16="http://schemas.microsoft.com/office/drawing/2014/main" id="{C25AE41E-1041-43FC-9131-CD9984E2FEF9}"/>
+                <a16:creationId xmlns:a16="http://schemas.microsoft.com/office/drawing/2014/main" id="{B5C46AA2-D526-4A65-ABB7-8652ED11EC1F}"/>
               </a:ext>
             </a:extLst>
           </p:cNvPr>
@@ -19423,7 +19446,7 @@
           <p:cNvPr id="33" name="text">
             <a:extLst xmlns:a="http://schemas.openxmlformats.org/drawingml/2006/main">
               <a:ext uri="{FF2B5EF4-FFF2-40B4-BE49-F238E27FC236}">
-                <a16:creationId xmlns:a16="http://schemas.microsoft.com/office/drawing/2014/main" id="{D418FBF0-ACCC-422A-B91B-1F4551426106}"/>
+                <a16:creationId xmlns:a16="http://schemas.microsoft.com/office/drawing/2014/main" id="{0E4471A4-C84F-4F77-A9FE-C7713881BB6B}"/>
               </a:ext>
             </a:extLst>
           </p:cNvPr>
@@ -19481,7 +19504,7 @@
           <p:cNvPr id="34" name="text">
             <a:extLst xmlns:a="http://schemas.openxmlformats.org/drawingml/2006/main">
               <a:ext uri="{FF2B5EF4-FFF2-40B4-BE49-F238E27FC236}">
-                <a16:creationId xmlns:a16="http://schemas.microsoft.com/office/drawing/2014/main" id="{BC51982C-BB39-4F55-B47C-A99A4415D4E6}"/>
+                <a16:creationId xmlns:a16="http://schemas.microsoft.com/office/drawing/2014/main" id="{B8BAB97A-99BD-4C7C-803B-25BF11BF3A52}"/>
               </a:ext>
             </a:extLst>
           </p:cNvPr>
@@ -19539,7 +19562,7 @@
           <p:cNvPr id="35" name="text">
             <a:extLst xmlns:a="http://schemas.openxmlformats.org/drawingml/2006/main">
               <a:ext uri="{FF2B5EF4-FFF2-40B4-BE49-F238E27FC236}">
-                <a16:creationId xmlns:a16="http://schemas.microsoft.com/office/drawing/2014/main" id="{CD7FEF52-1ADD-4D94-84F1-81A8E1A9BF33}"/>
+                <a16:creationId xmlns:a16="http://schemas.microsoft.com/office/drawing/2014/main" id="{2014F1D2-123D-4798-AD26-685719E5E1FD}"/>
               </a:ext>
             </a:extLst>
           </p:cNvPr>
@@ -19595,7 +19618,7 @@
     </p:spTree>
     <p:extLst>
       <p:ext uri="{BB962C8B-B14F-4D97-AF65-F5344CB8AC3E}">
-        <p14:creationId xmlns:p14="http://schemas.microsoft.com/office/powerpoint/2010/main" val="570879834"/>
+        <p14:creationId xmlns:p14="http://schemas.microsoft.com/office/powerpoint/2010/main" val="1743269563"/>
       </p:ext>
     </p:extLst>
   </p:cSld>
@@ -19626,7 +19649,7 @@
           <p:cNvPr id="1" name="eyebrow-7">
             <a:extLst xmlns:a="http://schemas.openxmlformats.org/drawingml/2006/main">
               <a:ext uri="{FF2B5EF4-FFF2-40B4-BE49-F238E27FC236}">
-                <a16:creationId xmlns:a16="http://schemas.microsoft.com/office/drawing/2014/main" id="{1410C158-6AE8-4C50-BBEA-997475DF6503}"/>
+                <a16:creationId xmlns:a16="http://schemas.microsoft.com/office/drawing/2014/main" id="{A534CC9E-C1D0-4859-91DA-47F84449347A}"/>
               </a:ext>
             </a:extLst>
           </p:cNvPr>
@@ -19684,7 +19707,7 @@
           <p:cNvPr id="2" name="slide-title-7">
             <a:extLst xmlns:a="http://schemas.openxmlformats.org/drawingml/2006/main">
               <a:ext uri="{FF2B5EF4-FFF2-40B4-BE49-F238E27FC236}">
-                <a16:creationId xmlns:a16="http://schemas.microsoft.com/office/drawing/2014/main" id="{ACE6EED0-3C54-40D7-AC65-36E42423C13B}"/>
+                <a16:creationId xmlns:a16="http://schemas.microsoft.com/office/drawing/2014/main" id="{2463203D-756A-4CEA-B52A-D3A673727ABF}"/>
               </a:ext>
             </a:extLst>
           </p:cNvPr>
@@ -19742,7 +19765,7 @@
           <p:cNvPr id="3" name="title-rule-7">
             <a:extLst xmlns:a="http://schemas.openxmlformats.org/drawingml/2006/main">
               <a:ext uri="{FF2B5EF4-FFF2-40B4-BE49-F238E27FC236}">
-                <a16:creationId xmlns:a16="http://schemas.microsoft.com/office/drawing/2014/main" id="{A7A5AE36-9FC2-45C7-97AF-FDF759A24F62}"/>
+                <a16:creationId xmlns:a16="http://schemas.microsoft.com/office/drawing/2014/main" id="{0318FEA6-BCD4-4680-A5F6-6C3ECD3FCA02}"/>
               </a:ext>
             </a:extLst>
           </p:cNvPr>
@@ -19773,7 +19796,7 @@
           <p:cNvPr id="4" name="page-number-7">
             <a:extLst xmlns:a="http://schemas.openxmlformats.org/drawingml/2006/main">
               <a:ext uri="{FF2B5EF4-FFF2-40B4-BE49-F238E27FC236}">
-                <a16:creationId xmlns:a16="http://schemas.microsoft.com/office/drawing/2014/main" id="{27888651-1EB9-4728-AC93-A5C17B8E7F9A}"/>
+                <a16:creationId xmlns:a16="http://schemas.microsoft.com/office/drawing/2014/main" id="{81074260-D1A8-4261-9CEB-FC0190A7A917}"/>
               </a:ext>
             </a:extLst>
           </p:cNvPr>
@@ -19831,7 +19854,7 @@
           <p:cNvPr id="5" name="职位雷达页面-frame">
             <a:extLst xmlns:a="http://schemas.openxmlformats.org/drawingml/2006/main">
               <a:ext uri="{FF2B5EF4-FFF2-40B4-BE49-F238E27FC236}">
-                <a16:creationId xmlns:a16="http://schemas.microsoft.com/office/drawing/2014/main" id="{738D059D-8868-4EB2-BE42-580D1A7EBD9A}"/>
+                <a16:creationId xmlns:a16="http://schemas.microsoft.com/office/drawing/2014/main" id="{6467E3ED-78D8-464E-9D8B-C7A32BD24363}"/>
               </a:ext>
             </a:extLst>
           </p:cNvPr>
@@ -19870,7 +19893,7 @@
           <p:nvPr/>
         </p:nvPicPr>
         <p:blipFill>
-          <a:blip xmlns:r="http://schemas.openxmlformats.org/officeDocument/2006/relationships" xmlns:a="http://schemas.openxmlformats.org/drawingml/2006/main" r:embed="Rd8ffd2ac85ed4d71"/>
+          <a:blip xmlns:r="http://schemas.openxmlformats.org/officeDocument/2006/relationships" xmlns:a="http://schemas.openxmlformats.org/drawingml/2006/main" r:embed="Rfa18b22a16a74d27"/>
           <a:stretch xmlns:a="http://schemas.openxmlformats.org/drawingml/2006/main"/>
         </p:blipFill>
         <p:spPr>
@@ -19890,7 +19913,7 @@
           <p:cNvPr id="7" name="text">
             <a:extLst xmlns:a="http://schemas.openxmlformats.org/drawingml/2006/main">
               <a:ext uri="{FF2B5EF4-FFF2-40B4-BE49-F238E27FC236}">
-                <a16:creationId xmlns:a16="http://schemas.microsoft.com/office/drawing/2014/main" id="{6AEA3B20-144C-4C94-83E5-F22B957537C3}"/>
+                <a16:creationId xmlns:a16="http://schemas.microsoft.com/office/drawing/2014/main" id="{6DEEA00A-F80B-4028-B754-E10D215CD247}"/>
               </a:ext>
             </a:extLst>
           </p:cNvPr>
@@ -19948,7 +19971,7 @@
           <p:cNvPr id="8" name="四题模拟面试-frame">
             <a:extLst xmlns:a="http://schemas.openxmlformats.org/drawingml/2006/main">
               <a:ext uri="{FF2B5EF4-FFF2-40B4-BE49-F238E27FC236}">
-                <a16:creationId xmlns:a16="http://schemas.microsoft.com/office/drawing/2014/main" id="{0F0AB618-8985-44C7-ACB7-12C76C239D13}"/>
+                <a16:creationId xmlns:a16="http://schemas.microsoft.com/office/drawing/2014/main" id="{8F105CC7-8C44-4A64-919B-F23C70530138}"/>
               </a:ext>
             </a:extLst>
           </p:cNvPr>
@@ -19987,7 +20010,7 @@
           <p:nvPr/>
         </p:nvPicPr>
         <p:blipFill>
-          <a:blip xmlns:r="http://schemas.openxmlformats.org/officeDocument/2006/relationships" xmlns:a="http://schemas.openxmlformats.org/drawingml/2006/main" r:embed="Rb383ba4e456e4675"/>
+          <a:blip xmlns:r="http://schemas.openxmlformats.org/officeDocument/2006/relationships" xmlns:a="http://schemas.openxmlformats.org/drawingml/2006/main" r:embed="R5cbec60fafcd493c"/>
           <a:stretch xmlns:a="http://schemas.openxmlformats.org/drawingml/2006/main"/>
         </p:blipFill>
         <p:spPr>
@@ -20007,7 +20030,7 @@
           <p:cNvPr id="10" name="text">
             <a:extLst xmlns:a="http://schemas.openxmlformats.org/drawingml/2006/main">
               <a:ext uri="{FF2B5EF4-FFF2-40B4-BE49-F238E27FC236}">
-                <a16:creationId xmlns:a16="http://schemas.microsoft.com/office/drawing/2014/main" id="{21943D5D-DFC3-453E-8F76-BFDAD8673BBE}"/>
+                <a16:creationId xmlns:a16="http://schemas.microsoft.com/office/drawing/2014/main" id="{4DFE7F67-943A-4B28-B480-FF539580EB51}"/>
               </a:ext>
             </a:extLst>
           </p:cNvPr>
@@ -20065,7 +20088,7 @@
           <p:cNvPr id="11" name="消息中心-frame">
             <a:extLst xmlns:a="http://schemas.openxmlformats.org/drawingml/2006/main">
               <a:ext uri="{FF2B5EF4-FFF2-40B4-BE49-F238E27FC236}">
-                <a16:creationId xmlns:a16="http://schemas.microsoft.com/office/drawing/2014/main" id="{D1EEEFE5-8E4B-4C74-A489-3368C620B261}"/>
+                <a16:creationId xmlns:a16="http://schemas.microsoft.com/office/drawing/2014/main" id="{F3075FA2-AF51-44D3-A702-62F088CD7FBC}"/>
               </a:ext>
             </a:extLst>
           </p:cNvPr>
@@ -20104,7 +20127,7 @@
           <p:nvPr/>
         </p:nvPicPr>
         <p:blipFill>
-          <a:blip xmlns:r="http://schemas.openxmlformats.org/officeDocument/2006/relationships" xmlns:a="http://schemas.openxmlformats.org/drawingml/2006/main" r:embed="R2f9b8874dadb4a9e"/>
+          <a:blip xmlns:r="http://schemas.openxmlformats.org/officeDocument/2006/relationships" xmlns:a="http://schemas.openxmlformats.org/drawingml/2006/main" r:embed="R57a8513b4a484e8a"/>
           <a:stretch xmlns:a="http://schemas.openxmlformats.org/drawingml/2006/main"/>
         </p:blipFill>
         <p:spPr>
@@ -20124,7 +20147,7 @@
           <p:cNvPr id="13" name="text">
             <a:extLst xmlns:a="http://schemas.openxmlformats.org/drawingml/2006/main">
               <a:ext uri="{FF2B5EF4-FFF2-40B4-BE49-F238E27FC236}">
-                <a16:creationId xmlns:a16="http://schemas.microsoft.com/office/drawing/2014/main" id="{774EAC42-D0AC-46B0-BF02-C1BB1D7684C5}"/>
+                <a16:creationId xmlns:a16="http://schemas.microsoft.com/office/drawing/2014/main" id="{9C57DE1C-2CB9-4409-A8CF-144698D137EE}"/>
               </a:ext>
             </a:extLst>
           </p:cNvPr>
@@ -20180,7 +20203,7 @@
     </p:spTree>
     <p:extLst>
       <p:ext uri="{BB962C8B-B14F-4D97-AF65-F5344CB8AC3E}">
-        <p14:creationId xmlns:p14="http://schemas.microsoft.com/office/powerpoint/2010/main" val="37767191"/>
+        <p14:creationId xmlns:p14="http://schemas.microsoft.com/office/powerpoint/2010/main" val="1298671526"/>
       </p:ext>
     </p:extLst>
   </p:cSld>
@@ -20211,7 +20234,7 @@
           <p:cNvPr id="1" name="eyebrow-8">
             <a:extLst xmlns:a="http://schemas.openxmlformats.org/drawingml/2006/main">
               <a:ext uri="{FF2B5EF4-FFF2-40B4-BE49-F238E27FC236}">
-                <a16:creationId xmlns:a16="http://schemas.microsoft.com/office/drawing/2014/main" id="{01BC6B82-4D91-4F1E-9217-333102E4295D}"/>
+                <a16:creationId xmlns:a16="http://schemas.microsoft.com/office/drawing/2014/main" id="{22755413-0C86-489B-B0C1-C366523C0C50}"/>
               </a:ext>
             </a:extLst>
           </p:cNvPr>
@@ -20269,7 +20292,7 @@
           <p:cNvPr id="2" name="slide-title-8">
             <a:extLst xmlns:a="http://schemas.openxmlformats.org/drawingml/2006/main">
               <a:ext uri="{FF2B5EF4-FFF2-40B4-BE49-F238E27FC236}">
-                <a16:creationId xmlns:a16="http://schemas.microsoft.com/office/drawing/2014/main" id="{B203A861-8AC4-4C93-B864-5C35C94D4206}"/>
+                <a16:creationId xmlns:a16="http://schemas.microsoft.com/office/drawing/2014/main" id="{32FEBF47-857D-4208-804D-882C5281C125}"/>
               </a:ext>
             </a:extLst>
           </p:cNvPr>
@@ -20327,7 +20350,7 @@
           <p:cNvPr id="3" name="title-rule-8">
             <a:extLst xmlns:a="http://schemas.openxmlformats.org/drawingml/2006/main">
               <a:ext uri="{FF2B5EF4-FFF2-40B4-BE49-F238E27FC236}">
-                <a16:creationId xmlns:a16="http://schemas.microsoft.com/office/drawing/2014/main" id="{98F3AF96-9960-456D-9EC7-8BEFAF51A012}"/>
+                <a16:creationId xmlns:a16="http://schemas.microsoft.com/office/drawing/2014/main" id="{090D97FC-536F-48A6-A3BA-21D2D2108E10}"/>
               </a:ext>
             </a:extLst>
           </p:cNvPr>
@@ -20358,7 +20381,7 @@
           <p:cNvPr id="4" name="page-number-8">
             <a:extLst xmlns:a="http://schemas.openxmlformats.org/drawingml/2006/main">
               <a:ext uri="{FF2B5EF4-FFF2-40B4-BE49-F238E27FC236}">
-                <a16:creationId xmlns:a16="http://schemas.microsoft.com/office/drawing/2014/main" id="{7DCF58CF-19F6-428C-93F6-C9A634426275}"/>
+                <a16:creationId xmlns:a16="http://schemas.microsoft.com/office/drawing/2014/main" id="{4319C908-A6A1-4439-A69E-2BEAFB5C2A74}"/>
               </a:ext>
             </a:extLst>
           </p:cNvPr>
@@ -20416,7 +20439,7 @@
           <p:cNvPr id="5" name="redis-node-0">
             <a:extLst xmlns:a="http://schemas.openxmlformats.org/drawingml/2006/main">
               <a:ext uri="{FF2B5EF4-FFF2-40B4-BE49-F238E27FC236}">
-                <a16:creationId xmlns:a16="http://schemas.microsoft.com/office/drawing/2014/main" id="{F6079A8B-80C6-4541-8C25-BB2FF4C276D4}"/>
+                <a16:creationId xmlns:a16="http://schemas.microsoft.com/office/drawing/2014/main" id="{6FEB085F-7C5D-4C07-AFFC-4512EA8C04BF}"/>
               </a:ext>
             </a:extLst>
           </p:cNvPr>
@@ -20451,7 +20474,7 @@
           <p:cNvPr id="6" name="text">
             <a:extLst xmlns:a="http://schemas.openxmlformats.org/drawingml/2006/main">
               <a:ext uri="{FF2B5EF4-FFF2-40B4-BE49-F238E27FC236}">
-                <a16:creationId xmlns:a16="http://schemas.microsoft.com/office/drawing/2014/main" id="{E906D038-6193-429F-A9DF-8BF07A6BD2D9}"/>
+                <a16:creationId xmlns:a16="http://schemas.microsoft.com/office/drawing/2014/main" id="{E7DF47BB-9A31-47A1-B821-7FAC1E84B29C}"/>
               </a:ext>
             </a:extLst>
           </p:cNvPr>
@@ -20509,7 +20532,7 @@
           <p:cNvPr id="7" name="text">
             <a:extLst xmlns:a="http://schemas.openxmlformats.org/drawingml/2006/main">
               <a:ext uri="{FF2B5EF4-FFF2-40B4-BE49-F238E27FC236}">
-                <a16:creationId xmlns:a16="http://schemas.microsoft.com/office/drawing/2014/main" id="{6388ECF1-5DE7-4FA7-BACC-A7718107AA72}"/>
+                <a16:creationId xmlns:a16="http://schemas.microsoft.com/office/drawing/2014/main" id="{F1EE875D-5C0C-48A1-A555-A5A9D7BBA2BA}"/>
               </a:ext>
             </a:extLst>
           </p:cNvPr>
@@ -20567,7 +20590,7 @@
           <p:cNvPr id="8" name="arrow">
             <a:extLst xmlns:a="http://schemas.openxmlformats.org/drawingml/2006/main">
               <a:ext uri="{FF2B5EF4-FFF2-40B4-BE49-F238E27FC236}">
-                <a16:creationId xmlns:a16="http://schemas.microsoft.com/office/drawing/2014/main" id="{F8B75B64-9DF6-42AC-98C3-95FCD56CADDE}"/>
+                <a16:creationId xmlns:a16="http://schemas.microsoft.com/office/drawing/2014/main" id="{EABEBD24-6478-4B91-8512-ABDB924CB166}"/>
               </a:ext>
             </a:extLst>
           </p:cNvPr>
@@ -20625,7 +20648,7 @@
           <p:cNvPr id="9" name="redis-node-1">
             <a:extLst xmlns:a="http://schemas.openxmlformats.org/drawingml/2006/main">
               <a:ext uri="{FF2B5EF4-FFF2-40B4-BE49-F238E27FC236}">
-                <a16:creationId xmlns:a16="http://schemas.microsoft.com/office/drawing/2014/main" id="{3C7F1010-39BD-427E-9347-39B4EEE5ABC9}"/>
+                <a16:creationId xmlns:a16="http://schemas.microsoft.com/office/drawing/2014/main" id="{D7D0F980-2A9C-4F98-B68F-1ADE844269BB}"/>
               </a:ext>
             </a:extLst>
           </p:cNvPr>
@@ -20660,7 +20683,7 @@
           <p:cNvPr id="10" name="text">
             <a:extLst xmlns:a="http://schemas.openxmlformats.org/drawingml/2006/main">
               <a:ext uri="{FF2B5EF4-FFF2-40B4-BE49-F238E27FC236}">
-                <a16:creationId xmlns:a16="http://schemas.microsoft.com/office/drawing/2014/main" id="{66F02919-EE1C-4595-BA7A-F331C30D6DD4}"/>
+                <a16:creationId xmlns:a16="http://schemas.microsoft.com/office/drawing/2014/main" id="{ECF89999-094D-4920-988F-FFB5B3C2BC1F}"/>
               </a:ext>
             </a:extLst>
           </p:cNvPr>
@@ -20718,7 +20741,7 @@
           <p:cNvPr id="11" name="text">
             <a:extLst xmlns:a="http://schemas.openxmlformats.org/drawingml/2006/main">
               <a:ext uri="{FF2B5EF4-FFF2-40B4-BE49-F238E27FC236}">
-                <a16:creationId xmlns:a16="http://schemas.microsoft.com/office/drawing/2014/main" id="{0E40D326-94BD-4F44-AA7D-0039A9E0BD76}"/>
+                <a16:creationId xmlns:a16="http://schemas.microsoft.com/office/drawing/2014/main" id="{1D95AEE4-5D32-470F-806C-B428FC9A1190}"/>
               </a:ext>
             </a:extLst>
           </p:cNvPr>
@@ -20776,7 +20799,7 @@
           <p:cNvPr id="12" name="arrow">
             <a:extLst xmlns:a="http://schemas.openxmlformats.org/drawingml/2006/main">
               <a:ext uri="{FF2B5EF4-FFF2-40B4-BE49-F238E27FC236}">
-                <a16:creationId xmlns:a16="http://schemas.microsoft.com/office/drawing/2014/main" id="{C0DC5C19-C1EB-460E-BDE8-0A9130F2A1B7}"/>
+                <a16:creationId xmlns:a16="http://schemas.microsoft.com/office/drawing/2014/main" id="{F016EB53-B9B8-4FBE-9CB1-AF0E001B8669}"/>
               </a:ext>
             </a:extLst>
           </p:cNvPr>
@@ -20834,7 +20857,7 @@
           <p:cNvPr id="13" name="redis-node-2">
             <a:extLst xmlns:a="http://schemas.openxmlformats.org/drawingml/2006/main">
               <a:ext uri="{FF2B5EF4-FFF2-40B4-BE49-F238E27FC236}">
-                <a16:creationId xmlns:a16="http://schemas.microsoft.com/office/drawing/2014/main" id="{0FB6E5AF-53C9-483B-A196-A86CDE44086C}"/>
+                <a16:creationId xmlns:a16="http://schemas.microsoft.com/office/drawing/2014/main" id="{EFDBFDF1-27BA-4127-BA49-1740B904F2BE}"/>
               </a:ext>
             </a:extLst>
           </p:cNvPr>
@@ -20869,7 +20892,7 @@
           <p:cNvPr id="14" name="text">
             <a:extLst xmlns:a="http://schemas.openxmlformats.org/drawingml/2006/main">
               <a:ext uri="{FF2B5EF4-FFF2-40B4-BE49-F238E27FC236}">
-                <a16:creationId xmlns:a16="http://schemas.microsoft.com/office/drawing/2014/main" id="{E2433AA0-8DC9-4279-B6FD-A00C523A4AC4}"/>
+                <a16:creationId xmlns:a16="http://schemas.microsoft.com/office/drawing/2014/main" id="{D87F0AD5-7A9D-418D-9C6F-3F681EC11D1B}"/>
               </a:ext>
             </a:extLst>
           </p:cNvPr>
@@ -20927,7 +20950,7 @@
           <p:cNvPr id="15" name="text">
             <a:extLst xmlns:a="http://schemas.openxmlformats.org/drawingml/2006/main">
               <a:ext uri="{FF2B5EF4-FFF2-40B4-BE49-F238E27FC236}">
-                <a16:creationId xmlns:a16="http://schemas.microsoft.com/office/drawing/2014/main" id="{A7E53E91-0F33-4A48-A678-71659E3FB84B}"/>
+                <a16:creationId xmlns:a16="http://schemas.microsoft.com/office/drawing/2014/main" id="{3EBA675A-7DA7-4C58-8A0E-00741EAA141B}"/>
               </a:ext>
             </a:extLst>
           </p:cNvPr>
@@ -20985,7 +21008,7 @@
           <p:cNvPr id="16" name="arrow">
             <a:extLst xmlns:a="http://schemas.openxmlformats.org/drawingml/2006/main">
               <a:ext uri="{FF2B5EF4-FFF2-40B4-BE49-F238E27FC236}">
-                <a16:creationId xmlns:a16="http://schemas.microsoft.com/office/drawing/2014/main" id="{CC6E449A-960A-459E-846B-149C8CEEF021}"/>
+                <a16:creationId xmlns:a16="http://schemas.microsoft.com/office/drawing/2014/main" id="{B5075ACE-EA18-4AF5-B9B8-BDD0E164404B}"/>
               </a:ext>
             </a:extLst>
           </p:cNvPr>
@@ -21043,7 +21066,7 @@
           <p:cNvPr id="17" name="redis-node-3">
             <a:extLst xmlns:a="http://schemas.openxmlformats.org/drawingml/2006/main">
               <a:ext uri="{FF2B5EF4-FFF2-40B4-BE49-F238E27FC236}">
-                <a16:creationId xmlns:a16="http://schemas.microsoft.com/office/drawing/2014/main" id="{192AB7B3-C9B6-4E20-BAC6-1C097F24A70A}"/>
+                <a16:creationId xmlns:a16="http://schemas.microsoft.com/office/drawing/2014/main" id="{3D14EFDE-2075-4D85-9357-050A6AF43A2E}"/>
               </a:ext>
             </a:extLst>
           </p:cNvPr>
@@ -21078,7 +21101,7 @@
           <p:cNvPr id="18" name="text">
             <a:extLst xmlns:a="http://schemas.openxmlformats.org/drawingml/2006/main">
               <a:ext uri="{FF2B5EF4-FFF2-40B4-BE49-F238E27FC236}">
-                <a16:creationId xmlns:a16="http://schemas.microsoft.com/office/drawing/2014/main" id="{9AD46C1A-F136-460E-9864-49238A32CEE0}"/>
+                <a16:creationId xmlns:a16="http://schemas.microsoft.com/office/drawing/2014/main" id="{1AFB3F20-98D2-49DF-A483-01A7E76E5348}"/>
               </a:ext>
             </a:extLst>
           </p:cNvPr>
@@ -21136,7 +21159,7 @@
           <p:cNvPr id="19" name="text">
             <a:extLst xmlns:a="http://schemas.openxmlformats.org/drawingml/2006/main">
               <a:ext uri="{FF2B5EF4-FFF2-40B4-BE49-F238E27FC236}">
-                <a16:creationId xmlns:a16="http://schemas.microsoft.com/office/drawing/2014/main" id="{63E7EF43-25AC-4668-88DB-669A9A4A66F9}"/>
+                <a16:creationId xmlns:a16="http://schemas.microsoft.com/office/drawing/2014/main" id="{85455B64-4166-474F-9439-AE220FA0D436}"/>
               </a:ext>
             </a:extLst>
           </p:cNvPr>
@@ -21194,7 +21217,7 @@
           <p:cNvPr id="20" name="stat-JSON 缓存过期时间">
             <a:extLst xmlns:a="http://schemas.openxmlformats.org/drawingml/2006/main">
               <a:ext uri="{FF2B5EF4-FFF2-40B4-BE49-F238E27FC236}">
-                <a16:creationId xmlns:a16="http://schemas.microsoft.com/office/drawing/2014/main" id="{436256C9-06D3-455F-9B57-AE2FF970E96F}"/>
+                <a16:creationId xmlns:a16="http://schemas.microsoft.com/office/drawing/2014/main" id="{087AB3C4-1417-4BF6-809A-2EC9A816F8D3}"/>
               </a:ext>
             </a:extLst>
           </p:cNvPr>
@@ -21229,7 +21252,7 @@
           <p:cNvPr id="21" name="stat-accent-JSON 缓存过期时间">
             <a:extLst xmlns:a="http://schemas.openxmlformats.org/drawingml/2006/main">
               <a:ext uri="{FF2B5EF4-FFF2-40B4-BE49-F238E27FC236}">
-                <a16:creationId xmlns:a16="http://schemas.microsoft.com/office/drawing/2014/main" id="{18F640A8-8C10-412D-B6CA-137BDD1531AB}"/>
+                <a16:creationId xmlns:a16="http://schemas.microsoft.com/office/drawing/2014/main" id="{32487C38-4CA7-4B29-A70E-7CDB001AEC02}"/>
               </a:ext>
             </a:extLst>
           </p:cNvPr>
@@ -21260,7 +21283,7 @@
           <p:cNvPr id="22" name="stat-value-JSON 缓存过期时间">
             <a:extLst xmlns:a="http://schemas.openxmlformats.org/drawingml/2006/main">
               <a:ext uri="{FF2B5EF4-FFF2-40B4-BE49-F238E27FC236}">
-                <a16:creationId xmlns:a16="http://schemas.microsoft.com/office/drawing/2014/main" id="{CA7798E8-ACA8-43D6-A2B7-547EFE5BE213}"/>
+                <a16:creationId xmlns:a16="http://schemas.microsoft.com/office/drawing/2014/main" id="{213B4A4B-CE8E-44AD-988A-1A87218AD556}"/>
               </a:ext>
             </a:extLst>
           </p:cNvPr>
@@ -21318,7 +21341,7 @@
           <p:cNvPr id="23" name="stat-label-JSON 缓存过期时间">
             <a:extLst xmlns:a="http://schemas.openxmlformats.org/drawingml/2006/main">
               <a:ext uri="{FF2B5EF4-FFF2-40B4-BE49-F238E27FC236}">
-                <a16:creationId xmlns:a16="http://schemas.microsoft.com/office/drawing/2014/main" id="{227F812A-B908-4555-A197-28CAFC9CE814}"/>
+                <a16:creationId xmlns:a16="http://schemas.microsoft.com/office/drawing/2014/main" id="{B9DB2434-15E4-4193-819C-F66EFDDDE1EC}"/>
               </a:ext>
             </a:extLst>
           </p:cNvPr>
@@ -21376,7 +21399,7 @@
           <p:cNvPr id="24" name="stat-列表与详情缓存">
             <a:extLst xmlns:a="http://schemas.openxmlformats.org/drawingml/2006/main">
               <a:ext uri="{FF2B5EF4-FFF2-40B4-BE49-F238E27FC236}">
-                <a16:creationId xmlns:a16="http://schemas.microsoft.com/office/drawing/2014/main" id="{CA4473D7-AA38-4DF3-A3C6-2BCDEE11BDB1}"/>
+                <a16:creationId xmlns:a16="http://schemas.microsoft.com/office/drawing/2014/main" id="{2E3C2CB8-C16F-4AD1-9CF8-E7032197D060}"/>
               </a:ext>
             </a:extLst>
           </p:cNvPr>
@@ -21411,7 +21434,7 @@
           <p:cNvPr id="25" name="stat-accent-列表与详情缓存">
             <a:extLst xmlns:a="http://schemas.openxmlformats.org/drawingml/2006/main">
               <a:ext uri="{FF2B5EF4-FFF2-40B4-BE49-F238E27FC236}">
-                <a16:creationId xmlns:a16="http://schemas.microsoft.com/office/drawing/2014/main" id="{AA56E4E3-00FF-4A5D-B70B-6170BDAF07DD}"/>
+                <a16:creationId xmlns:a16="http://schemas.microsoft.com/office/drawing/2014/main" id="{AFBBE9FA-FAD7-459C-95E8-9FB034D42B64}"/>
               </a:ext>
             </a:extLst>
           </p:cNvPr>
@@ -21442,7 +21465,7 @@
           <p:cNvPr id="26" name="stat-value-列表与详情缓存">
             <a:extLst xmlns:a="http://schemas.openxmlformats.org/drawingml/2006/main">
               <a:ext uri="{FF2B5EF4-FFF2-40B4-BE49-F238E27FC236}">
-                <a16:creationId xmlns:a16="http://schemas.microsoft.com/office/drawing/2014/main" id="{F5F32903-FA05-465A-96ED-9C09FB25CC16}"/>
+                <a16:creationId xmlns:a16="http://schemas.microsoft.com/office/drawing/2014/main" id="{B579C426-95CB-4C36-9CC1-97FD67BB1ACE}"/>
               </a:ext>
             </a:extLst>
           </p:cNvPr>
@@ -21500,7 +21523,7 @@
           <p:cNvPr id="27" name="stat-label-列表与详情缓存">
             <a:extLst xmlns:a="http://schemas.openxmlformats.org/drawingml/2006/main">
               <a:ext uri="{FF2B5EF4-FFF2-40B4-BE49-F238E27FC236}">
-                <a16:creationId xmlns:a16="http://schemas.microsoft.com/office/drawing/2014/main" id="{780FF8D1-C6A9-456A-B185-083290F72757}"/>
+                <a16:creationId xmlns:a16="http://schemas.microsoft.com/office/drawing/2014/main" id="{BC4033D0-9A1F-4AD4-B730-BFB11E712394}"/>
               </a:ext>
             </a:extLst>
           </p:cNvPr>
@@ -21558,7 +21581,7 @@
           <p:cNvPr id="28" name="stat-radar: 便于课堂演示">
             <a:extLst xmlns:a="http://schemas.openxmlformats.org/drawingml/2006/main">
               <a:ext uri="{FF2B5EF4-FFF2-40B4-BE49-F238E27FC236}">
-                <a16:creationId xmlns:a16="http://schemas.microsoft.com/office/drawing/2014/main" id="{431408CE-ECF5-4DF7-9393-939955EF546D}"/>
+                <a16:creationId xmlns:a16="http://schemas.microsoft.com/office/drawing/2014/main" id="{D570CAEA-0D0B-4B6D-A592-9186624B3F81}"/>
               </a:ext>
             </a:extLst>
           </p:cNvPr>
@@ -21593,7 +21616,7 @@
           <p:cNvPr id="29" name="stat-accent-radar: 便于课堂演示">
             <a:extLst xmlns:a="http://schemas.openxmlformats.org/drawingml/2006/main">
               <a:ext uri="{FF2B5EF4-FFF2-40B4-BE49-F238E27FC236}">
-                <a16:creationId xmlns:a16="http://schemas.microsoft.com/office/drawing/2014/main" id="{91B6DEDE-7C64-4E92-8010-BAE29B4C2B1A}"/>
+                <a16:creationId xmlns:a16="http://schemas.microsoft.com/office/drawing/2014/main" id="{F35361CB-4606-4BEF-9EC1-B514AC034DAA}"/>
               </a:ext>
             </a:extLst>
           </p:cNvPr>
@@ -21624,7 +21647,7 @@
           <p:cNvPr id="30" name="stat-value-radar: 便于课堂演示">
             <a:extLst xmlns:a="http://schemas.openxmlformats.org/drawingml/2006/main">
               <a:ext uri="{FF2B5EF4-FFF2-40B4-BE49-F238E27FC236}">
-                <a16:creationId xmlns:a16="http://schemas.microsoft.com/office/drawing/2014/main" id="{817B995E-76D4-47FD-BEC8-CEA68B217EA7}"/>
+                <a16:creationId xmlns:a16="http://schemas.microsoft.com/office/drawing/2014/main" id="{97B4659B-1AFC-497D-9D47-2E78E8679FE0}"/>
               </a:ext>
             </a:extLst>
           </p:cNvPr>
@@ -21682,7 +21705,7 @@
           <p:cNvPr id="31" name="stat-label-radar: 便于课堂演示">
             <a:extLst xmlns:a="http://schemas.openxmlformats.org/drawingml/2006/main">
               <a:ext uri="{FF2B5EF4-FFF2-40B4-BE49-F238E27FC236}">
-                <a16:creationId xmlns:a16="http://schemas.microsoft.com/office/drawing/2014/main" id="{6FEED567-8B10-4764-B857-012A5F1A56D5}"/>
+                <a16:creationId xmlns:a16="http://schemas.microsoft.com/office/drawing/2014/main" id="{42989246-D3D6-40A8-ADDA-A5C2E0A09508}"/>
               </a:ext>
             </a:extLst>
           </p:cNvPr>
@@ -21740,7 +21763,7 @@
           <p:cNvPr id="32" name="text">
             <a:extLst xmlns:a="http://schemas.openxmlformats.org/drawingml/2006/main">
               <a:ext uri="{FF2B5EF4-FFF2-40B4-BE49-F238E27FC236}">
-                <a16:creationId xmlns:a16="http://schemas.microsoft.com/office/drawing/2014/main" id="{E00BAC31-4ADF-4BCD-A29A-D003F79A8582}"/>
+                <a16:creationId xmlns:a16="http://schemas.microsoft.com/office/drawing/2014/main" id="{4DAAC315-BC56-4EDA-9A03-16DBBDBB0283}"/>
               </a:ext>
             </a:extLst>
           </p:cNvPr>
@@ -21796,7 +21819,7 @@
     </p:spTree>
     <p:extLst>
       <p:ext uri="{BB962C8B-B14F-4D97-AF65-F5344CB8AC3E}">
-        <p14:creationId xmlns:p14="http://schemas.microsoft.com/office/powerpoint/2010/main" val="750370329"/>
+        <p14:creationId xmlns:p14="http://schemas.microsoft.com/office/powerpoint/2010/main" val="2107200429"/>
       </p:ext>
     </p:extLst>
   </p:cSld>
@@ -21827,7 +21850,7 @@
           <p:cNvPr id="1" name="eyebrow-9">
             <a:extLst xmlns:a="http://schemas.openxmlformats.org/drawingml/2006/main">
               <a:ext uri="{FF2B5EF4-FFF2-40B4-BE49-F238E27FC236}">
-                <a16:creationId xmlns:a16="http://schemas.microsoft.com/office/drawing/2014/main" id="{60F69DCC-88CA-4437-9202-73146D966224}"/>
+                <a16:creationId xmlns:a16="http://schemas.microsoft.com/office/drawing/2014/main" id="{334BC53E-458F-4504-B306-2543E8EC42BE}"/>
               </a:ext>
             </a:extLst>
           </p:cNvPr>
@@ -21885,7 +21908,7 @@
           <p:cNvPr id="2" name="slide-title-9">
             <a:extLst xmlns:a="http://schemas.openxmlformats.org/drawingml/2006/main">
               <a:ext uri="{FF2B5EF4-FFF2-40B4-BE49-F238E27FC236}">
-                <a16:creationId xmlns:a16="http://schemas.microsoft.com/office/drawing/2014/main" id="{41C08D3A-5433-4665-BC54-CD0EF972F80A}"/>
+                <a16:creationId xmlns:a16="http://schemas.microsoft.com/office/drawing/2014/main" id="{7B08331D-224F-45B2-B445-5E6FE027149F}"/>
               </a:ext>
             </a:extLst>
           </p:cNvPr>
@@ -21943,7 +21966,7 @@
           <p:cNvPr id="3" name="title-rule-9">
             <a:extLst xmlns:a="http://schemas.openxmlformats.org/drawingml/2006/main">
               <a:ext uri="{FF2B5EF4-FFF2-40B4-BE49-F238E27FC236}">
-                <a16:creationId xmlns:a16="http://schemas.microsoft.com/office/drawing/2014/main" id="{AD225829-5421-43D1-8311-08FC32D433AC}"/>
+                <a16:creationId xmlns:a16="http://schemas.microsoft.com/office/drawing/2014/main" id="{029000E7-428A-43CF-B21C-EDEFFCE40FAF}"/>
               </a:ext>
             </a:extLst>
           </p:cNvPr>
@@ -21974,7 +21997,7 @@
           <p:cNvPr id="4" name="page-number-9">
             <a:extLst xmlns:a="http://schemas.openxmlformats.org/drawingml/2006/main">
               <a:ext uri="{FF2B5EF4-FFF2-40B4-BE49-F238E27FC236}">
-                <a16:creationId xmlns:a16="http://schemas.microsoft.com/office/drawing/2014/main" id="{ED083390-3750-4C6E-BFE6-FEDACF09189B}"/>
+                <a16:creationId xmlns:a16="http://schemas.microsoft.com/office/drawing/2014/main" id="{A8FA7648-73CC-428D-A64E-ED3A953CFE08}"/>
               </a:ext>
             </a:extLst>
           </p:cNvPr>
@@ -22032,7 +22055,7 @@
           <p:cNvPr id="5" name="mq-0">
             <a:extLst xmlns:a="http://schemas.openxmlformats.org/drawingml/2006/main">
               <a:ext uri="{FF2B5EF4-FFF2-40B4-BE49-F238E27FC236}">
-                <a16:creationId xmlns:a16="http://schemas.microsoft.com/office/drawing/2014/main" id="{3D4AC9DB-C858-4653-8A41-02C0FFC932D8}"/>
+                <a16:creationId xmlns:a16="http://schemas.microsoft.com/office/drawing/2014/main" id="{9DF4459C-18FD-49DD-9FA5-2FE3BDEFDB2D}"/>
               </a:ext>
             </a:extLst>
           </p:cNvPr>
@@ -22067,7 +22090,7 @@
           <p:cNvPr id="6" name="text">
             <a:extLst xmlns:a="http://schemas.openxmlformats.org/drawingml/2006/main">
               <a:ext uri="{FF2B5EF4-FFF2-40B4-BE49-F238E27FC236}">
-                <a16:creationId xmlns:a16="http://schemas.microsoft.com/office/drawing/2014/main" id="{C61D4AA1-248D-44C2-AD75-CA5082C15F19}"/>
+                <a16:creationId xmlns:a16="http://schemas.microsoft.com/office/drawing/2014/main" id="{C06149A0-3C3C-4349-BFE7-EDD736E9ABE1}"/>
               </a:ext>
             </a:extLst>
           </p:cNvPr>
@@ -22125,7 +22148,7 @@
           <p:cNvPr id="7" name="text">
             <a:extLst xmlns:a="http://schemas.openxmlformats.org/drawingml/2006/main">
               <a:ext uri="{FF2B5EF4-FFF2-40B4-BE49-F238E27FC236}">
-                <a16:creationId xmlns:a16="http://schemas.microsoft.com/office/drawing/2014/main" id="{E562E997-708B-4976-B23F-5AC5FDD0E275}"/>
+                <a16:creationId xmlns:a16="http://schemas.microsoft.com/office/drawing/2014/main" id="{D83FC05B-C791-45D6-8756-3DAA105F80CC}"/>
               </a:ext>
             </a:extLst>
           </p:cNvPr>
@@ -22183,7 +22206,7 @@
           <p:cNvPr id="8" name="arrow">
             <a:extLst xmlns:a="http://schemas.openxmlformats.org/drawingml/2006/main">
               <a:ext uri="{FF2B5EF4-FFF2-40B4-BE49-F238E27FC236}">
-                <a16:creationId xmlns:a16="http://schemas.microsoft.com/office/drawing/2014/main" id="{9754A8A7-D79A-4643-9E4C-F5C12FBA5822}"/>
+                <a16:creationId xmlns:a16="http://schemas.microsoft.com/office/drawing/2014/main" id="{CE638BA3-4257-4E80-A7F3-B1E3F3EBF222}"/>
               </a:ext>
             </a:extLst>
           </p:cNvPr>
@@ -22241,7 +22264,7 @@
           <p:cNvPr id="9" name="mq-1">
             <a:extLst xmlns:a="http://schemas.openxmlformats.org/drawingml/2006/main">
               <a:ext uri="{FF2B5EF4-FFF2-40B4-BE49-F238E27FC236}">
-                <a16:creationId xmlns:a16="http://schemas.microsoft.com/office/drawing/2014/main" id="{E2E2E045-50AF-4E81-B00C-3E62ACBF1EEA}"/>
+                <a16:creationId xmlns:a16="http://schemas.microsoft.com/office/drawing/2014/main" id="{ABEB2842-ACBF-4C6B-B4E0-50105FF59A9A}"/>
               </a:ext>
             </a:extLst>
           </p:cNvPr>
@@ -22276,7 +22299,7 @@
           <p:cNvPr id="10" name="text">
             <a:extLst xmlns:a="http://schemas.openxmlformats.org/drawingml/2006/main">
               <a:ext uri="{FF2B5EF4-FFF2-40B4-BE49-F238E27FC236}">
-                <a16:creationId xmlns:a16="http://schemas.microsoft.com/office/drawing/2014/main" id="{62181A07-D045-4BE1-8580-CA831D6BD0C7}"/>
+                <a16:creationId xmlns:a16="http://schemas.microsoft.com/office/drawing/2014/main" id="{28B61C00-A7BA-4C57-A06E-D85717CAD00E}"/>
               </a:ext>
             </a:extLst>
           </p:cNvPr>
@@ -22334,7 +22357,7 @@
           <p:cNvPr id="11" name="text">
             <a:extLst xmlns:a="http://schemas.openxmlformats.org/drawingml/2006/main">
               <a:ext uri="{FF2B5EF4-FFF2-40B4-BE49-F238E27FC236}">
-                <a16:creationId xmlns:a16="http://schemas.microsoft.com/office/drawing/2014/main" id="{83427DAA-E710-4DA0-9A38-2EFE1FAEC774}"/>
+                <a16:creationId xmlns:a16="http://schemas.microsoft.com/office/drawing/2014/main" id="{B4102C2E-2629-4E04-BE29-C0CCEC01DB73}"/>
               </a:ext>
             </a:extLst>
           </p:cNvPr>
@@ -22392,7 +22415,7 @@
           <p:cNvPr id="12" name="arrow">
             <a:extLst xmlns:a="http://schemas.openxmlformats.org/drawingml/2006/main">
               <a:ext uri="{FF2B5EF4-FFF2-40B4-BE49-F238E27FC236}">
-                <a16:creationId xmlns:a16="http://schemas.microsoft.com/office/drawing/2014/main" id="{75B3A915-3525-4607-AC39-681D4FC18A14}"/>
+                <a16:creationId xmlns:a16="http://schemas.microsoft.com/office/drawing/2014/main" id="{376601FB-35F7-4D4D-BFCC-106396E676B3}"/>
               </a:ext>
             </a:extLst>
           </p:cNvPr>
@@ -22450,7 +22473,7 @@
           <p:cNvPr id="13" name="mq-2">
             <a:extLst xmlns:a="http://schemas.openxmlformats.org/drawingml/2006/main">
               <a:ext uri="{FF2B5EF4-FFF2-40B4-BE49-F238E27FC236}">
-                <a16:creationId xmlns:a16="http://schemas.microsoft.com/office/drawing/2014/main" id="{53DADE2C-7C90-4A50-93C9-0EF0C819656F}"/>
+                <a16:creationId xmlns:a16="http://schemas.microsoft.com/office/drawing/2014/main" id="{9EAF95C5-9372-42EA-ABEE-D31B57934E19}"/>
               </a:ext>
             </a:extLst>
           </p:cNvPr>
@@ -22485,7 +22508,7 @@
           <p:cNvPr id="14" name="text">
             <a:extLst xmlns:a="http://schemas.openxmlformats.org/drawingml/2006/main">
               <a:ext uri="{FF2B5EF4-FFF2-40B4-BE49-F238E27FC236}">
-                <a16:creationId xmlns:a16="http://schemas.microsoft.com/office/drawing/2014/main" id="{6D4F2486-00F7-42D6-99BD-0E1CC86C2D5B}"/>
+                <a16:creationId xmlns:a16="http://schemas.microsoft.com/office/drawing/2014/main" id="{06537A12-B884-4F75-B33A-7A79427A7F55}"/>
               </a:ext>
             </a:extLst>
           </p:cNvPr>
@@ -22543,7 +22566,7 @@
           <p:cNvPr id="15" name="text">
             <a:extLst xmlns:a="http://schemas.openxmlformats.org/drawingml/2006/main">
               <a:ext uri="{FF2B5EF4-FFF2-40B4-BE49-F238E27FC236}">
-                <a16:creationId xmlns:a16="http://schemas.microsoft.com/office/drawing/2014/main" id="{E98097CA-69A7-43BC-ABB9-7717E6B31011}"/>
+                <a16:creationId xmlns:a16="http://schemas.microsoft.com/office/drawing/2014/main" id="{D76AB896-1D79-4B19-AC43-2CA5D5B54667}"/>
               </a:ext>
             </a:extLst>
           </p:cNvPr>
@@ -22601,7 +22624,7 @@
           <p:cNvPr id="16" name="arrow">
             <a:extLst xmlns:a="http://schemas.openxmlformats.org/drawingml/2006/main">
               <a:ext uri="{FF2B5EF4-FFF2-40B4-BE49-F238E27FC236}">
-                <a16:creationId xmlns:a16="http://schemas.microsoft.com/office/drawing/2014/main" id="{36579D46-CEA2-478F-AB9E-EF801639FE0B}"/>
+                <a16:creationId xmlns:a16="http://schemas.microsoft.com/office/drawing/2014/main" id="{EEB5008F-6C06-4DBD-BC05-9F6B8AE6800D}"/>
               </a:ext>
             </a:extLst>
           </p:cNvPr>
@@ -22659,7 +22682,7 @@
           <p:cNvPr id="17" name="mq-3">
             <a:extLst xmlns:a="http://schemas.openxmlformats.org/drawingml/2006/main">
               <a:ext uri="{FF2B5EF4-FFF2-40B4-BE49-F238E27FC236}">
-                <a16:creationId xmlns:a16="http://schemas.microsoft.com/office/drawing/2014/main" id="{1D90F234-F1F6-49DE-B472-9D6B655C8409}"/>
+                <a16:creationId xmlns:a16="http://schemas.microsoft.com/office/drawing/2014/main" id="{F54CAE0E-70D3-44DB-8F1E-69AA8764578A}"/>
               </a:ext>
             </a:extLst>
           </p:cNvPr>
@@ -22694,7 +22717,7 @@
           <p:cNvPr id="18" name="text">
             <a:extLst xmlns:a="http://schemas.openxmlformats.org/drawingml/2006/main">
               <a:ext uri="{FF2B5EF4-FFF2-40B4-BE49-F238E27FC236}">
-                <a16:creationId xmlns:a16="http://schemas.microsoft.com/office/drawing/2014/main" id="{AABFE3B4-D961-4668-9148-3F2C7904AD0B}"/>
+                <a16:creationId xmlns:a16="http://schemas.microsoft.com/office/drawing/2014/main" id="{103CDD01-657A-419E-9B8A-01AB847C9C8E}"/>
               </a:ext>
             </a:extLst>
           </p:cNvPr>
@@ -22752,7 +22775,7 @@
           <p:cNvPr id="19" name="text">
             <a:extLst xmlns:a="http://schemas.openxmlformats.org/drawingml/2006/main">
               <a:ext uri="{FF2B5EF4-FFF2-40B4-BE49-F238E27FC236}">
-                <a16:creationId xmlns:a16="http://schemas.microsoft.com/office/drawing/2014/main" id="{F0B3A6DD-3D8B-4C85-B86A-5BAC20812B50}"/>
+                <a16:creationId xmlns:a16="http://schemas.microsoft.com/office/drawing/2014/main" id="{17B40D00-BF2B-4BDF-8C44-F07453FFD9BA}"/>
               </a:ext>
             </a:extLst>
           </p:cNvPr>
@@ -22810,7 +22833,7 @@
           <p:cNvPr id="20" name="mq-point-0">
             <a:extLst xmlns:a="http://schemas.openxmlformats.org/drawingml/2006/main">
               <a:ext uri="{FF2B5EF4-FFF2-40B4-BE49-F238E27FC236}">
-                <a16:creationId xmlns:a16="http://schemas.microsoft.com/office/drawing/2014/main" id="{ABB1F499-EEBB-409C-A936-2C2455348148}"/>
+                <a16:creationId xmlns:a16="http://schemas.microsoft.com/office/drawing/2014/main" id="{426BCBA5-6D48-44F0-84C4-CB48B6FE2032}"/>
               </a:ext>
             </a:extLst>
           </p:cNvPr>
@@ -22845,7 +22868,7 @@
           <p:cNvPr id="21" name="text">
             <a:extLst xmlns:a="http://schemas.openxmlformats.org/drawingml/2006/main">
               <a:ext uri="{FF2B5EF4-FFF2-40B4-BE49-F238E27FC236}">
-                <a16:creationId xmlns:a16="http://schemas.microsoft.com/office/drawing/2014/main" id="{6154755A-E92E-469B-8BC8-0D1C93407B4B}"/>
+                <a16:creationId xmlns:a16="http://schemas.microsoft.com/office/drawing/2014/main" id="{97DBB551-3B84-4978-A319-97E128777066}"/>
               </a:ext>
             </a:extLst>
           </p:cNvPr>
@@ -22903,7 +22926,7 @@
           <p:cNvPr id="22" name="text">
             <a:extLst xmlns:a="http://schemas.openxmlformats.org/drawingml/2006/main">
               <a:ext uri="{FF2B5EF4-FFF2-40B4-BE49-F238E27FC236}">
-                <a16:creationId xmlns:a16="http://schemas.microsoft.com/office/drawing/2014/main" id="{7DD27286-79CB-4201-B8F0-DDB65652EDC3}"/>
+                <a16:creationId xmlns:a16="http://schemas.microsoft.com/office/drawing/2014/main" id="{80485DDA-D76B-46DF-A020-687CBA82055C}"/>
               </a:ext>
             </a:extLst>
           </p:cNvPr>
@@ -22961,7 +22984,7 @@
           <p:cNvPr id="23" name="mq-point-1">
             <a:extLst xmlns:a="http://schemas.openxmlformats.org/drawingml/2006/main">
               <a:ext uri="{FF2B5EF4-FFF2-40B4-BE49-F238E27FC236}">
-                <a16:creationId xmlns:a16="http://schemas.microsoft.com/office/drawing/2014/main" id="{077DAD4E-4309-475F-8E0C-7D434BF642DA}"/>
+                <a16:creationId xmlns:a16="http://schemas.microsoft.com/office/drawing/2014/main" id="{04DC19D4-238E-405D-96F8-6120482AD8D0}"/>
               </a:ext>
             </a:extLst>
           </p:cNvPr>
@@ -22996,7 +23019,7 @@
           <p:cNvPr id="24" name="text">
             <a:extLst xmlns:a="http://schemas.openxmlformats.org/drawingml/2006/main">
               <a:ext uri="{FF2B5EF4-FFF2-40B4-BE49-F238E27FC236}">
-                <a16:creationId xmlns:a16="http://schemas.microsoft.com/office/drawing/2014/main" id="{71DBFF3F-2A77-41E2-8767-540A1CDAE746}"/>
+                <a16:creationId xmlns:a16="http://schemas.microsoft.com/office/drawing/2014/main" id="{035A62AF-E92F-4A99-B06A-F12BF4CFE61E}"/>
               </a:ext>
             </a:extLst>
           </p:cNvPr>
@@ -23054,7 +23077,7 @@
           <p:cNvPr id="25" name="text">
             <a:extLst xmlns:a="http://schemas.openxmlformats.org/drawingml/2006/main">
               <a:ext uri="{FF2B5EF4-FFF2-40B4-BE49-F238E27FC236}">
-                <a16:creationId xmlns:a16="http://schemas.microsoft.com/office/drawing/2014/main" id="{A6493B32-975E-456B-99FB-6DE5567DA93A}"/>
+                <a16:creationId xmlns:a16="http://schemas.microsoft.com/office/drawing/2014/main" id="{75975B97-4D66-4CB4-823D-40B3ABD50AB8}"/>
               </a:ext>
             </a:extLst>
           </p:cNvPr>
@@ -23112,7 +23135,7 @@
           <p:cNvPr id="26" name="mq-point-2">
             <a:extLst xmlns:a="http://schemas.openxmlformats.org/drawingml/2006/main">
               <a:ext uri="{FF2B5EF4-FFF2-40B4-BE49-F238E27FC236}">
-                <a16:creationId xmlns:a16="http://schemas.microsoft.com/office/drawing/2014/main" id="{DA4963A3-DF13-41CC-ABD6-2335E5AF6B33}"/>
+                <a16:creationId xmlns:a16="http://schemas.microsoft.com/office/drawing/2014/main" id="{0B583569-8D28-48CD-ABCF-4AD408AA39D4}"/>
               </a:ext>
             </a:extLst>
           </p:cNvPr>
@@ -23147,7 +23170,7 @@
           <p:cNvPr id="27" name="text">
             <a:extLst xmlns:a="http://schemas.openxmlformats.org/drawingml/2006/main">
               <a:ext uri="{FF2B5EF4-FFF2-40B4-BE49-F238E27FC236}">
-                <a16:creationId xmlns:a16="http://schemas.microsoft.com/office/drawing/2014/main" id="{8FE2ABB6-6F9C-4A3C-815A-104C1D45D00C}"/>
+                <a16:creationId xmlns:a16="http://schemas.microsoft.com/office/drawing/2014/main" id="{E2C6A3AB-A617-4907-BA71-DF2E6FCEF233}"/>
               </a:ext>
             </a:extLst>
           </p:cNvPr>
@@ -23205,7 +23228,7 @@
           <p:cNvPr id="28" name="text">
             <a:extLst xmlns:a="http://schemas.openxmlformats.org/drawingml/2006/main">
               <a:ext uri="{FF2B5EF4-FFF2-40B4-BE49-F238E27FC236}">
-                <a16:creationId xmlns:a16="http://schemas.microsoft.com/office/drawing/2014/main" id="{F1E180B5-BB9A-4FB2-9B4C-AFA46DF04BD6}"/>
+                <a16:creationId xmlns:a16="http://schemas.microsoft.com/office/drawing/2014/main" id="{9D1FF344-411F-481B-B632-099B26D111A1}"/>
               </a:ext>
             </a:extLst>
           </p:cNvPr>
@@ -23263,7 +23286,7 @@
           <p:cNvPr id="29" name="text">
             <a:extLst xmlns:a="http://schemas.openxmlformats.org/drawingml/2006/main">
               <a:ext uri="{FF2B5EF4-FFF2-40B4-BE49-F238E27FC236}">
-                <a16:creationId xmlns:a16="http://schemas.microsoft.com/office/drawing/2014/main" id="{87DF64D1-B706-4FE0-BA4B-B650D8B46ADF}"/>
+                <a16:creationId xmlns:a16="http://schemas.microsoft.com/office/drawing/2014/main" id="{A37345CC-2141-4AC7-888E-1C1C323270CE}"/>
               </a:ext>
             </a:extLst>
           </p:cNvPr>
@@ -23311,7 +23334,7 @@
                 <a:ea typeface="Microsoft YaHei"/>
                 <a:cs typeface="Microsoft YaHei"/>
               </a:rPr>
-              <a:t>现场启动 RabbitMQ 后即可演示真实异步消费；未启动时发布器容错，投递主流程仍可演示。</a:t>
+              <a:t>本机已验证真实异步消费：投递状态更新为 OFFER 后，消息中心自动新增对应通知。</a:t>
             </a:r>
           </a:p>
         </p:txBody>
@@ -23319,7 +23342,7 @@
     </p:spTree>
     <p:extLst>
       <p:ext uri="{BB962C8B-B14F-4D97-AF65-F5344CB8AC3E}">
-        <p14:creationId xmlns:p14="http://schemas.microsoft.com/office/powerpoint/2010/main" val="409614956"/>
+        <p14:creationId xmlns:p14="http://schemas.microsoft.com/office/powerpoint/2010/main" val="37011045"/>
       </p:ext>
     </p:extLst>
   </p:cSld>

</xml_diff>